<commit_message>
Update UI icons and presentation files
- Modified the 'modedark.svg' icon to adjust path coordinates and ensure proper rendering.
- Updated 'sprites-ui.svg' to replace the 'modedark' symbol with the revised version, ensuring consistency across the UI.
- Changed the 'Icons_UI.pptx' presentation file to reflect the latest icon updates.
</commit_message>
<xml_diff>
--- a/Icons_UI/Icons_UI.pptx
+++ b/Icons_UI/Icons_UI.pptx
@@ -25723,459 +25723,330 @@
           </a:p>
         </p:txBody>
       </p:sp>
-      <p:grpSp>
-        <p:nvGrpSpPr>
-          <p:cNvPr id="36" name="Group 35">
+      <p:sp>
+        <p:nvSpPr>
+          <p:cNvPr id="3" name="Freeform: Shape 2">
             <a:extLst>
               <a:ext uri="{FF2B5EF4-FFF2-40B4-BE49-F238E27FC236}">
-                <a16:creationId xmlns:a16="http://schemas.microsoft.com/office/drawing/2014/main" id="{4FBD93CD-9010-22D1-E7AC-D2E1DAAD897B}"/>
+                <a16:creationId xmlns:a16="http://schemas.microsoft.com/office/drawing/2014/main" id="{F2B7A7E0-C297-BA50-9403-962B567EC93F}"/>
               </a:ext>
             </a:extLst>
           </p:cNvPr>
-          <p:cNvGrpSpPr/>
+          <p:cNvSpPr/>
           <p:nvPr/>
-        </p:nvGrpSpPr>
-        <p:grpSpPr>
+        </p:nvSpPr>
+        <p:spPr>
+          <a:xfrm rot="19319567">
+            <a:off x="6304634" y="675989"/>
+            <a:ext cx="627137" cy="900000"/>
+          </a:xfrm>
+          <a:custGeom>
+            <a:avLst/>
+            <a:gdLst>
+              <a:gd name="csX0" fmla="*/ 450000 w 645150"/>
+              <a:gd name="csY0" fmla="*/ 0 h 900000"/>
+              <a:gd name="csX1" fmla="*/ 625161 w 645150"/>
+              <a:gd name="csY1" fmla="*/ 35364 h 900000"/>
+              <a:gd name="csX2" fmla="*/ 645150 w 645150"/>
+              <a:gd name="csY2" fmla="*/ 46214 h 900000"/>
+              <a:gd name="csX3" fmla="*/ 588701 w 645150"/>
+              <a:gd name="csY3" fmla="*/ 76853 h 900000"/>
+              <a:gd name="csX4" fmla="*/ 390300 w 645150"/>
+              <a:gd name="csY4" fmla="*/ 450000 h 900000"/>
+              <a:gd name="csX5" fmla="*/ 588701 w 645150"/>
+              <a:gd name="csY5" fmla="*/ 823147 h 900000"/>
+              <a:gd name="csX6" fmla="*/ 645150 w 645150"/>
+              <a:gd name="csY6" fmla="*/ 853787 h 900000"/>
+              <a:gd name="csX7" fmla="*/ 625161 w 645150"/>
+              <a:gd name="csY7" fmla="*/ 864637 h 900000"/>
+              <a:gd name="csX8" fmla="*/ 450000 w 645150"/>
+              <a:gd name="csY8" fmla="*/ 900000 h 900000"/>
+              <a:gd name="csX9" fmla="*/ 0 w 645150"/>
+              <a:gd name="csY9" fmla="*/ 450000 h 900000"/>
+              <a:gd name="csX10" fmla="*/ 450000 w 645150"/>
+              <a:gd name="csY10" fmla="*/ 0 h 900000"/>
+              <a:gd name="csX0" fmla="*/ 450000 w 645150"/>
+              <a:gd name="csY0" fmla="*/ 0 h 900000"/>
+              <a:gd name="csX1" fmla="*/ 625161 w 645150"/>
+              <a:gd name="csY1" fmla="*/ 35364 h 900000"/>
+              <a:gd name="csX2" fmla="*/ 588701 w 645150"/>
+              <a:gd name="csY2" fmla="*/ 76853 h 900000"/>
+              <a:gd name="csX3" fmla="*/ 390300 w 645150"/>
+              <a:gd name="csY3" fmla="*/ 450000 h 900000"/>
+              <a:gd name="csX4" fmla="*/ 588701 w 645150"/>
+              <a:gd name="csY4" fmla="*/ 823147 h 900000"/>
+              <a:gd name="csX5" fmla="*/ 645150 w 645150"/>
+              <a:gd name="csY5" fmla="*/ 853787 h 900000"/>
+              <a:gd name="csX6" fmla="*/ 625161 w 645150"/>
+              <a:gd name="csY6" fmla="*/ 864637 h 900000"/>
+              <a:gd name="csX7" fmla="*/ 450000 w 645150"/>
+              <a:gd name="csY7" fmla="*/ 900000 h 900000"/>
+              <a:gd name="csX8" fmla="*/ 0 w 645150"/>
+              <a:gd name="csY8" fmla="*/ 450000 h 900000"/>
+              <a:gd name="csX9" fmla="*/ 450000 w 645150"/>
+              <a:gd name="csY9" fmla="*/ 0 h 900000"/>
+              <a:gd name="csX0" fmla="*/ 450000 w 625161"/>
+              <a:gd name="csY0" fmla="*/ 0 h 900000"/>
+              <a:gd name="csX1" fmla="*/ 625161 w 625161"/>
+              <a:gd name="csY1" fmla="*/ 35364 h 900000"/>
+              <a:gd name="csX2" fmla="*/ 588701 w 625161"/>
+              <a:gd name="csY2" fmla="*/ 76853 h 900000"/>
+              <a:gd name="csX3" fmla="*/ 390300 w 625161"/>
+              <a:gd name="csY3" fmla="*/ 450000 h 900000"/>
+              <a:gd name="csX4" fmla="*/ 588701 w 625161"/>
+              <a:gd name="csY4" fmla="*/ 823147 h 900000"/>
+              <a:gd name="csX5" fmla="*/ 625161 w 625161"/>
+              <a:gd name="csY5" fmla="*/ 864637 h 900000"/>
+              <a:gd name="csX6" fmla="*/ 450000 w 625161"/>
+              <a:gd name="csY6" fmla="*/ 900000 h 900000"/>
+              <a:gd name="csX7" fmla="*/ 0 w 625161"/>
+              <a:gd name="csY7" fmla="*/ 450000 h 900000"/>
+              <a:gd name="csX8" fmla="*/ 450000 w 625161"/>
+              <a:gd name="csY8" fmla="*/ 0 h 900000"/>
+              <a:gd name="csX0" fmla="*/ 450000 w 627137"/>
+              <a:gd name="csY0" fmla="*/ 0 h 900000"/>
+              <a:gd name="csX1" fmla="*/ 625161 w 627137"/>
+              <a:gd name="csY1" fmla="*/ 35364 h 900000"/>
+              <a:gd name="csX2" fmla="*/ 588701 w 627137"/>
+              <a:gd name="csY2" fmla="*/ 76853 h 900000"/>
+              <a:gd name="csX3" fmla="*/ 390300 w 627137"/>
+              <a:gd name="csY3" fmla="*/ 450000 h 900000"/>
+              <a:gd name="csX4" fmla="*/ 588701 w 627137"/>
+              <a:gd name="csY4" fmla="*/ 823147 h 900000"/>
+              <a:gd name="csX5" fmla="*/ 625161 w 627137"/>
+              <a:gd name="csY5" fmla="*/ 864637 h 900000"/>
+              <a:gd name="csX6" fmla="*/ 450000 w 627137"/>
+              <a:gd name="csY6" fmla="*/ 900000 h 900000"/>
+              <a:gd name="csX7" fmla="*/ 0 w 627137"/>
+              <a:gd name="csY7" fmla="*/ 450000 h 900000"/>
+              <a:gd name="csX8" fmla="*/ 450000 w 627137"/>
+              <a:gd name="csY8" fmla="*/ 0 h 900000"/>
+              <a:gd name="csX0" fmla="*/ 450000 w 627137"/>
+              <a:gd name="csY0" fmla="*/ 0 h 900000"/>
+              <a:gd name="csX1" fmla="*/ 625161 w 627137"/>
+              <a:gd name="csY1" fmla="*/ 35364 h 900000"/>
+              <a:gd name="csX2" fmla="*/ 588701 w 627137"/>
+              <a:gd name="csY2" fmla="*/ 76853 h 900000"/>
+              <a:gd name="csX3" fmla="*/ 390300 w 627137"/>
+              <a:gd name="csY3" fmla="*/ 450000 h 900000"/>
+              <a:gd name="csX4" fmla="*/ 588701 w 627137"/>
+              <a:gd name="csY4" fmla="*/ 823147 h 900000"/>
+              <a:gd name="csX5" fmla="*/ 625161 w 627137"/>
+              <a:gd name="csY5" fmla="*/ 864637 h 900000"/>
+              <a:gd name="csX6" fmla="*/ 450000 w 627137"/>
+              <a:gd name="csY6" fmla="*/ 900000 h 900000"/>
+              <a:gd name="csX7" fmla="*/ 0 w 627137"/>
+              <a:gd name="csY7" fmla="*/ 450000 h 900000"/>
+              <a:gd name="csX8" fmla="*/ 450000 w 627137"/>
+              <a:gd name="csY8" fmla="*/ 0 h 900000"/>
+            </a:gdLst>
+            <a:ahLst/>
+            <a:cxnLst>
+              <a:cxn ang="0">
+                <a:pos x="csX0" y="csY0"/>
+              </a:cxn>
+              <a:cxn ang="0">
+                <a:pos x="csX1" y="csY1"/>
+              </a:cxn>
+              <a:cxn ang="0">
+                <a:pos x="csX2" y="csY2"/>
+              </a:cxn>
+              <a:cxn ang="0">
+                <a:pos x="csX3" y="csY3"/>
+              </a:cxn>
+              <a:cxn ang="0">
+                <a:pos x="csX4" y="csY4"/>
+              </a:cxn>
+              <a:cxn ang="0">
+                <a:pos x="csX5" y="csY5"/>
+              </a:cxn>
+              <a:cxn ang="0">
+                <a:pos x="csX6" y="csY6"/>
+              </a:cxn>
+              <a:cxn ang="0">
+                <a:pos x="csX7" y="csY7"/>
+              </a:cxn>
+              <a:cxn ang="0">
+                <a:pos x="csX8" y="csY8"/>
+              </a:cxn>
+            </a:cxnLst>
+            <a:rect l="l" t="t" r="r" b="b"/>
+            <a:pathLst>
+              <a:path w="627137" h="900000">
+                <a:moveTo>
+                  <a:pt x="450000" y="0"/>
+                </a:moveTo>
+                <a:cubicBezTo>
+                  <a:pt x="512132" y="0"/>
+                  <a:pt x="571323" y="12592"/>
+                  <a:pt x="625161" y="35364"/>
+                </a:cubicBezTo>
+                <a:cubicBezTo>
+                  <a:pt x="635760" y="54886"/>
+                  <a:pt x="600854" y="63023"/>
+                  <a:pt x="588701" y="76853"/>
+                </a:cubicBezTo>
+                <a:cubicBezTo>
+                  <a:pt x="469000" y="157722"/>
+                  <a:pt x="390300" y="294670"/>
+                  <a:pt x="390300" y="450000"/>
+                </a:cubicBezTo>
+                <a:cubicBezTo>
+                  <a:pt x="390300" y="605330"/>
+                  <a:pt x="469000" y="742279"/>
+                  <a:pt x="588701" y="823147"/>
+                </a:cubicBezTo>
+                <a:cubicBezTo>
+                  <a:pt x="600854" y="836977"/>
+                  <a:pt x="630540" y="855442"/>
+                  <a:pt x="625161" y="864637"/>
+                </a:cubicBezTo>
+                <a:cubicBezTo>
+                  <a:pt x="571323" y="887408"/>
+                  <a:pt x="512132" y="900000"/>
+                  <a:pt x="450000" y="900000"/>
+                </a:cubicBezTo>
+                <a:cubicBezTo>
+                  <a:pt x="201472" y="900000"/>
+                  <a:pt x="0" y="698528"/>
+                  <a:pt x="0" y="450000"/>
+                </a:cubicBezTo>
+                <a:cubicBezTo>
+                  <a:pt x="0" y="201472"/>
+                  <a:pt x="201472" y="0"/>
+                  <a:pt x="450000" y="0"/>
+                </a:cubicBezTo>
+                <a:close/>
+              </a:path>
+            </a:pathLst>
+          </a:custGeom>
+          <a:solidFill>
+            <a:schemeClr val="tx1"/>
+          </a:solidFill>
+          <a:ln w="74613" cap="flat">
+            <a:noFill/>
+            <a:prstDash val="solid"/>
+            <a:miter/>
+          </a:ln>
+        </p:spPr>
+        <p:txBody>
+          <a:bodyPr wrap="square">
+            <a:noAutofit/>
+          </a:bodyPr>
+          <a:lstStyle/>
+          <a:p>
+            <a:endParaRPr lang="en-US"/>
+          </a:p>
+        </p:txBody>
+      </p:sp>
+      <p:sp>
+        <p:nvSpPr>
+          <p:cNvPr id="17" name="Oval 16">
+            <a:extLst>
+              <a:ext uri="{FF2B5EF4-FFF2-40B4-BE49-F238E27FC236}">
+                <a16:creationId xmlns:a16="http://schemas.microsoft.com/office/drawing/2014/main" id="{5F4AF6DA-7D07-E738-4A9F-CEE710B947E8}"/>
+              </a:ext>
+            </a:extLst>
+          </p:cNvPr>
+          <p:cNvSpPr/>
+          <p:nvPr/>
+        </p:nvSpPr>
+        <p:spPr>
           <a:xfrm>
             <a:off x="5974687" y="293525"/>
-            <a:ext cx="1500000" cy="1500000"/>
-            <a:chOff x="5974687" y="293525"/>
-            <a:chExt cx="1500000" cy="1500000"/>
+            <a:ext cx="3600" cy="3600"/>
           </a:xfrm>
-        </p:grpSpPr>
-        <p:sp>
-          <p:nvSpPr>
-            <p:cNvPr id="3" name="Freeform: Shape 2">
-              <a:extLst>
-                <a:ext uri="{FF2B5EF4-FFF2-40B4-BE49-F238E27FC236}">
-                  <a16:creationId xmlns:a16="http://schemas.microsoft.com/office/drawing/2014/main" id="{F2B7A7E0-C297-BA50-9403-962B567EC93F}"/>
-                </a:ext>
-              </a:extLst>
-            </p:cNvPr>
-            <p:cNvSpPr/>
-            <p:nvPr/>
-          </p:nvSpPr>
-          <p:spPr>
-            <a:xfrm rot="19319567">
-              <a:off x="6304634" y="675989"/>
-              <a:ext cx="627137" cy="900000"/>
-            </a:xfrm>
-            <a:custGeom>
-              <a:avLst/>
-              <a:gdLst>
-                <a:gd name="csX0" fmla="*/ 450000 w 645150"/>
-                <a:gd name="csY0" fmla="*/ 0 h 900000"/>
-                <a:gd name="csX1" fmla="*/ 625161 w 645150"/>
-                <a:gd name="csY1" fmla="*/ 35364 h 900000"/>
-                <a:gd name="csX2" fmla="*/ 645150 w 645150"/>
-                <a:gd name="csY2" fmla="*/ 46214 h 900000"/>
-                <a:gd name="csX3" fmla="*/ 588701 w 645150"/>
-                <a:gd name="csY3" fmla="*/ 76853 h 900000"/>
-                <a:gd name="csX4" fmla="*/ 390300 w 645150"/>
-                <a:gd name="csY4" fmla="*/ 450000 h 900000"/>
-                <a:gd name="csX5" fmla="*/ 588701 w 645150"/>
-                <a:gd name="csY5" fmla="*/ 823147 h 900000"/>
-                <a:gd name="csX6" fmla="*/ 645150 w 645150"/>
-                <a:gd name="csY6" fmla="*/ 853787 h 900000"/>
-                <a:gd name="csX7" fmla="*/ 625161 w 645150"/>
-                <a:gd name="csY7" fmla="*/ 864637 h 900000"/>
-                <a:gd name="csX8" fmla="*/ 450000 w 645150"/>
-                <a:gd name="csY8" fmla="*/ 900000 h 900000"/>
-                <a:gd name="csX9" fmla="*/ 0 w 645150"/>
-                <a:gd name="csY9" fmla="*/ 450000 h 900000"/>
-                <a:gd name="csX10" fmla="*/ 450000 w 645150"/>
-                <a:gd name="csY10" fmla="*/ 0 h 900000"/>
-                <a:gd name="csX0" fmla="*/ 450000 w 645150"/>
-                <a:gd name="csY0" fmla="*/ 0 h 900000"/>
-                <a:gd name="csX1" fmla="*/ 625161 w 645150"/>
-                <a:gd name="csY1" fmla="*/ 35364 h 900000"/>
-                <a:gd name="csX2" fmla="*/ 588701 w 645150"/>
-                <a:gd name="csY2" fmla="*/ 76853 h 900000"/>
-                <a:gd name="csX3" fmla="*/ 390300 w 645150"/>
-                <a:gd name="csY3" fmla="*/ 450000 h 900000"/>
-                <a:gd name="csX4" fmla="*/ 588701 w 645150"/>
-                <a:gd name="csY4" fmla="*/ 823147 h 900000"/>
-                <a:gd name="csX5" fmla="*/ 645150 w 645150"/>
-                <a:gd name="csY5" fmla="*/ 853787 h 900000"/>
-                <a:gd name="csX6" fmla="*/ 625161 w 645150"/>
-                <a:gd name="csY6" fmla="*/ 864637 h 900000"/>
-                <a:gd name="csX7" fmla="*/ 450000 w 645150"/>
-                <a:gd name="csY7" fmla="*/ 900000 h 900000"/>
-                <a:gd name="csX8" fmla="*/ 0 w 645150"/>
-                <a:gd name="csY8" fmla="*/ 450000 h 900000"/>
-                <a:gd name="csX9" fmla="*/ 450000 w 645150"/>
-                <a:gd name="csY9" fmla="*/ 0 h 900000"/>
-                <a:gd name="csX0" fmla="*/ 450000 w 625161"/>
-                <a:gd name="csY0" fmla="*/ 0 h 900000"/>
-                <a:gd name="csX1" fmla="*/ 625161 w 625161"/>
-                <a:gd name="csY1" fmla="*/ 35364 h 900000"/>
-                <a:gd name="csX2" fmla="*/ 588701 w 625161"/>
-                <a:gd name="csY2" fmla="*/ 76853 h 900000"/>
-                <a:gd name="csX3" fmla="*/ 390300 w 625161"/>
-                <a:gd name="csY3" fmla="*/ 450000 h 900000"/>
-                <a:gd name="csX4" fmla="*/ 588701 w 625161"/>
-                <a:gd name="csY4" fmla="*/ 823147 h 900000"/>
-                <a:gd name="csX5" fmla="*/ 625161 w 625161"/>
-                <a:gd name="csY5" fmla="*/ 864637 h 900000"/>
-                <a:gd name="csX6" fmla="*/ 450000 w 625161"/>
-                <a:gd name="csY6" fmla="*/ 900000 h 900000"/>
-                <a:gd name="csX7" fmla="*/ 0 w 625161"/>
-                <a:gd name="csY7" fmla="*/ 450000 h 900000"/>
-                <a:gd name="csX8" fmla="*/ 450000 w 625161"/>
-                <a:gd name="csY8" fmla="*/ 0 h 900000"/>
-                <a:gd name="csX0" fmla="*/ 450000 w 627137"/>
-                <a:gd name="csY0" fmla="*/ 0 h 900000"/>
-                <a:gd name="csX1" fmla="*/ 625161 w 627137"/>
-                <a:gd name="csY1" fmla="*/ 35364 h 900000"/>
-                <a:gd name="csX2" fmla="*/ 588701 w 627137"/>
-                <a:gd name="csY2" fmla="*/ 76853 h 900000"/>
-                <a:gd name="csX3" fmla="*/ 390300 w 627137"/>
-                <a:gd name="csY3" fmla="*/ 450000 h 900000"/>
-                <a:gd name="csX4" fmla="*/ 588701 w 627137"/>
-                <a:gd name="csY4" fmla="*/ 823147 h 900000"/>
-                <a:gd name="csX5" fmla="*/ 625161 w 627137"/>
-                <a:gd name="csY5" fmla="*/ 864637 h 900000"/>
-                <a:gd name="csX6" fmla="*/ 450000 w 627137"/>
-                <a:gd name="csY6" fmla="*/ 900000 h 900000"/>
-                <a:gd name="csX7" fmla="*/ 0 w 627137"/>
-                <a:gd name="csY7" fmla="*/ 450000 h 900000"/>
-                <a:gd name="csX8" fmla="*/ 450000 w 627137"/>
-                <a:gd name="csY8" fmla="*/ 0 h 900000"/>
-                <a:gd name="csX0" fmla="*/ 450000 w 627137"/>
-                <a:gd name="csY0" fmla="*/ 0 h 900000"/>
-                <a:gd name="csX1" fmla="*/ 625161 w 627137"/>
-                <a:gd name="csY1" fmla="*/ 35364 h 900000"/>
-                <a:gd name="csX2" fmla="*/ 588701 w 627137"/>
-                <a:gd name="csY2" fmla="*/ 76853 h 900000"/>
-                <a:gd name="csX3" fmla="*/ 390300 w 627137"/>
-                <a:gd name="csY3" fmla="*/ 450000 h 900000"/>
-                <a:gd name="csX4" fmla="*/ 588701 w 627137"/>
-                <a:gd name="csY4" fmla="*/ 823147 h 900000"/>
-                <a:gd name="csX5" fmla="*/ 625161 w 627137"/>
-                <a:gd name="csY5" fmla="*/ 864637 h 900000"/>
-                <a:gd name="csX6" fmla="*/ 450000 w 627137"/>
-                <a:gd name="csY6" fmla="*/ 900000 h 900000"/>
-                <a:gd name="csX7" fmla="*/ 0 w 627137"/>
-                <a:gd name="csY7" fmla="*/ 450000 h 900000"/>
-                <a:gd name="csX8" fmla="*/ 450000 w 627137"/>
-                <a:gd name="csY8" fmla="*/ 0 h 900000"/>
-              </a:gdLst>
-              <a:ahLst/>
-              <a:cxnLst>
-                <a:cxn ang="0">
-                  <a:pos x="csX0" y="csY0"/>
-                </a:cxn>
-                <a:cxn ang="0">
-                  <a:pos x="csX1" y="csY1"/>
-                </a:cxn>
-                <a:cxn ang="0">
-                  <a:pos x="csX2" y="csY2"/>
-                </a:cxn>
-                <a:cxn ang="0">
-                  <a:pos x="csX3" y="csY3"/>
-                </a:cxn>
-                <a:cxn ang="0">
-                  <a:pos x="csX4" y="csY4"/>
-                </a:cxn>
-                <a:cxn ang="0">
-                  <a:pos x="csX5" y="csY5"/>
-                </a:cxn>
-                <a:cxn ang="0">
-                  <a:pos x="csX6" y="csY6"/>
-                </a:cxn>
-                <a:cxn ang="0">
-                  <a:pos x="csX7" y="csY7"/>
-                </a:cxn>
-                <a:cxn ang="0">
-                  <a:pos x="csX8" y="csY8"/>
-                </a:cxn>
-              </a:cxnLst>
-              <a:rect l="l" t="t" r="r" b="b"/>
-              <a:pathLst>
-                <a:path w="627137" h="900000">
-                  <a:moveTo>
-                    <a:pt x="450000" y="0"/>
-                  </a:moveTo>
-                  <a:cubicBezTo>
-                    <a:pt x="512132" y="0"/>
-                    <a:pt x="571323" y="12592"/>
-                    <a:pt x="625161" y="35364"/>
-                  </a:cubicBezTo>
-                  <a:cubicBezTo>
-                    <a:pt x="635760" y="54886"/>
-                    <a:pt x="600854" y="63023"/>
-                    <a:pt x="588701" y="76853"/>
-                  </a:cubicBezTo>
-                  <a:cubicBezTo>
-                    <a:pt x="469000" y="157722"/>
-                    <a:pt x="390300" y="294670"/>
-                    <a:pt x="390300" y="450000"/>
-                  </a:cubicBezTo>
-                  <a:cubicBezTo>
-                    <a:pt x="390300" y="605330"/>
-                    <a:pt x="469000" y="742279"/>
-                    <a:pt x="588701" y="823147"/>
-                  </a:cubicBezTo>
-                  <a:cubicBezTo>
-                    <a:pt x="600854" y="836977"/>
-                    <a:pt x="630540" y="855442"/>
-                    <a:pt x="625161" y="864637"/>
-                  </a:cubicBezTo>
-                  <a:cubicBezTo>
-                    <a:pt x="571323" y="887408"/>
-                    <a:pt x="512132" y="900000"/>
-                    <a:pt x="450000" y="900000"/>
-                  </a:cubicBezTo>
-                  <a:cubicBezTo>
-                    <a:pt x="201472" y="900000"/>
-                    <a:pt x="0" y="698528"/>
-                    <a:pt x="0" y="450000"/>
-                  </a:cubicBezTo>
-                  <a:cubicBezTo>
-                    <a:pt x="0" y="201472"/>
-                    <a:pt x="201472" y="0"/>
-                    <a:pt x="450000" y="0"/>
-                  </a:cubicBezTo>
-                  <a:close/>
-                </a:path>
-              </a:pathLst>
-            </a:custGeom>
-            <a:solidFill>
-              <a:schemeClr val="tx1"/>
-            </a:solidFill>
-            <a:ln w="74613" cap="flat">
-              <a:noFill/>
-              <a:prstDash val="solid"/>
-              <a:miter/>
-            </a:ln>
-          </p:spPr>
-          <p:txBody>
-            <a:bodyPr wrap="square">
-              <a:noAutofit/>
-            </a:bodyPr>
-            <a:lstStyle/>
-            <a:p>
-              <a:endParaRPr lang="en-US"/>
-            </a:p>
-          </p:txBody>
-        </p:sp>
-        <p:sp>
-          <p:nvSpPr>
-            <p:cNvPr id="17" name="Oval 16">
-              <a:extLst>
-                <a:ext uri="{FF2B5EF4-FFF2-40B4-BE49-F238E27FC236}">
-                  <a16:creationId xmlns:a16="http://schemas.microsoft.com/office/drawing/2014/main" id="{5F4AF6DA-7D07-E738-4A9F-CEE710B947E8}"/>
-                </a:ext>
-              </a:extLst>
-            </p:cNvPr>
-            <p:cNvSpPr/>
-            <p:nvPr/>
-          </p:nvSpPr>
-          <p:spPr>
-            <a:xfrm>
-              <a:off x="5974687" y="1042325"/>
-              <a:ext cx="3600" cy="3600"/>
-            </a:xfrm>
-            <a:prstGeom prst="ellipse">
-              <a:avLst/>
-            </a:prstGeom>
-            <a:solidFill>
-              <a:schemeClr val="bg1">
-                <a:lumMod val="85000"/>
-              </a:schemeClr>
-            </a:solidFill>
-            <a:ln>
-              <a:noFill/>
-            </a:ln>
-          </p:spPr>
-          <p:style>
-            <a:lnRef idx="2">
-              <a:schemeClr val="accent1">
-                <a:shade val="15000"/>
-              </a:schemeClr>
-            </a:lnRef>
-            <a:fillRef idx="1">
-              <a:schemeClr val="accent1"/>
-            </a:fillRef>
-            <a:effectRef idx="0">
-              <a:schemeClr val="accent1"/>
-            </a:effectRef>
-            <a:fontRef idx="minor">
-              <a:schemeClr val="lt1"/>
-            </a:fontRef>
-          </p:style>
-          <p:txBody>
-            <a:bodyPr rtlCol="0" anchor="ctr"/>
-            <a:lstStyle/>
-            <a:p>
-              <a:pPr algn="ctr"/>
-              <a:endParaRPr lang="en-US"/>
-            </a:p>
-          </p:txBody>
-        </p:sp>
-        <p:sp>
-          <p:nvSpPr>
-            <p:cNvPr id="21" name="Oval 20">
-              <a:extLst>
-                <a:ext uri="{FF2B5EF4-FFF2-40B4-BE49-F238E27FC236}">
-                  <a16:creationId xmlns:a16="http://schemas.microsoft.com/office/drawing/2014/main" id="{4A06DBC8-DB99-B205-768A-6AA1573788CD}"/>
-                </a:ext>
-              </a:extLst>
-            </p:cNvPr>
-            <p:cNvSpPr/>
-            <p:nvPr/>
-          </p:nvSpPr>
-          <p:spPr>
-            <a:xfrm>
-              <a:off x="6722287" y="293525"/>
-              <a:ext cx="3600" cy="3600"/>
-            </a:xfrm>
-            <a:prstGeom prst="ellipse">
-              <a:avLst/>
-            </a:prstGeom>
-            <a:solidFill>
-              <a:schemeClr val="bg1">
-                <a:lumMod val="85000"/>
-              </a:schemeClr>
-            </a:solidFill>
-            <a:ln>
-              <a:noFill/>
-            </a:ln>
-          </p:spPr>
-          <p:style>
-            <a:lnRef idx="2">
-              <a:schemeClr val="accent1">
-                <a:shade val="15000"/>
-              </a:schemeClr>
-            </a:lnRef>
-            <a:fillRef idx="1">
-              <a:schemeClr val="accent1"/>
-            </a:fillRef>
-            <a:effectRef idx="0">
-              <a:schemeClr val="accent1"/>
-            </a:effectRef>
-            <a:fontRef idx="minor">
-              <a:schemeClr val="lt1"/>
-            </a:fontRef>
-          </p:style>
-          <p:txBody>
-            <a:bodyPr rtlCol="0" anchor="ctr"/>
-            <a:lstStyle/>
-            <a:p>
-              <a:pPr algn="ctr"/>
-              <a:endParaRPr lang="en-US"/>
-            </a:p>
-          </p:txBody>
-        </p:sp>
-        <p:sp>
-          <p:nvSpPr>
-            <p:cNvPr id="31" name="Oval 30">
-              <a:extLst>
-                <a:ext uri="{FF2B5EF4-FFF2-40B4-BE49-F238E27FC236}">
-                  <a16:creationId xmlns:a16="http://schemas.microsoft.com/office/drawing/2014/main" id="{52B824D2-7DE3-E2C3-50F3-E6B764B52C3F}"/>
-                </a:ext>
-              </a:extLst>
-            </p:cNvPr>
-            <p:cNvSpPr/>
-            <p:nvPr/>
-          </p:nvSpPr>
-          <p:spPr>
-            <a:xfrm>
-              <a:off x="7471087" y="1042325"/>
-              <a:ext cx="3600" cy="3600"/>
-            </a:xfrm>
-            <a:prstGeom prst="ellipse">
-              <a:avLst/>
-            </a:prstGeom>
-            <a:solidFill>
-              <a:schemeClr val="bg1">
-                <a:lumMod val="85000"/>
-              </a:schemeClr>
-            </a:solidFill>
-            <a:ln>
-              <a:noFill/>
-            </a:ln>
-          </p:spPr>
-          <p:style>
-            <a:lnRef idx="2">
-              <a:schemeClr val="accent1">
-                <a:shade val="15000"/>
-              </a:schemeClr>
-            </a:lnRef>
-            <a:fillRef idx="1">
-              <a:schemeClr val="accent1"/>
-            </a:fillRef>
-            <a:effectRef idx="0">
-              <a:schemeClr val="accent1"/>
-            </a:effectRef>
-            <a:fontRef idx="minor">
-              <a:schemeClr val="lt1"/>
-            </a:fontRef>
-          </p:style>
-          <p:txBody>
-            <a:bodyPr rtlCol="0" anchor="ctr"/>
-            <a:lstStyle/>
-            <a:p>
-              <a:pPr algn="ctr"/>
-              <a:endParaRPr lang="en-US"/>
-            </a:p>
-          </p:txBody>
-        </p:sp>
-        <p:sp>
-          <p:nvSpPr>
-            <p:cNvPr id="33" name="Oval 32">
-              <a:extLst>
-                <a:ext uri="{FF2B5EF4-FFF2-40B4-BE49-F238E27FC236}">
-                  <a16:creationId xmlns:a16="http://schemas.microsoft.com/office/drawing/2014/main" id="{7EC5F638-C6A8-4AA9-1D86-D3C9D9E22C93}"/>
-                </a:ext>
-              </a:extLst>
-            </p:cNvPr>
-            <p:cNvSpPr/>
-            <p:nvPr/>
-          </p:nvSpPr>
-          <p:spPr>
-            <a:xfrm>
-              <a:off x="6723487" y="1789925"/>
-              <a:ext cx="3600" cy="3600"/>
-            </a:xfrm>
-            <a:prstGeom prst="ellipse">
-              <a:avLst/>
-            </a:prstGeom>
-            <a:solidFill>
-              <a:schemeClr val="bg1">
-                <a:lumMod val="85000"/>
-              </a:schemeClr>
-            </a:solidFill>
-            <a:ln>
-              <a:noFill/>
-            </a:ln>
-          </p:spPr>
-          <p:style>
-            <a:lnRef idx="2">
-              <a:schemeClr val="accent1">
-                <a:shade val="15000"/>
-              </a:schemeClr>
-            </a:lnRef>
-            <a:fillRef idx="1">
-              <a:schemeClr val="accent1"/>
-            </a:fillRef>
-            <a:effectRef idx="0">
-              <a:schemeClr val="accent1"/>
-            </a:effectRef>
-            <a:fontRef idx="minor">
-              <a:schemeClr val="lt1"/>
-            </a:fontRef>
-          </p:style>
-          <p:txBody>
-            <a:bodyPr rtlCol="0" anchor="ctr"/>
-            <a:lstStyle/>
-            <a:p>
-              <a:pPr algn="ctr"/>
-              <a:endParaRPr lang="en-US"/>
-            </a:p>
-          </p:txBody>
-        </p:sp>
-      </p:grpSp>
+          <a:prstGeom prst="ellipse">
+            <a:avLst/>
+          </a:prstGeom>
+          <a:solidFill>
+            <a:schemeClr val="bg1">
+              <a:lumMod val="85000"/>
+            </a:schemeClr>
+          </a:solidFill>
+          <a:ln>
+            <a:noFill/>
+          </a:ln>
+        </p:spPr>
+        <p:style>
+          <a:lnRef idx="2">
+            <a:schemeClr val="accent1">
+              <a:shade val="15000"/>
+            </a:schemeClr>
+          </a:lnRef>
+          <a:fillRef idx="1">
+            <a:schemeClr val="accent1"/>
+          </a:fillRef>
+          <a:effectRef idx="0">
+            <a:schemeClr val="accent1"/>
+          </a:effectRef>
+          <a:fontRef idx="minor">
+            <a:schemeClr val="lt1"/>
+          </a:fontRef>
+        </p:style>
+        <p:txBody>
+          <a:bodyPr rtlCol="0" anchor="ctr"/>
+          <a:lstStyle/>
+          <a:p>
+            <a:pPr algn="ctr"/>
+            <a:endParaRPr lang="en-US"/>
+          </a:p>
+        </p:txBody>
+      </p:sp>
+      <p:sp>
+        <p:nvSpPr>
+          <p:cNvPr id="31" name="Oval 30">
+            <a:extLst>
+              <a:ext uri="{FF2B5EF4-FFF2-40B4-BE49-F238E27FC236}">
+                <a16:creationId xmlns:a16="http://schemas.microsoft.com/office/drawing/2014/main" id="{52B824D2-7DE3-E2C3-50F3-E6B764B52C3F}"/>
+              </a:ext>
+            </a:extLst>
+          </p:cNvPr>
+          <p:cNvSpPr/>
+          <p:nvPr/>
+        </p:nvSpPr>
+        <p:spPr>
+          <a:xfrm>
+            <a:off x="7471087" y="1789925"/>
+            <a:ext cx="3600" cy="3600"/>
+          </a:xfrm>
+          <a:prstGeom prst="ellipse">
+            <a:avLst/>
+          </a:prstGeom>
+          <a:solidFill>
+            <a:schemeClr val="bg1">
+              <a:lumMod val="85000"/>
+            </a:schemeClr>
+          </a:solidFill>
+          <a:ln>
+            <a:noFill/>
+          </a:ln>
+        </p:spPr>
+        <p:style>
+          <a:lnRef idx="2">
+            <a:schemeClr val="accent1">
+              <a:shade val="15000"/>
+            </a:schemeClr>
+          </a:lnRef>
+          <a:fillRef idx="1">
+            <a:schemeClr val="accent1"/>
+          </a:fillRef>
+          <a:effectRef idx="0">
+            <a:schemeClr val="accent1"/>
+          </a:effectRef>
+          <a:fontRef idx="minor">
+            <a:schemeClr val="lt1"/>
+          </a:fontRef>
+        </p:style>
+        <p:txBody>
+          <a:bodyPr rtlCol="0" anchor="ctr"/>
+          <a:lstStyle/>
+          <a:p>
+            <a:pPr algn="ctr"/>
+            <a:endParaRPr lang="en-US"/>
+          </a:p>
+        </p:txBody>
+      </p:sp>
     </p:spTree>
     <p:extLst>
       <p:ext uri="{BB962C8B-B14F-4D97-AF65-F5344CB8AC3E}">

</xml_diff>

<commit_message>
Update icons and user settings
- Updated Icons_UI.pptx with new icon assets.
- Modified sprites-ui.svg to include new 'recap' and 'redo' symbols.
- Changed userSettings.json to update timeContainer value from "2" to "4".
- Added recap.svg to UI_Toolbar with the specified SVG content.
</commit_message>
<xml_diff>
--- a/Icons_UI/Icons_UI.pptx
+++ b/Icons_UI/Icons_UI.pptx
@@ -9,6 +9,8 @@
     <p:sldId id="257" r:id="rId3"/>
     <p:sldId id="256" r:id="rId4"/>
     <p:sldId id="259" r:id="rId5"/>
+    <p:sldId id="260" r:id="rId6"/>
+    <p:sldId id="261" r:id="rId7"/>
   </p:sldIdLst>
   <p:sldSz cx="12192000" cy="6858000"/>
   <p:notesSz cx="6858000" cy="9144000"/>
@@ -26060,6 +26062,3856 @@
 </p:sld>
 </file>
 
+<file path=ppt/slides/slide5.xml><?xml version="1.0" encoding="utf-8"?>
+<p:sld xmlns:a="http://schemas.openxmlformats.org/drawingml/2006/main" xmlns:r="http://schemas.openxmlformats.org/officeDocument/2006/relationships" xmlns:p="http://schemas.openxmlformats.org/presentationml/2006/main">
+  <p:cSld>
+    <p:spTree>
+      <p:nvGrpSpPr>
+        <p:cNvPr id="1" name=""/>
+        <p:cNvGrpSpPr/>
+        <p:nvPr/>
+      </p:nvGrpSpPr>
+      <p:grpSpPr>
+        <a:xfrm>
+          <a:off x="0" y="0"/>
+          <a:ext cx="0" cy="0"/>
+          <a:chOff x="0" y="0"/>
+          <a:chExt cx="0" cy="0"/>
+        </a:xfrm>
+      </p:grpSpPr>
+    </p:spTree>
+    <p:extLst>
+      <p:ext uri="{BB962C8B-B14F-4D97-AF65-F5344CB8AC3E}">
+        <p14:creationId xmlns:p14="http://schemas.microsoft.com/office/powerpoint/2010/main" val="628180008"/>
+      </p:ext>
+    </p:extLst>
+  </p:cSld>
+  <p:clrMapOvr>
+    <a:masterClrMapping/>
+  </p:clrMapOvr>
+</p:sld>
+</file>
+
+<file path=ppt/slides/slide6.xml><?xml version="1.0" encoding="utf-8"?>
+<p:sld xmlns:a="http://schemas.openxmlformats.org/drawingml/2006/main" xmlns:r="http://schemas.openxmlformats.org/officeDocument/2006/relationships" xmlns:p="http://schemas.openxmlformats.org/presentationml/2006/main">
+  <p:cSld>
+    <p:spTree>
+      <p:nvGrpSpPr>
+        <p:cNvPr id="1" name="">
+          <a:extLst>
+            <a:ext uri="{FF2B5EF4-FFF2-40B4-BE49-F238E27FC236}">
+              <a16:creationId xmlns:a16="http://schemas.microsoft.com/office/drawing/2014/main" id="{2BD9461E-2929-F0E0-9A9A-C64B19510092}"/>
+            </a:ext>
+          </a:extLst>
+        </p:cNvPr>
+        <p:cNvGrpSpPr/>
+        <p:nvPr/>
+      </p:nvGrpSpPr>
+      <p:grpSpPr>
+        <a:xfrm>
+          <a:off x="0" y="0"/>
+          <a:ext cx="0" cy="0"/>
+          <a:chOff x="0" y="0"/>
+          <a:chExt cx="0" cy="0"/>
+        </a:xfrm>
+      </p:grpSpPr>
+      <p:grpSp>
+        <p:nvGrpSpPr>
+          <p:cNvPr id="12" name="Group 11">
+            <a:extLst>
+              <a:ext uri="{FF2B5EF4-FFF2-40B4-BE49-F238E27FC236}">
+                <a16:creationId xmlns:a16="http://schemas.microsoft.com/office/drawing/2014/main" id="{CAC00753-113C-F4B2-ED45-47CEF096D495}"/>
+              </a:ext>
+            </a:extLst>
+          </p:cNvPr>
+          <p:cNvGrpSpPr/>
+          <p:nvPr/>
+        </p:nvGrpSpPr>
+        <p:grpSpPr>
+          <a:xfrm>
+            <a:off x="320040" y="2292972"/>
+            <a:ext cx="11871960" cy="1501200"/>
+            <a:chOff x="1644242" y="6040073"/>
+            <a:chExt cx="7684316" cy="562063"/>
+          </a:xfrm>
+        </p:grpSpPr>
+        <p:cxnSp>
+          <p:nvCxnSpPr>
+            <p:cNvPr id="10" name="Straight Connector 9">
+              <a:extLst>
+                <a:ext uri="{FF2B5EF4-FFF2-40B4-BE49-F238E27FC236}">
+                  <a16:creationId xmlns:a16="http://schemas.microsoft.com/office/drawing/2014/main" id="{E34B6E2B-930C-BFFA-DD7B-980FC90E76AC}"/>
+                </a:ext>
+              </a:extLst>
+            </p:cNvPr>
+            <p:cNvCxnSpPr/>
+            <p:nvPr/>
+          </p:nvCxnSpPr>
+          <p:spPr>
+            <a:xfrm>
+              <a:off x="1644242" y="6040073"/>
+              <a:ext cx="7684316" cy="0"/>
+            </a:xfrm>
+            <a:prstGeom prst="line">
+              <a:avLst/>
+            </a:prstGeom>
+          </p:spPr>
+          <p:style>
+            <a:lnRef idx="1">
+              <a:schemeClr val="accent1"/>
+            </a:lnRef>
+            <a:fillRef idx="0">
+              <a:schemeClr val="accent1"/>
+            </a:fillRef>
+            <a:effectRef idx="0">
+              <a:schemeClr val="accent1"/>
+            </a:effectRef>
+            <a:fontRef idx="minor">
+              <a:schemeClr val="tx1"/>
+            </a:fontRef>
+          </p:style>
+        </p:cxnSp>
+        <p:cxnSp>
+          <p:nvCxnSpPr>
+            <p:cNvPr id="11" name="Straight Connector 10">
+              <a:extLst>
+                <a:ext uri="{FF2B5EF4-FFF2-40B4-BE49-F238E27FC236}">
+                  <a16:creationId xmlns:a16="http://schemas.microsoft.com/office/drawing/2014/main" id="{C3217390-DEF4-2509-2D15-1F1A1DC1C622}"/>
+                </a:ext>
+              </a:extLst>
+            </p:cNvPr>
+            <p:cNvCxnSpPr/>
+            <p:nvPr/>
+          </p:nvCxnSpPr>
+          <p:spPr>
+            <a:xfrm>
+              <a:off x="1644242" y="6602136"/>
+              <a:ext cx="7684316" cy="0"/>
+            </a:xfrm>
+            <a:prstGeom prst="line">
+              <a:avLst/>
+            </a:prstGeom>
+          </p:spPr>
+          <p:style>
+            <a:lnRef idx="1">
+              <a:schemeClr val="accent1"/>
+            </a:lnRef>
+            <a:fillRef idx="0">
+              <a:schemeClr val="accent1"/>
+            </a:fillRef>
+            <a:effectRef idx="0">
+              <a:schemeClr val="accent1"/>
+            </a:effectRef>
+            <a:fontRef idx="minor">
+              <a:schemeClr val="tx1"/>
+            </a:fontRef>
+          </p:style>
+        </p:cxnSp>
+      </p:grpSp>
+      <p:grpSp>
+        <p:nvGrpSpPr>
+          <p:cNvPr id="143" name="Group 142">
+            <a:extLst>
+              <a:ext uri="{FF2B5EF4-FFF2-40B4-BE49-F238E27FC236}">
+                <a16:creationId xmlns:a16="http://schemas.microsoft.com/office/drawing/2014/main" id="{BCE097D1-9A27-9DBD-691C-02A1221F5784}"/>
+              </a:ext>
+            </a:extLst>
+          </p:cNvPr>
+          <p:cNvGrpSpPr/>
+          <p:nvPr/>
+        </p:nvGrpSpPr>
+        <p:grpSpPr>
+          <a:xfrm flipV="1">
+            <a:off x="320040" y="4211901"/>
+            <a:ext cx="11871960" cy="1501200"/>
+            <a:chOff x="1644242" y="6040073"/>
+            <a:chExt cx="7684316" cy="562063"/>
+          </a:xfrm>
+        </p:grpSpPr>
+        <p:cxnSp>
+          <p:nvCxnSpPr>
+            <p:cNvPr id="144" name="Straight Connector 143">
+              <a:extLst>
+                <a:ext uri="{FF2B5EF4-FFF2-40B4-BE49-F238E27FC236}">
+                  <a16:creationId xmlns:a16="http://schemas.microsoft.com/office/drawing/2014/main" id="{FB86424E-09E6-9480-D056-7D4801914F94}"/>
+                </a:ext>
+              </a:extLst>
+            </p:cNvPr>
+            <p:cNvCxnSpPr/>
+            <p:nvPr/>
+          </p:nvCxnSpPr>
+          <p:spPr>
+            <a:xfrm>
+              <a:off x="1644242" y="6040073"/>
+              <a:ext cx="7684316" cy="0"/>
+            </a:xfrm>
+            <a:prstGeom prst="line">
+              <a:avLst/>
+            </a:prstGeom>
+          </p:spPr>
+          <p:style>
+            <a:lnRef idx="1">
+              <a:schemeClr val="accent1"/>
+            </a:lnRef>
+            <a:fillRef idx="0">
+              <a:schemeClr val="accent1"/>
+            </a:fillRef>
+            <a:effectRef idx="0">
+              <a:schemeClr val="accent1"/>
+            </a:effectRef>
+            <a:fontRef idx="minor">
+              <a:schemeClr val="tx1"/>
+            </a:fontRef>
+          </p:style>
+        </p:cxnSp>
+        <p:cxnSp>
+          <p:nvCxnSpPr>
+            <p:cNvPr id="145" name="Straight Connector 144">
+              <a:extLst>
+                <a:ext uri="{FF2B5EF4-FFF2-40B4-BE49-F238E27FC236}">
+                  <a16:creationId xmlns:a16="http://schemas.microsoft.com/office/drawing/2014/main" id="{DEF670F8-E3EB-A435-69A3-6C35EA2BF1E0}"/>
+                </a:ext>
+              </a:extLst>
+            </p:cNvPr>
+            <p:cNvCxnSpPr/>
+            <p:nvPr/>
+          </p:nvCxnSpPr>
+          <p:spPr>
+            <a:xfrm>
+              <a:off x="1644242" y="6602136"/>
+              <a:ext cx="7684316" cy="0"/>
+            </a:xfrm>
+            <a:prstGeom prst="line">
+              <a:avLst/>
+            </a:prstGeom>
+          </p:spPr>
+          <p:style>
+            <a:lnRef idx="1">
+              <a:schemeClr val="accent1"/>
+            </a:lnRef>
+            <a:fillRef idx="0">
+              <a:schemeClr val="accent1"/>
+            </a:fillRef>
+            <a:effectRef idx="0">
+              <a:schemeClr val="accent1"/>
+            </a:effectRef>
+            <a:fontRef idx="minor">
+              <a:schemeClr val="tx1"/>
+            </a:fontRef>
+          </p:style>
+        </p:cxnSp>
+      </p:grpSp>
+      <p:grpSp>
+        <p:nvGrpSpPr>
+          <p:cNvPr id="8" name="Group 7">
+            <a:extLst>
+              <a:ext uri="{FF2B5EF4-FFF2-40B4-BE49-F238E27FC236}">
+                <a16:creationId xmlns:a16="http://schemas.microsoft.com/office/drawing/2014/main" id="{CB20A9D2-09F8-1826-5EC1-CEFA68B2F4C8}"/>
+              </a:ext>
+            </a:extLst>
+          </p:cNvPr>
+          <p:cNvGrpSpPr/>
+          <p:nvPr/>
+        </p:nvGrpSpPr>
+        <p:grpSpPr>
+          <a:xfrm>
+            <a:off x="649852" y="2292971"/>
+            <a:ext cx="2962440" cy="1501199"/>
+            <a:chOff x="5643562" y="3199729"/>
+            <a:chExt cx="904875" cy="458540"/>
+          </a:xfrm>
+        </p:grpSpPr>
+        <p:sp>
+          <p:nvSpPr>
+            <p:cNvPr id="5" name="Freeform: Shape 4">
+              <a:extLst>
+                <a:ext uri="{FF2B5EF4-FFF2-40B4-BE49-F238E27FC236}">
+                  <a16:creationId xmlns:a16="http://schemas.microsoft.com/office/drawing/2014/main" id="{8FB3DCA9-97C1-7B67-DF7E-7FFB662B2E59}"/>
+                </a:ext>
+              </a:extLst>
+            </p:cNvPr>
+            <p:cNvSpPr/>
+            <p:nvPr/>
+          </p:nvSpPr>
+          <p:spPr>
+            <a:xfrm>
+              <a:off x="6089930" y="3199746"/>
+              <a:ext cx="458507" cy="458507"/>
+            </a:xfrm>
+            <a:custGeom>
+              <a:avLst/>
+              <a:gdLst>
+                <a:gd name="csX0" fmla="*/ 452360 w 458507"/>
+                <a:gd name="csY0" fmla="*/ 244118 h 458507"/>
+                <a:gd name="csX1" fmla="*/ 244118 w 458507"/>
+                <a:gd name="csY1" fmla="*/ 452360 h 458507"/>
+                <a:gd name="csX2" fmla="*/ 214389 w 458507"/>
+                <a:gd name="csY2" fmla="*/ 452360 h 458507"/>
+                <a:gd name="csX3" fmla="*/ 6148 w 458507"/>
+                <a:gd name="csY3" fmla="*/ 244118 h 458507"/>
+                <a:gd name="csX4" fmla="*/ 6148 w 458507"/>
+                <a:gd name="csY4" fmla="*/ 214389 h 458507"/>
+                <a:gd name="csX5" fmla="*/ 214389 w 458507"/>
+                <a:gd name="csY5" fmla="*/ 6147 h 458507"/>
+                <a:gd name="csX6" fmla="*/ 244118 w 458507"/>
+                <a:gd name="csY6" fmla="*/ 6147 h 458507"/>
+                <a:gd name="csX7" fmla="*/ 452360 w 458507"/>
+                <a:gd name="csY7" fmla="*/ 214389 h 458507"/>
+                <a:gd name="csX8" fmla="*/ 452360 w 458507"/>
+                <a:gd name="csY8" fmla="*/ 244118 h 458507"/>
+              </a:gdLst>
+              <a:ahLst/>
+              <a:cxnLst>
+                <a:cxn ang="0">
+                  <a:pos x="csX0" y="csY0"/>
+                </a:cxn>
+                <a:cxn ang="0">
+                  <a:pos x="csX1" y="csY1"/>
+                </a:cxn>
+                <a:cxn ang="0">
+                  <a:pos x="csX2" y="csY2"/>
+                </a:cxn>
+                <a:cxn ang="0">
+                  <a:pos x="csX3" y="csY3"/>
+                </a:cxn>
+                <a:cxn ang="0">
+                  <a:pos x="csX4" y="csY4"/>
+                </a:cxn>
+                <a:cxn ang="0">
+                  <a:pos x="csX5" y="csY5"/>
+                </a:cxn>
+                <a:cxn ang="0">
+                  <a:pos x="csX6" y="csY6"/>
+                </a:cxn>
+                <a:cxn ang="0">
+                  <a:pos x="csX7" y="csY7"/>
+                </a:cxn>
+                <a:cxn ang="0">
+                  <a:pos x="csX8" y="csY8"/>
+                </a:cxn>
+              </a:cxnLst>
+              <a:rect l="l" t="t" r="r" b="b"/>
+              <a:pathLst>
+                <a:path w="458507" h="458507">
+                  <a:moveTo>
+                    <a:pt x="452360" y="244118"/>
+                  </a:moveTo>
+                  <a:lnTo>
+                    <a:pt x="244118" y="452360"/>
+                  </a:lnTo>
+                  <a:cubicBezTo>
+                    <a:pt x="235922" y="460556"/>
+                    <a:pt x="222586" y="460556"/>
+                    <a:pt x="214389" y="452360"/>
+                  </a:cubicBezTo>
+                  <a:lnTo>
+                    <a:pt x="6148" y="244118"/>
+                  </a:lnTo>
+                  <a:cubicBezTo>
+                    <a:pt x="-2049" y="235922"/>
+                    <a:pt x="-2049" y="222586"/>
+                    <a:pt x="6148" y="214389"/>
+                  </a:cubicBezTo>
+                  <a:lnTo>
+                    <a:pt x="214389" y="6147"/>
+                  </a:lnTo>
+                  <a:cubicBezTo>
+                    <a:pt x="222586" y="-2049"/>
+                    <a:pt x="235922" y="-2049"/>
+                    <a:pt x="244118" y="6147"/>
+                  </a:cubicBezTo>
+                  <a:lnTo>
+                    <a:pt x="452360" y="214389"/>
+                  </a:lnTo>
+                  <a:cubicBezTo>
+                    <a:pt x="460556" y="222586"/>
+                    <a:pt x="460556" y="235922"/>
+                    <a:pt x="452360" y="244118"/>
+                  </a:cubicBezTo>
+                  <a:close/>
+                </a:path>
+              </a:pathLst>
+            </a:custGeom>
+            <a:solidFill>
+              <a:srgbClr val="000000"/>
+            </a:solidFill>
+            <a:ln w="9525" cap="flat">
+              <a:noFill/>
+              <a:prstDash val="solid"/>
+              <a:miter/>
+            </a:ln>
+          </p:spPr>
+          <p:txBody>
+            <a:bodyPr/>
+            <a:lstStyle/>
+            <a:p>
+              <a:endParaRPr lang="en-US"/>
+            </a:p>
+          </p:txBody>
+        </p:sp>
+        <p:sp>
+          <p:nvSpPr>
+            <p:cNvPr id="6" name="Freeform: Shape 5">
+              <a:extLst>
+                <a:ext uri="{FF2B5EF4-FFF2-40B4-BE49-F238E27FC236}">
+                  <a16:creationId xmlns:a16="http://schemas.microsoft.com/office/drawing/2014/main" id="{B5FF091A-D82C-3031-4129-2EDB41B66220}"/>
+                </a:ext>
+              </a:extLst>
+            </p:cNvPr>
+            <p:cNvSpPr/>
+            <p:nvPr/>
+          </p:nvSpPr>
+          <p:spPr>
+            <a:xfrm>
+              <a:off x="5866787" y="3199729"/>
+              <a:ext cx="318581" cy="458540"/>
+            </a:xfrm>
+            <a:custGeom>
+              <a:avLst/>
+              <a:gdLst>
+                <a:gd name="csX0" fmla="*/ 184669 w 318581"/>
+                <a:gd name="csY0" fmla="*/ 244098 h 458540"/>
+                <a:gd name="csX1" fmla="*/ 318581 w 318581"/>
+                <a:gd name="csY1" fmla="*/ 378010 h 458540"/>
+                <a:gd name="csX2" fmla="*/ 244098 w 318581"/>
+                <a:gd name="csY2" fmla="*/ 452381 h 458540"/>
+                <a:gd name="csX3" fmla="*/ 214327 w 318581"/>
+                <a:gd name="csY3" fmla="*/ 452381 h 458540"/>
+                <a:gd name="csX4" fmla="*/ 6159 w 318581"/>
+                <a:gd name="csY4" fmla="*/ 244098 h 458540"/>
+                <a:gd name="csX5" fmla="*/ 6159 w 318581"/>
+                <a:gd name="csY5" fmla="*/ 214442 h 458540"/>
+                <a:gd name="csX6" fmla="*/ 214327 w 318581"/>
+                <a:gd name="csY6" fmla="*/ 6160 h 458540"/>
+                <a:gd name="csX7" fmla="*/ 244098 w 318581"/>
+                <a:gd name="csY7" fmla="*/ 6160 h 458540"/>
+                <a:gd name="csX8" fmla="*/ 318581 w 318581"/>
+                <a:gd name="csY8" fmla="*/ 80644 h 458540"/>
+                <a:gd name="csX9" fmla="*/ 184669 w 318581"/>
+                <a:gd name="csY9" fmla="*/ 214442 h 458540"/>
+                <a:gd name="csX10" fmla="*/ 184669 w 318581"/>
+                <a:gd name="csY10" fmla="*/ 244098 h 458540"/>
+              </a:gdLst>
+              <a:ahLst/>
+              <a:cxnLst>
+                <a:cxn ang="0">
+                  <a:pos x="csX0" y="csY0"/>
+                </a:cxn>
+                <a:cxn ang="0">
+                  <a:pos x="csX1" y="csY1"/>
+                </a:cxn>
+                <a:cxn ang="0">
+                  <a:pos x="csX2" y="csY2"/>
+                </a:cxn>
+                <a:cxn ang="0">
+                  <a:pos x="csX3" y="csY3"/>
+                </a:cxn>
+                <a:cxn ang="0">
+                  <a:pos x="csX4" y="csY4"/>
+                </a:cxn>
+                <a:cxn ang="0">
+                  <a:pos x="csX5" y="csY5"/>
+                </a:cxn>
+                <a:cxn ang="0">
+                  <a:pos x="csX6" y="csY6"/>
+                </a:cxn>
+                <a:cxn ang="0">
+                  <a:pos x="csX7" y="csY7"/>
+                </a:cxn>
+                <a:cxn ang="0">
+                  <a:pos x="csX8" y="csY8"/>
+                </a:cxn>
+                <a:cxn ang="0">
+                  <a:pos x="csX9" y="csY9"/>
+                </a:cxn>
+                <a:cxn ang="0">
+                  <a:pos x="csX10" y="csY10"/>
+                </a:cxn>
+              </a:cxnLst>
+              <a:rect l="l" t="t" r="r" b="b"/>
+              <a:pathLst>
+                <a:path w="318581" h="458540">
+                  <a:moveTo>
+                    <a:pt x="184669" y="244098"/>
+                  </a:moveTo>
+                  <a:lnTo>
+                    <a:pt x="318581" y="378010"/>
+                  </a:lnTo>
+                  <a:lnTo>
+                    <a:pt x="244098" y="452381"/>
+                  </a:lnTo>
+                  <a:cubicBezTo>
+                    <a:pt x="235884" y="460594"/>
+                    <a:pt x="222540" y="460594"/>
+                    <a:pt x="214327" y="452381"/>
+                  </a:cubicBezTo>
+                  <a:lnTo>
+                    <a:pt x="6159" y="244098"/>
+                  </a:lnTo>
+                  <a:cubicBezTo>
+                    <a:pt x="-2053" y="235886"/>
+                    <a:pt x="-2053" y="222654"/>
+                    <a:pt x="6159" y="214442"/>
+                  </a:cubicBezTo>
+                  <a:lnTo>
+                    <a:pt x="214327" y="6160"/>
+                  </a:lnTo>
+                  <a:cubicBezTo>
+                    <a:pt x="222540" y="-2053"/>
+                    <a:pt x="235884" y="-2053"/>
+                    <a:pt x="244098" y="6160"/>
+                  </a:cubicBezTo>
+                  <a:lnTo>
+                    <a:pt x="318581" y="80644"/>
+                  </a:lnTo>
+                  <a:lnTo>
+                    <a:pt x="184669" y="214442"/>
+                  </a:lnTo>
+                  <a:cubicBezTo>
+                    <a:pt x="176457" y="222654"/>
+                    <a:pt x="176457" y="235886"/>
+                    <a:pt x="184669" y="244098"/>
+                  </a:cubicBezTo>
+                  <a:close/>
+                </a:path>
+              </a:pathLst>
+            </a:custGeom>
+            <a:solidFill>
+              <a:srgbClr val="000000"/>
+            </a:solidFill>
+            <a:ln w="9525" cap="flat">
+              <a:noFill/>
+              <a:prstDash val="solid"/>
+              <a:miter/>
+            </a:ln>
+          </p:spPr>
+          <p:txBody>
+            <a:bodyPr/>
+            <a:lstStyle/>
+            <a:p>
+              <a:endParaRPr lang="en-US"/>
+            </a:p>
+          </p:txBody>
+        </p:sp>
+        <p:sp>
+          <p:nvSpPr>
+            <p:cNvPr id="7" name="Freeform: Shape 6">
+              <a:extLst>
+                <a:ext uri="{FF2B5EF4-FFF2-40B4-BE49-F238E27FC236}">
+                  <a16:creationId xmlns:a16="http://schemas.microsoft.com/office/drawing/2014/main" id="{69122843-D9E5-C879-0C5E-0067314F1FE0}"/>
+                </a:ext>
+              </a:extLst>
+            </p:cNvPr>
+            <p:cNvSpPr/>
+            <p:nvPr/>
+          </p:nvSpPr>
+          <p:spPr>
+            <a:xfrm>
+              <a:off x="5643562" y="3199729"/>
+              <a:ext cx="318582" cy="458540"/>
+            </a:xfrm>
+            <a:custGeom>
+              <a:avLst/>
+              <a:gdLst>
+                <a:gd name="csX0" fmla="*/ 184671 w 318582"/>
+                <a:gd name="csY0" fmla="*/ 244098 h 458540"/>
+                <a:gd name="csX1" fmla="*/ 318582 w 318582"/>
+                <a:gd name="csY1" fmla="*/ 378010 h 458540"/>
+                <a:gd name="csX2" fmla="*/ 244099 w 318582"/>
+                <a:gd name="csY2" fmla="*/ 452381 h 458540"/>
+                <a:gd name="csX3" fmla="*/ 214441 w 318582"/>
+                <a:gd name="csY3" fmla="*/ 452381 h 458540"/>
+                <a:gd name="csX4" fmla="*/ 6159 w 318582"/>
+                <a:gd name="csY4" fmla="*/ 244098 h 458540"/>
+                <a:gd name="csX5" fmla="*/ 6159 w 318582"/>
+                <a:gd name="csY5" fmla="*/ 214442 h 458540"/>
+                <a:gd name="csX6" fmla="*/ 214441 w 318582"/>
+                <a:gd name="csY6" fmla="*/ 6160 h 458540"/>
+                <a:gd name="csX7" fmla="*/ 244099 w 318582"/>
+                <a:gd name="csY7" fmla="*/ 6160 h 458540"/>
+                <a:gd name="csX8" fmla="*/ 318582 w 318582"/>
+                <a:gd name="csY8" fmla="*/ 80644 h 458540"/>
+                <a:gd name="csX9" fmla="*/ 184671 w 318582"/>
+                <a:gd name="csY9" fmla="*/ 214442 h 458540"/>
+                <a:gd name="csX10" fmla="*/ 184671 w 318582"/>
+                <a:gd name="csY10" fmla="*/ 244098 h 458540"/>
+              </a:gdLst>
+              <a:ahLst/>
+              <a:cxnLst>
+                <a:cxn ang="0">
+                  <a:pos x="csX0" y="csY0"/>
+                </a:cxn>
+                <a:cxn ang="0">
+                  <a:pos x="csX1" y="csY1"/>
+                </a:cxn>
+                <a:cxn ang="0">
+                  <a:pos x="csX2" y="csY2"/>
+                </a:cxn>
+                <a:cxn ang="0">
+                  <a:pos x="csX3" y="csY3"/>
+                </a:cxn>
+                <a:cxn ang="0">
+                  <a:pos x="csX4" y="csY4"/>
+                </a:cxn>
+                <a:cxn ang="0">
+                  <a:pos x="csX5" y="csY5"/>
+                </a:cxn>
+                <a:cxn ang="0">
+                  <a:pos x="csX6" y="csY6"/>
+                </a:cxn>
+                <a:cxn ang="0">
+                  <a:pos x="csX7" y="csY7"/>
+                </a:cxn>
+                <a:cxn ang="0">
+                  <a:pos x="csX8" y="csY8"/>
+                </a:cxn>
+                <a:cxn ang="0">
+                  <a:pos x="csX9" y="csY9"/>
+                </a:cxn>
+                <a:cxn ang="0">
+                  <a:pos x="csX10" y="csY10"/>
+                </a:cxn>
+              </a:cxnLst>
+              <a:rect l="l" t="t" r="r" b="b"/>
+              <a:pathLst>
+                <a:path w="318582" h="458540">
+                  <a:moveTo>
+                    <a:pt x="184671" y="244098"/>
+                  </a:moveTo>
+                  <a:lnTo>
+                    <a:pt x="318582" y="378010"/>
+                  </a:lnTo>
+                  <a:lnTo>
+                    <a:pt x="244099" y="452381"/>
+                  </a:lnTo>
+                  <a:cubicBezTo>
+                    <a:pt x="236000" y="460594"/>
+                    <a:pt x="222654" y="460594"/>
+                    <a:pt x="214441" y="452381"/>
+                  </a:cubicBezTo>
+                  <a:lnTo>
+                    <a:pt x="6159" y="244098"/>
+                  </a:lnTo>
+                  <a:cubicBezTo>
+                    <a:pt x="-2053" y="235886"/>
+                    <a:pt x="-2053" y="222654"/>
+                    <a:pt x="6159" y="214442"/>
+                  </a:cubicBezTo>
+                  <a:lnTo>
+                    <a:pt x="214441" y="6160"/>
+                  </a:lnTo>
+                  <a:cubicBezTo>
+                    <a:pt x="222654" y="-2053"/>
+                    <a:pt x="236000" y="-2053"/>
+                    <a:pt x="244099" y="6160"/>
+                  </a:cubicBezTo>
+                  <a:lnTo>
+                    <a:pt x="318582" y="80644"/>
+                  </a:lnTo>
+                  <a:lnTo>
+                    <a:pt x="184671" y="214442"/>
+                  </a:lnTo>
+                  <a:cubicBezTo>
+                    <a:pt x="176458" y="222654"/>
+                    <a:pt x="176458" y="235886"/>
+                    <a:pt x="184671" y="244098"/>
+                  </a:cubicBezTo>
+                  <a:close/>
+                </a:path>
+              </a:pathLst>
+            </a:custGeom>
+            <a:solidFill>
+              <a:srgbClr val="000000"/>
+            </a:solidFill>
+            <a:ln w="9525" cap="flat">
+              <a:noFill/>
+              <a:prstDash val="solid"/>
+              <a:miter/>
+            </a:ln>
+          </p:spPr>
+          <p:txBody>
+            <a:bodyPr/>
+            <a:lstStyle/>
+            <a:p>
+              <a:endParaRPr lang="en-US"/>
+            </a:p>
+          </p:txBody>
+        </p:sp>
+      </p:grpSp>
+      <p:sp>
+        <p:nvSpPr>
+          <p:cNvPr id="34" name="Rectangle: Rounded Corners 33">
+            <a:extLst>
+              <a:ext uri="{FF2B5EF4-FFF2-40B4-BE49-F238E27FC236}">
+                <a16:creationId xmlns:a16="http://schemas.microsoft.com/office/drawing/2014/main" id="{DBD53FC3-465C-3EF6-49EE-E9F4BB74D7FB}"/>
+              </a:ext>
+            </a:extLst>
+          </p:cNvPr>
+          <p:cNvSpPr/>
+          <p:nvPr/>
+        </p:nvSpPr>
+        <p:spPr>
+          <a:xfrm>
+            <a:off x="278869" y="238054"/>
+            <a:ext cx="1101792" cy="1101792"/>
+          </a:xfrm>
+          <a:prstGeom prst="roundRect">
+            <a:avLst>
+              <a:gd name="adj" fmla="val 6293"/>
+            </a:avLst>
+          </a:prstGeom>
+          <a:solidFill>
+            <a:srgbClr val="FFC000"/>
+          </a:solidFill>
+          <a:ln w="9525" cap="flat">
+            <a:noFill/>
+            <a:prstDash val="solid"/>
+            <a:miter/>
+          </a:ln>
+        </p:spPr>
+        <p:txBody>
+          <a:bodyPr/>
+          <a:lstStyle/>
+          <a:p>
+            <a:endParaRPr lang="en-US">
+              <a:solidFill>
+                <a:schemeClr val="tx1"/>
+              </a:solidFill>
+            </a:endParaRPr>
+          </a:p>
+        </p:txBody>
+      </p:sp>
+      <p:sp>
+        <p:nvSpPr>
+          <p:cNvPr id="35" name="Rectangle: Rounded Corners 34">
+            <a:extLst>
+              <a:ext uri="{FF2B5EF4-FFF2-40B4-BE49-F238E27FC236}">
+                <a16:creationId xmlns:a16="http://schemas.microsoft.com/office/drawing/2014/main" id="{48F151B1-F377-E0E4-8308-DECA3D02F25F}"/>
+              </a:ext>
+            </a:extLst>
+          </p:cNvPr>
+          <p:cNvSpPr/>
+          <p:nvPr/>
+        </p:nvSpPr>
+        <p:spPr>
+          <a:xfrm>
+            <a:off x="380574" y="339759"/>
+            <a:ext cx="898382" cy="898382"/>
+          </a:xfrm>
+          <a:prstGeom prst="roundRect">
+            <a:avLst>
+              <a:gd name="adj" fmla="val 7088"/>
+            </a:avLst>
+          </a:prstGeom>
+          <a:solidFill>
+            <a:schemeClr val="tx2">
+              <a:lumMod val="60000"/>
+              <a:lumOff val="40000"/>
+            </a:schemeClr>
+          </a:solidFill>
+          <a:ln w="9525" cap="flat">
+            <a:noFill/>
+            <a:prstDash val="solid"/>
+            <a:miter/>
+          </a:ln>
+        </p:spPr>
+        <p:txBody>
+          <a:bodyPr/>
+          <a:lstStyle/>
+          <a:p>
+            <a:endParaRPr lang="en-US">
+              <a:solidFill>
+                <a:schemeClr val="tx1"/>
+              </a:solidFill>
+            </a:endParaRPr>
+          </a:p>
+        </p:txBody>
+      </p:sp>
+      <p:sp>
+        <p:nvSpPr>
+          <p:cNvPr id="42" name="Freeform: Shape 41">
+            <a:extLst>
+              <a:ext uri="{FF2B5EF4-FFF2-40B4-BE49-F238E27FC236}">
+                <a16:creationId xmlns:a16="http://schemas.microsoft.com/office/drawing/2014/main" id="{7BF73B3A-9A2D-B872-771E-5EAE9A4EEF3B}"/>
+              </a:ext>
+            </a:extLst>
+          </p:cNvPr>
+          <p:cNvSpPr/>
+          <p:nvPr/>
+        </p:nvSpPr>
+        <p:spPr>
+          <a:xfrm flipV="1">
+            <a:off x="649852" y="4211901"/>
+            <a:ext cx="1101792" cy="1501201"/>
+          </a:xfrm>
+          <a:custGeom>
+            <a:avLst/>
+            <a:gdLst>
+              <a:gd name="csX0" fmla="*/ 165382 w 1101792"/>
+              <a:gd name="csY0" fmla="*/ 1399496 h 1501201"/>
+              <a:gd name="csX1" fmla="*/ 101705 w 1101792"/>
+              <a:gd name="csY1" fmla="*/ 1335819 h 1501201"/>
+              <a:gd name="csX2" fmla="*/ 101705 w 1101792"/>
+              <a:gd name="csY2" fmla="*/ 817139 h 1501201"/>
+              <a:gd name="csX3" fmla="*/ 101705 w 1101792"/>
+              <a:gd name="csY3" fmla="*/ 684062 h 1501201"/>
+              <a:gd name="csX4" fmla="*/ 101705 w 1101792"/>
+              <a:gd name="csY4" fmla="*/ 165382 h 1501201"/>
+              <a:gd name="csX5" fmla="*/ 165382 w 1101792"/>
+              <a:gd name="csY5" fmla="*/ 101705 h 1501201"/>
+              <a:gd name="csX6" fmla="*/ 936410 w 1101792"/>
+              <a:gd name="csY6" fmla="*/ 101705 h 1501201"/>
+              <a:gd name="csX7" fmla="*/ 1000087 w 1101792"/>
+              <a:gd name="csY7" fmla="*/ 165382 h 1501201"/>
+              <a:gd name="csX8" fmla="*/ 1000087 w 1101792"/>
+              <a:gd name="csY8" fmla="*/ 684062 h 1501201"/>
+              <a:gd name="csX9" fmla="*/ 1000087 w 1101792"/>
+              <a:gd name="csY9" fmla="*/ 817139 h 1501201"/>
+              <a:gd name="csX10" fmla="*/ 1000087 w 1101792"/>
+              <a:gd name="csY10" fmla="*/ 1335819 h 1501201"/>
+              <a:gd name="csX11" fmla="*/ 936410 w 1101792"/>
+              <a:gd name="csY11" fmla="*/ 1399496 h 1501201"/>
+              <a:gd name="csX12" fmla="*/ 69336 w 1101792"/>
+              <a:gd name="csY12" fmla="*/ 1501201 h 1501201"/>
+              <a:gd name="csX13" fmla="*/ 1032456 w 1101792"/>
+              <a:gd name="csY13" fmla="*/ 1501201 h 1501201"/>
+              <a:gd name="csX14" fmla="*/ 1101792 w 1101792"/>
+              <a:gd name="csY14" fmla="*/ 1431865 h 1501201"/>
+              <a:gd name="csX15" fmla="*/ 1101792 w 1101792"/>
+              <a:gd name="csY15" fmla="*/ 817139 h 1501201"/>
+              <a:gd name="csX16" fmla="*/ 1101792 w 1101792"/>
+              <a:gd name="csY16" fmla="*/ 684062 h 1501201"/>
+              <a:gd name="csX17" fmla="*/ 1101792 w 1101792"/>
+              <a:gd name="csY17" fmla="*/ 69336 h 1501201"/>
+              <a:gd name="csX18" fmla="*/ 1032456 w 1101792"/>
+              <a:gd name="csY18" fmla="*/ 0 h 1501201"/>
+              <a:gd name="csX19" fmla="*/ 69336 w 1101792"/>
+              <a:gd name="csY19" fmla="*/ 0 h 1501201"/>
+              <a:gd name="csX20" fmla="*/ 0 w 1101792"/>
+              <a:gd name="csY20" fmla="*/ 69336 h 1501201"/>
+              <a:gd name="csX21" fmla="*/ 0 w 1101792"/>
+              <a:gd name="csY21" fmla="*/ 684062 h 1501201"/>
+              <a:gd name="csX22" fmla="*/ 0 w 1101792"/>
+              <a:gd name="csY22" fmla="*/ 817139 h 1501201"/>
+              <a:gd name="csX23" fmla="*/ 0 w 1101792"/>
+              <a:gd name="csY23" fmla="*/ 1431865 h 1501201"/>
+              <a:gd name="csX24" fmla="*/ 69336 w 1101792"/>
+              <a:gd name="csY24" fmla="*/ 1501201 h 1501201"/>
+              <a:gd name="csX0" fmla="*/ 165382 w 1101792"/>
+              <a:gd name="csY0" fmla="*/ 1399496 h 1501201"/>
+              <a:gd name="csX1" fmla="*/ 101705 w 1101792"/>
+              <a:gd name="csY1" fmla="*/ 1335819 h 1501201"/>
+              <a:gd name="csX2" fmla="*/ 101705 w 1101792"/>
+              <a:gd name="csY2" fmla="*/ 684062 h 1501201"/>
+              <a:gd name="csX3" fmla="*/ 101705 w 1101792"/>
+              <a:gd name="csY3" fmla="*/ 165382 h 1501201"/>
+              <a:gd name="csX4" fmla="*/ 165382 w 1101792"/>
+              <a:gd name="csY4" fmla="*/ 101705 h 1501201"/>
+              <a:gd name="csX5" fmla="*/ 936410 w 1101792"/>
+              <a:gd name="csY5" fmla="*/ 101705 h 1501201"/>
+              <a:gd name="csX6" fmla="*/ 1000087 w 1101792"/>
+              <a:gd name="csY6" fmla="*/ 165382 h 1501201"/>
+              <a:gd name="csX7" fmla="*/ 1000087 w 1101792"/>
+              <a:gd name="csY7" fmla="*/ 684062 h 1501201"/>
+              <a:gd name="csX8" fmla="*/ 1000087 w 1101792"/>
+              <a:gd name="csY8" fmla="*/ 817139 h 1501201"/>
+              <a:gd name="csX9" fmla="*/ 1000087 w 1101792"/>
+              <a:gd name="csY9" fmla="*/ 1335819 h 1501201"/>
+              <a:gd name="csX10" fmla="*/ 936410 w 1101792"/>
+              <a:gd name="csY10" fmla="*/ 1399496 h 1501201"/>
+              <a:gd name="csX11" fmla="*/ 165382 w 1101792"/>
+              <a:gd name="csY11" fmla="*/ 1399496 h 1501201"/>
+              <a:gd name="csX12" fmla="*/ 69336 w 1101792"/>
+              <a:gd name="csY12" fmla="*/ 1501201 h 1501201"/>
+              <a:gd name="csX13" fmla="*/ 1032456 w 1101792"/>
+              <a:gd name="csY13" fmla="*/ 1501201 h 1501201"/>
+              <a:gd name="csX14" fmla="*/ 1101792 w 1101792"/>
+              <a:gd name="csY14" fmla="*/ 1431865 h 1501201"/>
+              <a:gd name="csX15" fmla="*/ 1101792 w 1101792"/>
+              <a:gd name="csY15" fmla="*/ 817139 h 1501201"/>
+              <a:gd name="csX16" fmla="*/ 1101792 w 1101792"/>
+              <a:gd name="csY16" fmla="*/ 684062 h 1501201"/>
+              <a:gd name="csX17" fmla="*/ 1101792 w 1101792"/>
+              <a:gd name="csY17" fmla="*/ 69336 h 1501201"/>
+              <a:gd name="csX18" fmla="*/ 1032456 w 1101792"/>
+              <a:gd name="csY18" fmla="*/ 0 h 1501201"/>
+              <a:gd name="csX19" fmla="*/ 69336 w 1101792"/>
+              <a:gd name="csY19" fmla="*/ 0 h 1501201"/>
+              <a:gd name="csX20" fmla="*/ 0 w 1101792"/>
+              <a:gd name="csY20" fmla="*/ 69336 h 1501201"/>
+              <a:gd name="csX21" fmla="*/ 0 w 1101792"/>
+              <a:gd name="csY21" fmla="*/ 684062 h 1501201"/>
+              <a:gd name="csX22" fmla="*/ 0 w 1101792"/>
+              <a:gd name="csY22" fmla="*/ 817139 h 1501201"/>
+              <a:gd name="csX23" fmla="*/ 0 w 1101792"/>
+              <a:gd name="csY23" fmla="*/ 1431865 h 1501201"/>
+              <a:gd name="csX24" fmla="*/ 69336 w 1101792"/>
+              <a:gd name="csY24" fmla="*/ 1501201 h 1501201"/>
+              <a:gd name="csX0" fmla="*/ 165382 w 1101792"/>
+              <a:gd name="csY0" fmla="*/ 1399496 h 1501201"/>
+              <a:gd name="csX1" fmla="*/ 101705 w 1101792"/>
+              <a:gd name="csY1" fmla="*/ 1335819 h 1501201"/>
+              <a:gd name="csX2" fmla="*/ 101705 w 1101792"/>
+              <a:gd name="csY2" fmla="*/ 165382 h 1501201"/>
+              <a:gd name="csX3" fmla="*/ 165382 w 1101792"/>
+              <a:gd name="csY3" fmla="*/ 101705 h 1501201"/>
+              <a:gd name="csX4" fmla="*/ 936410 w 1101792"/>
+              <a:gd name="csY4" fmla="*/ 101705 h 1501201"/>
+              <a:gd name="csX5" fmla="*/ 1000087 w 1101792"/>
+              <a:gd name="csY5" fmla="*/ 165382 h 1501201"/>
+              <a:gd name="csX6" fmla="*/ 1000087 w 1101792"/>
+              <a:gd name="csY6" fmla="*/ 684062 h 1501201"/>
+              <a:gd name="csX7" fmla="*/ 1000087 w 1101792"/>
+              <a:gd name="csY7" fmla="*/ 817139 h 1501201"/>
+              <a:gd name="csX8" fmla="*/ 1000087 w 1101792"/>
+              <a:gd name="csY8" fmla="*/ 1335819 h 1501201"/>
+              <a:gd name="csX9" fmla="*/ 936410 w 1101792"/>
+              <a:gd name="csY9" fmla="*/ 1399496 h 1501201"/>
+              <a:gd name="csX10" fmla="*/ 165382 w 1101792"/>
+              <a:gd name="csY10" fmla="*/ 1399496 h 1501201"/>
+              <a:gd name="csX11" fmla="*/ 69336 w 1101792"/>
+              <a:gd name="csY11" fmla="*/ 1501201 h 1501201"/>
+              <a:gd name="csX12" fmla="*/ 1032456 w 1101792"/>
+              <a:gd name="csY12" fmla="*/ 1501201 h 1501201"/>
+              <a:gd name="csX13" fmla="*/ 1101792 w 1101792"/>
+              <a:gd name="csY13" fmla="*/ 1431865 h 1501201"/>
+              <a:gd name="csX14" fmla="*/ 1101792 w 1101792"/>
+              <a:gd name="csY14" fmla="*/ 817139 h 1501201"/>
+              <a:gd name="csX15" fmla="*/ 1101792 w 1101792"/>
+              <a:gd name="csY15" fmla="*/ 684062 h 1501201"/>
+              <a:gd name="csX16" fmla="*/ 1101792 w 1101792"/>
+              <a:gd name="csY16" fmla="*/ 69336 h 1501201"/>
+              <a:gd name="csX17" fmla="*/ 1032456 w 1101792"/>
+              <a:gd name="csY17" fmla="*/ 0 h 1501201"/>
+              <a:gd name="csX18" fmla="*/ 69336 w 1101792"/>
+              <a:gd name="csY18" fmla="*/ 0 h 1501201"/>
+              <a:gd name="csX19" fmla="*/ 0 w 1101792"/>
+              <a:gd name="csY19" fmla="*/ 69336 h 1501201"/>
+              <a:gd name="csX20" fmla="*/ 0 w 1101792"/>
+              <a:gd name="csY20" fmla="*/ 684062 h 1501201"/>
+              <a:gd name="csX21" fmla="*/ 0 w 1101792"/>
+              <a:gd name="csY21" fmla="*/ 817139 h 1501201"/>
+              <a:gd name="csX22" fmla="*/ 0 w 1101792"/>
+              <a:gd name="csY22" fmla="*/ 1431865 h 1501201"/>
+              <a:gd name="csX23" fmla="*/ 69336 w 1101792"/>
+              <a:gd name="csY23" fmla="*/ 1501201 h 1501201"/>
+              <a:gd name="csX0" fmla="*/ 165382 w 1101792"/>
+              <a:gd name="csY0" fmla="*/ 1399496 h 1501201"/>
+              <a:gd name="csX1" fmla="*/ 101705 w 1101792"/>
+              <a:gd name="csY1" fmla="*/ 1335819 h 1501201"/>
+              <a:gd name="csX2" fmla="*/ 101705 w 1101792"/>
+              <a:gd name="csY2" fmla="*/ 165382 h 1501201"/>
+              <a:gd name="csX3" fmla="*/ 165382 w 1101792"/>
+              <a:gd name="csY3" fmla="*/ 101705 h 1501201"/>
+              <a:gd name="csX4" fmla="*/ 936410 w 1101792"/>
+              <a:gd name="csY4" fmla="*/ 101705 h 1501201"/>
+              <a:gd name="csX5" fmla="*/ 1000087 w 1101792"/>
+              <a:gd name="csY5" fmla="*/ 165382 h 1501201"/>
+              <a:gd name="csX6" fmla="*/ 1000087 w 1101792"/>
+              <a:gd name="csY6" fmla="*/ 817139 h 1501201"/>
+              <a:gd name="csX7" fmla="*/ 1000087 w 1101792"/>
+              <a:gd name="csY7" fmla="*/ 1335819 h 1501201"/>
+              <a:gd name="csX8" fmla="*/ 936410 w 1101792"/>
+              <a:gd name="csY8" fmla="*/ 1399496 h 1501201"/>
+              <a:gd name="csX9" fmla="*/ 165382 w 1101792"/>
+              <a:gd name="csY9" fmla="*/ 1399496 h 1501201"/>
+              <a:gd name="csX10" fmla="*/ 69336 w 1101792"/>
+              <a:gd name="csY10" fmla="*/ 1501201 h 1501201"/>
+              <a:gd name="csX11" fmla="*/ 1032456 w 1101792"/>
+              <a:gd name="csY11" fmla="*/ 1501201 h 1501201"/>
+              <a:gd name="csX12" fmla="*/ 1101792 w 1101792"/>
+              <a:gd name="csY12" fmla="*/ 1431865 h 1501201"/>
+              <a:gd name="csX13" fmla="*/ 1101792 w 1101792"/>
+              <a:gd name="csY13" fmla="*/ 817139 h 1501201"/>
+              <a:gd name="csX14" fmla="*/ 1101792 w 1101792"/>
+              <a:gd name="csY14" fmla="*/ 684062 h 1501201"/>
+              <a:gd name="csX15" fmla="*/ 1101792 w 1101792"/>
+              <a:gd name="csY15" fmla="*/ 69336 h 1501201"/>
+              <a:gd name="csX16" fmla="*/ 1032456 w 1101792"/>
+              <a:gd name="csY16" fmla="*/ 0 h 1501201"/>
+              <a:gd name="csX17" fmla="*/ 69336 w 1101792"/>
+              <a:gd name="csY17" fmla="*/ 0 h 1501201"/>
+              <a:gd name="csX18" fmla="*/ 0 w 1101792"/>
+              <a:gd name="csY18" fmla="*/ 69336 h 1501201"/>
+              <a:gd name="csX19" fmla="*/ 0 w 1101792"/>
+              <a:gd name="csY19" fmla="*/ 684062 h 1501201"/>
+              <a:gd name="csX20" fmla="*/ 0 w 1101792"/>
+              <a:gd name="csY20" fmla="*/ 817139 h 1501201"/>
+              <a:gd name="csX21" fmla="*/ 0 w 1101792"/>
+              <a:gd name="csY21" fmla="*/ 1431865 h 1501201"/>
+              <a:gd name="csX22" fmla="*/ 69336 w 1101792"/>
+              <a:gd name="csY22" fmla="*/ 1501201 h 1501201"/>
+              <a:gd name="csX0" fmla="*/ 165382 w 1101792"/>
+              <a:gd name="csY0" fmla="*/ 1399496 h 1501201"/>
+              <a:gd name="csX1" fmla="*/ 101705 w 1101792"/>
+              <a:gd name="csY1" fmla="*/ 1335819 h 1501201"/>
+              <a:gd name="csX2" fmla="*/ 101705 w 1101792"/>
+              <a:gd name="csY2" fmla="*/ 165382 h 1501201"/>
+              <a:gd name="csX3" fmla="*/ 165382 w 1101792"/>
+              <a:gd name="csY3" fmla="*/ 101705 h 1501201"/>
+              <a:gd name="csX4" fmla="*/ 936410 w 1101792"/>
+              <a:gd name="csY4" fmla="*/ 101705 h 1501201"/>
+              <a:gd name="csX5" fmla="*/ 1000087 w 1101792"/>
+              <a:gd name="csY5" fmla="*/ 165382 h 1501201"/>
+              <a:gd name="csX6" fmla="*/ 1000087 w 1101792"/>
+              <a:gd name="csY6" fmla="*/ 1335819 h 1501201"/>
+              <a:gd name="csX7" fmla="*/ 936410 w 1101792"/>
+              <a:gd name="csY7" fmla="*/ 1399496 h 1501201"/>
+              <a:gd name="csX8" fmla="*/ 165382 w 1101792"/>
+              <a:gd name="csY8" fmla="*/ 1399496 h 1501201"/>
+              <a:gd name="csX9" fmla="*/ 69336 w 1101792"/>
+              <a:gd name="csY9" fmla="*/ 1501201 h 1501201"/>
+              <a:gd name="csX10" fmla="*/ 1032456 w 1101792"/>
+              <a:gd name="csY10" fmla="*/ 1501201 h 1501201"/>
+              <a:gd name="csX11" fmla="*/ 1101792 w 1101792"/>
+              <a:gd name="csY11" fmla="*/ 1431865 h 1501201"/>
+              <a:gd name="csX12" fmla="*/ 1101792 w 1101792"/>
+              <a:gd name="csY12" fmla="*/ 817139 h 1501201"/>
+              <a:gd name="csX13" fmla="*/ 1101792 w 1101792"/>
+              <a:gd name="csY13" fmla="*/ 684062 h 1501201"/>
+              <a:gd name="csX14" fmla="*/ 1101792 w 1101792"/>
+              <a:gd name="csY14" fmla="*/ 69336 h 1501201"/>
+              <a:gd name="csX15" fmla="*/ 1032456 w 1101792"/>
+              <a:gd name="csY15" fmla="*/ 0 h 1501201"/>
+              <a:gd name="csX16" fmla="*/ 69336 w 1101792"/>
+              <a:gd name="csY16" fmla="*/ 0 h 1501201"/>
+              <a:gd name="csX17" fmla="*/ 0 w 1101792"/>
+              <a:gd name="csY17" fmla="*/ 69336 h 1501201"/>
+              <a:gd name="csX18" fmla="*/ 0 w 1101792"/>
+              <a:gd name="csY18" fmla="*/ 684062 h 1501201"/>
+              <a:gd name="csX19" fmla="*/ 0 w 1101792"/>
+              <a:gd name="csY19" fmla="*/ 817139 h 1501201"/>
+              <a:gd name="csX20" fmla="*/ 0 w 1101792"/>
+              <a:gd name="csY20" fmla="*/ 1431865 h 1501201"/>
+              <a:gd name="csX21" fmla="*/ 69336 w 1101792"/>
+              <a:gd name="csY21" fmla="*/ 1501201 h 1501201"/>
+              <a:gd name="csX0" fmla="*/ 165382 w 1101792"/>
+              <a:gd name="csY0" fmla="*/ 1399496 h 1501201"/>
+              <a:gd name="csX1" fmla="*/ 101705 w 1101792"/>
+              <a:gd name="csY1" fmla="*/ 1335819 h 1501201"/>
+              <a:gd name="csX2" fmla="*/ 101705 w 1101792"/>
+              <a:gd name="csY2" fmla="*/ 165382 h 1501201"/>
+              <a:gd name="csX3" fmla="*/ 165382 w 1101792"/>
+              <a:gd name="csY3" fmla="*/ 101705 h 1501201"/>
+              <a:gd name="csX4" fmla="*/ 936410 w 1101792"/>
+              <a:gd name="csY4" fmla="*/ 101705 h 1501201"/>
+              <a:gd name="csX5" fmla="*/ 1000087 w 1101792"/>
+              <a:gd name="csY5" fmla="*/ 165382 h 1501201"/>
+              <a:gd name="csX6" fmla="*/ 1000087 w 1101792"/>
+              <a:gd name="csY6" fmla="*/ 1335819 h 1501201"/>
+              <a:gd name="csX7" fmla="*/ 936410 w 1101792"/>
+              <a:gd name="csY7" fmla="*/ 1399496 h 1501201"/>
+              <a:gd name="csX8" fmla="*/ 165382 w 1101792"/>
+              <a:gd name="csY8" fmla="*/ 1399496 h 1501201"/>
+              <a:gd name="csX9" fmla="*/ 69336 w 1101792"/>
+              <a:gd name="csY9" fmla="*/ 1501201 h 1501201"/>
+              <a:gd name="csX10" fmla="*/ 1032456 w 1101792"/>
+              <a:gd name="csY10" fmla="*/ 1501201 h 1501201"/>
+              <a:gd name="csX11" fmla="*/ 1101792 w 1101792"/>
+              <a:gd name="csY11" fmla="*/ 1431865 h 1501201"/>
+              <a:gd name="csX12" fmla="*/ 1101792 w 1101792"/>
+              <a:gd name="csY12" fmla="*/ 817139 h 1501201"/>
+              <a:gd name="csX13" fmla="*/ 1101792 w 1101792"/>
+              <a:gd name="csY13" fmla="*/ 69336 h 1501201"/>
+              <a:gd name="csX14" fmla="*/ 1032456 w 1101792"/>
+              <a:gd name="csY14" fmla="*/ 0 h 1501201"/>
+              <a:gd name="csX15" fmla="*/ 69336 w 1101792"/>
+              <a:gd name="csY15" fmla="*/ 0 h 1501201"/>
+              <a:gd name="csX16" fmla="*/ 0 w 1101792"/>
+              <a:gd name="csY16" fmla="*/ 69336 h 1501201"/>
+              <a:gd name="csX17" fmla="*/ 0 w 1101792"/>
+              <a:gd name="csY17" fmla="*/ 684062 h 1501201"/>
+              <a:gd name="csX18" fmla="*/ 0 w 1101792"/>
+              <a:gd name="csY18" fmla="*/ 817139 h 1501201"/>
+              <a:gd name="csX19" fmla="*/ 0 w 1101792"/>
+              <a:gd name="csY19" fmla="*/ 1431865 h 1501201"/>
+              <a:gd name="csX20" fmla="*/ 69336 w 1101792"/>
+              <a:gd name="csY20" fmla="*/ 1501201 h 1501201"/>
+              <a:gd name="csX0" fmla="*/ 165382 w 1101792"/>
+              <a:gd name="csY0" fmla="*/ 1399496 h 1501201"/>
+              <a:gd name="csX1" fmla="*/ 101705 w 1101792"/>
+              <a:gd name="csY1" fmla="*/ 1335819 h 1501201"/>
+              <a:gd name="csX2" fmla="*/ 101705 w 1101792"/>
+              <a:gd name="csY2" fmla="*/ 165382 h 1501201"/>
+              <a:gd name="csX3" fmla="*/ 165382 w 1101792"/>
+              <a:gd name="csY3" fmla="*/ 101705 h 1501201"/>
+              <a:gd name="csX4" fmla="*/ 936410 w 1101792"/>
+              <a:gd name="csY4" fmla="*/ 101705 h 1501201"/>
+              <a:gd name="csX5" fmla="*/ 1000087 w 1101792"/>
+              <a:gd name="csY5" fmla="*/ 165382 h 1501201"/>
+              <a:gd name="csX6" fmla="*/ 1000087 w 1101792"/>
+              <a:gd name="csY6" fmla="*/ 1335819 h 1501201"/>
+              <a:gd name="csX7" fmla="*/ 936410 w 1101792"/>
+              <a:gd name="csY7" fmla="*/ 1399496 h 1501201"/>
+              <a:gd name="csX8" fmla="*/ 165382 w 1101792"/>
+              <a:gd name="csY8" fmla="*/ 1399496 h 1501201"/>
+              <a:gd name="csX9" fmla="*/ 69336 w 1101792"/>
+              <a:gd name="csY9" fmla="*/ 1501201 h 1501201"/>
+              <a:gd name="csX10" fmla="*/ 1032456 w 1101792"/>
+              <a:gd name="csY10" fmla="*/ 1501201 h 1501201"/>
+              <a:gd name="csX11" fmla="*/ 1101792 w 1101792"/>
+              <a:gd name="csY11" fmla="*/ 1431865 h 1501201"/>
+              <a:gd name="csX12" fmla="*/ 1101792 w 1101792"/>
+              <a:gd name="csY12" fmla="*/ 69336 h 1501201"/>
+              <a:gd name="csX13" fmla="*/ 1032456 w 1101792"/>
+              <a:gd name="csY13" fmla="*/ 0 h 1501201"/>
+              <a:gd name="csX14" fmla="*/ 69336 w 1101792"/>
+              <a:gd name="csY14" fmla="*/ 0 h 1501201"/>
+              <a:gd name="csX15" fmla="*/ 0 w 1101792"/>
+              <a:gd name="csY15" fmla="*/ 69336 h 1501201"/>
+              <a:gd name="csX16" fmla="*/ 0 w 1101792"/>
+              <a:gd name="csY16" fmla="*/ 684062 h 1501201"/>
+              <a:gd name="csX17" fmla="*/ 0 w 1101792"/>
+              <a:gd name="csY17" fmla="*/ 817139 h 1501201"/>
+              <a:gd name="csX18" fmla="*/ 0 w 1101792"/>
+              <a:gd name="csY18" fmla="*/ 1431865 h 1501201"/>
+              <a:gd name="csX19" fmla="*/ 69336 w 1101792"/>
+              <a:gd name="csY19" fmla="*/ 1501201 h 1501201"/>
+              <a:gd name="csX0" fmla="*/ 165382 w 1101792"/>
+              <a:gd name="csY0" fmla="*/ 1399496 h 1501201"/>
+              <a:gd name="csX1" fmla="*/ 101705 w 1101792"/>
+              <a:gd name="csY1" fmla="*/ 1335819 h 1501201"/>
+              <a:gd name="csX2" fmla="*/ 101705 w 1101792"/>
+              <a:gd name="csY2" fmla="*/ 165382 h 1501201"/>
+              <a:gd name="csX3" fmla="*/ 165382 w 1101792"/>
+              <a:gd name="csY3" fmla="*/ 101705 h 1501201"/>
+              <a:gd name="csX4" fmla="*/ 936410 w 1101792"/>
+              <a:gd name="csY4" fmla="*/ 101705 h 1501201"/>
+              <a:gd name="csX5" fmla="*/ 1000087 w 1101792"/>
+              <a:gd name="csY5" fmla="*/ 165382 h 1501201"/>
+              <a:gd name="csX6" fmla="*/ 1000087 w 1101792"/>
+              <a:gd name="csY6" fmla="*/ 1335819 h 1501201"/>
+              <a:gd name="csX7" fmla="*/ 936410 w 1101792"/>
+              <a:gd name="csY7" fmla="*/ 1399496 h 1501201"/>
+              <a:gd name="csX8" fmla="*/ 165382 w 1101792"/>
+              <a:gd name="csY8" fmla="*/ 1399496 h 1501201"/>
+              <a:gd name="csX9" fmla="*/ 69336 w 1101792"/>
+              <a:gd name="csY9" fmla="*/ 1501201 h 1501201"/>
+              <a:gd name="csX10" fmla="*/ 1032456 w 1101792"/>
+              <a:gd name="csY10" fmla="*/ 1501201 h 1501201"/>
+              <a:gd name="csX11" fmla="*/ 1101792 w 1101792"/>
+              <a:gd name="csY11" fmla="*/ 1431865 h 1501201"/>
+              <a:gd name="csX12" fmla="*/ 1101792 w 1101792"/>
+              <a:gd name="csY12" fmla="*/ 69336 h 1501201"/>
+              <a:gd name="csX13" fmla="*/ 1032456 w 1101792"/>
+              <a:gd name="csY13" fmla="*/ 0 h 1501201"/>
+              <a:gd name="csX14" fmla="*/ 69336 w 1101792"/>
+              <a:gd name="csY14" fmla="*/ 0 h 1501201"/>
+              <a:gd name="csX15" fmla="*/ 0 w 1101792"/>
+              <a:gd name="csY15" fmla="*/ 69336 h 1501201"/>
+              <a:gd name="csX16" fmla="*/ 0 w 1101792"/>
+              <a:gd name="csY16" fmla="*/ 684062 h 1501201"/>
+              <a:gd name="csX17" fmla="*/ 0 w 1101792"/>
+              <a:gd name="csY17" fmla="*/ 1431865 h 1501201"/>
+              <a:gd name="csX18" fmla="*/ 69336 w 1101792"/>
+              <a:gd name="csY18" fmla="*/ 1501201 h 1501201"/>
+              <a:gd name="csX0" fmla="*/ 165382 w 1101792"/>
+              <a:gd name="csY0" fmla="*/ 1399496 h 1501201"/>
+              <a:gd name="csX1" fmla="*/ 101705 w 1101792"/>
+              <a:gd name="csY1" fmla="*/ 1335819 h 1501201"/>
+              <a:gd name="csX2" fmla="*/ 101705 w 1101792"/>
+              <a:gd name="csY2" fmla="*/ 165382 h 1501201"/>
+              <a:gd name="csX3" fmla="*/ 165382 w 1101792"/>
+              <a:gd name="csY3" fmla="*/ 101705 h 1501201"/>
+              <a:gd name="csX4" fmla="*/ 936410 w 1101792"/>
+              <a:gd name="csY4" fmla="*/ 101705 h 1501201"/>
+              <a:gd name="csX5" fmla="*/ 1000087 w 1101792"/>
+              <a:gd name="csY5" fmla="*/ 165382 h 1501201"/>
+              <a:gd name="csX6" fmla="*/ 1000087 w 1101792"/>
+              <a:gd name="csY6" fmla="*/ 1335819 h 1501201"/>
+              <a:gd name="csX7" fmla="*/ 936410 w 1101792"/>
+              <a:gd name="csY7" fmla="*/ 1399496 h 1501201"/>
+              <a:gd name="csX8" fmla="*/ 165382 w 1101792"/>
+              <a:gd name="csY8" fmla="*/ 1399496 h 1501201"/>
+              <a:gd name="csX9" fmla="*/ 69336 w 1101792"/>
+              <a:gd name="csY9" fmla="*/ 1501201 h 1501201"/>
+              <a:gd name="csX10" fmla="*/ 1032456 w 1101792"/>
+              <a:gd name="csY10" fmla="*/ 1501201 h 1501201"/>
+              <a:gd name="csX11" fmla="*/ 1101792 w 1101792"/>
+              <a:gd name="csY11" fmla="*/ 1431865 h 1501201"/>
+              <a:gd name="csX12" fmla="*/ 1101792 w 1101792"/>
+              <a:gd name="csY12" fmla="*/ 69336 h 1501201"/>
+              <a:gd name="csX13" fmla="*/ 1032456 w 1101792"/>
+              <a:gd name="csY13" fmla="*/ 0 h 1501201"/>
+              <a:gd name="csX14" fmla="*/ 69336 w 1101792"/>
+              <a:gd name="csY14" fmla="*/ 0 h 1501201"/>
+              <a:gd name="csX15" fmla="*/ 0 w 1101792"/>
+              <a:gd name="csY15" fmla="*/ 69336 h 1501201"/>
+              <a:gd name="csX16" fmla="*/ 0 w 1101792"/>
+              <a:gd name="csY16" fmla="*/ 1431865 h 1501201"/>
+              <a:gd name="csX17" fmla="*/ 69336 w 1101792"/>
+              <a:gd name="csY17" fmla="*/ 1501201 h 1501201"/>
+            </a:gdLst>
+            <a:ahLst/>
+            <a:cxnLst>
+              <a:cxn ang="0">
+                <a:pos x="csX0" y="csY0"/>
+              </a:cxn>
+              <a:cxn ang="0">
+                <a:pos x="csX1" y="csY1"/>
+              </a:cxn>
+              <a:cxn ang="0">
+                <a:pos x="csX2" y="csY2"/>
+              </a:cxn>
+              <a:cxn ang="0">
+                <a:pos x="csX3" y="csY3"/>
+              </a:cxn>
+              <a:cxn ang="0">
+                <a:pos x="csX4" y="csY4"/>
+              </a:cxn>
+              <a:cxn ang="0">
+                <a:pos x="csX5" y="csY5"/>
+              </a:cxn>
+              <a:cxn ang="0">
+                <a:pos x="csX6" y="csY6"/>
+              </a:cxn>
+              <a:cxn ang="0">
+                <a:pos x="csX7" y="csY7"/>
+              </a:cxn>
+              <a:cxn ang="0">
+                <a:pos x="csX8" y="csY8"/>
+              </a:cxn>
+              <a:cxn ang="0">
+                <a:pos x="csX9" y="csY9"/>
+              </a:cxn>
+              <a:cxn ang="0">
+                <a:pos x="csX10" y="csY10"/>
+              </a:cxn>
+              <a:cxn ang="0">
+                <a:pos x="csX11" y="csY11"/>
+              </a:cxn>
+              <a:cxn ang="0">
+                <a:pos x="csX12" y="csY12"/>
+              </a:cxn>
+              <a:cxn ang="0">
+                <a:pos x="csX13" y="csY13"/>
+              </a:cxn>
+              <a:cxn ang="0">
+                <a:pos x="csX14" y="csY14"/>
+              </a:cxn>
+              <a:cxn ang="0">
+                <a:pos x="csX15" y="csY15"/>
+              </a:cxn>
+              <a:cxn ang="0">
+                <a:pos x="csX16" y="csY16"/>
+              </a:cxn>
+              <a:cxn ang="0">
+                <a:pos x="csX17" y="csY17"/>
+              </a:cxn>
+            </a:cxnLst>
+            <a:rect l="l" t="t" r="r" b="b"/>
+            <a:pathLst>
+              <a:path w="1101792" h="1501201">
+                <a:moveTo>
+                  <a:pt x="165382" y="1399496"/>
+                </a:moveTo>
+                <a:cubicBezTo>
+                  <a:pt x="130214" y="1399496"/>
+                  <a:pt x="101705" y="1370987"/>
+                  <a:pt x="101705" y="1335819"/>
+                </a:cubicBezTo>
+                <a:lnTo>
+                  <a:pt x="101705" y="165382"/>
+                </a:lnTo>
+                <a:cubicBezTo>
+                  <a:pt x="101705" y="130214"/>
+                  <a:pt x="130214" y="101705"/>
+                  <a:pt x="165382" y="101705"/>
+                </a:cubicBezTo>
+                <a:lnTo>
+                  <a:pt x="936410" y="101705"/>
+                </a:lnTo>
+                <a:cubicBezTo>
+                  <a:pt x="971578" y="101705"/>
+                  <a:pt x="1000087" y="130214"/>
+                  <a:pt x="1000087" y="165382"/>
+                </a:cubicBezTo>
+                <a:lnTo>
+                  <a:pt x="1000087" y="1335819"/>
+                </a:lnTo>
+                <a:cubicBezTo>
+                  <a:pt x="1000087" y="1370987"/>
+                  <a:pt x="971578" y="1399496"/>
+                  <a:pt x="936410" y="1399496"/>
+                </a:cubicBezTo>
+                <a:lnTo>
+                  <a:pt x="165382" y="1399496"/>
+                </a:lnTo>
+                <a:close/>
+                <a:moveTo>
+                  <a:pt x="69336" y="1501201"/>
+                </a:moveTo>
+                <a:lnTo>
+                  <a:pt x="1032456" y="1501201"/>
+                </a:lnTo>
+                <a:cubicBezTo>
+                  <a:pt x="1070749" y="1501201"/>
+                  <a:pt x="1101792" y="1470158"/>
+                  <a:pt x="1101792" y="1431865"/>
+                </a:cubicBezTo>
+                <a:lnTo>
+                  <a:pt x="1101792" y="69336"/>
+                </a:lnTo>
+                <a:cubicBezTo>
+                  <a:pt x="1101792" y="31043"/>
+                  <a:pt x="1070749" y="0"/>
+                  <a:pt x="1032456" y="0"/>
+                </a:cubicBezTo>
+                <a:lnTo>
+                  <a:pt x="69336" y="0"/>
+                </a:lnTo>
+                <a:cubicBezTo>
+                  <a:pt x="31043" y="0"/>
+                  <a:pt x="0" y="31043"/>
+                  <a:pt x="0" y="69336"/>
+                </a:cubicBezTo>
+                <a:lnTo>
+                  <a:pt x="0" y="1431865"/>
+                </a:lnTo>
+                <a:cubicBezTo>
+                  <a:pt x="0" y="1470158"/>
+                  <a:pt x="31043" y="1501201"/>
+                  <a:pt x="69336" y="1501201"/>
+                </a:cubicBezTo>
+                <a:close/>
+              </a:path>
+            </a:pathLst>
+          </a:custGeom>
+          <a:solidFill>
+            <a:schemeClr val="tx1"/>
+          </a:solidFill>
+          <a:ln w="9525" cap="flat">
+            <a:noFill/>
+            <a:prstDash val="solid"/>
+            <a:miter/>
+          </a:ln>
+        </p:spPr>
+        <p:txBody>
+          <a:bodyPr wrap="square">
+            <a:noAutofit/>
+          </a:bodyPr>
+          <a:lstStyle/>
+          <a:p>
+            <a:endParaRPr lang="en-US">
+              <a:solidFill>
+                <a:schemeClr val="tx1"/>
+              </a:solidFill>
+            </a:endParaRPr>
+          </a:p>
+        </p:txBody>
+      </p:sp>
+      <p:sp>
+        <p:nvSpPr>
+          <p:cNvPr id="43" name="Freeform: Shape 42">
+            <a:extLst>
+              <a:ext uri="{FF2B5EF4-FFF2-40B4-BE49-F238E27FC236}">
+                <a16:creationId xmlns:a16="http://schemas.microsoft.com/office/drawing/2014/main" id="{0B0D09F6-4C3A-32D6-D18B-ABB91E84B616}"/>
+              </a:ext>
+            </a:extLst>
+          </p:cNvPr>
+          <p:cNvSpPr/>
+          <p:nvPr/>
+        </p:nvSpPr>
+        <p:spPr>
+          <a:xfrm flipV="1">
+            <a:off x="2510500" y="4211901"/>
+            <a:ext cx="1101792" cy="1501201"/>
+          </a:xfrm>
+          <a:custGeom>
+            <a:avLst/>
+            <a:gdLst>
+              <a:gd name="csX0" fmla="*/ 165382 w 1101792"/>
+              <a:gd name="csY0" fmla="*/ 1399496 h 1501201"/>
+              <a:gd name="csX1" fmla="*/ 101705 w 1101792"/>
+              <a:gd name="csY1" fmla="*/ 1335819 h 1501201"/>
+              <a:gd name="csX2" fmla="*/ 101705 w 1101792"/>
+              <a:gd name="csY2" fmla="*/ 817139 h 1501201"/>
+              <a:gd name="csX3" fmla="*/ 101705 w 1101792"/>
+              <a:gd name="csY3" fmla="*/ 684062 h 1501201"/>
+              <a:gd name="csX4" fmla="*/ 101705 w 1101792"/>
+              <a:gd name="csY4" fmla="*/ 165382 h 1501201"/>
+              <a:gd name="csX5" fmla="*/ 165382 w 1101792"/>
+              <a:gd name="csY5" fmla="*/ 101705 h 1501201"/>
+              <a:gd name="csX6" fmla="*/ 936410 w 1101792"/>
+              <a:gd name="csY6" fmla="*/ 101705 h 1501201"/>
+              <a:gd name="csX7" fmla="*/ 1000087 w 1101792"/>
+              <a:gd name="csY7" fmla="*/ 165382 h 1501201"/>
+              <a:gd name="csX8" fmla="*/ 1000087 w 1101792"/>
+              <a:gd name="csY8" fmla="*/ 684062 h 1501201"/>
+              <a:gd name="csX9" fmla="*/ 1000087 w 1101792"/>
+              <a:gd name="csY9" fmla="*/ 817139 h 1501201"/>
+              <a:gd name="csX10" fmla="*/ 1000087 w 1101792"/>
+              <a:gd name="csY10" fmla="*/ 1335819 h 1501201"/>
+              <a:gd name="csX11" fmla="*/ 936410 w 1101792"/>
+              <a:gd name="csY11" fmla="*/ 1399496 h 1501201"/>
+              <a:gd name="csX12" fmla="*/ 69336 w 1101792"/>
+              <a:gd name="csY12" fmla="*/ 1501201 h 1501201"/>
+              <a:gd name="csX13" fmla="*/ 1032456 w 1101792"/>
+              <a:gd name="csY13" fmla="*/ 1501201 h 1501201"/>
+              <a:gd name="csX14" fmla="*/ 1101792 w 1101792"/>
+              <a:gd name="csY14" fmla="*/ 1431865 h 1501201"/>
+              <a:gd name="csX15" fmla="*/ 1101792 w 1101792"/>
+              <a:gd name="csY15" fmla="*/ 817139 h 1501201"/>
+              <a:gd name="csX16" fmla="*/ 1101792 w 1101792"/>
+              <a:gd name="csY16" fmla="*/ 684062 h 1501201"/>
+              <a:gd name="csX17" fmla="*/ 1101792 w 1101792"/>
+              <a:gd name="csY17" fmla="*/ 69336 h 1501201"/>
+              <a:gd name="csX18" fmla="*/ 1032456 w 1101792"/>
+              <a:gd name="csY18" fmla="*/ 0 h 1501201"/>
+              <a:gd name="csX19" fmla="*/ 69336 w 1101792"/>
+              <a:gd name="csY19" fmla="*/ 0 h 1501201"/>
+              <a:gd name="csX20" fmla="*/ 0 w 1101792"/>
+              <a:gd name="csY20" fmla="*/ 69336 h 1501201"/>
+              <a:gd name="csX21" fmla="*/ 0 w 1101792"/>
+              <a:gd name="csY21" fmla="*/ 684062 h 1501201"/>
+              <a:gd name="csX22" fmla="*/ 0 w 1101792"/>
+              <a:gd name="csY22" fmla="*/ 817139 h 1501201"/>
+              <a:gd name="csX23" fmla="*/ 0 w 1101792"/>
+              <a:gd name="csY23" fmla="*/ 1431865 h 1501201"/>
+              <a:gd name="csX24" fmla="*/ 69336 w 1101792"/>
+              <a:gd name="csY24" fmla="*/ 1501201 h 1501201"/>
+              <a:gd name="csX0" fmla="*/ 165382 w 1101792"/>
+              <a:gd name="csY0" fmla="*/ 1399496 h 1501201"/>
+              <a:gd name="csX1" fmla="*/ 101705 w 1101792"/>
+              <a:gd name="csY1" fmla="*/ 1335819 h 1501201"/>
+              <a:gd name="csX2" fmla="*/ 101705 w 1101792"/>
+              <a:gd name="csY2" fmla="*/ 684062 h 1501201"/>
+              <a:gd name="csX3" fmla="*/ 101705 w 1101792"/>
+              <a:gd name="csY3" fmla="*/ 165382 h 1501201"/>
+              <a:gd name="csX4" fmla="*/ 165382 w 1101792"/>
+              <a:gd name="csY4" fmla="*/ 101705 h 1501201"/>
+              <a:gd name="csX5" fmla="*/ 936410 w 1101792"/>
+              <a:gd name="csY5" fmla="*/ 101705 h 1501201"/>
+              <a:gd name="csX6" fmla="*/ 1000087 w 1101792"/>
+              <a:gd name="csY6" fmla="*/ 165382 h 1501201"/>
+              <a:gd name="csX7" fmla="*/ 1000087 w 1101792"/>
+              <a:gd name="csY7" fmla="*/ 684062 h 1501201"/>
+              <a:gd name="csX8" fmla="*/ 1000087 w 1101792"/>
+              <a:gd name="csY8" fmla="*/ 817139 h 1501201"/>
+              <a:gd name="csX9" fmla="*/ 1000087 w 1101792"/>
+              <a:gd name="csY9" fmla="*/ 1335819 h 1501201"/>
+              <a:gd name="csX10" fmla="*/ 936410 w 1101792"/>
+              <a:gd name="csY10" fmla="*/ 1399496 h 1501201"/>
+              <a:gd name="csX11" fmla="*/ 165382 w 1101792"/>
+              <a:gd name="csY11" fmla="*/ 1399496 h 1501201"/>
+              <a:gd name="csX12" fmla="*/ 69336 w 1101792"/>
+              <a:gd name="csY12" fmla="*/ 1501201 h 1501201"/>
+              <a:gd name="csX13" fmla="*/ 1032456 w 1101792"/>
+              <a:gd name="csY13" fmla="*/ 1501201 h 1501201"/>
+              <a:gd name="csX14" fmla="*/ 1101792 w 1101792"/>
+              <a:gd name="csY14" fmla="*/ 1431865 h 1501201"/>
+              <a:gd name="csX15" fmla="*/ 1101792 w 1101792"/>
+              <a:gd name="csY15" fmla="*/ 817139 h 1501201"/>
+              <a:gd name="csX16" fmla="*/ 1101792 w 1101792"/>
+              <a:gd name="csY16" fmla="*/ 684062 h 1501201"/>
+              <a:gd name="csX17" fmla="*/ 1101792 w 1101792"/>
+              <a:gd name="csY17" fmla="*/ 69336 h 1501201"/>
+              <a:gd name="csX18" fmla="*/ 1032456 w 1101792"/>
+              <a:gd name="csY18" fmla="*/ 0 h 1501201"/>
+              <a:gd name="csX19" fmla="*/ 69336 w 1101792"/>
+              <a:gd name="csY19" fmla="*/ 0 h 1501201"/>
+              <a:gd name="csX20" fmla="*/ 0 w 1101792"/>
+              <a:gd name="csY20" fmla="*/ 69336 h 1501201"/>
+              <a:gd name="csX21" fmla="*/ 0 w 1101792"/>
+              <a:gd name="csY21" fmla="*/ 684062 h 1501201"/>
+              <a:gd name="csX22" fmla="*/ 0 w 1101792"/>
+              <a:gd name="csY22" fmla="*/ 817139 h 1501201"/>
+              <a:gd name="csX23" fmla="*/ 0 w 1101792"/>
+              <a:gd name="csY23" fmla="*/ 1431865 h 1501201"/>
+              <a:gd name="csX24" fmla="*/ 69336 w 1101792"/>
+              <a:gd name="csY24" fmla="*/ 1501201 h 1501201"/>
+              <a:gd name="csX0" fmla="*/ 165382 w 1101792"/>
+              <a:gd name="csY0" fmla="*/ 1399496 h 1501201"/>
+              <a:gd name="csX1" fmla="*/ 101705 w 1101792"/>
+              <a:gd name="csY1" fmla="*/ 1335819 h 1501201"/>
+              <a:gd name="csX2" fmla="*/ 101705 w 1101792"/>
+              <a:gd name="csY2" fmla="*/ 165382 h 1501201"/>
+              <a:gd name="csX3" fmla="*/ 165382 w 1101792"/>
+              <a:gd name="csY3" fmla="*/ 101705 h 1501201"/>
+              <a:gd name="csX4" fmla="*/ 936410 w 1101792"/>
+              <a:gd name="csY4" fmla="*/ 101705 h 1501201"/>
+              <a:gd name="csX5" fmla="*/ 1000087 w 1101792"/>
+              <a:gd name="csY5" fmla="*/ 165382 h 1501201"/>
+              <a:gd name="csX6" fmla="*/ 1000087 w 1101792"/>
+              <a:gd name="csY6" fmla="*/ 684062 h 1501201"/>
+              <a:gd name="csX7" fmla="*/ 1000087 w 1101792"/>
+              <a:gd name="csY7" fmla="*/ 817139 h 1501201"/>
+              <a:gd name="csX8" fmla="*/ 1000087 w 1101792"/>
+              <a:gd name="csY8" fmla="*/ 1335819 h 1501201"/>
+              <a:gd name="csX9" fmla="*/ 936410 w 1101792"/>
+              <a:gd name="csY9" fmla="*/ 1399496 h 1501201"/>
+              <a:gd name="csX10" fmla="*/ 165382 w 1101792"/>
+              <a:gd name="csY10" fmla="*/ 1399496 h 1501201"/>
+              <a:gd name="csX11" fmla="*/ 69336 w 1101792"/>
+              <a:gd name="csY11" fmla="*/ 1501201 h 1501201"/>
+              <a:gd name="csX12" fmla="*/ 1032456 w 1101792"/>
+              <a:gd name="csY12" fmla="*/ 1501201 h 1501201"/>
+              <a:gd name="csX13" fmla="*/ 1101792 w 1101792"/>
+              <a:gd name="csY13" fmla="*/ 1431865 h 1501201"/>
+              <a:gd name="csX14" fmla="*/ 1101792 w 1101792"/>
+              <a:gd name="csY14" fmla="*/ 817139 h 1501201"/>
+              <a:gd name="csX15" fmla="*/ 1101792 w 1101792"/>
+              <a:gd name="csY15" fmla="*/ 684062 h 1501201"/>
+              <a:gd name="csX16" fmla="*/ 1101792 w 1101792"/>
+              <a:gd name="csY16" fmla="*/ 69336 h 1501201"/>
+              <a:gd name="csX17" fmla="*/ 1032456 w 1101792"/>
+              <a:gd name="csY17" fmla="*/ 0 h 1501201"/>
+              <a:gd name="csX18" fmla="*/ 69336 w 1101792"/>
+              <a:gd name="csY18" fmla="*/ 0 h 1501201"/>
+              <a:gd name="csX19" fmla="*/ 0 w 1101792"/>
+              <a:gd name="csY19" fmla="*/ 69336 h 1501201"/>
+              <a:gd name="csX20" fmla="*/ 0 w 1101792"/>
+              <a:gd name="csY20" fmla="*/ 684062 h 1501201"/>
+              <a:gd name="csX21" fmla="*/ 0 w 1101792"/>
+              <a:gd name="csY21" fmla="*/ 817139 h 1501201"/>
+              <a:gd name="csX22" fmla="*/ 0 w 1101792"/>
+              <a:gd name="csY22" fmla="*/ 1431865 h 1501201"/>
+              <a:gd name="csX23" fmla="*/ 69336 w 1101792"/>
+              <a:gd name="csY23" fmla="*/ 1501201 h 1501201"/>
+              <a:gd name="csX0" fmla="*/ 165382 w 1101792"/>
+              <a:gd name="csY0" fmla="*/ 1399496 h 1501201"/>
+              <a:gd name="csX1" fmla="*/ 101705 w 1101792"/>
+              <a:gd name="csY1" fmla="*/ 1335819 h 1501201"/>
+              <a:gd name="csX2" fmla="*/ 101705 w 1101792"/>
+              <a:gd name="csY2" fmla="*/ 165382 h 1501201"/>
+              <a:gd name="csX3" fmla="*/ 165382 w 1101792"/>
+              <a:gd name="csY3" fmla="*/ 101705 h 1501201"/>
+              <a:gd name="csX4" fmla="*/ 936410 w 1101792"/>
+              <a:gd name="csY4" fmla="*/ 101705 h 1501201"/>
+              <a:gd name="csX5" fmla="*/ 1000087 w 1101792"/>
+              <a:gd name="csY5" fmla="*/ 165382 h 1501201"/>
+              <a:gd name="csX6" fmla="*/ 1000087 w 1101792"/>
+              <a:gd name="csY6" fmla="*/ 817139 h 1501201"/>
+              <a:gd name="csX7" fmla="*/ 1000087 w 1101792"/>
+              <a:gd name="csY7" fmla="*/ 1335819 h 1501201"/>
+              <a:gd name="csX8" fmla="*/ 936410 w 1101792"/>
+              <a:gd name="csY8" fmla="*/ 1399496 h 1501201"/>
+              <a:gd name="csX9" fmla="*/ 165382 w 1101792"/>
+              <a:gd name="csY9" fmla="*/ 1399496 h 1501201"/>
+              <a:gd name="csX10" fmla="*/ 69336 w 1101792"/>
+              <a:gd name="csY10" fmla="*/ 1501201 h 1501201"/>
+              <a:gd name="csX11" fmla="*/ 1032456 w 1101792"/>
+              <a:gd name="csY11" fmla="*/ 1501201 h 1501201"/>
+              <a:gd name="csX12" fmla="*/ 1101792 w 1101792"/>
+              <a:gd name="csY12" fmla="*/ 1431865 h 1501201"/>
+              <a:gd name="csX13" fmla="*/ 1101792 w 1101792"/>
+              <a:gd name="csY13" fmla="*/ 817139 h 1501201"/>
+              <a:gd name="csX14" fmla="*/ 1101792 w 1101792"/>
+              <a:gd name="csY14" fmla="*/ 684062 h 1501201"/>
+              <a:gd name="csX15" fmla="*/ 1101792 w 1101792"/>
+              <a:gd name="csY15" fmla="*/ 69336 h 1501201"/>
+              <a:gd name="csX16" fmla="*/ 1032456 w 1101792"/>
+              <a:gd name="csY16" fmla="*/ 0 h 1501201"/>
+              <a:gd name="csX17" fmla="*/ 69336 w 1101792"/>
+              <a:gd name="csY17" fmla="*/ 0 h 1501201"/>
+              <a:gd name="csX18" fmla="*/ 0 w 1101792"/>
+              <a:gd name="csY18" fmla="*/ 69336 h 1501201"/>
+              <a:gd name="csX19" fmla="*/ 0 w 1101792"/>
+              <a:gd name="csY19" fmla="*/ 684062 h 1501201"/>
+              <a:gd name="csX20" fmla="*/ 0 w 1101792"/>
+              <a:gd name="csY20" fmla="*/ 817139 h 1501201"/>
+              <a:gd name="csX21" fmla="*/ 0 w 1101792"/>
+              <a:gd name="csY21" fmla="*/ 1431865 h 1501201"/>
+              <a:gd name="csX22" fmla="*/ 69336 w 1101792"/>
+              <a:gd name="csY22" fmla="*/ 1501201 h 1501201"/>
+              <a:gd name="csX0" fmla="*/ 165382 w 1101792"/>
+              <a:gd name="csY0" fmla="*/ 1399496 h 1501201"/>
+              <a:gd name="csX1" fmla="*/ 101705 w 1101792"/>
+              <a:gd name="csY1" fmla="*/ 1335819 h 1501201"/>
+              <a:gd name="csX2" fmla="*/ 101705 w 1101792"/>
+              <a:gd name="csY2" fmla="*/ 165382 h 1501201"/>
+              <a:gd name="csX3" fmla="*/ 165382 w 1101792"/>
+              <a:gd name="csY3" fmla="*/ 101705 h 1501201"/>
+              <a:gd name="csX4" fmla="*/ 936410 w 1101792"/>
+              <a:gd name="csY4" fmla="*/ 101705 h 1501201"/>
+              <a:gd name="csX5" fmla="*/ 1000087 w 1101792"/>
+              <a:gd name="csY5" fmla="*/ 165382 h 1501201"/>
+              <a:gd name="csX6" fmla="*/ 1000087 w 1101792"/>
+              <a:gd name="csY6" fmla="*/ 1335819 h 1501201"/>
+              <a:gd name="csX7" fmla="*/ 936410 w 1101792"/>
+              <a:gd name="csY7" fmla="*/ 1399496 h 1501201"/>
+              <a:gd name="csX8" fmla="*/ 165382 w 1101792"/>
+              <a:gd name="csY8" fmla="*/ 1399496 h 1501201"/>
+              <a:gd name="csX9" fmla="*/ 69336 w 1101792"/>
+              <a:gd name="csY9" fmla="*/ 1501201 h 1501201"/>
+              <a:gd name="csX10" fmla="*/ 1032456 w 1101792"/>
+              <a:gd name="csY10" fmla="*/ 1501201 h 1501201"/>
+              <a:gd name="csX11" fmla="*/ 1101792 w 1101792"/>
+              <a:gd name="csY11" fmla="*/ 1431865 h 1501201"/>
+              <a:gd name="csX12" fmla="*/ 1101792 w 1101792"/>
+              <a:gd name="csY12" fmla="*/ 817139 h 1501201"/>
+              <a:gd name="csX13" fmla="*/ 1101792 w 1101792"/>
+              <a:gd name="csY13" fmla="*/ 684062 h 1501201"/>
+              <a:gd name="csX14" fmla="*/ 1101792 w 1101792"/>
+              <a:gd name="csY14" fmla="*/ 69336 h 1501201"/>
+              <a:gd name="csX15" fmla="*/ 1032456 w 1101792"/>
+              <a:gd name="csY15" fmla="*/ 0 h 1501201"/>
+              <a:gd name="csX16" fmla="*/ 69336 w 1101792"/>
+              <a:gd name="csY16" fmla="*/ 0 h 1501201"/>
+              <a:gd name="csX17" fmla="*/ 0 w 1101792"/>
+              <a:gd name="csY17" fmla="*/ 69336 h 1501201"/>
+              <a:gd name="csX18" fmla="*/ 0 w 1101792"/>
+              <a:gd name="csY18" fmla="*/ 684062 h 1501201"/>
+              <a:gd name="csX19" fmla="*/ 0 w 1101792"/>
+              <a:gd name="csY19" fmla="*/ 817139 h 1501201"/>
+              <a:gd name="csX20" fmla="*/ 0 w 1101792"/>
+              <a:gd name="csY20" fmla="*/ 1431865 h 1501201"/>
+              <a:gd name="csX21" fmla="*/ 69336 w 1101792"/>
+              <a:gd name="csY21" fmla="*/ 1501201 h 1501201"/>
+              <a:gd name="csX0" fmla="*/ 165382 w 1101792"/>
+              <a:gd name="csY0" fmla="*/ 1399496 h 1501201"/>
+              <a:gd name="csX1" fmla="*/ 101705 w 1101792"/>
+              <a:gd name="csY1" fmla="*/ 1335819 h 1501201"/>
+              <a:gd name="csX2" fmla="*/ 101705 w 1101792"/>
+              <a:gd name="csY2" fmla="*/ 165382 h 1501201"/>
+              <a:gd name="csX3" fmla="*/ 165382 w 1101792"/>
+              <a:gd name="csY3" fmla="*/ 101705 h 1501201"/>
+              <a:gd name="csX4" fmla="*/ 936410 w 1101792"/>
+              <a:gd name="csY4" fmla="*/ 101705 h 1501201"/>
+              <a:gd name="csX5" fmla="*/ 1000087 w 1101792"/>
+              <a:gd name="csY5" fmla="*/ 165382 h 1501201"/>
+              <a:gd name="csX6" fmla="*/ 1000087 w 1101792"/>
+              <a:gd name="csY6" fmla="*/ 1335819 h 1501201"/>
+              <a:gd name="csX7" fmla="*/ 936410 w 1101792"/>
+              <a:gd name="csY7" fmla="*/ 1399496 h 1501201"/>
+              <a:gd name="csX8" fmla="*/ 165382 w 1101792"/>
+              <a:gd name="csY8" fmla="*/ 1399496 h 1501201"/>
+              <a:gd name="csX9" fmla="*/ 69336 w 1101792"/>
+              <a:gd name="csY9" fmla="*/ 1501201 h 1501201"/>
+              <a:gd name="csX10" fmla="*/ 1032456 w 1101792"/>
+              <a:gd name="csY10" fmla="*/ 1501201 h 1501201"/>
+              <a:gd name="csX11" fmla="*/ 1101792 w 1101792"/>
+              <a:gd name="csY11" fmla="*/ 1431865 h 1501201"/>
+              <a:gd name="csX12" fmla="*/ 1101792 w 1101792"/>
+              <a:gd name="csY12" fmla="*/ 817139 h 1501201"/>
+              <a:gd name="csX13" fmla="*/ 1101792 w 1101792"/>
+              <a:gd name="csY13" fmla="*/ 69336 h 1501201"/>
+              <a:gd name="csX14" fmla="*/ 1032456 w 1101792"/>
+              <a:gd name="csY14" fmla="*/ 0 h 1501201"/>
+              <a:gd name="csX15" fmla="*/ 69336 w 1101792"/>
+              <a:gd name="csY15" fmla="*/ 0 h 1501201"/>
+              <a:gd name="csX16" fmla="*/ 0 w 1101792"/>
+              <a:gd name="csY16" fmla="*/ 69336 h 1501201"/>
+              <a:gd name="csX17" fmla="*/ 0 w 1101792"/>
+              <a:gd name="csY17" fmla="*/ 684062 h 1501201"/>
+              <a:gd name="csX18" fmla="*/ 0 w 1101792"/>
+              <a:gd name="csY18" fmla="*/ 817139 h 1501201"/>
+              <a:gd name="csX19" fmla="*/ 0 w 1101792"/>
+              <a:gd name="csY19" fmla="*/ 1431865 h 1501201"/>
+              <a:gd name="csX20" fmla="*/ 69336 w 1101792"/>
+              <a:gd name="csY20" fmla="*/ 1501201 h 1501201"/>
+              <a:gd name="csX0" fmla="*/ 165382 w 1101792"/>
+              <a:gd name="csY0" fmla="*/ 1399496 h 1501201"/>
+              <a:gd name="csX1" fmla="*/ 101705 w 1101792"/>
+              <a:gd name="csY1" fmla="*/ 1335819 h 1501201"/>
+              <a:gd name="csX2" fmla="*/ 101705 w 1101792"/>
+              <a:gd name="csY2" fmla="*/ 165382 h 1501201"/>
+              <a:gd name="csX3" fmla="*/ 165382 w 1101792"/>
+              <a:gd name="csY3" fmla="*/ 101705 h 1501201"/>
+              <a:gd name="csX4" fmla="*/ 936410 w 1101792"/>
+              <a:gd name="csY4" fmla="*/ 101705 h 1501201"/>
+              <a:gd name="csX5" fmla="*/ 1000087 w 1101792"/>
+              <a:gd name="csY5" fmla="*/ 165382 h 1501201"/>
+              <a:gd name="csX6" fmla="*/ 1000087 w 1101792"/>
+              <a:gd name="csY6" fmla="*/ 1335819 h 1501201"/>
+              <a:gd name="csX7" fmla="*/ 936410 w 1101792"/>
+              <a:gd name="csY7" fmla="*/ 1399496 h 1501201"/>
+              <a:gd name="csX8" fmla="*/ 165382 w 1101792"/>
+              <a:gd name="csY8" fmla="*/ 1399496 h 1501201"/>
+              <a:gd name="csX9" fmla="*/ 69336 w 1101792"/>
+              <a:gd name="csY9" fmla="*/ 1501201 h 1501201"/>
+              <a:gd name="csX10" fmla="*/ 1032456 w 1101792"/>
+              <a:gd name="csY10" fmla="*/ 1501201 h 1501201"/>
+              <a:gd name="csX11" fmla="*/ 1101792 w 1101792"/>
+              <a:gd name="csY11" fmla="*/ 1431865 h 1501201"/>
+              <a:gd name="csX12" fmla="*/ 1101792 w 1101792"/>
+              <a:gd name="csY12" fmla="*/ 69336 h 1501201"/>
+              <a:gd name="csX13" fmla="*/ 1032456 w 1101792"/>
+              <a:gd name="csY13" fmla="*/ 0 h 1501201"/>
+              <a:gd name="csX14" fmla="*/ 69336 w 1101792"/>
+              <a:gd name="csY14" fmla="*/ 0 h 1501201"/>
+              <a:gd name="csX15" fmla="*/ 0 w 1101792"/>
+              <a:gd name="csY15" fmla="*/ 69336 h 1501201"/>
+              <a:gd name="csX16" fmla="*/ 0 w 1101792"/>
+              <a:gd name="csY16" fmla="*/ 684062 h 1501201"/>
+              <a:gd name="csX17" fmla="*/ 0 w 1101792"/>
+              <a:gd name="csY17" fmla="*/ 817139 h 1501201"/>
+              <a:gd name="csX18" fmla="*/ 0 w 1101792"/>
+              <a:gd name="csY18" fmla="*/ 1431865 h 1501201"/>
+              <a:gd name="csX19" fmla="*/ 69336 w 1101792"/>
+              <a:gd name="csY19" fmla="*/ 1501201 h 1501201"/>
+              <a:gd name="csX0" fmla="*/ 165382 w 1101792"/>
+              <a:gd name="csY0" fmla="*/ 1399496 h 1501201"/>
+              <a:gd name="csX1" fmla="*/ 101705 w 1101792"/>
+              <a:gd name="csY1" fmla="*/ 1335819 h 1501201"/>
+              <a:gd name="csX2" fmla="*/ 101705 w 1101792"/>
+              <a:gd name="csY2" fmla="*/ 165382 h 1501201"/>
+              <a:gd name="csX3" fmla="*/ 165382 w 1101792"/>
+              <a:gd name="csY3" fmla="*/ 101705 h 1501201"/>
+              <a:gd name="csX4" fmla="*/ 936410 w 1101792"/>
+              <a:gd name="csY4" fmla="*/ 101705 h 1501201"/>
+              <a:gd name="csX5" fmla="*/ 1000087 w 1101792"/>
+              <a:gd name="csY5" fmla="*/ 165382 h 1501201"/>
+              <a:gd name="csX6" fmla="*/ 1000087 w 1101792"/>
+              <a:gd name="csY6" fmla="*/ 1335819 h 1501201"/>
+              <a:gd name="csX7" fmla="*/ 936410 w 1101792"/>
+              <a:gd name="csY7" fmla="*/ 1399496 h 1501201"/>
+              <a:gd name="csX8" fmla="*/ 165382 w 1101792"/>
+              <a:gd name="csY8" fmla="*/ 1399496 h 1501201"/>
+              <a:gd name="csX9" fmla="*/ 69336 w 1101792"/>
+              <a:gd name="csY9" fmla="*/ 1501201 h 1501201"/>
+              <a:gd name="csX10" fmla="*/ 1032456 w 1101792"/>
+              <a:gd name="csY10" fmla="*/ 1501201 h 1501201"/>
+              <a:gd name="csX11" fmla="*/ 1101792 w 1101792"/>
+              <a:gd name="csY11" fmla="*/ 1431865 h 1501201"/>
+              <a:gd name="csX12" fmla="*/ 1101792 w 1101792"/>
+              <a:gd name="csY12" fmla="*/ 69336 h 1501201"/>
+              <a:gd name="csX13" fmla="*/ 1032456 w 1101792"/>
+              <a:gd name="csY13" fmla="*/ 0 h 1501201"/>
+              <a:gd name="csX14" fmla="*/ 69336 w 1101792"/>
+              <a:gd name="csY14" fmla="*/ 0 h 1501201"/>
+              <a:gd name="csX15" fmla="*/ 0 w 1101792"/>
+              <a:gd name="csY15" fmla="*/ 69336 h 1501201"/>
+              <a:gd name="csX16" fmla="*/ 0 w 1101792"/>
+              <a:gd name="csY16" fmla="*/ 684062 h 1501201"/>
+              <a:gd name="csX17" fmla="*/ 0 w 1101792"/>
+              <a:gd name="csY17" fmla="*/ 1431865 h 1501201"/>
+              <a:gd name="csX18" fmla="*/ 69336 w 1101792"/>
+              <a:gd name="csY18" fmla="*/ 1501201 h 1501201"/>
+              <a:gd name="csX0" fmla="*/ 165382 w 1101792"/>
+              <a:gd name="csY0" fmla="*/ 1399496 h 1501201"/>
+              <a:gd name="csX1" fmla="*/ 101705 w 1101792"/>
+              <a:gd name="csY1" fmla="*/ 1335819 h 1501201"/>
+              <a:gd name="csX2" fmla="*/ 101705 w 1101792"/>
+              <a:gd name="csY2" fmla="*/ 165382 h 1501201"/>
+              <a:gd name="csX3" fmla="*/ 165382 w 1101792"/>
+              <a:gd name="csY3" fmla="*/ 101705 h 1501201"/>
+              <a:gd name="csX4" fmla="*/ 936410 w 1101792"/>
+              <a:gd name="csY4" fmla="*/ 101705 h 1501201"/>
+              <a:gd name="csX5" fmla="*/ 1000087 w 1101792"/>
+              <a:gd name="csY5" fmla="*/ 165382 h 1501201"/>
+              <a:gd name="csX6" fmla="*/ 1000087 w 1101792"/>
+              <a:gd name="csY6" fmla="*/ 1335819 h 1501201"/>
+              <a:gd name="csX7" fmla="*/ 936410 w 1101792"/>
+              <a:gd name="csY7" fmla="*/ 1399496 h 1501201"/>
+              <a:gd name="csX8" fmla="*/ 165382 w 1101792"/>
+              <a:gd name="csY8" fmla="*/ 1399496 h 1501201"/>
+              <a:gd name="csX9" fmla="*/ 69336 w 1101792"/>
+              <a:gd name="csY9" fmla="*/ 1501201 h 1501201"/>
+              <a:gd name="csX10" fmla="*/ 1032456 w 1101792"/>
+              <a:gd name="csY10" fmla="*/ 1501201 h 1501201"/>
+              <a:gd name="csX11" fmla="*/ 1101792 w 1101792"/>
+              <a:gd name="csY11" fmla="*/ 1431865 h 1501201"/>
+              <a:gd name="csX12" fmla="*/ 1101792 w 1101792"/>
+              <a:gd name="csY12" fmla="*/ 69336 h 1501201"/>
+              <a:gd name="csX13" fmla="*/ 1032456 w 1101792"/>
+              <a:gd name="csY13" fmla="*/ 0 h 1501201"/>
+              <a:gd name="csX14" fmla="*/ 69336 w 1101792"/>
+              <a:gd name="csY14" fmla="*/ 0 h 1501201"/>
+              <a:gd name="csX15" fmla="*/ 0 w 1101792"/>
+              <a:gd name="csY15" fmla="*/ 69336 h 1501201"/>
+              <a:gd name="csX16" fmla="*/ 0 w 1101792"/>
+              <a:gd name="csY16" fmla="*/ 1431865 h 1501201"/>
+              <a:gd name="csX17" fmla="*/ 69336 w 1101792"/>
+              <a:gd name="csY17" fmla="*/ 1501201 h 1501201"/>
+            </a:gdLst>
+            <a:ahLst/>
+            <a:cxnLst>
+              <a:cxn ang="0">
+                <a:pos x="csX0" y="csY0"/>
+              </a:cxn>
+              <a:cxn ang="0">
+                <a:pos x="csX1" y="csY1"/>
+              </a:cxn>
+              <a:cxn ang="0">
+                <a:pos x="csX2" y="csY2"/>
+              </a:cxn>
+              <a:cxn ang="0">
+                <a:pos x="csX3" y="csY3"/>
+              </a:cxn>
+              <a:cxn ang="0">
+                <a:pos x="csX4" y="csY4"/>
+              </a:cxn>
+              <a:cxn ang="0">
+                <a:pos x="csX5" y="csY5"/>
+              </a:cxn>
+              <a:cxn ang="0">
+                <a:pos x="csX6" y="csY6"/>
+              </a:cxn>
+              <a:cxn ang="0">
+                <a:pos x="csX7" y="csY7"/>
+              </a:cxn>
+              <a:cxn ang="0">
+                <a:pos x="csX8" y="csY8"/>
+              </a:cxn>
+              <a:cxn ang="0">
+                <a:pos x="csX9" y="csY9"/>
+              </a:cxn>
+              <a:cxn ang="0">
+                <a:pos x="csX10" y="csY10"/>
+              </a:cxn>
+              <a:cxn ang="0">
+                <a:pos x="csX11" y="csY11"/>
+              </a:cxn>
+              <a:cxn ang="0">
+                <a:pos x="csX12" y="csY12"/>
+              </a:cxn>
+              <a:cxn ang="0">
+                <a:pos x="csX13" y="csY13"/>
+              </a:cxn>
+              <a:cxn ang="0">
+                <a:pos x="csX14" y="csY14"/>
+              </a:cxn>
+              <a:cxn ang="0">
+                <a:pos x="csX15" y="csY15"/>
+              </a:cxn>
+              <a:cxn ang="0">
+                <a:pos x="csX16" y="csY16"/>
+              </a:cxn>
+              <a:cxn ang="0">
+                <a:pos x="csX17" y="csY17"/>
+              </a:cxn>
+            </a:cxnLst>
+            <a:rect l="l" t="t" r="r" b="b"/>
+            <a:pathLst>
+              <a:path w="1101792" h="1501201">
+                <a:moveTo>
+                  <a:pt x="165382" y="1399496"/>
+                </a:moveTo>
+                <a:cubicBezTo>
+                  <a:pt x="130214" y="1399496"/>
+                  <a:pt x="101705" y="1370987"/>
+                  <a:pt x="101705" y="1335819"/>
+                </a:cubicBezTo>
+                <a:lnTo>
+                  <a:pt x="101705" y="165382"/>
+                </a:lnTo>
+                <a:cubicBezTo>
+                  <a:pt x="101705" y="130214"/>
+                  <a:pt x="130214" y="101705"/>
+                  <a:pt x="165382" y="101705"/>
+                </a:cubicBezTo>
+                <a:lnTo>
+                  <a:pt x="936410" y="101705"/>
+                </a:lnTo>
+                <a:cubicBezTo>
+                  <a:pt x="971578" y="101705"/>
+                  <a:pt x="1000087" y="130214"/>
+                  <a:pt x="1000087" y="165382"/>
+                </a:cubicBezTo>
+                <a:lnTo>
+                  <a:pt x="1000087" y="1335819"/>
+                </a:lnTo>
+                <a:cubicBezTo>
+                  <a:pt x="1000087" y="1370987"/>
+                  <a:pt x="971578" y="1399496"/>
+                  <a:pt x="936410" y="1399496"/>
+                </a:cubicBezTo>
+                <a:lnTo>
+                  <a:pt x="165382" y="1399496"/>
+                </a:lnTo>
+                <a:close/>
+                <a:moveTo>
+                  <a:pt x="69336" y="1501201"/>
+                </a:moveTo>
+                <a:lnTo>
+                  <a:pt x="1032456" y="1501201"/>
+                </a:lnTo>
+                <a:cubicBezTo>
+                  <a:pt x="1070749" y="1501201"/>
+                  <a:pt x="1101792" y="1470158"/>
+                  <a:pt x="1101792" y="1431865"/>
+                </a:cubicBezTo>
+                <a:lnTo>
+                  <a:pt x="1101792" y="69336"/>
+                </a:lnTo>
+                <a:cubicBezTo>
+                  <a:pt x="1101792" y="31043"/>
+                  <a:pt x="1070749" y="0"/>
+                  <a:pt x="1032456" y="0"/>
+                </a:cubicBezTo>
+                <a:lnTo>
+                  <a:pt x="69336" y="0"/>
+                </a:lnTo>
+                <a:cubicBezTo>
+                  <a:pt x="31043" y="0"/>
+                  <a:pt x="0" y="31043"/>
+                  <a:pt x="0" y="69336"/>
+                </a:cubicBezTo>
+                <a:lnTo>
+                  <a:pt x="0" y="1431865"/>
+                </a:lnTo>
+                <a:cubicBezTo>
+                  <a:pt x="0" y="1470158"/>
+                  <a:pt x="31043" y="1501201"/>
+                  <a:pt x="69336" y="1501201"/>
+                </a:cubicBezTo>
+                <a:close/>
+              </a:path>
+            </a:pathLst>
+          </a:custGeom>
+          <a:solidFill>
+            <a:schemeClr val="tx1"/>
+          </a:solidFill>
+          <a:ln w="9525" cap="flat">
+            <a:noFill/>
+            <a:prstDash val="solid"/>
+            <a:miter/>
+          </a:ln>
+        </p:spPr>
+        <p:txBody>
+          <a:bodyPr wrap="square">
+            <a:noAutofit/>
+          </a:bodyPr>
+          <a:lstStyle/>
+          <a:p>
+            <a:endParaRPr lang="en-US">
+              <a:solidFill>
+                <a:schemeClr val="tx1"/>
+              </a:solidFill>
+            </a:endParaRPr>
+          </a:p>
+        </p:txBody>
+      </p:sp>
+      <p:sp>
+        <p:nvSpPr>
+          <p:cNvPr id="44" name="Freeform: Shape 43">
+            <a:extLst>
+              <a:ext uri="{FF2B5EF4-FFF2-40B4-BE49-F238E27FC236}">
+                <a16:creationId xmlns:a16="http://schemas.microsoft.com/office/drawing/2014/main" id="{2DA370E5-95A3-8B9C-B567-3CBDE8359A0F}"/>
+              </a:ext>
+            </a:extLst>
+          </p:cNvPr>
+          <p:cNvSpPr/>
+          <p:nvPr/>
+        </p:nvSpPr>
+        <p:spPr>
+          <a:xfrm flipV="1">
+            <a:off x="1580176" y="4211901"/>
+            <a:ext cx="1101792" cy="1501201"/>
+          </a:xfrm>
+          <a:custGeom>
+            <a:avLst/>
+            <a:gdLst>
+              <a:gd name="csX0" fmla="*/ 165382 w 1101792"/>
+              <a:gd name="csY0" fmla="*/ 1399496 h 1501201"/>
+              <a:gd name="csX1" fmla="*/ 101705 w 1101792"/>
+              <a:gd name="csY1" fmla="*/ 1335819 h 1501201"/>
+              <a:gd name="csX2" fmla="*/ 101705 w 1101792"/>
+              <a:gd name="csY2" fmla="*/ 817139 h 1501201"/>
+              <a:gd name="csX3" fmla="*/ 101705 w 1101792"/>
+              <a:gd name="csY3" fmla="*/ 684062 h 1501201"/>
+              <a:gd name="csX4" fmla="*/ 101705 w 1101792"/>
+              <a:gd name="csY4" fmla="*/ 165382 h 1501201"/>
+              <a:gd name="csX5" fmla="*/ 165382 w 1101792"/>
+              <a:gd name="csY5" fmla="*/ 101705 h 1501201"/>
+              <a:gd name="csX6" fmla="*/ 936410 w 1101792"/>
+              <a:gd name="csY6" fmla="*/ 101705 h 1501201"/>
+              <a:gd name="csX7" fmla="*/ 1000087 w 1101792"/>
+              <a:gd name="csY7" fmla="*/ 165382 h 1501201"/>
+              <a:gd name="csX8" fmla="*/ 1000087 w 1101792"/>
+              <a:gd name="csY8" fmla="*/ 684062 h 1501201"/>
+              <a:gd name="csX9" fmla="*/ 1000087 w 1101792"/>
+              <a:gd name="csY9" fmla="*/ 817139 h 1501201"/>
+              <a:gd name="csX10" fmla="*/ 1000087 w 1101792"/>
+              <a:gd name="csY10" fmla="*/ 1335819 h 1501201"/>
+              <a:gd name="csX11" fmla="*/ 936410 w 1101792"/>
+              <a:gd name="csY11" fmla="*/ 1399496 h 1501201"/>
+              <a:gd name="csX12" fmla="*/ 69336 w 1101792"/>
+              <a:gd name="csY12" fmla="*/ 1501201 h 1501201"/>
+              <a:gd name="csX13" fmla="*/ 1032456 w 1101792"/>
+              <a:gd name="csY13" fmla="*/ 1501201 h 1501201"/>
+              <a:gd name="csX14" fmla="*/ 1101792 w 1101792"/>
+              <a:gd name="csY14" fmla="*/ 1431865 h 1501201"/>
+              <a:gd name="csX15" fmla="*/ 1101792 w 1101792"/>
+              <a:gd name="csY15" fmla="*/ 817139 h 1501201"/>
+              <a:gd name="csX16" fmla="*/ 1101792 w 1101792"/>
+              <a:gd name="csY16" fmla="*/ 684062 h 1501201"/>
+              <a:gd name="csX17" fmla="*/ 1101792 w 1101792"/>
+              <a:gd name="csY17" fmla="*/ 69336 h 1501201"/>
+              <a:gd name="csX18" fmla="*/ 1032456 w 1101792"/>
+              <a:gd name="csY18" fmla="*/ 0 h 1501201"/>
+              <a:gd name="csX19" fmla="*/ 69336 w 1101792"/>
+              <a:gd name="csY19" fmla="*/ 0 h 1501201"/>
+              <a:gd name="csX20" fmla="*/ 0 w 1101792"/>
+              <a:gd name="csY20" fmla="*/ 69336 h 1501201"/>
+              <a:gd name="csX21" fmla="*/ 0 w 1101792"/>
+              <a:gd name="csY21" fmla="*/ 684062 h 1501201"/>
+              <a:gd name="csX22" fmla="*/ 0 w 1101792"/>
+              <a:gd name="csY22" fmla="*/ 817139 h 1501201"/>
+              <a:gd name="csX23" fmla="*/ 0 w 1101792"/>
+              <a:gd name="csY23" fmla="*/ 1431865 h 1501201"/>
+              <a:gd name="csX24" fmla="*/ 69336 w 1101792"/>
+              <a:gd name="csY24" fmla="*/ 1501201 h 1501201"/>
+              <a:gd name="csX0" fmla="*/ 165382 w 1101792"/>
+              <a:gd name="csY0" fmla="*/ 1399496 h 1501201"/>
+              <a:gd name="csX1" fmla="*/ 101705 w 1101792"/>
+              <a:gd name="csY1" fmla="*/ 1335819 h 1501201"/>
+              <a:gd name="csX2" fmla="*/ 101705 w 1101792"/>
+              <a:gd name="csY2" fmla="*/ 684062 h 1501201"/>
+              <a:gd name="csX3" fmla="*/ 101705 w 1101792"/>
+              <a:gd name="csY3" fmla="*/ 165382 h 1501201"/>
+              <a:gd name="csX4" fmla="*/ 165382 w 1101792"/>
+              <a:gd name="csY4" fmla="*/ 101705 h 1501201"/>
+              <a:gd name="csX5" fmla="*/ 936410 w 1101792"/>
+              <a:gd name="csY5" fmla="*/ 101705 h 1501201"/>
+              <a:gd name="csX6" fmla="*/ 1000087 w 1101792"/>
+              <a:gd name="csY6" fmla="*/ 165382 h 1501201"/>
+              <a:gd name="csX7" fmla="*/ 1000087 w 1101792"/>
+              <a:gd name="csY7" fmla="*/ 684062 h 1501201"/>
+              <a:gd name="csX8" fmla="*/ 1000087 w 1101792"/>
+              <a:gd name="csY8" fmla="*/ 817139 h 1501201"/>
+              <a:gd name="csX9" fmla="*/ 1000087 w 1101792"/>
+              <a:gd name="csY9" fmla="*/ 1335819 h 1501201"/>
+              <a:gd name="csX10" fmla="*/ 936410 w 1101792"/>
+              <a:gd name="csY10" fmla="*/ 1399496 h 1501201"/>
+              <a:gd name="csX11" fmla="*/ 165382 w 1101792"/>
+              <a:gd name="csY11" fmla="*/ 1399496 h 1501201"/>
+              <a:gd name="csX12" fmla="*/ 69336 w 1101792"/>
+              <a:gd name="csY12" fmla="*/ 1501201 h 1501201"/>
+              <a:gd name="csX13" fmla="*/ 1032456 w 1101792"/>
+              <a:gd name="csY13" fmla="*/ 1501201 h 1501201"/>
+              <a:gd name="csX14" fmla="*/ 1101792 w 1101792"/>
+              <a:gd name="csY14" fmla="*/ 1431865 h 1501201"/>
+              <a:gd name="csX15" fmla="*/ 1101792 w 1101792"/>
+              <a:gd name="csY15" fmla="*/ 817139 h 1501201"/>
+              <a:gd name="csX16" fmla="*/ 1101792 w 1101792"/>
+              <a:gd name="csY16" fmla="*/ 684062 h 1501201"/>
+              <a:gd name="csX17" fmla="*/ 1101792 w 1101792"/>
+              <a:gd name="csY17" fmla="*/ 69336 h 1501201"/>
+              <a:gd name="csX18" fmla="*/ 1032456 w 1101792"/>
+              <a:gd name="csY18" fmla="*/ 0 h 1501201"/>
+              <a:gd name="csX19" fmla="*/ 69336 w 1101792"/>
+              <a:gd name="csY19" fmla="*/ 0 h 1501201"/>
+              <a:gd name="csX20" fmla="*/ 0 w 1101792"/>
+              <a:gd name="csY20" fmla="*/ 69336 h 1501201"/>
+              <a:gd name="csX21" fmla="*/ 0 w 1101792"/>
+              <a:gd name="csY21" fmla="*/ 684062 h 1501201"/>
+              <a:gd name="csX22" fmla="*/ 0 w 1101792"/>
+              <a:gd name="csY22" fmla="*/ 817139 h 1501201"/>
+              <a:gd name="csX23" fmla="*/ 0 w 1101792"/>
+              <a:gd name="csY23" fmla="*/ 1431865 h 1501201"/>
+              <a:gd name="csX24" fmla="*/ 69336 w 1101792"/>
+              <a:gd name="csY24" fmla="*/ 1501201 h 1501201"/>
+              <a:gd name="csX0" fmla="*/ 165382 w 1101792"/>
+              <a:gd name="csY0" fmla="*/ 1399496 h 1501201"/>
+              <a:gd name="csX1" fmla="*/ 101705 w 1101792"/>
+              <a:gd name="csY1" fmla="*/ 1335819 h 1501201"/>
+              <a:gd name="csX2" fmla="*/ 101705 w 1101792"/>
+              <a:gd name="csY2" fmla="*/ 165382 h 1501201"/>
+              <a:gd name="csX3" fmla="*/ 165382 w 1101792"/>
+              <a:gd name="csY3" fmla="*/ 101705 h 1501201"/>
+              <a:gd name="csX4" fmla="*/ 936410 w 1101792"/>
+              <a:gd name="csY4" fmla="*/ 101705 h 1501201"/>
+              <a:gd name="csX5" fmla="*/ 1000087 w 1101792"/>
+              <a:gd name="csY5" fmla="*/ 165382 h 1501201"/>
+              <a:gd name="csX6" fmla="*/ 1000087 w 1101792"/>
+              <a:gd name="csY6" fmla="*/ 684062 h 1501201"/>
+              <a:gd name="csX7" fmla="*/ 1000087 w 1101792"/>
+              <a:gd name="csY7" fmla="*/ 817139 h 1501201"/>
+              <a:gd name="csX8" fmla="*/ 1000087 w 1101792"/>
+              <a:gd name="csY8" fmla="*/ 1335819 h 1501201"/>
+              <a:gd name="csX9" fmla="*/ 936410 w 1101792"/>
+              <a:gd name="csY9" fmla="*/ 1399496 h 1501201"/>
+              <a:gd name="csX10" fmla="*/ 165382 w 1101792"/>
+              <a:gd name="csY10" fmla="*/ 1399496 h 1501201"/>
+              <a:gd name="csX11" fmla="*/ 69336 w 1101792"/>
+              <a:gd name="csY11" fmla="*/ 1501201 h 1501201"/>
+              <a:gd name="csX12" fmla="*/ 1032456 w 1101792"/>
+              <a:gd name="csY12" fmla="*/ 1501201 h 1501201"/>
+              <a:gd name="csX13" fmla="*/ 1101792 w 1101792"/>
+              <a:gd name="csY13" fmla="*/ 1431865 h 1501201"/>
+              <a:gd name="csX14" fmla="*/ 1101792 w 1101792"/>
+              <a:gd name="csY14" fmla="*/ 817139 h 1501201"/>
+              <a:gd name="csX15" fmla="*/ 1101792 w 1101792"/>
+              <a:gd name="csY15" fmla="*/ 684062 h 1501201"/>
+              <a:gd name="csX16" fmla="*/ 1101792 w 1101792"/>
+              <a:gd name="csY16" fmla="*/ 69336 h 1501201"/>
+              <a:gd name="csX17" fmla="*/ 1032456 w 1101792"/>
+              <a:gd name="csY17" fmla="*/ 0 h 1501201"/>
+              <a:gd name="csX18" fmla="*/ 69336 w 1101792"/>
+              <a:gd name="csY18" fmla="*/ 0 h 1501201"/>
+              <a:gd name="csX19" fmla="*/ 0 w 1101792"/>
+              <a:gd name="csY19" fmla="*/ 69336 h 1501201"/>
+              <a:gd name="csX20" fmla="*/ 0 w 1101792"/>
+              <a:gd name="csY20" fmla="*/ 684062 h 1501201"/>
+              <a:gd name="csX21" fmla="*/ 0 w 1101792"/>
+              <a:gd name="csY21" fmla="*/ 817139 h 1501201"/>
+              <a:gd name="csX22" fmla="*/ 0 w 1101792"/>
+              <a:gd name="csY22" fmla="*/ 1431865 h 1501201"/>
+              <a:gd name="csX23" fmla="*/ 69336 w 1101792"/>
+              <a:gd name="csY23" fmla="*/ 1501201 h 1501201"/>
+              <a:gd name="csX0" fmla="*/ 165382 w 1101792"/>
+              <a:gd name="csY0" fmla="*/ 1399496 h 1501201"/>
+              <a:gd name="csX1" fmla="*/ 101705 w 1101792"/>
+              <a:gd name="csY1" fmla="*/ 1335819 h 1501201"/>
+              <a:gd name="csX2" fmla="*/ 101705 w 1101792"/>
+              <a:gd name="csY2" fmla="*/ 165382 h 1501201"/>
+              <a:gd name="csX3" fmla="*/ 165382 w 1101792"/>
+              <a:gd name="csY3" fmla="*/ 101705 h 1501201"/>
+              <a:gd name="csX4" fmla="*/ 936410 w 1101792"/>
+              <a:gd name="csY4" fmla="*/ 101705 h 1501201"/>
+              <a:gd name="csX5" fmla="*/ 1000087 w 1101792"/>
+              <a:gd name="csY5" fmla="*/ 165382 h 1501201"/>
+              <a:gd name="csX6" fmla="*/ 1000087 w 1101792"/>
+              <a:gd name="csY6" fmla="*/ 817139 h 1501201"/>
+              <a:gd name="csX7" fmla="*/ 1000087 w 1101792"/>
+              <a:gd name="csY7" fmla="*/ 1335819 h 1501201"/>
+              <a:gd name="csX8" fmla="*/ 936410 w 1101792"/>
+              <a:gd name="csY8" fmla="*/ 1399496 h 1501201"/>
+              <a:gd name="csX9" fmla="*/ 165382 w 1101792"/>
+              <a:gd name="csY9" fmla="*/ 1399496 h 1501201"/>
+              <a:gd name="csX10" fmla="*/ 69336 w 1101792"/>
+              <a:gd name="csY10" fmla="*/ 1501201 h 1501201"/>
+              <a:gd name="csX11" fmla="*/ 1032456 w 1101792"/>
+              <a:gd name="csY11" fmla="*/ 1501201 h 1501201"/>
+              <a:gd name="csX12" fmla="*/ 1101792 w 1101792"/>
+              <a:gd name="csY12" fmla="*/ 1431865 h 1501201"/>
+              <a:gd name="csX13" fmla="*/ 1101792 w 1101792"/>
+              <a:gd name="csY13" fmla="*/ 817139 h 1501201"/>
+              <a:gd name="csX14" fmla="*/ 1101792 w 1101792"/>
+              <a:gd name="csY14" fmla="*/ 684062 h 1501201"/>
+              <a:gd name="csX15" fmla="*/ 1101792 w 1101792"/>
+              <a:gd name="csY15" fmla="*/ 69336 h 1501201"/>
+              <a:gd name="csX16" fmla="*/ 1032456 w 1101792"/>
+              <a:gd name="csY16" fmla="*/ 0 h 1501201"/>
+              <a:gd name="csX17" fmla="*/ 69336 w 1101792"/>
+              <a:gd name="csY17" fmla="*/ 0 h 1501201"/>
+              <a:gd name="csX18" fmla="*/ 0 w 1101792"/>
+              <a:gd name="csY18" fmla="*/ 69336 h 1501201"/>
+              <a:gd name="csX19" fmla="*/ 0 w 1101792"/>
+              <a:gd name="csY19" fmla="*/ 684062 h 1501201"/>
+              <a:gd name="csX20" fmla="*/ 0 w 1101792"/>
+              <a:gd name="csY20" fmla="*/ 817139 h 1501201"/>
+              <a:gd name="csX21" fmla="*/ 0 w 1101792"/>
+              <a:gd name="csY21" fmla="*/ 1431865 h 1501201"/>
+              <a:gd name="csX22" fmla="*/ 69336 w 1101792"/>
+              <a:gd name="csY22" fmla="*/ 1501201 h 1501201"/>
+              <a:gd name="csX0" fmla="*/ 165382 w 1101792"/>
+              <a:gd name="csY0" fmla="*/ 1399496 h 1501201"/>
+              <a:gd name="csX1" fmla="*/ 101705 w 1101792"/>
+              <a:gd name="csY1" fmla="*/ 1335819 h 1501201"/>
+              <a:gd name="csX2" fmla="*/ 101705 w 1101792"/>
+              <a:gd name="csY2" fmla="*/ 165382 h 1501201"/>
+              <a:gd name="csX3" fmla="*/ 165382 w 1101792"/>
+              <a:gd name="csY3" fmla="*/ 101705 h 1501201"/>
+              <a:gd name="csX4" fmla="*/ 936410 w 1101792"/>
+              <a:gd name="csY4" fmla="*/ 101705 h 1501201"/>
+              <a:gd name="csX5" fmla="*/ 1000087 w 1101792"/>
+              <a:gd name="csY5" fmla="*/ 165382 h 1501201"/>
+              <a:gd name="csX6" fmla="*/ 1000087 w 1101792"/>
+              <a:gd name="csY6" fmla="*/ 1335819 h 1501201"/>
+              <a:gd name="csX7" fmla="*/ 936410 w 1101792"/>
+              <a:gd name="csY7" fmla="*/ 1399496 h 1501201"/>
+              <a:gd name="csX8" fmla="*/ 165382 w 1101792"/>
+              <a:gd name="csY8" fmla="*/ 1399496 h 1501201"/>
+              <a:gd name="csX9" fmla="*/ 69336 w 1101792"/>
+              <a:gd name="csY9" fmla="*/ 1501201 h 1501201"/>
+              <a:gd name="csX10" fmla="*/ 1032456 w 1101792"/>
+              <a:gd name="csY10" fmla="*/ 1501201 h 1501201"/>
+              <a:gd name="csX11" fmla="*/ 1101792 w 1101792"/>
+              <a:gd name="csY11" fmla="*/ 1431865 h 1501201"/>
+              <a:gd name="csX12" fmla="*/ 1101792 w 1101792"/>
+              <a:gd name="csY12" fmla="*/ 817139 h 1501201"/>
+              <a:gd name="csX13" fmla="*/ 1101792 w 1101792"/>
+              <a:gd name="csY13" fmla="*/ 684062 h 1501201"/>
+              <a:gd name="csX14" fmla="*/ 1101792 w 1101792"/>
+              <a:gd name="csY14" fmla="*/ 69336 h 1501201"/>
+              <a:gd name="csX15" fmla="*/ 1032456 w 1101792"/>
+              <a:gd name="csY15" fmla="*/ 0 h 1501201"/>
+              <a:gd name="csX16" fmla="*/ 69336 w 1101792"/>
+              <a:gd name="csY16" fmla="*/ 0 h 1501201"/>
+              <a:gd name="csX17" fmla="*/ 0 w 1101792"/>
+              <a:gd name="csY17" fmla="*/ 69336 h 1501201"/>
+              <a:gd name="csX18" fmla="*/ 0 w 1101792"/>
+              <a:gd name="csY18" fmla="*/ 684062 h 1501201"/>
+              <a:gd name="csX19" fmla="*/ 0 w 1101792"/>
+              <a:gd name="csY19" fmla="*/ 817139 h 1501201"/>
+              <a:gd name="csX20" fmla="*/ 0 w 1101792"/>
+              <a:gd name="csY20" fmla="*/ 1431865 h 1501201"/>
+              <a:gd name="csX21" fmla="*/ 69336 w 1101792"/>
+              <a:gd name="csY21" fmla="*/ 1501201 h 1501201"/>
+              <a:gd name="csX0" fmla="*/ 165382 w 1101792"/>
+              <a:gd name="csY0" fmla="*/ 1399496 h 1501201"/>
+              <a:gd name="csX1" fmla="*/ 101705 w 1101792"/>
+              <a:gd name="csY1" fmla="*/ 1335819 h 1501201"/>
+              <a:gd name="csX2" fmla="*/ 101705 w 1101792"/>
+              <a:gd name="csY2" fmla="*/ 165382 h 1501201"/>
+              <a:gd name="csX3" fmla="*/ 165382 w 1101792"/>
+              <a:gd name="csY3" fmla="*/ 101705 h 1501201"/>
+              <a:gd name="csX4" fmla="*/ 936410 w 1101792"/>
+              <a:gd name="csY4" fmla="*/ 101705 h 1501201"/>
+              <a:gd name="csX5" fmla="*/ 1000087 w 1101792"/>
+              <a:gd name="csY5" fmla="*/ 165382 h 1501201"/>
+              <a:gd name="csX6" fmla="*/ 1000087 w 1101792"/>
+              <a:gd name="csY6" fmla="*/ 1335819 h 1501201"/>
+              <a:gd name="csX7" fmla="*/ 936410 w 1101792"/>
+              <a:gd name="csY7" fmla="*/ 1399496 h 1501201"/>
+              <a:gd name="csX8" fmla="*/ 165382 w 1101792"/>
+              <a:gd name="csY8" fmla="*/ 1399496 h 1501201"/>
+              <a:gd name="csX9" fmla="*/ 69336 w 1101792"/>
+              <a:gd name="csY9" fmla="*/ 1501201 h 1501201"/>
+              <a:gd name="csX10" fmla="*/ 1032456 w 1101792"/>
+              <a:gd name="csY10" fmla="*/ 1501201 h 1501201"/>
+              <a:gd name="csX11" fmla="*/ 1101792 w 1101792"/>
+              <a:gd name="csY11" fmla="*/ 1431865 h 1501201"/>
+              <a:gd name="csX12" fmla="*/ 1101792 w 1101792"/>
+              <a:gd name="csY12" fmla="*/ 817139 h 1501201"/>
+              <a:gd name="csX13" fmla="*/ 1101792 w 1101792"/>
+              <a:gd name="csY13" fmla="*/ 69336 h 1501201"/>
+              <a:gd name="csX14" fmla="*/ 1032456 w 1101792"/>
+              <a:gd name="csY14" fmla="*/ 0 h 1501201"/>
+              <a:gd name="csX15" fmla="*/ 69336 w 1101792"/>
+              <a:gd name="csY15" fmla="*/ 0 h 1501201"/>
+              <a:gd name="csX16" fmla="*/ 0 w 1101792"/>
+              <a:gd name="csY16" fmla="*/ 69336 h 1501201"/>
+              <a:gd name="csX17" fmla="*/ 0 w 1101792"/>
+              <a:gd name="csY17" fmla="*/ 684062 h 1501201"/>
+              <a:gd name="csX18" fmla="*/ 0 w 1101792"/>
+              <a:gd name="csY18" fmla="*/ 817139 h 1501201"/>
+              <a:gd name="csX19" fmla="*/ 0 w 1101792"/>
+              <a:gd name="csY19" fmla="*/ 1431865 h 1501201"/>
+              <a:gd name="csX20" fmla="*/ 69336 w 1101792"/>
+              <a:gd name="csY20" fmla="*/ 1501201 h 1501201"/>
+              <a:gd name="csX0" fmla="*/ 165382 w 1101792"/>
+              <a:gd name="csY0" fmla="*/ 1399496 h 1501201"/>
+              <a:gd name="csX1" fmla="*/ 101705 w 1101792"/>
+              <a:gd name="csY1" fmla="*/ 1335819 h 1501201"/>
+              <a:gd name="csX2" fmla="*/ 101705 w 1101792"/>
+              <a:gd name="csY2" fmla="*/ 165382 h 1501201"/>
+              <a:gd name="csX3" fmla="*/ 165382 w 1101792"/>
+              <a:gd name="csY3" fmla="*/ 101705 h 1501201"/>
+              <a:gd name="csX4" fmla="*/ 936410 w 1101792"/>
+              <a:gd name="csY4" fmla="*/ 101705 h 1501201"/>
+              <a:gd name="csX5" fmla="*/ 1000087 w 1101792"/>
+              <a:gd name="csY5" fmla="*/ 165382 h 1501201"/>
+              <a:gd name="csX6" fmla="*/ 1000087 w 1101792"/>
+              <a:gd name="csY6" fmla="*/ 1335819 h 1501201"/>
+              <a:gd name="csX7" fmla="*/ 936410 w 1101792"/>
+              <a:gd name="csY7" fmla="*/ 1399496 h 1501201"/>
+              <a:gd name="csX8" fmla="*/ 165382 w 1101792"/>
+              <a:gd name="csY8" fmla="*/ 1399496 h 1501201"/>
+              <a:gd name="csX9" fmla="*/ 69336 w 1101792"/>
+              <a:gd name="csY9" fmla="*/ 1501201 h 1501201"/>
+              <a:gd name="csX10" fmla="*/ 1032456 w 1101792"/>
+              <a:gd name="csY10" fmla="*/ 1501201 h 1501201"/>
+              <a:gd name="csX11" fmla="*/ 1101792 w 1101792"/>
+              <a:gd name="csY11" fmla="*/ 1431865 h 1501201"/>
+              <a:gd name="csX12" fmla="*/ 1101792 w 1101792"/>
+              <a:gd name="csY12" fmla="*/ 69336 h 1501201"/>
+              <a:gd name="csX13" fmla="*/ 1032456 w 1101792"/>
+              <a:gd name="csY13" fmla="*/ 0 h 1501201"/>
+              <a:gd name="csX14" fmla="*/ 69336 w 1101792"/>
+              <a:gd name="csY14" fmla="*/ 0 h 1501201"/>
+              <a:gd name="csX15" fmla="*/ 0 w 1101792"/>
+              <a:gd name="csY15" fmla="*/ 69336 h 1501201"/>
+              <a:gd name="csX16" fmla="*/ 0 w 1101792"/>
+              <a:gd name="csY16" fmla="*/ 684062 h 1501201"/>
+              <a:gd name="csX17" fmla="*/ 0 w 1101792"/>
+              <a:gd name="csY17" fmla="*/ 817139 h 1501201"/>
+              <a:gd name="csX18" fmla="*/ 0 w 1101792"/>
+              <a:gd name="csY18" fmla="*/ 1431865 h 1501201"/>
+              <a:gd name="csX19" fmla="*/ 69336 w 1101792"/>
+              <a:gd name="csY19" fmla="*/ 1501201 h 1501201"/>
+              <a:gd name="csX0" fmla="*/ 165382 w 1101792"/>
+              <a:gd name="csY0" fmla="*/ 1399496 h 1501201"/>
+              <a:gd name="csX1" fmla="*/ 101705 w 1101792"/>
+              <a:gd name="csY1" fmla="*/ 1335819 h 1501201"/>
+              <a:gd name="csX2" fmla="*/ 101705 w 1101792"/>
+              <a:gd name="csY2" fmla="*/ 165382 h 1501201"/>
+              <a:gd name="csX3" fmla="*/ 165382 w 1101792"/>
+              <a:gd name="csY3" fmla="*/ 101705 h 1501201"/>
+              <a:gd name="csX4" fmla="*/ 936410 w 1101792"/>
+              <a:gd name="csY4" fmla="*/ 101705 h 1501201"/>
+              <a:gd name="csX5" fmla="*/ 1000087 w 1101792"/>
+              <a:gd name="csY5" fmla="*/ 165382 h 1501201"/>
+              <a:gd name="csX6" fmla="*/ 1000087 w 1101792"/>
+              <a:gd name="csY6" fmla="*/ 1335819 h 1501201"/>
+              <a:gd name="csX7" fmla="*/ 936410 w 1101792"/>
+              <a:gd name="csY7" fmla="*/ 1399496 h 1501201"/>
+              <a:gd name="csX8" fmla="*/ 165382 w 1101792"/>
+              <a:gd name="csY8" fmla="*/ 1399496 h 1501201"/>
+              <a:gd name="csX9" fmla="*/ 69336 w 1101792"/>
+              <a:gd name="csY9" fmla="*/ 1501201 h 1501201"/>
+              <a:gd name="csX10" fmla="*/ 1032456 w 1101792"/>
+              <a:gd name="csY10" fmla="*/ 1501201 h 1501201"/>
+              <a:gd name="csX11" fmla="*/ 1101792 w 1101792"/>
+              <a:gd name="csY11" fmla="*/ 1431865 h 1501201"/>
+              <a:gd name="csX12" fmla="*/ 1101792 w 1101792"/>
+              <a:gd name="csY12" fmla="*/ 69336 h 1501201"/>
+              <a:gd name="csX13" fmla="*/ 1032456 w 1101792"/>
+              <a:gd name="csY13" fmla="*/ 0 h 1501201"/>
+              <a:gd name="csX14" fmla="*/ 69336 w 1101792"/>
+              <a:gd name="csY14" fmla="*/ 0 h 1501201"/>
+              <a:gd name="csX15" fmla="*/ 0 w 1101792"/>
+              <a:gd name="csY15" fmla="*/ 69336 h 1501201"/>
+              <a:gd name="csX16" fmla="*/ 0 w 1101792"/>
+              <a:gd name="csY16" fmla="*/ 684062 h 1501201"/>
+              <a:gd name="csX17" fmla="*/ 0 w 1101792"/>
+              <a:gd name="csY17" fmla="*/ 1431865 h 1501201"/>
+              <a:gd name="csX18" fmla="*/ 69336 w 1101792"/>
+              <a:gd name="csY18" fmla="*/ 1501201 h 1501201"/>
+              <a:gd name="csX0" fmla="*/ 165382 w 1101792"/>
+              <a:gd name="csY0" fmla="*/ 1399496 h 1501201"/>
+              <a:gd name="csX1" fmla="*/ 101705 w 1101792"/>
+              <a:gd name="csY1" fmla="*/ 1335819 h 1501201"/>
+              <a:gd name="csX2" fmla="*/ 101705 w 1101792"/>
+              <a:gd name="csY2" fmla="*/ 165382 h 1501201"/>
+              <a:gd name="csX3" fmla="*/ 165382 w 1101792"/>
+              <a:gd name="csY3" fmla="*/ 101705 h 1501201"/>
+              <a:gd name="csX4" fmla="*/ 936410 w 1101792"/>
+              <a:gd name="csY4" fmla="*/ 101705 h 1501201"/>
+              <a:gd name="csX5" fmla="*/ 1000087 w 1101792"/>
+              <a:gd name="csY5" fmla="*/ 165382 h 1501201"/>
+              <a:gd name="csX6" fmla="*/ 1000087 w 1101792"/>
+              <a:gd name="csY6" fmla="*/ 1335819 h 1501201"/>
+              <a:gd name="csX7" fmla="*/ 936410 w 1101792"/>
+              <a:gd name="csY7" fmla="*/ 1399496 h 1501201"/>
+              <a:gd name="csX8" fmla="*/ 165382 w 1101792"/>
+              <a:gd name="csY8" fmla="*/ 1399496 h 1501201"/>
+              <a:gd name="csX9" fmla="*/ 69336 w 1101792"/>
+              <a:gd name="csY9" fmla="*/ 1501201 h 1501201"/>
+              <a:gd name="csX10" fmla="*/ 1032456 w 1101792"/>
+              <a:gd name="csY10" fmla="*/ 1501201 h 1501201"/>
+              <a:gd name="csX11" fmla="*/ 1101792 w 1101792"/>
+              <a:gd name="csY11" fmla="*/ 1431865 h 1501201"/>
+              <a:gd name="csX12" fmla="*/ 1101792 w 1101792"/>
+              <a:gd name="csY12" fmla="*/ 69336 h 1501201"/>
+              <a:gd name="csX13" fmla="*/ 1032456 w 1101792"/>
+              <a:gd name="csY13" fmla="*/ 0 h 1501201"/>
+              <a:gd name="csX14" fmla="*/ 69336 w 1101792"/>
+              <a:gd name="csY14" fmla="*/ 0 h 1501201"/>
+              <a:gd name="csX15" fmla="*/ 0 w 1101792"/>
+              <a:gd name="csY15" fmla="*/ 69336 h 1501201"/>
+              <a:gd name="csX16" fmla="*/ 0 w 1101792"/>
+              <a:gd name="csY16" fmla="*/ 1431865 h 1501201"/>
+              <a:gd name="csX17" fmla="*/ 69336 w 1101792"/>
+              <a:gd name="csY17" fmla="*/ 1501201 h 1501201"/>
+            </a:gdLst>
+            <a:ahLst/>
+            <a:cxnLst>
+              <a:cxn ang="0">
+                <a:pos x="csX0" y="csY0"/>
+              </a:cxn>
+              <a:cxn ang="0">
+                <a:pos x="csX1" y="csY1"/>
+              </a:cxn>
+              <a:cxn ang="0">
+                <a:pos x="csX2" y="csY2"/>
+              </a:cxn>
+              <a:cxn ang="0">
+                <a:pos x="csX3" y="csY3"/>
+              </a:cxn>
+              <a:cxn ang="0">
+                <a:pos x="csX4" y="csY4"/>
+              </a:cxn>
+              <a:cxn ang="0">
+                <a:pos x="csX5" y="csY5"/>
+              </a:cxn>
+              <a:cxn ang="0">
+                <a:pos x="csX6" y="csY6"/>
+              </a:cxn>
+              <a:cxn ang="0">
+                <a:pos x="csX7" y="csY7"/>
+              </a:cxn>
+              <a:cxn ang="0">
+                <a:pos x="csX8" y="csY8"/>
+              </a:cxn>
+              <a:cxn ang="0">
+                <a:pos x="csX9" y="csY9"/>
+              </a:cxn>
+              <a:cxn ang="0">
+                <a:pos x="csX10" y="csY10"/>
+              </a:cxn>
+              <a:cxn ang="0">
+                <a:pos x="csX11" y="csY11"/>
+              </a:cxn>
+              <a:cxn ang="0">
+                <a:pos x="csX12" y="csY12"/>
+              </a:cxn>
+              <a:cxn ang="0">
+                <a:pos x="csX13" y="csY13"/>
+              </a:cxn>
+              <a:cxn ang="0">
+                <a:pos x="csX14" y="csY14"/>
+              </a:cxn>
+              <a:cxn ang="0">
+                <a:pos x="csX15" y="csY15"/>
+              </a:cxn>
+              <a:cxn ang="0">
+                <a:pos x="csX16" y="csY16"/>
+              </a:cxn>
+              <a:cxn ang="0">
+                <a:pos x="csX17" y="csY17"/>
+              </a:cxn>
+            </a:cxnLst>
+            <a:rect l="l" t="t" r="r" b="b"/>
+            <a:pathLst>
+              <a:path w="1101792" h="1501201">
+                <a:moveTo>
+                  <a:pt x="165382" y="1399496"/>
+                </a:moveTo>
+                <a:cubicBezTo>
+                  <a:pt x="130214" y="1399496"/>
+                  <a:pt x="101705" y="1370987"/>
+                  <a:pt x="101705" y="1335819"/>
+                </a:cubicBezTo>
+                <a:lnTo>
+                  <a:pt x="101705" y="165382"/>
+                </a:lnTo>
+                <a:cubicBezTo>
+                  <a:pt x="101705" y="130214"/>
+                  <a:pt x="130214" y="101705"/>
+                  <a:pt x="165382" y="101705"/>
+                </a:cubicBezTo>
+                <a:lnTo>
+                  <a:pt x="936410" y="101705"/>
+                </a:lnTo>
+                <a:cubicBezTo>
+                  <a:pt x="971578" y="101705"/>
+                  <a:pt x="1000087" y="130214"/>
+                  <a:pt x="1000087" y="165382"/>
+                </a:cubicBezTo>
+                <a:lnTo>
+                  <a:pt x="1000087" y="1335819"/>
+                </a:lnTo>
+                <a:cubicBezTo>
+                  <a:pt x="1000087" y="1370987"/>
+                  <a:pt x="971578" y="1399496"/>
+                  <a:pt x="936410" y="1399496"/>
+                </a:cubicBezTo>
+                <a:lnTo>
+                  <a:pt x="165382" y="1399496"/>
+                </a:lnTo>
+                <a:close/>
+                <a:moveTo>
+                  <a:pt x="69336" y="1501201"/>
+                </a:moveTo>
+                <a:lnTo>
+                  <a:pt x="1032456" y="1501201"/>
+                </a:lnTo>
+                <a:cubicBezTo>
+                  <a:pt x="1070749" y="1501201"/>
+                  <a:pt x="1101792" y="1470158"/>
+                  <a:pt x="1101792" y="1431865"/>
+                </a:cubicBezTo>
+                <a:lnTo>
+                  <a:pt x="1101792" y="69336"/>
+                </a:lnTo>
+                <a:cubicBezTo>
+                  <a:pt x="1101792" y="31043"/>
+                  <a:pt x="1070749" y="0"/>
+                  <a:pt x="1032456" y="0"/>
+                </a:cubicBezTo>
+                <a:lnTo>
+                  <a:pt x="69336" y="0"/>
+                </a:lnTo>
+                <a:cubicBezTo>
+                  <a:pt x="31043" y="0"/>
+                  <a:pt x="0" y="31043"/>
+                  <a:pt x="0" y="69336"/>
+                </a:cubicBezTo>
+                <a:lnTo>
+                  <a:pt x="0" y="1431865"/>
+                </a:lnTo>
+                <a:cubicBezTo>
+                  <a:pt x="0" y="1470158"/>
+                  <a:pt x="31043" y="1501201"/>
+                  <a:pt x="69336" y="1501201"/>
+                </a:cubicBezTo>
+                <a:close/>
+              </a:path>
+            </a:pathLst>
+          </a:custGeom>
+          <a:solidFill>
+            <a:schemeClr val="tx1"/>
+          </a:solidFill>
+          <a:ln w="9525" cap="flat">
+            <a:noFill/>
+            <a:prstDash val="solid"/>
+            <a:miter/>
+          </a:ln>
+        </p:spPr>
+        <p:txBody>
+          <a:bodyPr wrap="square">
+            <a:noAutofit/>
+          </a:bodyPr>
+          <a:lstStyle/>
+          <a:p>
+            <a:endParaRPr lang="en-US">
+              <a:solidFill>
+                <a:schemeClr val="tx1"/>
+              </a:solidFill>
+            </a:endParaRPr>
+          </a:p>
+        </p:txBody>
+      </p:sp>
+      <p:sp>
+        <p:nvSpPr>
+          <p:cNvPr id="59" name="Freeform: Shape 58">
+            <a:extLst>
+              <a:ext uri="{FF2B5EF4-FFF2-40B4-BE49-F238E27FC236}">
+                <a16:creationId xmlns:a16="http://schemas.microsoft.com/office/drawing/2014/main" id="{0135BCCE-790E-71A7-E46A-3B8CC0049B5A}"/>
+              </a:ext>
+            </a:extLst>
+          </p:cNvPr>
+          <p:cNvSpPr/>
+          <p:nvPr/>
+        </p:nvSpPr>
+        <p:spPr>
+          <a:xfrm>
+            <a:off x="5319134" y="4211901"/>
+            <a:ext cx="2962440" cy="1501201"/>
+          </a:xfrm>
+          <a:custGeom>
+            <a:avLst/>
+            <a:gdLst>
+              <a:gd name="csX0" fmla="*/ 165382 w 2962440"/>
+              <a:gd name="csY0" fmla="*/ 101705 h 1501201"/>
+              <a:gd name="csX1" fmla="*/ 101705 w 2962440"/>
+              <a:gd name="csY1" fmla="*/ 165382 h 1501201"/>
+              <a:gd name="csX2" fmla="*/ 101705 w 2962440"/>
+              <a:gd name="csY2" fmla="*/ 1335819 h 1501201"/>
+              <a:gd name="csX3" fmla="*/ 165382 w 2962440"/>
+              <a:gd name="csY3" fmla="*/ 1399496 h 1501201"/>
+              <a:gd name="csX4" fmla="*/ 575299 w 2962440"/>
+              <a:gd name="csY4" fmla="*/ 1399496 h 1501201"/>
+              <a:gd name="csX5" fmla="*/ 575299 w 2962440"/>
+              <a:gd name="csY5" fmla="*/ 1394368 h 1501201"/>
+              <a:gd name="csX6" fmla="*/ 605497 w 2962440"/>
+              <a:gd name="csY6" fmla="*/ 1399496 h 1501201"/>
+              <a:gd name="csX7" fmla="*/ 861858 w 2962440"/>
+              <a:gd name="csY7" fmla="*/ 1399496 h 1501201"/>
+              <a:gd name="csX8" fmla="*/ 2163120 w 2962440"/>
+              <a:gd name="csY8" fmla="*/ 1399496 h 1501201"/>
+              <a:gd name="csX9" fmla="*/ 2339299 w 2962440"/>
+              <a:gd name="csY9" fmla="*/ 1399496 h 1501201"/>
+              <a:gd name="csX10" fmla="*/ 2797058 w 2962440"/>
+              <a:gd name="csY10" fmla="*/ 1399496 h 1501201"/>
+              <a:gd name="csX11" fmla="*/ 2860735 w 2962440"/>
+              <a:gd name="csY11" fmla="*/ 1335819 h 1501201"/>
+              <a:gd name="csX12" fmla="*/ 2860735 w 2962440"/>
+              <a:gd name="csY12" fmla="*/ 165382 h 1501201"/>
+              <a:gd name="csX13" fmla="*/ 2797058 w 2962440"/>
+              <a:gd name="csY13" fmla="*/ 101705 h 1501201"/>
+              <a:gd name="csX14" fmla="*/ 2339299 w 2962440"/>
+              <a:gd name="csY14" fmla="*/ 101705 h 1501201"/>
+              <a:gd name="csX15" fmla="*/ 2163120 w 2962440"/>
+              <a:gd name="csY15" fmla="*/ 101705 h 1501201"/>
+              <a:gd name="csX16" fmla="*/ 861858 w 2962440"/>
+              <a:gd name="csY16" fmla="*/ 101705 h 1501201"/>
+              <a:gd name="csX17" fmla="*/ 605497 w 2962440"/>
+              <a:gd name="csY17" fmla="*/ 101705 h 1501201"/>
+              <a:gd name="csX18" fmla="*/ 575299 w 2962440"/>
+              <a:gd name="csY18" fmla="*/ 106833 h 1501201"/>
+              <a:gd name="csX19" fmla="*/ 575299 w 2962440"/>
+              <a:gd name="csY19" fmla="*/ 101705 h 1501201"/>
+              <a:gd name="csX20" fmla="*/ 69336 w 2962440"/>
+              <a:gd name="csY20" fmla="*/ 0 h 1501201"/>
+              <a:gd name="csX21" fmla="*/ 575299 w 2962440"/>
+              <a:gd name="csY21" fmla="*/ 0 h 1501201"/>
+              <a:gd name="csX22" fmla="*/ 861858 w 2962440"/>
+              <a:gd name="csY22" fmla="*/ 0 h 1501201"/>
+              <a:gd name="csX23" fmla="*/ 2163120 w 2962440"/>
+              <a:gd name="csY23" fmla="*/ 0 h 1501201"/>
+              <a:gd name="csX24" fmla="*/ 2339299 w 2962440"/>
+              <a:gd name="csY24" fmla="*/ 0 h 1501201"/>
+              <a:gd name="csX25" fmla="*/ 2893104 w 2962440"/>
+              <a:gd name="csY25" fmla="*/ 0 h 1501201"/>
+              <a:gd name="csX26" fmla="*/ 2962440 w 2962440"/>
+              <a:gd name="csY26" fmla="*/ 69336 h 1501201"/>
+              <a:gd name="csX27" fmla="*/ 2962440 w 2962440"/>
+              <a:gd name="csY27" fmla="*/ 1431865 h 1501201"/>
+              <a:gd name="csX28" fmla="*/ 2893104 w 2962440"/>
+              <a:gd name="csY28" fmla="*/ 1501201 h 1501201"/>
+              <a:gd name="csX29" fmla="*/ 2339299 w 2962440"/>
+              <a:gd name="csY29" fmla="*/ 1501201 h 1501201"/>
+              <a:gd name="csX30" fmla="*/ 2163120 w 2962440"/>
+              <a:gd name="csY30" fmla="*/ 1501201 h 1501201"/>
+              <a:gd name="csX31" fmla="*/ 861858 w 2962440"/>
+              <a:gd name="csY31" fmla="*/ 1501201 h 1501201"/>
+              <a:gd name="csX32" fmla="*/ 575299 w 2962440"/>
+              <a:gd name="csY32" fmla="*/ 1501201 h 1501201"/>
+              <a:gd name="csX33" fmla="*/ 69336 w 2962440"/>
+              <a:gd name="csY33" fmla="*/ 1501201 h 1501201"/>
+              <a:gd name="csX34" fmla="*/ 0 w 2962440"/>
+              <a:gd name="csY34" fmla="*/ 1431865 h 1501201"/>
+              <a:gd name="csX35" fmla="*/ 0 w 2962440"/>
+              <a:gd name="csY35" fmla="*/ 69336 h 1501201"/>
+              <a:gd name="csX36" fmla="*/ 69336 w 2962440"/>
+              <a:gd name="csY36" fmla="*/ 0 h 1501201"/>
+              <a:gd name="csX0" fmla="*/ 165382 w 2962440"/>
+              <a:gd name="csY0" fmla="*/ 101705 h 1501201"/>
+              <a:gd name="csX1" fmla="*/ 101705 w 2962440"/>
+              <a:gd name="csY1" fmla="*/ 165382 h 1501201"/>
+              <a:gd name="csX2" fmla="*/ 101705 w 2962440"/>
+              <a:gd name="csY2" fmla="*/ 1335819 h 1501201"/>
+              <a:gd name="csX3" fmla="*/ 165382 w 2962440"/>
+              <a:gd name="csY3" fmla="*/ 1399496 h 1501201"/>
+              <a:gd name="csX4" fmla="*/ 575299 w 2962440"/>
+              <a:gd name="csY4" fmla="*/ 1399496 h 1501201"/>
+              <a:gd name="csX5" fmla="*/ 605497 w 2962440"/>
+              <a:gd name="csY5" fmla="*/ 1399496 h 1501201"/>
+              <a:gd name="csX6" fmla="*/ 861858 w 2962440"/>
+              <a:gd name="csY6" fmla="*/ 1399496 h 1501201"/>
+              <a:gd name="csX7" fmla="*/ 2163120 w 2962440"/>
+              <a:gd name="csY7" fmla="*/ 1399496 h 1501201"/>
+              <a:gd name="csX8" fmla="*/ 2339299 w 2962440"/>
+              <a:gd name="csY8" fmla="*/ 1399496 h 1501201"/>
+              <a:gd name="csX9" fmla="*/ 2797058 w 2962440"/>
+              <a:gd name="csY9" fmla="*/ 1399496 h 1501201"/>
+              <a:gd name="csX10" fmla="*/ 2860735 w 2962440"/>
+              <a:gd name="csY10" fmla="*/ 1335819 h 1501201"/>
+              <a:gd name="csX11" fmla="*/ 2860735 w 2962440"/>
+              <a:gd name="csY11" fmla="*/ 165382 h 1501201"/>
+              <a:gd name="csX12" fmla="*/ 2797058 w 2962440"/>
+              <a:gd name="csY12" fmla="*/ 101705 h 1501201"/>
+              <a:gd name="csX13" fmla="*/ 2339299 w 2962440"/>
+              <a:gd name="csY13" fmla="*/ 101705 h 1501201"/>
+              <a:gd name="csX14" fmla="*/ 2163120 w 2962440"/>
+              <a:gd name="csY14" fmla="*/ 101705 h 1501201"/>
+              <a:gd name="csX15" fmla="*/ 861858 w 2962440"/>
+              <a:gd name="csY15" fmla="*/ 101705 h 1501201"/>
+              <a:gd name="csX16" fmla="*/ 605497 w 2962440"/>
+              <a:gd name="csY16" fmla="*/ 101705 h 1501201"/>
+              <a:gd name="csX17" fmla="*/ 575299 w 2962440"/>
+              <a:gd name="csY17" fmla="*/ 106833 h 1501201"/>
+              <a:gd name="csX18" fmla="*/ 575299 w 2962440"/>
+              <a:gd name="csY18" fmla="*/ 101705 h 1501201"/>
+              <a:gd name="csX19" fmla="*/ 165382 w 2962440"/>
+              <a:gd name="csY19" fmla="*/ 101705 h 1501201"/>
+              <a:gd name="csX20" fmla="*/ 69336 w 2962440"/>
+              <a:gd name="csY20" fmla="*/ 0 h 1501201"/>
+              <a:gd name="csX21" fmla="*/ 575299 w 2962440"/>
+              <a:gd name="csY21" fmla="*/ 0 h 1501201"/>
+              <a:gd name="csX22" fmla="*/ 861858 w 2962440"/>
+              <a:gd name="csY22" fmla="*/ 0 h 1501201"/>
+              <a:gd name="csX23" fmla="*/ 2163120 w 2962440"/>
+              <a:gd name="csY23" fmla="*/ 0 h 1501201"/>
+              <a:gd name="csX24" fmla="*/ 2339299 w 2962440"/>
+              <a:gd name="csY24" fmla="*/ 0 h 1501201"/>
+              <a:gd name="csX25" fmla="*/ 2893104 w 2962440"/>
+              <a:gd name="csY25" fmla="*/ 0 h 1501201"/>
+              <a:gd name="csX26" fmla="*/ 2962440 w 2962440"/>
+              <a:gd name="csY26" fmla="*/ 69336 h 1501201"/>
+              <a:gd name="csX27" fmla="*/ 2962440 w 2962440"/>
+              <a:gd name="csY27" fmla="*/ 1431865 h 1501201"/>
+              <a:gd name="csX28" fmla="*/ 2893104 w 2962440"/>
+              <a:gd name="csY28" fmla="*/ 1501201 h 1501201"/>
+              <a:gd name="csX29" fmla="*/ 2339299 w 2962440"/>
+              <a:gd name="csY29" fmla="*/ 1501201 h 1501201"/>
+              <a:gd name="csX30" fmla="*/ 2163120 w 2962440"/>
+              <a:gd name="csY30" fmla="*/ 1501201 h 1501201"/>
+              <a:gd name="csX31" fmla="*/ 861858 w 2962440"/>
+              <a:gd name="csY31" fmla="*/ 1501201 h 1501201"/>
+              <a:gd name="csX32" fmla="*/ 575299 w 2962440"/>
+              <a:gd name="csY32" fmla="*/ 1501201 h 1501201"/>
+              <a:gd name="csX33" fmla="*/ 69336 w 2962440"/>
+              <a:gd name="csY33" fmla="*/ 1501201 h 1501201"/>
+              <a:gd name="csX34" fmla="*/ 0 w 2962440"/>
+              <a:gd name="csY34" fmla="*/ 1431865 h 1501201"/>
+              <a:gd name="csX35" fmla="*/ 0 w 2962440"/>
+              <a:gd name="csY35" fmla="*/ 69336 h 1501201"/>
+              <a:gd name="csX36" fmla="*/ 69336 w 2962440"/>
+              <a:gd name="csY36" fmla="*/ 0 h 1501201"/>
+              <a:gd name="csX0" fmla="*/ 165382 w 2962440"/>
+              <a:gd name="csY0" fmla="*/ 101705 h 1501201"/>
+              <a:gd name="csX1" fmla="*/ 101705 w 2962440"/>
+              <a:gd name="csY1" fmla="*/ 165382 h 1501201"/>
+              <a:gd name="csX2" fmla="*/ 101705 w 2962440"/>
+              <a:gd name="csY2" fmla="*/ 1335819 h 1501201"/>
+              <a:gd name="csX3" fmla="*/ 165382 w 2962440"/>
+              <a:gd name="csY3" fmla="*/ 1399496 h 1501201"/>
+              <a:gd name="csX4" fmla="*/ 575299 w 2962440"/>
+              <a:gd name="csY4" fmla="*/ 1399496 h 1501201"/>
+              <a:gd name="csX5" fmla="*/ 861858 w 2962440"/>
+              <a:gd name="csY5" fmla="*/ 1399496 h 1501201"/>
+              <a:gd name="csX6" fmla="*/ 2163120 w 2962440"/>
+              <a:gd name="csY6" fmla="*/ 1399496 h 1501201"/>
+              <a:gd name="csX7" fmla="*/ 2339299 w 2962440"/>
+              <a:gd name="csY7" fmla="*/ 1399496 h 1501201"/>
+              <a:gd name="csX8" fmla="*/ 2797058 w 2962440"/>
+              <a:gd name="csY8" fmla="*/ 1399496 h 1501201"/>
+              <a:gd name="csX9" fmla="*/ 2860735 w 2962440"/>
+              <a:gd name="csY9" fmla="*/ 1335819 h 1501201"/>
+              <a:gd name="csX10" fmla="*/ 2860735 w 2962440"/>
+              <a:gd name="csY10" fmla="*/ 165382 h 1501201"/>
+              <a:gd name="csX11" fmla="*/ 2797058 w 2962440"/>
+              <a:gd name="csY11" fmla="*/ 101705 h 1501201"/>
+              <a:gd name="csX12" fmla="*/ 2339299 w 2962440"/>
+              <a:gd name="csY12" fmla="*/ 101705 h 1501201"/>
+              <a:gd name="csX13" fmla="*/ 2163120 w 2962440"/>
+              <a:gd name="csY13" fmla="*/ 101705 h 1501201"/>
+              <a:gd name="csX14" fmla="*/ 861858 w 2962440"/>
+              <a:gd name="csY14" fmla="*/ 101705 h 1501201"/>
+              <a:gd name="csX15" fmla="*/ 605497 w 2962440"/>
+              <a:gd name="csY15" fmla="*/ 101705 h 1501201"/>
+              <a:gd name="csX16" fmla="*/ 575299 w 2962440"/>
+              <a:gd name="csY16" fmla="*/ 106833 h 1501201"/>
+              <a:gd name="csX17" fmla="*/ 575299 w 2962440"/>
+              <a:gd name="csY17" fmla="*/ 101705 h 1501201"/>
+              <a:gd name="csX18" fmla="*/ 165382 w 2962440"/>
+              <a:gd name="csY18" fmla="*/ 101705 h 1501201"/>
+              <a:gd name="csX19" fmla="*/ 69336 w 2962440"/>
+              <a:gd name="csY19" fmla="*/ 0 h 1501201"/>
+              <a:gd name="csX20" fmla="*/ 575299 w 2962440"/>
+              <a:gd name="csY20" fmla="*/ 0 h 1501201"/>
+              <a:gd name="csX21" fmla="*/ 861858 w 2962440"/>
+              <a:gd name="csY21" fmla="*/ 0 h 1501201"/>
+              <a:gd name="csX22" fmla="*/ 2163120 w 2962440"/>
+              <a:gd name="csY22" fmla="*/ 0 h 1501201"/>
+              <a:gd name="csX23" fmla="*/ 2339299 w 2962440"/>
+              <a:gd name="csY23" fmla="*/ 0 h 1501201"/>
+              <a:gd name="csX24" fmla="*/ 2893104 w 2962440"/>
+              <a:gd name="csY24" fmla="*/ 0 h 1501201"/>
+              <a:gd name="csX25" fmla="*/ 2962440 w 2962440"/>
+              <a:gd name="csY25" fmla="*/ 69336 h 1501201"/>
+              <a:gd name="csX26" fmla="*/ 2962440 w 2962440"/>
+              <a:gd name="csY26" fmla="*/ 1431865 h 1501201"/>
+              <a:gd name="csX27" fmla="*/ 2893104 w 2962440"/>
+              <a:gd name="csY27" fmla="*/ 1501201 h 1501201"/>
+              <a:gd name="csX28" fmla="*/ 2339299 w 2962440"/>
+              <a:gd name="csY28" fmla="*/ 1501201 h 1501201"/>
+              <a:gd name="csX29" fmla="*/ 2163120 w 2962440"/>
+              <a:gd name="csY29" fmla="*/ 1501201 h 1501201"/>
+              <a:gd name="csX30" fmla="*/ 861858 w 2962440"/>
+              <a:gd name="csY30" fmla="*/ 1501201 h 1501201"/>
+              <a:gd name="csX31" fmla="*/ 575299 w 2962440"/>
+              <a:gd name="csY31" fmla="*/ 1501201 h 1501201"/>
+              <a:gd name="csX32" fmla="*/ 69336 w 2962440"/>
+              <a:gd name="csY32" fmla="*/ 1501201 h 1501201"/>
+              <a:gd name="csX33" fmla="*/ 0 w 2962440"/>
+              <a:gd name="csY33" fmla="*/ 1431865 h 1501201"/>
+              <a:gd name="csX34" fmla="*/ 0 w 2962440"/>
+              <a:gd name="csY34" fmla="*/ 69336 h 1501201"/>
+              <a:gd name="csX35" fmla="*/ 69336 w 2962440"/>
+              <a:gd name="csY35" fmla="*/ 0 h 1501201"/>
+              <a:gd name="csX0" fmla="*/ 165382 w 2962440"/>
+              <a:gd name="csY0" fmla="*/ 101705 h 1501201"/>
+              <a:gd name="csX1" fmla="*/ 101705 w 2962440"/>
+              <a:gd name="csY1" fmla="*/ 165382 h 1501201"/>
+              <a:gd name="csX2" fmla="*/ 101705 w 2962440"/>
+              <a:gd name="csY2" fmla="*/ 1335819 h 1501201"/>
+              <a:gd name="csX3" fmla="*/ 165382 w 2962440"/>
+              <a:gd name="csY3" fmla="*/ 1399496 h 1501201"/>
+              <a:gd name="csX4" fmla="*/ 861858 w 2962440"/>
+              <a:gd name="csY4" fmla="*/ 1399496 h 1501201"/>
+              <a:gd name="csX5" fmla="*/ 2163120 w 2962440"/>
+              <a:gd name="csY5" fmla="*/ 1399496 h 1501201"/>
+              <a:gd name="csX6" fmla="*/ 2339299 w 2962440"/>
+              <a:gd name="csY6" fmla="*/ 1399496 h 1501201"/>
+              <a:gd name="csX7" fmla="*/ 2797058 w 2962440"/>
+              <a:gd name="csY7" fmla="*/ 1399496 h 1501201"/>
+              <a:gd name="csX8" fmla="*/ 2860735 w 2962440"/>
+              <a:gd name="csY8" fmla="*/ 1335819 h 1501201"/>
+              <a:gd name="csX9" fmla="*/ 2860735 w 2962440"/>
+              <a:gd name="csY9" fmla="*/ 165382 h 1501201"/>
+              <a:gd name="csX10" fmla="*/ 2797058 w 2962440"/>
+              <a:gd name="csY10" fmla="*/ 101705 h 1501201"/>
+              <a:gd name="csX11" fmla="*/ 2339299 w 2962440"/>
+              <a:gd name="csY11" fmla="*/ 101705 h 1501201"/>
+              <a:gd name="csX12" fmla="*/ 2163120 w 2962440"/>
+              <a:gd name="csY12" fmla="*/ 101705 h 1501201"/>
+              <a:gd name="csX13" fmla="*/ 861858 w 2962440"/>
+              <a:gd name="csY13" fmla="*/ 101705 h 1501201"/>
+              <a:gd name="csX14" fmla="*/ 605497 w 2962440"/>
+              <a:gd name="csY14" fmla="*/ 101705 h 1501201"/>
+              <a:gd name="csX15" fmla="*/ 575299 w 2962440"/>
+              <a:gd name="csY15" fmla="*/ 106833 h 1501201"/>
+              <a:gd name="csX16" fmla="*/ 575299 w 2962440"/>
+              <a:gd name="csY16" fmla="*/ 101705 h 1501201"/>
+              <a:gd name="csX17" fmla="*/ 165382 w 2962440"/>
+              <a:gd name="csY17" fmla="*/ 101705 h 1501201"/>
+              <a:gd name="csX18" fmla="*/ 69336 w 2962440"/>
+              <a:gd name="csY18" fmla="*/ 0 h 1501201"/>
+              <a:gd name="csX19" fmla="*/ 575299 w 2962440"/>
+              <a:gd name="csY19" fmla="*/ 0 h 1501201"/>
+              <a:gd name="csX20" fmla="*/ 861858 w 2962440"/>
+              <a:gd name="csY20" fmla="*/ 0 h 1501201"/>
+              <a:gd name="csX21" fmla="*/ 2163120 w 2962440"/>
+              <a:gd name="csY21" fmla="*/ 0 h 1501201"/>
+              <a:gd name="csX22" fmla="*/ 2339299 w 2962440"/>
+              <a:gd name="csY22" fmla="*/ 0 h 1501201"/>
+              <a:gd name="csX23" fmla="*/ 2893104 w 2962440"/>
+              <a:gd name="csY23" fmla="*/ 0 h 1501201"/>
+              <a:gd name="csX24" fmla="*/ 2962440 w 2962440"/>
+              <a:gd name="csY24" fmla="*/ 69336 h 1501201"/>
+              <a:gd name="csX25" fmla="*/ 2962440 w 2962440"/>
+              <a:gd name="csY25" fmla="*/ 1431865 h 1501201"/>
+              <a:gd name="csX26" fmla="*/ 2893104 w 2962440"/>
+              <a:gd name="csY26" fmla="*/ 1501201 h 1501201"/>
+              <a:gd name="csX27" fmla="*/ 2339299 w 2962440"/>
+              <a:gd name="csY27" fmla="*/ 1501201 h 1501201"/>
+              <a:gd name="csX28" fmla="*/ 2163120 w 2962440"/>
+              <a:gd name="csY28" fmla="*/ 1501201 h 1501201"/>
+              <a:gd name="csX29" fmla="*/ 861858 w 2962440"/>
+              <a:gd name="csY29" fmla="*/ 1501201 h 1501201"/>
+              <a:gd name="csX30" fmla="*/ 575299 w 2962440"/>
+              <a:gd name="csY30" fmla="*/ 1501201 h 1501201"/>
+              <a:gd name="csX31" fmla="*/ 69336 w 2962440"/>
+              <a:gd name="csY31" fmla="*/ 1501201 h 1501201"/>
+              <a:gd name="csX32" fmla="*/ 0 w 2962440"/>
+              <a:gd name="csY32" fmla="*/ 1431865 h 1501201"/>
+              <a:gd name="csX33" fmla="*/ 0 w 2962440"/>
+              <a:gd name="csY33" fmla="*/ 69336 h 1501201"/>
+              <a:gd name="csX34" fmla="*/ 69336 w 2962440"/>
+              <a:gd name="csY34" fmla="*/ 0 h 1501201"/>
+              <a:gd name="csX0" fmla="*/ 165382 w 2962440"/>
+              <a:gd name="csY0" fmla="*/ 101705 h 1501201"/>
+              <a:gd name="csX1" fmla="*/ 101705 w 2962440"/>
+              <a:gd name="csY1" fmla="*/ 165382 h 1501201"/>
+              <a:gd name="csX2" fmla="*/ 101705 w 2962440"/>
+              <a:gd name="csY2" fmla="*/ 1335819 h 1501201"/>
+              <a:gd name="csX3" fmla="*/ 165382 w 2962440"/>
+              <a:gd name="csY3" fmla="*/ 1399496 h 1501201"/>
+              <a:gd name="csX4" fmla="*/ 2163120 w 2962440"/>
+              <a:gd name="csY4" fmla="*/ 1399496 h 1501201"/>
+              <a:gd name="csX5" fmla="*/ 2339299 w 2962440"/>
+              <a:gd name="csY5" fmla="*/ 1399496 h 1501201"/>
+              <a:gd name="csX6" fmla="*/ 2797058 w 2962440"/>
+              <a:gd name="csY6" fmla="*/ 1399496 h 1501201"/>
+              <a:gd name="csX7" fmla="*/ 2860735 w 2962440"/>
+              <a:gd name="csY7" fmla="*/ 1335819 h 1501201"/>
+              <a:gd name="csX8" fmla="*/ 2860735 w 2962440"/>
+              <a:gd name="csY8" fmla="*/ 165382 h 1501201"/>
+              <a:gd name="csX9" fmla="*/ 2797058 w 2962440"/>
+              <a:gd name="csY9" fmla="*/ 101705 h 1501201"/>
+              <a:gd name="csX10" fmla="*/ 2339299 w 2962440"/>
+              <a:gd name="csY10" fmla="*/ 101705 h 1501201"/>
+              <a:gd name="csX11" fmla="*/ 2163120 w 2962440"/>
+              <a:gd name="csY11" fmla="*/ 101705 h 1501201"/>
+              <a:gd name="csX12" fmla="*/ 861858 w 2962440"/>
+              <a:gd name="csY12" fmla="*/ 101705 h 1501201"/>
+              <a:gd name="csX13" fmla="*/ 605497 w 2962440"/>
+              <a:gd name="csY13" fmla="*/ 101705 h 1501201"/>
+              <a:gd name="csX14" fmla="*/ 575299 w 2962440"/>
+              <a:gd name="csY14" fmla="*/ 106833 h 1501201"/>
+              <a:gd name="csX15" fmla="*/ 575299 w 2962440"/>
+              <a:gd name="csY15" fmla="*/ 101705 h 1501201"/>
+              <a:gd name="csX16" fmla="*/ 165382 w 2962440"/>
+              <a:gd name="csY16" fmla="*/ 101705 h 1501201"/>
+              <a:gd name="csX17" fmla="*/ 69336 w 2962440"/>
+              <a:gd name="csY17" fmla="*/ 0 h 1501201"/>
+              <a:gd name="csX18" fmla="*/ 575299 w 2962440"/>
+              <a:gd name="csY18" fmla="*/ 0 h 1501201"/>
+              <a:gd name="csX19" fmla="*/ 861858 w 2962440"/>
+              <a:gd name="csY19" fmla="*/ 0 h 1501201"/>
+              <a:gd name="csX20" fmla="*/ 2163120 w 2962440"/>
+              <a:gd name="csY20" fmla="*/ 0 h 1501201"/>
+              <a:gd name="csX21" fmla="*/ 2339299 w 2962440"/>
+              <a:gd name="csY21" fmla="*/ 0 h 1501201"/>
+              <a:gd name="csX22" fmla="*/ 2893104 w 2962440"/>
+              <a:gd name="csY22" fmla="*/ 0 h 1501201"/>
+              <a:gd name="csX23" fmla="*/ 2962440 w 2962440"/>
+              <a:gd name="csY23" fmla="*/ 69336 h 1501201"/>
+              <a:gd name="csX24" fmla="*/ 2962440 w 2962440"/>
+              <a:gd name="csY24" fmla="*/ 1431865 h 1501201"/>
+              <a:gd name="csX25" fmla="*/ 2893104 w 2962440"/>
+              <a:gd name="csY25" fmla="*/ 1501201 h 1501201"/>
+              <a:gd name="csX26" fmla="*/ 2339299 w 2962440"/>
+              <a:gd name="csY26" fmla="*/ 1501201 h 1501201"/>
+              <a:gd name="csX27" fmla="*/ 2163120 w 2962440"/>
+              <a:gd name="csY27" fmla="*/ 1501201 h 1501201"/>
+              <a:gd name="csX28" fmla="*/ 861858 w 2962440"/>
+              <a:gd name="csY28" fmla="*/ 1501201 h 1501201"/>
+              <a:gd name="csX29" fmla="*/ 575299 w 2962440"/>
+              <a:gd name="csY29" fmla="*/ 1501201 h 1501201"/>
+              <a:gd name="csX30" fmla="*/ 69336 w 2962440"/>
+              <a:gd name="csY30" fmla="*/ 1501201 h 1501201"/>
+              <a:gd name="csX31" fmla="*/ 0 w 2962440"/>
+              <a:gd name="csY31" fmla="*/ 1431865 h 1501201"/>
+              <a:gd name="csX32" fmla="*/ 0 w 2962440"/>
+              <a:gd name="csY32" fmla="*/ 69336 h 1501201"/>
+              <a:gd name="csX33" fmla="*/ 69336 w 2962440"/>
+              <a:gd name="csY33" fmla="*/ 0 h 1501201"/>
+              <a:gd name="csX0" fmla="*/ 165382 w 2962440"/>
+              <a:gd name="csY0" fmla="*/ 101705 h 1501201"/>
+              <a:gd name="csX1" fmla="*/ 101705 w 2962440"/>
+              <a:gd name="csY1" fmla="*/ 165382 h 1501201"/>
+              <a:gd name="csX2" fmla="*/ 101705 w 2962440"/>
+              <a:gd name="csY2" fmla="*/ 1335819 h 1501201"/>
+              <a:gd name="csX3" fmla="*/ 165382 w 2962440"/>
+              <a:gd name="csY3" fmla="*/ 1399496 h 1501201"/>
+              <a:gd name="csX4" fmla="*/ 2339299 w 2962440"/>
+              <a:gd name="csY4" fmla="*/ 1399496 h 1501201"/>
+              <a:gd name="csX5" fmla="*/ 2797058 w 2962440"/>
+              <a:gd name="csY5" fmla="*/ 1399496 h 1501201"/>
+              <a:gd name="csX6" fmla="*/ 2860735 w 2962440"/>
+              <a:gd name="csY6" fmla="*/ 1335819 h 1501201"/>
+              <a:gd name="csX7" fmla="*/ 2860735 w 2962440"/>
+              <a:gd name="csY7" fmla="*/ 165382 h 1501201"/>
+              <a:gd name="csX8" fmla="*/ 2797058 w 2962440"/>
+              <a:gd name="csY8" fmla="*/ 101705 h 1501201"/>
+              <a:gd name="csX9" fmla="*/ 2339299 w 2962440"/>
+              <a:gd name="csY9" fmla="*/ 101705 h 1501201"/>
+              <a:gd name="csX10" fmla="*/ 2163120 w 2962440"/>
+              <a:gd name="csY10" fmla="*/ 101705 h 1501201"/>
+              <a:gd name="csX11" fmla="*/ 861858 w 2962440"/>
+              <a:gd name="csY11" fmla="*/ 101705 h 1501201"/>
+              <a:gd name="csX12" fmla="*/ 605497 w 2962440"/>
+              <a:gd name="csY12" fmla="*/ 101705 h 1501201"/>
+              <a:gd name="csX13" fmla="*/ 575299 w 2962440"/>
+              <a:gd name="csY13" fmla="*/ 106833 h 1501201"/>
+              <a:gd name="csX14" fmla="*/ 575299 w 2962440"/>
+              <a:gd name="csY14" fmla="*/ 101705 h 1501201"/>
+              <a:gd name="csX15" fmla="*/ 165382 w 2962440"/>
+              <a:gd name="csY15" fmla="*/ 101705 h 1501201"/>
+              <a:gd name="csX16" fmla="*/ 69336 w 2962440"/>
+              <a:gd name="csY16" fmla="*/ 0 h 1501201"/>
+              <a:gd name="csX17" fmla="*/ 575299 w 2962440"/>
+              <a:gd name="csY17" fmla="*/ 0 h 1501201"/>
+              <a:gd name="csX18" fmla="*/ 861858 w 2962440"/>
+              <a:gd name="csY18" fmla="*/ 0 h 1501201"/>
+              <a:gd name="csX19" fmla="*/ 2163120 w 2962440"/>
+              <a:gd name="csY19" fmla="*/ 0 h 1501201"/>
+              <a:gd name="csX20" fmla="*/ 2339299 w 2962440"/>
+              <a:gd name="csY20" fmla="*/ 0 h 1501201"/>
+              <a:gd name="csX21" fmla="*/ 2893104 w 2962440"/>
+              <a:gd name="csY21" fmla="*/ 0 h 1501201"/>
+              <a:gd name="csX22" fmla="*/ 2962440 w 2962440"/>
+              <a:gd name="csY22" fmla="*/ 69336 h 1501201"/>
+              <a:gd name="csX23" fmla="*/ 2962440 w 2962440"/>
+              <a:gd name="csY23" fmla="*/ 1431865 h 1501201"/>
+              <a:gd name="csX24" fmla="*/ 2893104 w 2962440"/>
+              <a:gd name="csY24" fmla="*/ 1501201 h 1501201"/>
+              <a:gd name="csX25" fmla="*/ 2339299 w 2962440"/>
+              <a:gd name="csY25" fmla="*/ 1501201 h 1501201"/>
+              <a:gd name="csX26" fmla="*/ 2163120 w 2962440"/>
+              <a:gd name="csY26" fmla="*/ 1501201 h 1501201"/>
+              <a:gd name="csX27" fmla="*/ 861858 w 2962440"/>
+              <a:gd name="csY27" fmla="*/ 1501201 h 1501201"/>
+              <a:gd name="csX28" fmla="*/ 575299 w 2962440"/>
+              <a:gd name="csY28" fmla="*/ 1501201 h 1501201"/>
+              <a:gd name="csX29" fmla="*/ 69336 w 2962440"/>
+              <a:gd name="csY29" fmla="*/ 1501201 h 1501201"/>
+              <a:gd name="csX30" fmla="*/ 0 w 2962440"/>
+              <a:gd name="csY30" fmla="*/ 1431865 h 1501201"/>
+              <a:gd name="csX31" fmla="*/ 0 w 2962440"/>
+              <a:gd name="csY31" fmla="*/ 69336 h 1501201"/>
+              <a:gd name="csX32" fmla="*/ 69336 w 2962440"/>
+              <a:gd name="csY32" fmla="*/ 0 h 1501201"/>
+              <a:gd name="csX0" fmla="*/ 165382 w 2962440"/>
+              <a:gd name="csY0" fmla="*/ 101705 h 1501201"/>
+              <a:gd name="csX1" fmla="*/ 101705 w 2962440"/>
+              <a:gd name="csY1" fmla="*/ 165382 h 1501201"/>
+              <a:gd name="csX2" fmla="*/ 101705 w 2962440"/>
+              <a:gd name="csY2" fmla="*/ 1335819 h 1501201"/>
+              <a:gd name="csX3" fmla="*/ 165382 w 2962440"/>
+              <a:gd name="csY3" fmla="*/ 1399496 h 1501201"/>
+              <a:gd name="csX4" fmla="*/ 2797058 w 2962440"/>
+              <a:gd name="csY4" fmla="*/ 1399496 h 1501201"/>
+              <a:gd name="csX5" fmla="*/ 2860735 w 2962440"/>
+              <a:gd name="csY5" fmla="*/ 1335819 h 1501201"/>
+              <a:gd name="csX6" fmla="*/ 2860735 w 2962440"/>
+              <a:gd name="csY6" fmla="*/ 165382 h 1501201"/>
+              <a:gd name="csX7" fmla="*/ 2797058 w 2962440"/>
+              <a:gd name="csY7" fmla="*/ 101705 h 1501201"/>
+              <a:gd name="csX8" fmla="*/ 2339299 w 2962440"/>
+              <a:gd name="csY8" fmla="*/ 101705 h 1501201"/>
+              <a:gd name="csX9" fmla="*/ 2163120 w 2962440"/>
+              <a:gd name="csY9" fmla="*/ 101705 h 1501201"/>
+              <a:gd name="csX10" fmla="*/ 861858 w 2962440"/>
+              <a:gd name="csY10" fmla="*/ 101705 h 1501201"/>
+              <a:gd name="csX11" fmla="*/ 605497 w 2962440"/>
+              <a:gd name="csY11" fmla="*/ 101705 h 1501201"/>
+              <a:gd name="csX12" fmla="*/ 575299 w 2962440"/>
+              <a:gd name="csY12" fmla="*/ 106833 h 1501201"/>
+              <a:gd name="csX13" fmla="*/ 575299 w 2962440"/>
+              <a:gd name="csY13" fmla="*/ 101705 h 1501201"/>
+              <a:gd name="csX14" fmla="*/ 165382 w 2962440"/>
+              <a:gd name="csY14" fmla="*/ 101705 h 1501201"/>
+              <a:gd name="csX15" fmla="*/ 69336 w 2962440"/>
+              <a:gd name="csY15" fmla="*/ 0 h 1501201"/>
+              <a:gd name="csX16" fmla="*/ 575299 w 2962440"/>
+              <a:gd name="csY16" fmla="*/ 0 h 1501201"/>
+              <a:gd name="csX17" fmla="*/ 861858 w 2962440"/>
+              <a:gd name="csY17" fmla="*/ 0 h 1501201"/>
+              <a:gd name="csX18" fmla="*/ 2163120 w 2962440"/>
+              <a:gd name="csY18" fmla="*/ 0 h 1501201"/>
+              <a:gd name="csX19" fmla="*/ 2339299 w 2962440"/>
+              <a:gd name="csY19" fmla="*/ 0 h 1501201"/>
+              <a:gd name="csX20" fmla="*/ 2893104 w 2962440"/>
+              <a:gd name="csY20" fmla="*/ 0 h 1501201"/>
+              <a:gd name="csX21" fmla="*/ 2962440 w 2962440"/>
+              <a:gd name="csY21" fmla="*/ 69336 h 1501201"/>
+              <a:gd name="csX22" fmla="*/ 2962440 w 2962440"/>
+              <a:gd name="csY22" fmla="*/ 1431865 h 1501201"/>
+              <a:gd name="csX23" fmla="*/ 2893104 w 2962440"/>
+              <a:gd name="csY23" fmla="*/ 1501201 h 1501201"/>
+              <a:gd name="csX24" fmla="*/ 2339299 w 2962440"/>
+              <a:gd name="csY24" fmla="*/ 1501201 h 1501201"/>
+              <a:gd name="csX25" fmla="*/ 2163120 w 2962440"/>
+              <a:gd name="csY25" fmla="*/ 1501201 h 1501201"/>
+              <a:gd name="csX26" fmla="*/ 861858 w 2962440"/>
+              <a:gd name="csY26" fmla="*/ 1501201 h 1501201"/>
+              <a:gd name="csX27" fmla="*/ 575299 w 2962440"/>
+              <a:gd name="csY27" fmla="*/ 1501201 h 1501201"/>
+              <a:gd name="csX28" fmla="*/ 69336 w 2962440"/>
+              <a:gd name="csY28" fmla="*/ 1501201 h 1501201"/>
+              <a:gd name="csX29" fmla="*/ 0 w 2962440"/>
+              <a:gd name="csY29" fmla="*/ 1431865 h 1501201"/>
+              <a:gd name="csX30" fmla="*/ 0 w 2962440"/>
+              <a:gd name="csY30" fmla="*/ 69336 h 1501201"/>
+              <a:gd name="csX31" fmla="*/ 69336 w 2962440"/>
+              <a:gd name="csY31" fmla="*/ 0 h 1501201"/>
+              <a:gd name="csX0" fmla="*/ 165382 w 2962440"/>
+              <a:gd name="csY0" fmla="*/ 101705 h 1501201"/>
+              <a:gd name="csX1" fmla="*/ 101705 w 2962440"/>
+              <a:gd name="csY1" fmla="*/ 165382 h 1501201"/>
+              <a:gd name="csX2" fmla="*/ 101705 w 2962440"/>
+              <a:gd name="csY2" fmla="*/ 1335819 h 1501201"/>
+              <a:gd name="csX3" fmla="*/ 165382 w 2962440"/>
+              <a:gd name="csY3" fmla="*/ 1399496 h 1501201"/>
+              <a:gd name="csX4" fmla="*/ 2797058 w 2962440"/>
+              <a:gd name="csY4" fmla="*/ 1399496 h 1501201"/>
+              <a:gd name="csX5" fmla="*/ 2860735 w 2962440"/>
+              <a:gd name="csY5" fmla="*/ 1335819 h 1501201"/>
+              <a:gd name="csX6" fmla="*/ 2860735 w 2962440"/>
+              <a:gd name="csY6" fmla="*/ 165382 h 1501201"/>
+              <a:gd name="csX7" fmla="*/ 2797058 w 2962440"/>
+              <a:gd name="csY7" fmla="*/ 101705 h 1501201"/>
+              <a:gd name="csX8" fmla="*/ 2163120 w 2962440"/>
+              <a:gd name="csY8" fmla="*/ 101705 h 1501201"/>
+              <a:gd name="csX9" fmla="*/ 861858 w 2962440"/>
+              <a:gd name="csY9" fmla="*/ 101705 h 1501201"/>
+              <a:gd name="csX10" fmla="*/ 605497 w 2962440"/>
+              <a:gd name="csY10" fmla="*/ 101705 h 1501201"/>
+              <a:gd name="csX11" fmla="*/ 575299 w 2962440"/>
+              <a:gd name="csY11" fmla="*/ 106833 h 1501201"/>
+              <a:gd name="csX12" fmla="*/ 575299 w 2962440"/>
+              <a:gd name="csY12" fmla="*/ 101705 h 1501201"/>
+              <a:gd name="csX13" fmla="*/ 165382 w 2962440"/>
+              <a:gd name="csY13" fmla="*/ 101705 h 1501201"/>
+              <a:gd name="csX14" fmla="*/ 69336 w 2962440"/>
+              <a:gd name="csY14" fmla="*/ 0 h 1501201"/>
+              <a:gd name="csX15" fmla="*/ 575299 w 2962440"/>
+              <a:gd name="csY15" fmla="*/ 0 h 1501201"/>
+              <a:gd name="csX16" fmla="*/ 861858 w 2962440"/>
+              <a:gd name="csY16" fmla="*/ 0 h 1501201"/>
+              <a:gd name="csX17" fmla="*/ 2163120 w 2962440"/>
+              <a:gd name="csY17" fmla="*/ 0 h 1501201"/>
+              <a:gd name="csX18" fmla="*/ 2339299 w 2962440"/>
+              <a:gd name="csY18" fmla="*/ 0 h 1501201"/>
+              <a:gd name="csX19" fmla="*/ 2893104 w 2962440"/>
+              <a:gd name="csY19" fmla="*/ 0 h 1501201"/>
+              <a:gd name="csX20" fmla="*/ 2962440 w 2962440"/>
+              <a:gd name="csY20" fmla="*/ 69336 h 1501201"/>
+              <a:gd name="csX21" fmla="*/ 2962440 w 2962440"/>
+              <a:gd name="csY21" fmla="*/ 1431865 h 1501201"/>
+              <a:gd name="csX22" fmla="*/ 2893104 w 2962440"/>
+              <a:gd name="csY22" fmla="*/ 1501201 h 1501201"/>
+              <a:gd name="csX23" fmla="*/ 2339299 w 2962440"/>
+              <a:gd name="csY23" fmla="*/ 1501201 h 1501201"/>
+              <a:gd name="csX24" fmla="*/ 2163120 w 2962440"/>
+              <a:gd name="csY24" fmla="*/ 1501201 h 1501201"/>
+              <a:gd name="csX25" fmla="*/ 861858 w 2962440"/>
+              <a:gd name="csY25" fmla="*/ 1501201 h 1501201"/>
+              <a:gd name="csX26" fmla="*/ 575299 w 2962440"/>
+              <a:gd name="csY26" fmla="*/ 1501201 h 1501201"/>
+              <a:gd name="csX27" fmla="*/ 69336 w 2962440"/>
+              <a:gd name="csY27" fmla="*/ 1501201 h 1501201"/>
+              <a:gd name="csX28" fmla="*/ 0 w 2962440"/>
+              <a:gd name="csY28" fmla="*/ 1431865 h 1501201"/>
+              <a:gd name="csX29" fmla="*/ 0 w 2962440"/>
+              <a:gd name="csY29" fmla="*/ 69336 h 1501201"/>
+              <a:gd name="csX30" fmla="*/ 69336 w 2962440"/>
+              <a:gd name="csY30" fmla="*/ 0 h 1501201"/>
+              <a:gd name="csX0" fmla="*/ 165382 w 2962440"/>
+              <a:gd name="csY0" fmla="*/ 101705 h 1501201"/>
+              <a:gd name="csX1" fmla="*/ 101705 w 2962440"/>
+              <a:gd name="csY1" fmla="*/ 165382 h 1501201"/>
+              <a:gd name="csX2" fmla="*/ 101705 w 2962440"/>
+              <a:gd name="csY2" fmla="*/ 1335819 h 1501201"/>
+              <a:gd name="csX3" fmla="*/ 165382 w 2962440"/>
+              <a:gd name="csY3" fmla="*/ 1399496 h 1501201"/>
+              <a:gd name="csX4" fmla="*/ 2797058 w 2962440"/>
+              <a:gd name="csY4" fmla="*/ 1399496 h 1501201"/>
+              <a:gd name="csX5" fmla="*/ 2860735 w 2962440"/>
+              <a:gd name="csY5" fmla="*/ 1335819 h 1501201"/>
+              <a:gd name="csX6" fmla="*/ 2860735 w 2962440"/>
+              <a:gd name="csY6" fmla="*/ 165382 h 1501201"/>
+              <a:gd name="csX7" fmla="*/ 2797058 w 2962440"/>
+              <a:gd name="csY7" fmla="*/ 101705 h 1501201"/>
+              <a:gd name="csX8" fmla="*/ 861858 w 2962440"/>
+              <a:gd name="csY8" fmla="*/ 101705 h 1501201"/>
+              <a:gd name="csX9" fmla="*/ 605497 w 2962440"/>
+              <a:gd name="csY9" fmla="*/ 101705 h 1501201"/>
+              <a:gd name="csX10" fmla="*/ 575299 w 2962440"/>
+              <a:gd name="csY10" fmla="*/ 106833 h 1501201"/>
+              <a:gd name="csX11" fmla="*/ 575299 w 2962440"/>
+              <a:gd name="csY11" fmla="*/ 101705 h 1501201"/>
+              <a:gd name="csX12" fmla="*/ 165382 w 2962440"/>
+              <a:gd name="csY12" fmla="*/ 101705 h 1501201"/>
+              <a:gd name="csX13" fmla="*/ 69336 w 2962440"/>
+              <a:gd name="csY13" fmla="*/ 0 h 1501201"/>
+              <a:gd name="csX14" fmla="*/ 575299 w 2962440"/>
+              <a:gd name="csY14" fmla="*/ 0 h 1501201"/>
+              <a:gd name="csX15" fmla="*/ 861858 w 2962440"/>
+              <a:gd name="csY15" fmla="*/ 0 h 1501201"/>
+              <a:gd name="csX16" fmla="*/ 2163120 w 2962440"/>
+              <a:gd name="csY16" fmla="*/ 0 h 1501201"/>
+              <a:gd name="csX17" fmla="*/ 2339299 w 2962440"/>
+              <a:gd name="csY17" fmla="*/ 0 h 1501201"/>
+              <a:gd name="csX18" fmla="*/ 2893104 w 2962440"/>
+              <a:gd name="csY18" fmla="*/ 0 h 1501201"/>
+              <a:gd name="csX19" fmla="*/ 2962440 w 2962440"/>
+              <a:gd name="csY19" fmla="*/ 69336 h 1501201"/>
+              <a:gd name="csX20" fmla="*/ 2962440 w 2962440"/>
+              <a:gd name="csY20" fmla="*/ 1431865 h 1501201"/>
+              <a:gd name="csX21" fmla="*/ 2893104 w 2962440"/>
+              <a:gd name="csY21" fmla="*/ 1501201 h 1501201"/>
+              <a:gd name="csX22" fmla="*/ 2339299 w 2962440"/>
+              <a:gd name="csY22" fmla="*/ 1501201 h 1501201"/>
+              <a:gd name="csX23" fmla="*/ 2163120 w 2962440"/>
+              <a:gd name="csY23" fmla="*/ 1501201 h 1501201"/>
+              <a:gd name="csX24" fmla="*/ 861858 w 2962440"/>
+              <a:gd name="csY24" fmla="*/ 1501201 h 1501201"/>
+              <a:gd name="csX25" fmla="*/ 575299 w 2962440"/>
+              <a:gd name="csY25" fmla="*/ 1501201 h 1501201"/>
+              <a:gd name="csX26" fmla="*/ 69336 w 2962440"/>
+              <a:gd name="csY26" fmla="*/ 1501201 h 1501201"/>
+              <a:gd name="csX27" fmla="*/ 0 w 2962440"/>
+              <a:gd name="csY27" fmla="*/ 1431865 h 1501201"/>
+              <a:gd name="csX28" fmla="*/ 0 w 2962440"/>
+              <a:gd name="csY28" fmla="*/ 69336 h 1501201"/>
+              <a:gd name="csX29" fmla="*/ 69336 w 2962440"/>
+              <a:gd name="csY29" fmla="*/ 0 h 1501201"/>
+              <a:gd name="csX0" fmla="*/ 165382 w 2962440"/>
+              <a:gd name="csY0" fmla="*/ 101705 h 1501201"/>
+              <a:gd name="csX1" fmla="*/ 101705 w 2962440"/>
+              <a:gd name="csY1" fmla="*/ 165382 h 1501201"/>
+              <a:gd name="csX2" fmla="*/ 101705 w 2962440"/>
+              <a:gd name="csY2" fmla="*/ 1335819 h 1501201"/>
+              <a:gd name="csX3" fmla="*/ 165382 w 2962440"/>
+              <a:gd name="csY3" fmla="*/ 1399496 h 1501201"/>
+              <a:gd name="csX4" fmla="*/ 2797058 w 2962440"/>
+              <a:gd name="csY4" fmla="*/ 1399496 h 1501201"/>
+              <a:gd name="csX5" fmla="*/ 2860735 w 2962440"/>
+              <a:gd name="csY5" fmla="*/ 1335819 h 1501201"/>
+              <a:gd name="csX6" fmla="*/ 2860735 w 2962440"/>
+              <a:gd name="csY6" fmla="*/ 165382 h 1501201"/>
+              <a:gd name="csX7" fmla="*/ 2797058 w 2962440"/>
+              <a:gd name="csY7" fmla="*/ 101705 h 1501201"/>
+              <a:gd name="csX8" fmla="*/ 605497 w 2962440"/>
+              <a:gd name="csY8" fmla="*/ 101705 h 1501201"/>
+              <a:gd name="csX9" fmla="*/ 575299 w 2962440"/>
+              <a:gd name="csY9" fmla="*/ 106833 h 1501201"/>
+              <a:gd name="csX10" fmla="*/ 575299 w 2962440"/>
+              <a:gd name="csY10" fmla="*/ 101705 h 1501201"/>
+              <a:gd name="csX11" fmla="*/ 165382 w 2962440"/>
+              <a:gd name="csY11" fmla="*/ 101705 h 1501201"/>
+              <a:gd name="csX12" fmla="*/ 69336 w 2962440"/>
+              <a:gd name="csY12" fmla="*/ 0 h 1501201"/>
+              <a:gd name="csX13" fmla="*/ 575299 w 2962440"/>
+              <a:gd name="csY13" fmla="*/ 0 h 1501201"/>
+              <a:gd name="csX14" fmla="*/ 861858 w 2962440"/>
+              <a:gd name="csY14" fmla="*/ 0 h 1501201"/>
+              <a:gd name="csX15" fmla="*/ 2163120 w 2962440"/>
+              <a:gd name="csY15" fmla="*/ 0 h 1501201"/>
+              <a:gd name="csX16" fmla="*/ 2339299 w 2962440"/>
+              <a:gd name="csY16" fmla="*/ 0 h 1501201"/>
+              <a:gd name="csX17" fmla="*/ 2893104 w 2962440"/>
+              <a:gd name="csY17" fmla="*/ 0 h 1501201"/>
+              <a:gd name="csX18" fmla="*/ 2962440 w 2962440"/>
+              <a:gd name="csY18" fmla="*/ 69336 h 1501201"/>
+              <a:gd name="csX19" fmla="*/ 2962440 w 2962440"/>
+              <a:gd name="csY19" fmla="*/ 1431865 h 1501201"/>
+              <a:gd name="csX20" fmla="*/ 2893104 w 2962440"/>
+              <a:gd name="csY20" fmla="*/ 1501201 h 1501201"/>
+              <a:gd name="csX21" fmla="*/ 2339299 w 2962440"/>
+              <a:gd name="csY21" fmla="*/ 1501201 h 1501201"/>
+              <a:gd name="csX22" fmla="*/ 2163120 w 2962440"/>
+              <a:gd name="csY22" fmla="*/ 1501201 h 1501201"/>
+              <a:gd name="csX23" fmla="*/ 861858 w 2962440"/>
+              <a:gd name="csY23" fmla="*/ 1501201 h 1501201"/>
+              <a:gd name="csX24" fmla="*/ 575299 w 2962440"/>
+              <a:gd name="csY24" fmla="*/ 1501201 h 1501201"/>
+              <a:gd name="csX25" fmla="*/ 69336 w 2962440"/>
+              <a:gd name="csY25" fmla="*/ 1501201 h 1501201"/>
+              <a:gd name="csX26" fmla="*/ 0 w 2962440"/>
+              <a:gd name="csY26" fmla="*/ 1431865 h 1501201"/>
+              <a:gd name="csX27" fmla="*/ 0 w 2962440"/>
+              <a:gd name="csY27" fmla="*/ 69336 h 1501201"/>
+              <a:gd name="csX28" fmla="*/ 69336 w 2962440"/>
+              <a:gd name="csY28" fmla="*/ 0 h 1501201"/>
+              <a:gd name="csX0" fmla="*/ 165382 w 2962440"/>
+              <a:gd name="csY0" fmla="*/ 101705 h 1501201"/>
+              <a:gd name="csX1" fmla="*/ 101705 w 2962440"/>
+              <a:gd name="csY1" fmla="*/ 165382 h 1501201"/>
+              <a:gd name="csX2" fmla="*/ 101705 w 2962440"/>
+              <a:gd name="csY2" fmla="*/ 1335819 h 1501201"/>
+              <a:gd name="csX3" fmla="*/ 165382 w 2962440"/>
+              <a:gd name="csY3" fmla="*/ 1399496 h 1501201"/>
+              <a:gd name="csX4" fmla="*/ 2797058 w 2962440"/>
+              <a:gd name="csY4" fmla="*/ 1399496 h 1501201"/>
+              <a:gd name="csX5" fmla="*/ 2860735 w 2962440"/>
+              <a:gd name="csY5" fmla="*/ 1335819 h 1501201"/>
+              <a:gd name="csX6" fmla="*/ 2860735 w 2962440"/>
+              <a:gd name="csY6" fmla="*/ 165382 h 1501201"/>
+              <a:gd name="csX7" fmla="*/ 2797058 w 2962440"/>
+              <a:gd name="csY7" fmla="*/ 101705 h 1501201"/>
+              <a:gd name="csX8" fmla="*/ 575299 w 2962440"/>
+              <a:gd name="csY8" fmla="*/ 106833 h 1501201"/>
+              <a:gd name="csX9" fmla="*/ 575299 w 2962440"/>
+              <a:gd name="csY9" fmla="*/ 101705 h 1501201"/>
+              <a:gd name="csX10" fmla="*/ 165382 w 2962440"/>
+              <a:gd name="csY10" fmla="*/ 101705 h 1501201"/>
+              <a:gd name="csX11" fmla="*/ 69336 w 2962440"/>
+              <a:gd name="csY11" fmla="*/ 0 h 1501201"/>
+              <a:gd name="csX12" fmla="*/ 575299 w 2962440"/>
+              <a:gd name="csY12" fmla="*/ 0 h 1501201"/>
+              <a:gd name="csX13" fmla="*/ 861858 w 2962440"/>
+              <a:gd name="csY13" fmla="*/ 0 h 1501201"/>
+              <a:gd name="csX14" fmla="*/ 2163120 w 2962440"/>
+              <a:gd name="csY14" fmla="*/ 0 h 1501201"/>
+              <a:gd name="csX15" fmla="*/ 2339299 w 2962440"/>
+              <a:gd name="csY15" fmla="*/ 0 h 1501201"/>
+              <a:gd name="csX16" fmla="*/ 2893104 w 2962440"/>
+              <a:gd name="csY16" fmla="*/ 0 h 1501201"/>
+              <a:gd name="csX17" fmla="*/ 2962440 w 2962440"/>
+              <a:gd name="csY17" fmla="*/ 69336 h 1501201"/>
+              <a:gd name="csX18" fmla="*/ 2962440 w 2962440"/>
+              <a:gd name="csY18" fmla="*/ 1431865 h 1501201"/>
+              <a:gd name="csX19" fmla="*/ 2893104 w 2962440"/>
+              <a:gd name="csY19" fmla="*/ 1501201 h 1501201"/>
+              <a:gd name="csX20" fmla="*/ 2339299 w 2962440"/>
+              <a:gd name="csY20" fmla="*/ 1501201 h 1501201"/>
+              <a:gd name="csX21" fmla="*/ 2163120 w 2962440"/>
+              <a:gd name="csY21" fmla="*/ 1501201 h 1501201"/>
+              <a:gd name="csX22" fmla="*/ 861858 w 2962440"/>
+              <a:gd name="csY22" fmla="*/ 1501201 h 1501201"/>
+              <a:gd name="csX23" fmla="*/ 575299 w 2962440"/>
+              <a:gd name="csY23" fmla="*/ 1501201 h 1501201"/>
+              <a:gd name="csX24" fmla="*/ 69336 w 2962440"/>
+              <a:gd name="csY24" fmla="*/ 1501201 h 1501201"/>
+              <a:gd name="csX25" fmla="*/ 0 w 2962440"/>
+              <a:gd name="csY25" fmla="*/ 1431865 h 1501201"/>
+              <a:gd name="csX26" fmla="*/ 0 w 2962440"/>
+              <a:gd name="csY26" fmla="*/ 69336 h 1501201"/>
+              <a:gd name="csX27" fmla="*/ 69336 w 2962440"/>
+              <a:gd name="csY27" fmla="*/ 0 h 1501201"/>
+              <a:gd name="csX0" fmla="*/ 165382 w 2962440"/>
+              <a:gd name="csY0" fmla="*/ 101705 h 1501201"/>
+              <a:gd name="csX1" fmla="*/ 101705 w 2962440"/>
+              <a:gd name="csY1" fmla="*/ 165382 h 1501201"/>
+              <a:gd name="csX2" fmla="*/ 101705 w 2962440"/>
+              <a:gd name="csY2" fmla="*/ 1335819 h 1501201"/>
+              <a:gd name="csX3" fmla="*/ 165382 w 2962440"/>
+              <a:gd name="csY3" fmla="*/ 1399496 h 1501201"/>
+              <a:gd name="csX4" fmla="*/ 2797058 w 2962440"/>
+              <a:gd name="csY4" fmla="*/ 1399496 h 1501201"/>
+              <a:gd name="csX5" fmla="*/ 2860735 w 2962440"/>
+              <a:gd name="csY5" fmla="*/ 1335819 h 1501201"/>
+              <a:gd name="csX6" fmla="*/ 2860735 w 2962440"/>
+              <a:gd name="csY6" fmla="*/ 165382 h 1501201"/>
+              <a:gd name="csX7" fmla="*/ 2797058 w 2962440"/>
+              <a:gd name="csY7" fmla="*/ 101705 h 1501201"/>
+              <a:gd name="csX8" fmla="*/ 575299 w 2962440"/>
+              <a:gd name="csY8" fmla="*/ 106833 h 1501201"/>
+              <a:gd name="csX9" fmla="*/ 165382 w 2962440"/>
+              <a:gd name="csY9" fmla="*/ 101705 h 1501201"/>
+              <a:gd name="csX10" fmla="*/ 69336 w 2962440"/>
+              <a:gd name="csY10" fmla="*/ 0 h 1501201"/>
+              <a:gd name="csX11" fmla="*/ 575299 w 2962440"/>
+              <a:gd name="csY11" fmla="*/ 0 h 1501201"/>
+              <a:gd name="csX12" fmla="*/ 861858 w 2962440"/>
+              <a:gd name="csY12" fmla="*/ 0 h 1501201"/>
+              <a:gd name="csX13" fmla="*/ 2163120 w 2962440"/>
+              <a:gd name="csY13" fmla="*/ 0 h 1501201"/>
+              <a:gd name="csX14" fmla="*/ 2339299 w 2962440"/>
+              <a:gd name="csY14" fmla="*/ 0 h 1501201"/>
+              <a:gd name="csX15" fmla="*/ 2893104 w 2962440"/>
+              <a:gd name="csY15" fmla="*/ 0 h 1501201"/>
+              <a:gd name="csX16" fmla="*/ 2962440 w 2962440"/>
+              <a:gd name="csY16" fmla="*/ 69336 h 1501201"/>
+              <a:gd name="csX17" fmla="*/ 2962440 w 2962440"/>
+              <a:gd name="csY17" fmla="*/ 1431865 h 1501201"/>
+              <a:gd name="csX18" fmla="*/ 2893104 w 2962440"/>
+              <a:gd name="csY18" fmla="*/ 1501201 h 1501201"/>
+              <a:gd name="csX19" fmla="*/ 2339299 w 2962440"/>
+              <a:gd name="csY19" fmla="*/ 1501201 h 1501201"/>
+              <a:gd name="csX20" fmla="*/ 2163120 w 2962440"/>
+              <a:gd name="csY20" fmla="*/ 1501201 h 1501201"/>
+              <a:gd name="csX21" fmla="*/ 861858 w 2962440"/>
+              <a:gd name="csY21" fmla="*/ 1501201 h 1501201"/>
+              <a:gd name="csX22" fmla="*/ 575299 w 2962440"/>
+              <a:gd name="csY22" fmla="*/ 1501201 h 1501201"/>
+              <a:gd name="csX23" fmla="*/ 69336 w 2962440"/>
+              <a:gd name="csY23" fmla="*/ 1501201 h 1501201"/>
+              <a:gd name="csX24" fmla="*/ 0 w 2962440"/>
+              <a:gd name="csY24" fmla="*/ 1431865 h 1501201"/>
+              <a:gd name="csX25" fmla="*/ 0 w 2962440"/>
+              <a:gd name="csY25" fmla="*/ 69336 h 1501201"/>
+              <a:gd name="csX26" fmla="*/ 69336 w 2962440"/>
+              <a:gd name="csY26" fmla="*/ 0 h 1501201"/>
+              <a:gd name="csX0" fmla="*/ 165382 w 2962440"/>
+              <a:gd name="csY0" fmla="*/ 101705 h 1501201"/>
+              <a:gd name="csX1" fmla="*/ 101705 w 2962440"/>
+              <a:gd name="csY1" fmla="*/ 165382 h 1501201"/>
+              <a:gd name="csX2" fmla="*/ 101705 w 2962440"/>
+              <a:gd name="csY2" fmla="*/ 1335819 h 1501201"/>
+              <a:gd name="csX3" fmla="*/ 165382 w 2962440"/>
+              <a:gd name="csY3" fmla="*/ 1399496 h 1501201"/>
+              <a:gd name="csX4" fmla="*/ 2797058 w 2962440"/>
+              <a:gd name="csY4" fmla="*/ 1399496 h 1501201"/>
+              <a:gd name="csX5" fmla="*/ 2860735 w 2962440"/>
+              <a:gd name="csY5" fmla="*/ 1335819 h 1501201"/>
+              <a:gd name="csX6" fmla="*/ 2860735 w 2962440"/>
+              <a:gd name="csY6" fmla="*/ 165382 h 1501201"/>
+              <a:gd name="csX7" fmla="*/ 2797058 w 2962440"/>
+              <a:gd name="csY7" fmla="*/ 101705 h 1501201"/>
+              <a:gd name="csX8" fmla="*/ 165382 w 2962440"/>
+              <a:gd name="csY8" fmla="*/ 101705 h 1501201"/>
+              <a:gd name="csX9" fmla="*/ 69336 w 2962440"/>
+              <a:gd name="csY9" fmla="*/ 0 h 1501201"/>
+              <a:gd name="csX10" fmla="*/ 575299 w 2962440"/>
+              <a:gd name="csY10" fmla="*/ 0 h 1501201"/>
+              <a:gd name="csX11" fmla="*/ 861858 w 2962440"/>
+              <a:gd name="csY11" fmla="*/ 0 h 1501201"/>
+              <a:gd name="csX12" fmla="*/ 2163120 w 2962440"/>
+              <a:gd name="csY12" fmla="*/ 0 h 1501201"/>
+              <a:gd name="csX13" fmla="*/ 2339299 w 2962440"/>
+              <a:gd name="csY13" fmla="*/ 0 h 1501201"/>
+              <a:gd name="csX14" fmla="*/ 2893104 w 2962440"/>
+              <a:gd name="csY14" fmla="*/ 0 h 1501201"/>
+              <a:gd name="csX15" fmla="*/ 2962440 w 2962440"/>
+              <a:gd name="csY15" fmla="*/ 69336 h 1501201"/>
+              <a:gd name="csX16" fmla="*/ 2962440 w 2962440"/>
+              <a:gd name="csY16" fmla="*/ 1431865 h 1501201"/>
+              <a:gd name="csX17" fmla="*/ 2893104 w 2962440"/>
+              <a:gd name="csY17" fmla="*/ 1501201 h 1501201"/>
+              <a:gd name="csX18" fmla="*/ 2339299 w 2962440"/>
+              <a:gd name="csY18" fmla="*/ 1501201 h 1501201"/>
+              <a:gd name="csX19" fmla="*/ 2163120 w 2962440"/>
+              <a:gd name="csY19" fmla="*/ 1501201 h 1501201"/>
+              <a:gd name="csX20" fmla="*/ 861858 w 2962440"/>
+              <a:gd name="csY20" fmla="*/ 1501201 h 1501201"/>
+              <a:gd name="csX21" fmla="*/ 575299 w 2962440"/>
+              <a:gd name="csY21" fmla="*/ 1501201 h 1501201"/>
+              <a:gd name="csX22" fmla="*/ 69336 w 2962440"/>
+              <a:gd name="csY22" fmla="*/ 1501201 h 1501201"/>
+              <a:gd name="csX23" fmla="*/ 0 w 2962440"/>
+              <a:gd name="csY23" fmla="*/ 1431865 h 1501201"/>
+              <a:gd name="csX24" fmla="*/ 0 w 2962440"/>
+              <a:gd name="csY24" fmla="*/ 69336 h 1501201"/>
+              <a:gd name="csX25" fmla="*/ 69336 w 2962440"/>
+              <a:gd name="csY25" fmla="*/ 0 h 1501201"/>
+              <a:gd name="csX0" fmla="*/ 165382 w 2962440"/>
+              <a:gd name="csY0" fmla="*/ 101705 h 1501201"/>
+              <a:gd name="csX1" fmla="*/ 101705 w 2962440"/>
+              <a:gd name="csY1" fmla="*/ 165382 h 1501201"/>
+              <a:gd name="csX2" fmla="*/ 101705 w 2962440"/>
+              <a:gd name="csY2" fmla="*/ 1335819 h 1501201"/>
+              <a:gd name="csX3" fmla="*/ 165382 w 2962440"/>
+              <a:gd name="csY3" fmla="*/ 1399496 h 1501201"/>
+              <a:gd name="csX4" fmla="*/ 2797058 w 2962440"/>
+              <a:gd name="csY4" fmla="*/ 1399496 h 1501201"/>
+              <a:gd name="csX5" fmla="*/ 2860735 w 2962440"/>
+              <a:gd name="csY5" fmla="*/ 1335819 h 1501201"/>
+              <a:gd name="csX6" fmla="*/ 2860735 w 2962440"/>
+              <a:gd name="csY6" fmla="*/ 165382 h 1501201"/>
+              <a:gd name="csX7" fmla="*/ 2797058 w 2962440"/>
+              <a:gd name="csY7" fmla="*/ 101705 h 1501201"/>
+              <a:gd name="csX8" fmla="*/ 165382 w 2962440"/>
+              <a:gd name="csY8" fmla="*/ 101705 h 1501201"/>
+              <a:gd name="csX9" fmla="*/ 69336 w 2962440"/>
+              <a:gd name="csY9" fmla="*/ 0 h 1501201"/>
+              <a:gd name="csX10" fmla="*/ 861858 w 2962440"/>
+              <a:gd name="csY10" fmla="*/ 0 h 1501201"/>
+              <a:gd name="csX11" fmla="*/ 2163120 w 2962440"/>
+              <a:gd name="csY11" fmla="*/ 0 h 1501201"/>
+              <a:gd name="csX12" fmla="*/ 2339299 w 2962440"/>
+              <a:gd name="csY12" fmla="*/ 0 h 1501201"/>
+              <a:gd name="csX13" fmla="*/ 2893104 w 2962440"/>
+              <a:gd name="csY13" fmla="*/ 0 h 1501201"/>
+              <a:gd name="csX14" fmla="*/ 2962440 w 2962440"/>
+              <a:gd name="csY14" fmla="*/ 69336 h 1501201"/>
+              <a:gd name="csX15" fmla="*/ 2962440 w 2962440"/>
+              <a:gd name="csY15" fmla="*/ 1431865 h 1501201"/>
+              <a:gd name="csX16" fmla="*/ 2893104 w 2962440"/>
+              <a:gd name="csY16" fmla="*/ 1501201 h 1501201"/>
+              <a:gd name="csX17" fmla="*/ 2339299 w 2962440"/>
+              <a:gd name="csY17" fmla="*/ 1501201 h 1501201"/>
+              <a:gd name="csX18" fmla="*/ 2163120 w 2962440"/>
+              <a:gd name="csY18" fmla="*/ 1501201 h 1501201"/>
+              <a:gd name="csX19" fmla="*/ 861858 w 2962440"/>
+              <a:gd name="csY19" fmla="*/ 1501201 h 1501201"/>
+              <a:gd name="csX20" fmla="*/ 575299 w 2962440"/>
+              <a:gd name="csY20" fmla="*/ 1501201 h 1501201"/>
+              <a:gd name="csX21" fmla="*/ 69336 w 2962440"/>
+              <a:gd name="csY21" fmla="*/ 1501201 h 1501201"/>
+              <a:gd name="csX22" fmla="*/ 0 w 2962440"/>
+              <a:gd name="csY22" fmla="*/ 1431865 h 1501201"/>
+              <a:gd name="csX23" fmla="*/ 0 w 2962440"/>
+              <a:gd name="csY23" fmla="*/ 69336 h 1501201"/>
+              <a:gd name="csX24" fmla="*/ 69336 w 2962440"/>
+              <a:gd name="csY24" fmla="*/ 0 h 1501201"/>
+              <a:gd name="csX0" fmla="*/ 165382 w 2962440"/>
+              <a:gd name="csY0" fmla="*/ 101705 h 1501201"/>
+              <a:gd name="csX1" fmla="*/ 101705 w 2962440"/>
+              <a:gd name="csY1" fmla="*/ 165382 h 1501201"/>
+              <a:gd name="csX2" fmla="*/ 101705 w 2962440"/>
+              <a:gd name="csY2" fmla="*/ 1335819 h 1501201"/>
+              <a:gd name="csX3" fmla="*/ 165382 w 2962440"/>
+              <a:gd name="csY3" fmla="*/ 1399496 h 1501201"/>
+              <a:gd name="csX4" fmla="*/ 2797058 w 2962440"/>
+              <a:gd name="csY4" fmla="*/ 1399496 h 1501201"/>
+              <a:gd name="csX5" fmla="*/ 2860735 w 2962440"/>
+              <a:gd name="csY5" fmla="*/ 1335819 h 1501201"/>
+              <a:gd name="csX6" fmla="*/ 2860735 w 2962440"/>
+              <a:gd name="csY6" fmla="*/ 165382 h 1501201"/>
+              <a:gd name="csX7" fmla="*/ 2797058 w 2962440"/>
+              <a:gd name="csY7" fmla="*/ 101705 h 1501201"/>
+              <a:gd name="csX8" fmla="*/ 165382 w 2962440"/>
+              <a:gd name="csY8" fmla="*/ 101705 h 1501201"/>
+              <a:gd name="csX9" fmla="*/ 69336 w 2962440"/>
+              <a:gd name="csY9" fmla="*/ 0 h 1501201"/>
+              <a:gd name="csX10" fmla="*/ 2163120 w 2962440"/>
+              <a:gd name="csY10" fmla="*/ 0 h 1501201"/>
+              <a:gd name="csX11" fmla="*/ 2339299 w 2962440"/>
+              <a:gd name="csY11" fmla="*/ 0 h 1501201"/>
+              <a:gd name="csX12" fmla="*/ 2893104 w 2962440"/>
+              <a:gd name="csY12" fmla="*/ 0 h 1501201"/>
+              <a:gd name="csX13" fmla="*/ 2962440 w 2962440"/>
+              <a:gd name="csY13" fmla="*/ 69336 h 1501201"/>
+              <a:gd name="csX14" fmla="*/ 2962440 w 2962440"/>
+              <a:gd name="csY14" fmla="*/ 1431865 h 1501201"/>
+              <a:gd name="csX15" fmla="*/ 2893104 w 2962440"/>
+              <a:gd name="csY15" fmla="*/ 1501201 h 1501201"/>
+              <a:gd name="csX16" fmla="*/ 2339299 w 2962440"/>
+              <a:gd name="csY16" fmla="*/ 1501201 h 1501201"/>
+              <a:gd name="csX17" fmla="*/ 2163120 w 2962440"/>
+              <a:gd name="csY17" fmla="*/ 1501201 h 1501201"/>
+              <a:gd name="csX18" fmla="*/ 861858 w 2962440"/>
+              <a:gd name="csY18" fmla="*/ 1501201 h 1501201"/>
+              <a:gd name="csX19" fmla="*/ 575299 w 2962440"/>
+              <a:gd name="csY19" fmla="*/ 1501201 h 1501201"/>
+              <a:gd name="csX20" fmla="*/ 69336 w 2962440"/>
+              <a:gd name="csY20" fmla="*/ 1501201 h 1501201"/>
+              <a:gd name="csX21" fmla="*/ 0 w 2962440"/>
+              <a:gd name="csY21" fmla="*/ 1431865 h 1501201"/>
+              <a:gd name="csX22" fmla="*/ 0 w 2962440"/>
+              <a:gd name="csY22" fmla="*/ 69336 h 1501201"/>
+              <a:gd name="csX23" fmla="*/ 69336 w 2962440"/>
+              <a:gd name="csY23" fmla="*/ 0 h 1501201"/>
+              <a:gd name="csX0" fmla="*/ 165382 w 2962440"/>
+              <a:gd name="csY0" fmla="*/ 101705 h 1501201"/>
+              <a:gd name="csX1" fmla="*/ 101705 w 2962440"/>
+              <a:gd name="csY1" fmla="*/ 165382 h 1501201"/>
+              <a:gd name="csX2" fmla="*/ 101705 w 2962440"/>
+              <a:gd name="csY2" fmla="*/ 1335819 h 1501201"/>
+              <a:gd name="csX3" fmla="*/ 165382 w 2962440"/>
+              <a:gd name="csY3" fmla="*/ 1399496 h 1501201"/>
+              <a:gd name="csX4" fmla="*/ 2797058 w 2962440"/>
+              <a:gd name="csY4" fmla="*/ 1399496 h 1501201"/>
+              <a:gd name="csX5" fmla="*/ 2860735 w 2962440"/>
+              <a:gd name="csY5" fmla="*/ 1335819 h 1501201"/>
+              <a:gd name="csX6" fmla="*/ 2860735 w 2962440"/>
+              <a:gd name="csY6" fmla="*/ 165382 h 1501201"/>
+              <a:gd name="csX7" fmla="*/ 2797058 w 2962440"/>
+              <a:gd name="csY7" fmla="*/ 101705 h 1501201"/>
+              <a:gd name="csX8" fmla="*/ 165382 w 2962440"/>
+              <a:gd name="csY8" fmla="*/ 101705 h 1501201"/>
+              <a:gd name="csX9" fmla="*/ 69336 w 2962440"/>
+              <a:gd name="csY9" fmla="*/ 0 h 1501201"/>
+              <a:gd name="csX10" fmla="*/ 2339299 w 2962440"/>
+              <a:gd name="csY10" fmla="*/ 0 h 1501201"/>
+              <a:gd name="csX11" fmla="*/ 2893104 w 2962440"/>
+              <a:gd name="csY11" fmla="*/ 0 h 1501201"/>
+              <a:gd name="csX12" fmla="*/ 2962440 w 2962440"/>
+              <a:gd name="csY12" fmla="*/ 69336 h 1501201"/>
+              <a:gd name="csX13" fmla="*/ 2962440 w 2962440"/>
+              <a:gd name="csY13" fmla="*/ 1431865 h 1501201"/>
+              <a:gd name="csX14" fmla="*/ 2893104 w 2962440"/>
+              <a:gd name="csY14" fmla="*/ 1501201 h 1501201"/>
+              <a:gd name="csX15" fmla="*/ 2339299 w 2962440"/>
+              <a:gd name="csY15" fmla="*/ 1501201 h 1501201"/>
+              <a:gd name="csX16" fmla="*/ 2163120 w 2962440"/>
+              <a:gd name="csY16" fmla="*/ 1501201 h 1501201"/>
+              <a:gd name="csX17" fmla="*/ 861858 w 2962440"/>
+              <a:gd name="csY17" fmla="*/ 1501201 h 1501201"/>
+              <a:gd name="csX18" fmla="*/ 575299 w 2962440"/>
+              <a:gd name="csY18" fmla="*/ 1501201 h 1501201"/>
+              <a:gd name="csX19" fmla="*/ 69336 w 2962440"/>
+              <a:gd name="csY19" fmla="*/ 1501201 h 1501201"/>
+              <a:gd name="csX20" fmla="*/ 0 w 2962440"/>
+              <a:gd name="csY20" fmla="*/ 1431865 h 1501201"/>
+              <a:gd name="csX21" fmla="*/ 0 w 2962440"/>
+              <a:gd name="csY21" fmla="*/ 69336 h 1501201"/>
+              <a:gd name="csX22" fmla="*/ 69336 w 2962440"/>
+              <a:gd name="csY22" fmla="*/ 0 h 1501201"/>
+              <a:gd name="csX0" fmla="*/ 165382 w 2962440"/>
+              <a:gd name="csY0" fmla="*/ 101705 h 1501201"/>
+              <a:gd name="csX1" fmla="*/ 101705 w 2962440"/>
+              <a:gd name="csY1" fmla="*/ 165382 h 1501201"/>
+              <a:gd name="csX2" fmla="*/ 101705 w 2962440"/>
+              <a:gd name="csY2" fmla="*/ 1335819 h 1501201"/>
+              <a:gd name="csX3" fmla="*/ 165382 w 2962440"/>
+              <a:gd name="csY3" fmla="*/ 1399496 h 1501201"/>
+              <a:gd name="csX4" fmla="*/ 2797058 w 2962440"/>
+              <a:gd name="csY4" fmla="*/ 1399496 h 1501201"/>
+              <a:gd name="csX5" fmla="*/ 2860735 w 2962440"/>
+              <a:gd name="csY5" fmla="*/ 1335819 h 1501201"/>
+              <a:gd name="csX6" fmla="*/ 2860735 w 2962440"/>
+              <a:gd name="csY6" fmla="*/ 165382 h 1501201"/>
+              <a:gd name="csX7" fmla="*/ 2797058 w 2962440"/>
+              <a:gd name="csY7" fmla="*/ 101705 h 1501201"/>
+              <a:gd name="csX8" fmla="*/ 165382 w 2962440"/>
+              <a:gd name="csY8" fmla="*/ 101705 h 1501201"/>
+              <a:gd name="csX9" fmla="*/ 69336 w 2962440"/>
+              <a:gd name="csY9" fmla="*/ 0 h 1501201"/>
+              <a:gd name="csX10" fmla="*/ 2893104 w 2962440"/>
+              <a:gd name="csY10" fmla="*/ 0 h 1501201"/>
+              <a:gd name="csX11" fmla="*/ 2962440 w 2962440"/>
+              <a:gd name="csY11" fmla="*/ 69336 h 1501201"/>
+              <a:gd name="csX12" fmla="*/ 2962440 w 2962440"/>
+              <a:gd name="csY12" fmla="*/ 1431865 h 1501201"/>
+              <a:gd name="csX13" fmla="*/ 2893104 w 2962440"/>
+              <a:gd name="csY13" fmla="*/ 1501201 h 1501201"/>
+              <a:gd name="csX14" fmla="*/ 2339299 w 2962440"/>
+              <a:gd name="csY14" fmla="*/ 1501201 h 1501201"/>
+              <a:gd name="csX15" fmla="*/ 2163120 w 2962440"/>
+              <a:gd name="csY15" fmla="*/ 1501201 h 1501201"/>
+              <a:gd name="csX16" fmla="*/ 861858 w 2962440"/>
+              <a:gd name="csY16" fmla="*/ 1501201 h 1501201"/>
+              <a:gd name="csX17" fmla="*/ 575299 w 2962440"/>
+              <a:gd name="csY17" fmla="*/ 1501201 h 1501201"/>
+              <a:gd name="csX18" fmla="*/ 69336 w 2962440"/>
+              <a:gd name="csY18" fmla="*/ 1501201 h 1501201"/>
+              <a:gd name="csX19" fmla="*/ 0 w 2962440"/>
+              <a:gd name="csY19" fmla="*/ 1431865 h 1501201"/>
+              <a:gd name="csX20" fmla="*/ 0 w 2962440"/>
+              <a:gd name="csY20" fmla="*/ 69336 h 1501201"/>
+              <a:gd name="csX21" fmla="*/ 69336 w 2962440"/>
+              <a:gd name="csY21" fmla="*/ 0 h 1501201"/>
+              <a:gd name="csX0" fmla="*/ 165382 w 2962440"/>
+              <a:gd name="csY0" fmla="*/ 101705 h 1501201"/>
+              <a:gd name="csX1" fmla="*/ 101705 w 2962440"/>
+              <a:gd name="csY1" fmla="*/ 165382 h 1501201"/>
+              <a:gd name="csX2" fmla="*/ 101705 w 2962440"/>
+              <a:gd name="csY2" fmla="*/ 1335819 h 1501201"/>
+              <a:gd name="csX3" fmla="*/ 165382 w 2962440"/>
+              <a:gd name="csY3" fmla="*/ 1399496 h 1501201"/>
+              <a:gd name="csX4" fmla="*/ 2797058 w 2962440"/>
+              <a:gd name="csY4" fmla="*/ 1399496 h 1501201"/>
+              <a:gd name="csX5" fmla="*/ 2860735 w 2962440"/>
+              <a:gd name="csY5" fmla="*/ 1335819 h 1501201"/>
+              <a:gd name="csX6" fmla="*/ 2860735 w 2962440"/>
+              <a:gd name="csY6" fmla="*/ 165382 h 1501201"/>
+              <a:gd name="csX7" fmla="*/ 2797058 w 2962440"/>
+              <a:gd name="csY7" fmla="*/ 101705 h 1501201"/>
+              <a:gd name="csX8" fmla="*/ 165382 w 2962440"/>
+              <a:gd name="csY8" fmla="*/ 101705 h 1501201"/>
+              <a:gd name="csX9" fmla="*/ 69336 w 2962440"/>
+              <a:gd name="csY9" fmla="*/ 0 h 1501201"/>
+              <a:gd name="csX10" fmla="*/ 2893104 w 2962440"/>
+              <a:gd name="csY10" fmla="*/ 0 h 1501201"/>
+              <a:gd name="csX11" fmla="*/ 2962440 w 2962440"/>
+              <a:gd name="csY11" fmla="*/ 69336 h 1501201"/>
+              <a:gd name="csX12" fmla="*/ 2962440 w 2962440"/>
+              <a:gd name="csY12" fmla="*/ 1431865 h 1501201"/>
+              <a:gd name="csX13" fmla="*/ 2893104 w 2962440"/>
+              <a:gd name="csY13" fmla="*/ 1501201 h 1501201"/>
+              <a:gd name="csX14" fmla="*/ 2163120 w 2962440"/>
+              <a:gd name="csY14" fmla="*/ 1501201 h 1501201"/>
+              <a:gd name="csX15" fmla="*/ 861858 w 2962440"/>
+              <a:gd name="csY15" fmla="*/ 1501201 h 1501201"/>
+              <a:gd name="csX16" fmla="*/ 575299 w 2962440"/>
+              <a:gd name="csY16" fmla="*/ 1501201 h 1501201"/>
+              <a:gd name="csX17" fmla="*/ 69336 w 2962440"/>
+              <a:gd name="csY17" fmla="*/ 1501201 h 1501201"/>
+              <a:gd name="csX18" fmla="*/ 0 w 2962440"/>
+              <a:gd name="csY18" fmla="*/ 1431865 h 1501201"/>
+              <a:gd name="csX19" fmla="*/ 0 w 2962440"/>
+              <a:gd name="csY19" fmla="*/ 69336 h 1501201"/>
+              <a:gd name="csX20" fmla="*/ 69336 w 2962440"/>
+              <a:gd name="csY20" fmla="*/ 0 h 1501201"/>
+              <a:gd name="csX0" fmla="*/ 165382 w 2962440"/>
+              <a:gd name="csY0" fmla="*/ 101705 h 1501201"/>
+              <a:gd name="csX1" fmla="*/ 101705 w 2962440"/>
+              <a:gd name="csY1" fmla="*/ 165382 h 1501201"/>
+              <a:gd name="csX2" fmla="*/ 101705 w 2962440"/>
+              <a:gd name="csY2" fmla="*/ 1335819 h 1501201"/>
+              <a:gd name="csX3" fmla="*/ 165382 w 2962440"/>
+              <a:gd name="csY3" fmla="*/ 1399496 h 1501201"/>
+              <a:gd name="csX4" fmla="*/ 2797058 w 2962440"/>
+              <a:gd name="csY4" fmla="*/ 1399496 h 1501201"/>
+              <a:gd name="csX5" fmla="*/ 2860735 w 2962440"/>
+              <a:gd name="csY5" fmla="*/ 1335819 h 1501201"/>
+              <a:gd name="csX6" fmla="*/ 2860735 w 2962440"/>
+              <a:gd name="csY6" fmla="*/ 165382 h 1501201"/>
+              <a:gd name="csX7" fmla="*/ 2797058 w 2962440"/>
+              <a:gd name="csY7" fmla="*/ 101705 h 1501201"/>
+              <a:gd name="csX8" fmla="*/ 165382 w 2962440"/>
+              <a:gd name="csY8" fmla="*/ 101705 h 1501201"/>
+              <a:gd name="csX9" fmla="*/ 69336 w 2962440"/>
+              <a:gd name="csY9" fmla="*/ 0 h 1501201"/>
+              <a:gd name="csX10" fmla="*/ 2893104 w 2962440"/>
+              <a:gd name="csY10" fmla="*/ 0 h 1501201"/>
+              <a:gd name="csX11" fmla="*/ 2962440 w 2962440"/>
+              <a:gd name="csY11" fmla="*/ 69336 h 1501201"/>
+              <a:gd name="csX12" fmla="*/ 2962440 w 2962440"/>
+              <a:gd name="csY12" fmla="*/ 1431865 h 1501201"/>
+              <a:gd name="csX13" fmla="*/ 2893104 w 2962440"/>
+              <a:gd name="csY13" fmla="*/ 1501201 h 1501201"/>
+              <a:gd name="csX14" fmla="*/ 861858 w 2962440"/>
+              <a:gd name="csY14" fmla="*/ 1501201 h 1501201"/>
+              <a:gd name="csX15" fmla="*/ 575299 w 2962440"/>
+              <a:gd name="csY15" fmla="*/ 1501201 h 1501201"/>
+              <a:gd name="csX16" fmla="*/ 69336 w 2962440"/>
+              <a:gd name="csY16" fmla="*/ 1501201 h 1501201"/>
+              <a:gd name="csX17" fmla="*/ 0 w 2962440"/>
+              <a:gd name="csY17" fmla="*/ 1431865 h 1501201"/>
+              <a:gd name="csX18" fmla="*/ 0 w 2962440"/>
+              <a:gd name="csY18" fmla="*/ 69336 h 1501201"/>
+              <a:gd name="csX19" fmla="*/ 69336 w 2962440"/>
+              <a:gd name="csY19" fmla="*/ 0 h 1501201"/>
+              <a:gd name="csX0" fmla="*/ 165382 w 2962440"/>
+              <a:gd name="csY0" fmla="*/ 101705 h 1501201"/>
+              <a:gd name="csX1" fmla="*/ 101705 w 2962440"/>
+              <a:gd name="csY1" fmla="*/ 165382 h 1501201"/>
+              <a:gd name="csX2" fmla="*/ 101705 w 2962440"/>
+              <a:gd name="csY2" fmla="*/ 1335819 h 1501201"/>
+              <a:gd name="csX3" fmla="*/ 165382 w 2962440"/>
+              <a:gd name="csY3" fmla="*/ 1399496 h 1501201"/>
+              <a:gd name="csX4" fmla="*/ 2797058 w 2962440"/>
+              <a:gd name="csY4" fmla="*/ 1399496 h 1501201"/>
+              <a:gd name="csX5" fmla="*/ 2860735 w 2962440"/>
+              <a:gd name="csY5" fmla="*/ 1335819 h 1501201"/>
+              <a:gd name="csX6" fmla="*/ 2860735 w 2962440"/>
+              <a:gd name="csY6" fmla="*/ 165382 h 1501201"/>
+              <a:gd name="csX7" fmla="*/ 2797058 w 2962440"/>
+              <a:gd name="csY7" fmla="*/ 101705 h 1501201"/>
+              <a:gd name="csX8" fmla="*/ 165382 w 2962440"/>
+              <a:gd name="csY8" fmla="*/ 101705 h 1501201"/>
+              <a:gd name="csX9" fmla="*/ 69336 w 2962440"/>
+              <a:gd name="csY9" fmla="*/ 0 h 1501201"/>
+              <a:gd name="csX10" fmla="*/ 2893104 w 2962440"/>
+              <a:gd name="csY10" fmla="*/ 0 h 1501201"/>
+              <a:gd name="csX11" fmla="*/ 2962440 w 2962440"/>
+              <a:gd name="csY11" fmla="*/ 69336 h 1501201"/>
+              <a:gd name="csX12" fmla="*/ 2962440 w 2962440"/>
+              <a:gd name="csY12" fmla="*/ 1431865 h 1501201"/>
+              <a:gd name="csX13" fmla="*/ 2893104 w 2962440"/>
+              <a:gd name="csY13" fmla="*/ 1501201 h 1501201"/>
+              <a:gd name="csX14" fmla="*/ 575299 w 2962440"/>
+              <a:gd name="csY14" fmla="*/ 1501201 h 1501201"/>
+              <a:gd name="csX15" fmla="*/ 69336 w 2962440"/>
+              <a:gd name="csY15" fmla="*/ 1501201 h 1501201"/>
+              <a:gd name="csX16" fmla="*/ 0 w 2962440"/>
+              <a:gd name="csY16" fmla="*/ 1431865 h 1501201"/>
+              <a:gd name="csX17" fmla="*/ 0 w 2962440"/>
+              <a:gd name="csY17" fmla="*/ 69336 h 1501201"/>
+              <a:gd name="csX18" fmla="*/ 69336 w 2962440"/>
+              <a:gd name="csY18" fmla="*/ 0 h 1501201"/>
+              <a:gd name="csX0" fmla="*/ 165382 w 2962440"/>
+              <a:gd name="csY0" fmla="*/ 101705 h 1501201"/>
+              <a:gd name="csX1" fmla="*/ 101705 w 2962440"/>
+              <a:gd name="csY1" fmla="*/ 165382 h 1501201"/>
+              <a:gd name="csX2" fmla="*/ 101705 w 2962440"/>
+              <a:gd name="csY2" fmla="*/ 1335819 h 1501201"/>
+              <a:gd name="csX3" fmla="*/ 165382 w 2962440"/>
+              <a:gd name="csY3" fmla="*/ 1399496 h 1501201"/>
+              <a:gd name="csX4" fmla="*/ 2797058 w 2962440"/>
+              <a:gd name="csY4" fmla="*/ 1399496 h 1501201"/>
+              <a:gd name="csX5" fmla="*/ 2860735 w 2962440"/>
+              <a:gd name="csY5" fmla="*/ 1335819 h 1501201"/>
+              <a:gd name="csX6" fmla="*/ 2860735 w 2962440"/>
+              <a:gd name="csY6" fmla="*/ 165382 h 1501201"/>
+              <a:gd name="csX7" fmla="*/ 2797058 w 2962440"/>
+              <a:gd name="csY7" fmla="*/ 101705 h 1501201"/>
+              <a:gd name="csX8" fmla="*/ 165382 w 2962440"/>
+              <a:gd name="csY8" fmla="*/ 101705 h 1501201"/>
+              <a:gd name="csX9" fmla="*/ 69336 w 2962440"/>
+              <a:gd name="csY9" fmla="*/ 0 h 1501201"/>
+              <a:gd name="csX10" fmla="*/ 2893104 w 2962440"/>
+              <a:gd name="csY10" fmla="*/ 0 h 1501201"/>
+              <a:gd name="csX11" fmla="*/ 2962440 w 2962440"/>
+              <a:gd name="csY11" fmla="*/ 69336 h 1501201"/>
+              <a:gd name="csX12" fmla="*/ 2962440 w 2962440"/>
+              <a:gd name="csY12" fmla="*/ 1431865 h 1501201"/>
+              <a:gd name="csX13" fmla="*/ 2893104 w 2962440"/>
+              <a:gd name="csY13" fmla="*/ 1501201 h 1501201"/>
+              <a:gd name="csX14" fmla="*/ 69336 w 2962440"/>
+              <a:gd name="csY14" fmla="*/ 1501201 h 1501201"/>
+              <a:gd name="csX15" fmla="*/ 0 w 2962440"/>
+              <a:gd name="csY15" fmla="*/ 1431865 h 1501201"/>
+              <a:gd name="csX16" fmla="*/ 0 w 2962440"/>
+              <a:gd name="csY16" fmla="*/ 69336 h 1501201"/>
+              <a:gd name="csX17" fmla="*/ 69336 w 2962440"/>
+              <a:gd name="csY17" fmla="*/ 0 h 1501201"/>
+            </a:gdLst>
+            <a:ahLst/>
+            <a:cxnLst>
+              <a:cxn ang="0">
+                <a:pos x="csX0" y="csY0"/>
+              </a:cxn>
+              <a:cxn ang="0">
+                <a:pos x="csX1" y="csY1"/>
+              </a:cxn>
+              <a:cxn ang="0">
+                <a:pos x="csX2" y="csY2"/>
+              </a:cxn>
+              <a:cxn ang="0">
+                <a:pos x="csX3" y="csY3"/>
+              </a:cxn>
+              <a:cxn ang="0">
+                <a:pos x="csX4" y="csY4"/>
+              </a:cxn>
+              <a:cxn ang="0">
+                <a:pos x="csX5" y="csY5"/>
+              </a:cxn>
+              <a:cxn ang="0">
+                <a:pos x="csX6" y="csY6"/>
+              </a:cxn>
+              <a:cxn ang="0">
+                <a:pos x="csX7" y="csY7"/>
+              </a:cxn>
+              <a:cxn ang="0">
+                <a:pos x="csX8" y="csY8"/>
+              </a:cxn>
+              <a:cxn ang="0">
+                <a:pos x="csX9" y="csY9"/>
+              </a:cxn>
+              <a:cxn ang="0">
+                <a:pos x="csX10" y="csY10"/>
+              </a:cxn>
+              <a:cxn ang="0">
+                <a:pos x="csX11" y="csY11"/>
+              </a:cxn>
+              <a:cxn ang="0">
+                <a:pos x="csX12" y="csY12"/>
+              </a:cxn>
+              <a:cxn ang="0">
+                <a:pos x="csX13" y="csY13"/>
+              </a:cxn>
+              <a:cxn ang="0">
+                <a:pos x="csX14" y="csY14"/>
+              </a:cxn>
+              <a:cxn ang="0">
+                <a:pos x="csX15" y="csY15"/>
+              </a:cxn>
+              <a:cxn ang="0">
+                <a:pos x="csX16" y="csY16"/>
+              </a:cxn>
+              <a:cxn ang="0">
+                <a:pos x="csX17" y="csY17"/>
+              </a:cxn>
+            </a:cxnLst>
+            <a:rect l="l" t="t" r="r" b="b"/>
+            <a:pathLst>
+              <a:path w="2962440" h="1501201">
+                <a:moveTo>
+                  <a:pt x="165382" y="101705"/>
+                </a:moveTo>
+                <a:cubicBezTo>
+                  <a:pt x="130214" y="101705"/>
+                  <a:pt x="101705" y="130214"/>
+                  <a:pt x="101705" y="165382"/>
+                </a:cubicBezTo>
+                <a:lnTo>
+                  <a:pt x="101705" y="1335819"/>
+                </a:lnTo>
+                <a:cubicBezTo>
+                  <a:pt x="101705" y="1370987"/>
+                  <a:pt x="130214" y="1399496"/>
+                  <a:pt x="165382" y="1399496"/>
+                </a:cubicBezTo>
+                <a:lnTo>
+                  <a:pt x="2797058" y="1399496"/>
+                </a:lnTo>
+                <a:cubicBezTo>
+                  <a:pt x="2832226" y="1399496"/>
+                  <a:pt x="2860735" y="1370987"/>
+                  <a:pt x="2860735" y="1335819"/>
+                </a:cubicBezTo>
+                <a:lnTo>
+                  <a:pt x="2860735" y="165382"/>
+                </a:lnTo>
+                <a:cubicBezTo>
+                  <a:pt x="2860735" y="130214"/>
+                  <a:pt x="2832226" y="101705"/>
+                  <a:pt x="2797058" y="101705"/>
+                </a:cubicBezTo>
+                <a:lnTo>
+                  <a:pt x="165382" y="101705"/>
+                </a:lnTo>
+                <a:close/>
+                <a:moveTo>
+                  <a:pt x="69336" y="0"/>
+                </a:moveTo>
+                <a:lnTo>
+                  <a:pt x="2893104" y="0"/>
+                </a:lnTo>
+                <a:cubicBezTo>
+                  <a:pt x="2931397" y="0"/>
+                  <a:pt x="2962440" y="31043"/>
+                  <a:pt x="2962440" y="69336"/>
+                </a:cubicBezTo>
+                <a:lnTo>
+                  <a:pt x="2962440" y="1431865"/>
+                </a:lnTo>
+                <a:cubicBezTo>
+                  <a:pt x="2962440" y="1470158"/>
+                  <a:pt x="2931397" y="1501201"/>
+                  <a:pt x="2893104" y="1501201"/>
+                </a:cubicBezTo>
+                <a:lnTo>
+                  <a:pt x="69336" y="1501201"/>
+                </a:lnTo>
+                <a:cubicBezTo>
+                  <a:pt x="31043" y="1501201"/>
+                  <a:pt x="0" y="1470158"/>
+                  <a:pt x="0" y="1431865"/>
+                </a:cubicBezTo>
+                <a:lnTo>
+                  <a:pt x="0" y="69336"/>
+                </a:lnTo>
+                <a:cubicBezTo>
+                  <a:pt x="0" y="31043"/>
+                  <a:pt x="31043" y="0"/>
+                  <a:pt x="69336" y="0"/>
+                </a:cubicBezTo>
+                <a:close/>
+              </a:path>
+            </a:pathLst>
+          </a:custGeom>
+          <a:solidFill>
+            <a:schemeClr val="tx1"/>
+          </a:solidFill>
+          <a:ln w="9525" cap="flat">
+            <a:noFill/>
+            <a:prstDash val="solid"/>
+            <a:miter/>
+          </a:ln>
+        </p:spPr>
+        <p:txBody>
+          <a:bodyPr wrap="square">
+            <a:noAutofit/>
+          </a:bodyPr>
+          <a:lstStyle/>
+          <a:p>
+            <a:endParaRPr lang="en-US">
+              <a:solidFill>
+                <a:schemeClr val="tx1"/>
+              </a:solidFill>
+            </a:endParaRPr>
+          </a:p>
+        </p:txBody>
+      </p:sp>
+    </p:spTree>
+    <p:extLst>
+      <p:ext uri="{BB962C8B-B14F-4D97-AF65-F5344CB8AC3E}">
+        <p14:creationId xmlns:p14="http://schemas.microsoft.com/office/powerpoint/2010/main" val="4219628539"/>
+      </p:ext>
+    </p:extLst>
+  </p:cSld>
+  <p:clrMapOvr>
+    <a:masterClrMapping/>
+  </p:clrMapOvr>
+</p:sld>
+</file>
+
 <file path=ppt/theme/theme1.xml><?xml version="1.0" encoding="utf-8"?>
 <a:theme xmlns:a="http://schemas.openxmlformats.org/drawingml/2006/main" name="Office Theme">
   <a:themeElements>

</xml_diff>

<commit_message>
Add new SVG icons for fullscreen and normal screen modes in UI Toolbar
</commit_message>
<xml_diff>
--- a/Icons_UI/Icons_UI.pptx
+++ b/Icons_UI/Icons_UI.pptx
@@ -26117,99 +26117,6 @@
       </p:grpSpPr>
       <p:grpSp>
         <p:nvGrpSpPr>
-          <p:cNvPr id="12" name="Group 11">
-            <a:extLst>
-              <a:ext uri="{FF2B5EF4-FFF2-40B4-BE49-F238E27FC236}">
-                <a16:creationId xmlns:a16="http://schemas.microsoft.com/office/drawing/2014/main" id="{CAC00753-113C-F4B2-ED45-47CEF096D495}"/>
-              </a:ext>
-            </a:extLst>
-          </p:cNvPr>
-          <p:cNvGrpSpPr/>
-          <p:nvPr/>
-        </p:nvGrpSpPr>
-        <p:grpSpPr>
-          <a:xfrm>
-            <a:off x="320040" y="2292972"/>
-            <a:ext cx="11871960" cy="1501200"/>
-            <a:chOff x="1644242" y="6040073"/>
-            <a:chExt cx="7684316" cy="562063"/>
-          </a:xfrm>
-        </p:grpSpPr>
-        <p:cxnSp>
-          <p:nvCxnSpPr>
-            <p:cNvPr id="10" name="Straight Connector 9">
-              <a:extLst>
-                <a:ext uri="{FF2B5EF4-FFF2-40B4-BE49-F238E27FC236}">
-                  <a16:creationId xmlns:a16="http://schemas.microsoft.com/office/drawing/2014/main" id="{E34B6E2B-930C-BFFA-DD7B-980FC90E76AC}"/>
-                </a:ext>
-              </a:extLst>
-            </p:cNvPr>
-            <p:cNvCxnSpPr/>
-            <p:nvPr/>
-          </p:nvCxnSpPr>
-          <p:spPr>
-            <a:xfrm>
-              <a:off x="1644242" y="6040073"/>
-              <a:ext cx="7684316" cy="0"/>
-            </a:xfrm>
-            <a:prstGeom prst="line">
-              <a:avLst/>
-            </a:prstGeom>
-          </p:spPr>
-          <p:style>
-            <a:lnRef idx="1">
-              <a:schemeClr val="accent1"/>
-            </a:lnRef>
-            <a:fillRef idx="0">
-              <a:schemeClr val="accent1"/>
-            </a:fillRef>
-            <a:effectRef idx="0">
-              <a:schemeClr val="accent1"/>
-            </a:effectRef>
-            <a:fontRef idx="minor">
-              <a:schemeClr val="tx1"/>
-            </a:fontRef>
-          </p:style>
-        </p:cxnSp>
-        <p:cxnSp>
-          <p:nvCxnSpPr>
-            <p:cNvPr id="11" name="Straight Connector 10">
-              <a:extLst>
-                <a:ext uri="{FF2B5EF4-FFF2-40B4-BE49-F238E27FC236}">
-                  <a16:creationId xmlns:a16="http://schemas.microsoft.com/office/drawing/2014/main" id="{C3217390-DEF4-2509-2D15-1F1A1DC1C622}"/>
-                </a:ext>
-              </a:extLst>
-            </p:cNvPr>
-            <p:cNvCxnSpPr/>
-            <p:nvPr/>
-          </p:nvCxnSpPr>
-          <p:spPr>
-            <a:xfrm>
-              <a:off x="1644242" y="6602136"/>
-              <a:ext cx="7684316" cy="0"/>
-            </a:xfrm>
-            <a:prstGeom prst="line">
-              <a:avLst/>
-            </a:prstGeom>
-          </p:spPr>
-          <p:style>
-            <a:lnRef idx="1">
-              <a:schemeClr val="accent1"/>
-            </a:lnRef>
-            <a:fillRef idx="0">
-              <a:schemeClr val="accent1"/>
-            </a:fillRef>
-            <a:effectRef idx="0">
-              <a:schemeClr val="accent1"/>
-            </a:effectRef>
-            <a:fontRef idx="minor">
-              <a:schemeClr val="tx1"/>
-            </a:fontRef>
-          </p:style>
-        </p:cxnSp>
-      </p:grpSp>
-      <p:grpSp>
-        <p:nvGrpSpPr>
           <p:cNvPr id="143" name="Group 142">
             <a:extLst>
               <a:ext uri="{FF2B5EF4-FFF2-40B4-BE49-F238E27FC236}">
@@ -29899,6 +29806,1728 @@
           </a:p>
         </p:txBody>
       </p:sp>
+      <p:sp>
+        <p:nvSpPr>
+          <p:cNvPr id="26" name="Freeform: Shape 25">
+            <a:extLst>
+              <a:ext uri="{FF2B5EF4-FFF2-40B4-BE49-F238E27FC236}">
+                <a16:creationId xmlns:a16="http://schemas.microsoft.com/office/drawing/2014/main" id="{CE05D37B-BC33-5991-7BB4-716E8DAB7952}"/>
+              </a:ext>
+            </a:extLst>
+          </p:cNvPr>
+          <p:cNvSpPr/>
+          <p:nvPr/>
+        </p:nvSpPr>
+        <p:spPr>
+          <a:xfrm flipH="1" flipV="1">
+            <a:off x="8148051" y="3043572"/>
+            <a:ext cx="375300" cy="375300"/>
+          </a:xfrm>
+          <a:custGeom>
+            <a:avLst/>
+            <a:gdLst>
+              <a:gd name="csX0" fmla="*/ 62550 w 375300"/>
+              <a:gd name="csY0" fmla="*/ 0 h 375300"/>
+              <a:gd name="csX1" fmla="*/ 125100 w 375300"/>
+              <a:gd name="csY1" fmla="*/ 62550 h 375300"/>
+              <a:gd name="csX2" fmla="*/ 125100 w 375300"/>
+              <a:gd name="csY2" fmla="*/ 161742 h 375300"/>
+              <a:gd name="csX3" fmla="*/ 268520 w 375300"/>
+              <a:gd name="csY3" fmla="*/ 18321 h 375300"/>
+              <a:gd name="csX4" fmla="*/ 356979 w 375300"/>
+              <a:gd name="csY4" fmla="*/ 18321 h 375300"/>
+              <a:gd name="csX5" fmla="*/ 356979 w 375300"/>
+              <a:gd name="csY5" fmla="*/ 106779 h 375300"/>
+              <a:gd name="csX6" fmla="*/ 213559 w 375300"/>
+              <a:gd name="csY6" fmla="*/ 250200 h 375300"/>
+              <a:gd name="csX7" fmla="*/ 312750 w 375300"/>
+              <a:gd name="csY7" fmla="*/ 250200 h 375300"/>
+              <a:gd name="csX8" fmla="*/ 375300 w 375300"/>
+              <a:gd name="csY8" fmla="*/ 312750 h 375300"/>
+              <a:gd name="csX9" fmla="*/ 312750 w 375300"/>
+              <a:gd name="csY9" fmla="*/ 375300 h 375300"/>
+              <a:gd name="csX10" fmla="*/ 62550 w 375300"/>
+              <a:gd name="csY10" fmla="*/ 375300 h 375300"/>
+              <a:gd name="csX11" fmla="*/ 18320 w 375300"/>
+              <a:gd name="csY11" fmla="*/ 356979 h 375300"/>
+              <a:gd name="csX12" fmla="*/ 0 w 375300"/>
+              <a:gd name="csY12" fmla="*/ 312750 h 375300"/>
+              <a:gd name="csX13" fmla="*/ 0 w 375300"/>
+              <a:gd name="csY13" fmla="*/ 62550 h 375300"/>
+              <a:gd name="csX14" fmla="*/ 62550 w 375300"/>
+              <a:gd name="csY14" fmla="*/ 0 h 375300"/>
+            </a:gdLst>
+            <a:ahLst/>
+            <a:cxnLst>
+              <a:cxn ang="0">
+                <a:pos x="csX0" y="csY0"/>
+              </a:cxn>
+              <a:cxn ang="0">
+                <a:pos x="csX1" y="csY1"/>
+              </a:cxn>
+              <a:cxn ang="0">
+                <a:pos x="csX2" y="csY2"/>
+              </a:cxn>
+              <a:cxn ang="0">
+                <a:pos x="csX3" y="csY3"/>
+              </a:cxn>
+              <a:cxn ang="0">
+                <a:pos x="csX4" y="csY4"/>
+              </a:cxn>
+              <a:cxn ang="0">
+                <a:pos x="csX5" y="csY5"/>
+              </a:cxn>
+              <a:cxn ang="0">
+                <a:pos x="csX6" y="csY6"/>
+              </a:cxn>
+              <a:cxn ang="0">
+                <a:pos x="csX7" y="csY7"/>
+              </a:cxn>
+              <a:cxn ang="0">
+                <a:pos x="csX8" y="csY8"/>
+              </a:cxn>
+              <a:cxn ang="0">
+                <a:pos x="csX9" y="csY9"/>
+              </a:cxn>
+              <a:cxn ang="0">
+                <a:pos x="csX10" y="csY10"/>
+              </a:cxn>
+              <a:cxn ang="0">
+                <a:pos x="csX11" y="csY11"/>
+              </a:cxn>
+              <a:cxn ang="0">
+                <a:pos x="csX12" y="csY12"/>
+              </a:cxn>
+              <a:cxn ang="0">
+                <a:pos x="csX13" y="csY13"/>
+              </a:cxn>
+              <a:cxn ang="0">
+                <a:pos x="csX14" y="csY14"/>
+              </a:cxn>
+            </a:cxnLst>
+            <a:rect l="l" t="t" r="r" b="b"/>
+            <a:pathLst>
+              <a:path w="375300" h="375300">
+                <a:moveTo>
+                  <a:pt x="62550" y="0"/>
+                </a:moveTo>
+                <a:cubicBezTo>
+                  <a:pt x="97096" y="0"/>
+                  <a:pt x="125100" y="28004"/>
+                  <a:pt x="125100" y="62550"/>
+                </a:cubicBezTo>
+                <a:lnTo>
+                  <a:pt x="125100" y="161742"/>
+                </a:lnTo>
+                <a:lnTo>
+                  <a:pt x="268520" y="18321"/>
+                </a:lnTo>
+                <a:cubicBezTo>
+                  <a:pt x="292948" y="-6105"/>
+                  <a:pt x="332553" y="-6105"/>
+                  <a:pt x="356979" y="18321"/>
+                </a:cubicBezTo>
+                <a:cubicBezTo>
+                  <a:pt x="381405" y="42747"/>
+                  <a:pt x="381405" y="82353"/>
+                  <a:pt x="356979" y="106779"/>
+                </a:cubicBezTo>
+                <a:lnTo>
+                  <a:pt x="213559" y="250200"/>
+                </a:lnTo>
+                <a:lnTo>
+                  <a:pt x="312750" y="250200"/>
+                </a:lnTo>
+                <a:cubicBezTo>
+                  <a:pt x="347296" y="250200"/>
+                  <a:pt x="375300" y="278204"/>
+                  <a:pt x="375300" y="312750"/>
+                </a:cubicBezTo>
+                <a:cubicBezTo>
+                  <a:pt x="375300" y="347296"/>
+                  <a:pt x="347296" y="375300"/>
+                  <a:pt x="312750" y="375300"/>
+                </a:cubicBezTo>
+                <a:lnTo>
+                  <a:pt x="62550" y="375300"/>
+                </a:lnTo>
+                <a:cubicBezTo>
+                  <a:pt x="45960" y="375300"/>
+                  <a:pt x="30051" y="368707"/>
+                  <a:pt x="18320" y="356979"/>
+                </a:cubicBezTo>
+                <a:cubicBezTo>
+                  <a:pt x="6590" y="345251"/>
+                  <a:pt x="0" y="329338"/>
+                  <a:pt x="0" y="312750"/>
+                </a:cubicBezTo>
+                <a:lnTo>
+                  <a:pt x="0" y="62550"/>
+                </a:lnTo>
+                <a:cubicBezTo>
+                  <a:pt x="0" y="28004"/>
+                  <a:pt x="28005" y="0"/>
+                  <a:pt x="62550" y="0"/>
+                </a:cubicBezTo>
+                <a:close/>
+              </a:path>
+            </a:pathLst>
+          </a:custGeom>
+          <a:solidFill>
+            <a:srgbClr val="111111"/>
+          </a:solidFill>
+          <a:ln w="62309" cap="flat">
+            <a:noFill/>
+            <a:prstDash val="solid"/>
+            <a:miter/>
+          </a:ln>
+        </p:spPr>
+        <p:txBody>
+          <a:bodyPr wrap="square">
+            <a:noAutofit/>
+          </a:bodyPr>
+          <a:lstStyle/>
+          <a:p>
+            <a:endParaRPr lang="en-US"/>
+          </a:p>
+        </p:txBody>
+      </p:sp>
+      <p:pic>
+        <p:nvPicPr>
+          <p:cNvPr id="28" name="Graphic 27">
+            <a:extLst>
+              <a:ext uri="{FF2B5EF4-FFF2-40B4-BE49-F238E27FC236}">
+                <a16:creationId xmlns:a16="http://schemas.microsoft.com/office/drawing/2014/main" id="{C052CD62-B1BA-0219-EE6A-89BA8E32B50A}"/>
+              </a:ext>
+            </a:extLst>
+          </p:cNvPr>
+          <p:cNvPicPr>
+            <a:picLocks noChangeAspect="1"/>
+          </p:cNvPicPr>
+          <p:nvPr/>
+        </p:nvPicPr>
+        <p:blipFill>
+          <a:blip>
+            <a:extLst>
+              <a:ext uri="{96DAC541-7B7A-43D3-8B79-37D633B846F1}">
+                <asvg:svgBlip xmlns:asvg="http://schemas.microsoft.com/office/drawing/2016/SVG/main" r:embed="rId2"/>
+              </a:ext>
+            </a:extLst>
+          </a:blip>
+          <a:stretch>
+            <a:fillRect/>
+          </a:stretch>
+        </p:blipFill>
+        <p:spPr>
+          <a:xfrm>
+            <a:off x="4190649" y="2292972"/>
+            <a:ext cx="1501200" cy="1501200"/>
+          </a:xfrm>
+          <a:prstGeom prst="rect">
+            <a:avLst/>
+          </a:prstGeom>
+        </p:spPr>
+      </p:pic>
+      <p:pic>
+        <p:nvPicPr>
+          <p:cNvPr id="29" name="Graphic 28">
+            <a:extLst>
+              <a:ext uri="{FF2B5EF4-FFF2-40B4-BE49-F238E27FC236}">
+                <a16:creationId xmlns:a16="http://schemas.microsoft.com/office/drawing/2014/main" id="{3A9D4A42-391F-24C1-32A7-AAAAEC9A46AE}"/>
+              </a:ext>
+            </a:extLst>
+          </p:cNvPr>
+          <p:cNvPicPr>
+            <a:picLocks noChangeAspect="1"/>
+          </p:cNvPicPr>
+          <p:nvPr/>
+        </p:nvPicPr>
+        <p:blipFill>
+          <a:blip>
+            <a:extLst>
+              <a:ext uri="{96DAC541-7B7A-43D3-8B79-37D633B846F1}">
+                <asvg:svgBlip xmlns:asvg="http://schemas.microsoft.com/office/drawing/2016/SVG/main" r:embed="rId2"/>
+              </a:ext>
+            </a:extLst>
+          </a:blip>
+          <a:srcRect/>
+          <a:stretch>
+            <a:fillRect/>
+          </a:stretch>
+        </p:blipFill>
+        <p:spPr>
+          <a:xfrm>
+            <a:off x="10534520" y="2292972"/>
+            <a:ext cx="1501200" cy="1501200"/>
+          </a:xfrm>
+          <a:custGeom>
+            <a:avLst/>
+            <a:gdLst>
+              <a:gd name="csX0" fmla="*/ 259709 w 1501200"/>
+              <a:gd name="csY0" fmla="*/ 198558 h 1501200"/>
+              <a:gd name="csX1" fmla="*/ 259709 w 1501200"/>
+              <a:gd name="csY1" fmla="*/ 1255568 h 1501200"/>
+              <a:gd name="csX2" fmla="*/ 1274777 w 1501200"/>
+              <a:gd name="csY2" fmla="*/ 1255568 h 1501200"/>
+              <a:gd name="csX3" fmla="*/ 1274777 w 1501200"/>
+              <a:gd name="csY3" fmla="*/ 198558 h 1501200"/>
+              <a:gd name="csX4" fmla="*/ 0 w 1501200"/>
+              <a:gd name="csY4" fmla="*/ 0 h 1501200"/>
+              <a:gd name="csX5" fmla="*/ 1501200 w 1501200"/>
+              <a:gd name="csY5" fmla="*/ 0 h 1501200"/>
+              <a:gd name="csX6" fmla="*/ 1501200 w 1501200"/>
+              <a:gd name="csY6" fmla="*/ 1501200 h 1501200"/>
+              <a:gd name="csX7" fmla="*/ 0 w 1501200"/>
+              <a:gd name="csY7" fmla="*/ 1501200 h 1501200"/>
+            </a:gdLst>
+            <a:ahLst/>
+            <a:cxnLst>
+              <a:cxn ang="0">
+                <a:pos x="csX0" y="csY0"/>
+              </a:cxn>
+              <a:cxn ang="0">
+                <a:pos x="csX1" y="csY1"/>
+              </a:cxn>
+              <a:cxn ang="0">
+                <a:pos x="csX2" y="csY2"/>
+              </a:cxn>
+              <a:cxn ang="0">
+                <a:pos x="csX3" y="csY3"/>
+              </a:cxn>
+              <a:cxn ang="0">
+                <a:pos x="csX4" y="csY4"/>
+              </a:cxn>
+              <a:cxn ang="0">
+                <a:pos x="csX5" y="csY5"/>
+              </a:cxn>
+              <a:cxn ang="0">
+                <a:pos x="csX6" y="csY6"/>
+              </a:cxn>
+              <a:cxn ang="0">
+                <a:pos x="csX7" y="csY7"/>
+              </a:cxn>
+            </a:cxnLst>
+            <a:rect l="l" t="t" r="r" b="b"/>
+            <a:pathLst>
+              <a:path w="1501200" h="1501200">
+                <a:moveTo>
+                  <a:pt x="259709" y="198558"/>
+                </a:moveTo>
+                <a:lnTo>
+                  <a:pt x="259709" y="1255568"/>
+                </a:lnTo>
+                <a:lnTo>
+                  <a:pt x="1274777" y="1255568"/>
+                </a:lnTo>
+                <a:lnTo>
+                  <a:pt x="1274777" y="198558"/>
+                </a:lnTo>
+                <a:close/>
+                <a:moveTo>
+                  <a:pt x="0" y="0"/>
+                </a:moveTo>
+                <a:lnTo>
+                  <a:pt x="1501200" y="0"/>
+                </a:lnTo>
+                <a:lnTo>
+                  <a:pt x="1501200" y="1501200"/>
+                </a:lnTo>
+                <a:lnTo>
+                  <a:pt x="0" y="1501200"/>
+                </a:lnTo>
+                <a:close/>
+              </a:path>
+            </a:pathLst>
+          </a:custGeom>
+        </p:spPr>
+      </p:pic>
+      <p:sp>
+        <p:nvSpPr>
+          <p:cNvPr id="27" name="Freeform: Shape 26">
+            <a:extLst>
+              <a:ext uri="{FF2B5EF4-FFF2-40B4-BE49-F238E27FC236}">
+                <a16:creationId xmlns:a16="http://schemas.microsoft.com/office/drawing/2014/main" id="{3CB6CA25-9D01-6918-B58E-031C96F085ED}"/>
+              </a:ext>
+            </a:extLst>
+          </p:cNvPr>
+          <p:cNvSpPr/>
+          <p:nvPr/>
+        </p:nvSpPr>
+        <p:spPr>
+          <a:xfrm flipH="1" flipV="1">
+            <a:off x="8523351" y="2668272"/>
+            <a:ext cx="375300" cy="375300"/>
+          </a:xfrm>
+          <a:custGeom>
+            <a:avLst/>
+            <a:gdLst>
+              <a:gd name="csX0" fmla="*/ 62550 w 375300"/>
+              <a:gd name="csY0" fmla="*/ 0 h 375300"/>
+              <a:gd name="csX1" fmla="*/ 312750 w 375300"/>
+              <a:gd name="csY1" fmla="*/ 0 h 375300"/>
+              <a:gd name="csX2" fmla="*/ 375300 w 375300"/>
+              <a:gd name="csY2" fmla="*/ 62550 h 375300"/>
+              <a:gd name="csX3" fmla="*/ 375300 w 375300"/>
+              <a:gd name="csY3" fmla="*/ 312750 h 375300"/>
+              <a:gd name="csX4" fmla="*/ 312750 w 375300"/>
+              <a:gd name="csY4" fmla="*/ 375300 h 375300"/>
+              <a:gd name="csX5" fmla="*/ 250200 w 375300"/>
+              <a:gd name="csY5" fmla="*/ 312750 h 375300"/>
+              <a:gd name="csX6" fmla="*/ 250200 w 375300"/>
+              <a:gd name="csY6" fmla="*/ 213559 h 375300"/>
+              <a:gd name="csX7" fmla="*/ 106779 w 375300"/>
+              <a:gd name="csY7" fmla="*/ 356979 h 375300"/>
+              <a:gd name="csX8" fmla="*/ 18321 w 375300"/>
+              <a:gd name="csY8" fmla="*/ 356979 h 375300"/>
+              <a:gd name="csX9" fmla="*/ 18321 w 375300"/>
+              <a:gd name="csY9" fmla="*/ 268520 h 375300"/>
+              <a:gd name="csX10" fmla="*/ 161742 w 375300"/>
+              <a:gd name="csY10" fmla="*/ 125100 h 375300"/>
+              <a:gd name="csX11" fmla="*/ 62550 w 375300"/>
+              <a:gd name="csY11" fmla="*/ 125100 h 375300"/>
+              <a:gd name="csX12" fmla="*/ 0 w 375300"/>
+              <a:gd name="csY12" fmla="*/ 62550 h 375300"/>
+              <a:gd name="csX13" fmla="*/ 62550 w 375300"/>
+              <a:gd name="csY13" fmla="*/ 0 h 375300"/>
+            </a:gdLst>
+            <a:ahLst/>
+            <a:cxnLst>
+              <a:cxn ang="0">
+                <a:pos x="csX0" y="csY0"/>
+              </a:cxn>
+              <a:cxn ang="0">
+                <a:pos x="csX1" y="csY1"/>
+              </a:cxn>
+              <a:cxn ang="0">
+                <a:pos x="csX2" y="csY2"/>
+              </a:cxn>
+              <a:cxn ang="0">
+                <a:pos x="csX3" y="csY3"/>
+              </a:cxn>
+              <a:cxn ang="0">
+                <a:pos x="csX4" y="csY4"/>
+              </a:cxn>
+              <a:cxn ang="0">
+                <a:pos x="csX5" y="csY5"/>
+              </a:cxn>
+              <a:cxn ang="0">
+                <a:pos x="csX6" y="csY6"/>
+              </a:cxn>
+              <a:cxn ang="0">
+                <a:pos x="csX7" y="csY7"/>
+              </a:cxn>
+              <a:cxn ang="0">
+                <a:pos x="csX8" y="csY8"/>
+              </a:cxn>
+              <a:cxn ang="0">
+                <a:pos x="csX9" y="csY9"/>
+              </a:cxn>
+              <a:cxn ang="0">
+                <a:pos x="csX10" y="csY10"/>
+              </a:cxn>
+              <a:cxn ang="0">
+                <a:pos x="csX11" y="csY11"/>
+              </a:cxn>
+              <a:cxn ang="0">
+                <a:pos x="csX12" y="csY12"/>
+              </a:cxn>
+              <a:cxn ang="0">
+                <a:pos x="csX13" y="csY13"/>
+              </a:cxn>
+            </a:cxnLst>
+            <a:rect l="l" t="t" r="r" b="b"/>
+            <a:pathLst>
+              <a:path w="375300" h="375300">
+                <a:moveTo>
+                  <a:pt x="62550" y="0"/>
+                </a:moveTo>
+                <a:lnTo>
+                  <a:pt x="312750" y="0"/>
+                </a:lnTo>
+                <a:cubicBezTo>
+                  <a:pt x="347296" y="0"/>
+                  <a:pt x="375300" y="28005"/>
+                  <a:pt x="375300" y="62550"/>
+                </a:cubicBezTo>
+                <a:lnTo>
+                  <a:pt x="375300" y="312750"/>
+                </a:lnTo>
+                <a:cubicBezTo>
+                  <a:pt x="375300" y="347296"/>
+                  <a:pt x="347296" y="375300"/>
+                  <a:pt x="312750" y="375300"/>
+                </a:cubicBezTo>
+                <a:cubicBezTo>
+                  <a:pt x="278204" y="375300"/>
+                  <a:pt x="250200" y="347296"/>
+                  <a:pt x="250200" y="312750"/>
+                </a:cubicBezTo>
+                <a:lnTo>
+                  <a:pt x="250200" y="213559"/>
+                </a:lnTo>
+                <a:lnTo>
+                  <a:pt x="106779" y="356979"/>
+                </a:lnTo>
+                <a:cubicBezTo>
+                  <a:pt x="82353" y="381405"/>
+                  <a:pt x="42747" y="381405"/>
+                  <a:pt x="18321" y="356979"/>
+                </a:cubicBezTo>
+                <a:cubicBezTo>
+                  <a:pt x="-6105" y="332553"/>
+                  <a:pt x="-6105" y="292948"/>
+                  <a:pt x="18321" y="268520"/>
+                </a:cubicBezTo>
+                <a:lnTo>
+                  <a:pt x="161742" y="125100"/>
+                </a:lnTo>
+                <a:lnTo>
+                  <a:pt x="62550" y="125100"/>
+                </a:lnTo>
+                <a:cubicBezTo>
+                  <a:pt x="28004" y="125100"/>
+                  <a:pt x="0" y="97096"/>
+                  <a:pt x="0" y="62550"/>
+                </a:cubicBezTo>
+                <a:cubicBezTo>
+                  <a:pt x="0" y="28005"/>
+                  <a:pt x="28004" y="0"/>
+                  <a:pt x="62550" y="0"/>
+                </a:cubicBezTo>
+                <a:close/>
+              </a:path>
+            </a:pathLst>
+          </a:custGeom>
+          <a:solidFill>
+            <a:srgbClr val="111111"/>
+          </a:solidFill>
+          <a:ln w="62309" cap="flat">
+            <a:noFill/>
+            <a:prstDash val="solid"/>
+            <a:miter/>
+          </a:ln>
+        </p:spPr>
+        <p:txBody>
+          <a:bodyPr wrap="square">
+            <a:noAutofit/>
+          </a:bodyPr>
+          <a:lstStyle/>
+          <a:p>
+            <a:endParaRPr lang="en-US"/>
+          </a:p>
+        </p:txBody>
+      </p:sp>
+      <p:pic>
+        <p:nvPicPr>
+          <p:cNvPr id="46" name="Graphic 45">
+            <a:extLst>
+              <a:ext uri="{FF2B5EF4-FFF2-40B4-BE49-F238E27FC236}">
+                <a16:creationId xmlns:a16="http://schemas.microsoft.com/office/drawing/2014/main" id="{5CE7CD63-D383-D607-7E98-5F8B624E0AFC}"/>
+              </a:ext>
+            </a:extLst>
+          </p:cNvPr>
+          <p:cNvPicPr>
+            <a:picLocks noChangeAspect="1"/>
+          </p:cNvPicPr>
+          <p:nvPr/>
+        </p:nvPicPr>
+        <p:blipFill>
+          <a:blip>
+            <a:extLst>
+              <a:ext uri="{96DAC541-7B7A-43D3-8B79-37D633B846F1}">
+                <asvg:svgBlip xmlns:asvg="http://schemas.microsoft.com/office/drawing/2016/SVG/main" r:embed="rId2"/>
+              </a:ext>
+            </a:extLst>
+          </a:blip>
+          <a:srcRect/>
+          <a:stretch>
+            <a:fillRect/>
+          </a:stretch>
+        </p:blipFill>
+        <p:spPr>
+          <a:xfrm>
+            <a:off x="7772751" y="2292972"/>
+            <a:ext cx="1501200" cy="1501200"/>
+          </a:xfrm>
+          <a:custGeom>
+            <a:avLst/>
+            <a:gdLst>
+              <a:gd name="csX0" fmla="*/ 259709 w 1501200"/>
+              <a:gd name="csY0" fmla="*/ 198558 h 1501200"/>
+              <a:gd name="csX1" fmla="*/ 259709 w 1501200"/>
+              <a:gd name="csY1" fmla="*/ 1255568 h 1501200"/>
+              <a:gd name="csX2" fmla="*/ 1274777 w 1501200"/>
+              <a:gd name="csY2" fmla="*/ 1255568 h 1501200"/>
+              <a:gd name="csX3" fmla="*/ 1274777 w 1501200"/>
+              <a:gd name="csY3" fmla="*/ 198558 h 1501200"/>
+              <a:gd name="csX4" fmla="*/ 0 w 1501200"/>
+              <a:gd name="csY4" fmla="*/ 0 h 1501200"/>
+              <a:gd name="csX5" fmla="*/ 1501200 w 1501200"/>
+              <a:gd name="csY5" fmla="*/ 0 h 1501200"/>
+              <a:gd name="csX6" fmla="*/ 1501200 w 1501200"/>
+              <a:gd name="csY6" fmla="*/ 1501200 h 1501200"/>
+              <a:gd name="csX7" fmla="*/ 0 w 1501200"/>
+              <a:gd name="csY7" fmla="*/ 1501200 h 1501200"/>
+            </a:gdLst>
+            <a:ahLst/>
+            <a:cxnLst>
+              <a:cxn ang="0">
+                <a:pos x="csX0" y="csY0"/>
+              </a:cxn>
+              <a:cxn ang="0">
+                <a:pos x="csX1" y="csY1"/>
+              </a:cxn>
+              <a:cxn ang="0">
+                <a:pos x="csX2" y="csY2"/>
+              </a:cxn>
+              <a:cxn ang="0">
+                <a:pos x="csX3" y="csY3"/>
+              </a:cxn>
+              <a:cxn ang="0">
+                <a:pos x="csX4" y="csY4"/>
+              </a:cxn>
+              <a:cxn ang="0">
+                <a:pos x="csX5" y="csY5"/>
+              </a:cxn>
+              <a:cxn ang="0">
+                <a:pos x="csX6" y="csY6"/>
+              </a:cxn>
+              <a:cxn ang="0">
+                <a:pos x="csX7" y="csY7"/>
+              </a:cxn>
+            </a:cxnLst>
+            <a:rect l="l" t="t" r="r" b="b"/>
+            <a:pathLst>
+              <a:path w="1501200" h="1501200">
+                <a:moveTo>
+                  <a:pt x="259709" y="198558"/>
+                </a:moveTo>
+                <a:lnTo>
+                  <a:pt x="259709" y="1255568"/>
+                </a:lnTo>
+                <a:lnTo>
+                  <a:pt x="1274777" y="1255568"/>
+                </a:lnTo>
+                <a:lnTo>
+                  <a:pt x="1274777" y="198558"/>
+                </a:lnTo>
+                <a:close/>
+                <a:moveTo>
+                  <a:pt x="0" y="0"/>
+                </a:moveTo>
+                <a:lnTo>
+                  <a:pt x="1501200" y="0"/>
+                </a:lnTo>
+                <a:lnTo>
+                  <a:pt x="1501200" y="1501200"/>
+                </a:lnTo>
+                <a:lnTo>
+                  <a:pt x="0" y="1501200"/>
+                </a:lnTo>
+                <a:close/>
+              </a:path>
+            </a:pathLst>
+          </a:custGeom>
+        </p:spPr>
+      </p:pic>
+      <p:cxnSp>
+        <p:nvCxnSpPr>
+          <p:cNvPr id="49" name="Straight Connector 48">
+            <a:extLst>
+              <a:ext uri="{FF2B5EF4-FFF2-40B4-BE49-F238E27FC236}">
+                <a16:creationId xmlns:a16="http://schemas.microsoft.com/office/drawing/2014/main" id="{B43086F4-ECAD-E641-E1CB-3347980FA2F8}"/>
+              </a:ext>
+            </a:extLst>
+          </p:cNvPr>
+          <p:cNvCxnSpPr>
+            <a:cxnSpLocks/>
+          </p:cNvCxnSpPr>
+          <p:nvPr/>
+        </p:nvCxnSpPr>
+        <p:spPr>
+          <a:xfrm>
+            <a:off x="8523351" y="1468073"/>
+            <a:ext cx="0" cy="2592199"/>
+          </a:xfrm>
+          <a:prstGeom prst="line">
+            <a:avLst/>
+          </a:prstGeom>
+        </p:spPr>
+        <p:style>
+          <a:lnRef idx="1">
+            <a:schemeClr val="accent1"/>
+          </a:lnRef>
+          <a:fillRef idx="0">
+            <a:schemeClr val="accent1"/>
+          </a:fillRef>
+          <a:effectRef idx="0">
+            <a:schemeClr val="accent1"/>
+          </a:effectRef>
+          <a:fontRef idx="minor">
+            <a:schemeClr val="tx1"/>
+          </a:fontRef>
+        </p:style>
+      </p:cxnSp>
+      <p:cxnSp>
+        <p:nvCxnSpPr>
+          <p:cNvPr id="11" name="Straight Connector 10">
+            <a:extLst>
+              <a:ext uri="{FF2B5EF4-FFF2-40B4-BE49-F238E27FC236}">
+                <a16:creationId xmlns:a16="http://schemas.microsoft.com/office/drawing/2014/main" id="{C3217390-DEF4-2509-2D15-1F1A1DC1C622}"/>
+              </a:ext>
+            </a:extLst>
+          </p:cNvPr>
+          <p:cNvCxnSpPr/>
+          <p:nvPr/>
+        </p:nvCxnSpPr>
+        <p:spPr>
+          <a:xfrm>
+            <a:off x="320040" y="3794172"/>
+            <a:ext cx="11871960" cy="0"/>
+          </a:xfrm>
+          <a:prstGeom prst="line">
+            <a:avLst/>
+          </a:prstGeom>
+        </p:spPr>
+        <p:style>
+          <a:lnRef idx="1">
+            <a:schemeClr val="accent1"/>
+          </a:lnRef>
+          <a:fillRef idx="0">
+            <a:schemeClr val="accent1"/>
+          </a:fillRef>
+          <a:effectRef idx="0">
+            <a:schemeClr val="accent1"/>
+          </a:effectRef>
+          <a:fontRef idx="minor">
+            <a:schemeClr val="tx1"/>
+          </a:fontRef>
+        </p:style>
+      </p:cxnSp>
+      <p:cxnSp>
+        <p:nvCxnSpPr>
+          <p:cNvPr id="51" name="Straight Connector 50">
+            <a:extLst>
+              <a:ext uri="{FF2B5EF4-FFF2-40B4-BE49-F238E27FC236}">
+                <a16:creationId xmlns:a16="http://schemas.microsoft.com/office/drawing/2014/main" id="{2B01A8A5-27FB-72E3-472D-5D5A581C3186}"/>
+              </a:ext>
+            </a:extLst>
+          </p:cNvPr>
+          <p:cNvCxnSpPr>
+            <a:cxnSpLocks/>
+          </p:cNvCxnSpPr>
+          <p:nvPr/>
+        </p:nvCxnSpPr>
+        <p:spPr>
+          <a:xfrm>
+            <a:off x="320040" y="3588857"/>
+            <a:ext cx="11871960" cy="0"/>
+          </a:xfrm>
+          <a:prstGeom prst="line">
+            <a:avLst/>
+          </a:prstGeom>
+        </p:spPr>
+        <p:style>
+          <a:lnRef idx="1">
+            <a:schemeClr val="accent1"/>
+          </a:lnRef>
+          <a:fillRef idx="0">
+            <a:schemeClr val="accent1"/>
+          </a:fillRef>
+          <a:effectRef idx="0">
+            <a:schemeClr val="accent1"/>
+          </a:effectRef>
+          <a:fontRef idx="minor">
+            <a:schemeClr val="tx1"/>
+          </a:fontRef>
+        </p:style>
+      </p:cxnSp>
+      <p:cxnSp>
+        <p:nvCxnSpPr>
+          <p:cNvPr id="53" name="Straight Connector 52">
+            <a:extLst>
+              <a:ext uri="{FF2B5EF4-FFF2-40B4-BE49-F238E27FC236}">
+                <a16:creationId xmlns:a16="http://schemas.microsoft.com/office/drawing/2014/main" id="{AFC95941-033E-D87C-2780-4A3FE5BB83F2}"/>
+              </a:ext>
+            </a:extLst>
+          </p:cNvPr>
+          <p:cNvCxnSpPr>
+            <a:cxnSpLocks/>
+          </p:cNvCxnSpPr>
+          <p:nvPr/>
+        </p:nvCxnSpPr>
+        <p:spPr>
+          <a:xfrm>
+            <a:off x="320040" y="3794172"/>
+            <a:ext cx="11871960" cy="0"/>
+          </a:xfrm>
+          <a:prstGeom prst="line">
+            <a:avLst/>
+          </a:prstGeom>
+        </p:spPr>
+        <p:style>
+          <a:lnRef idx="1">
+            <a:schemeClr val="accent1"/>
+          </a:lnRef>
+          <a:fillRef idx="0">
+            <a:schemeClr val="accent1"/>
+          </a:fillRef>
+          <a:effectRef idx="0">
+            <a:schemeClr val="accent1"/>
+          </a:effectRef>
+          <a:fontRef idx="minor">
+            <a:schemeClr val="tx1"/>
+          </a:fontRef>
+        </p:style>
+      </p:cxnSp>
+      <p:cxnSp>
+        <p:nvCxnSpPr>
+          <p:cNvPr id="129" name="Straight Connector 128">
+            <a:extLst>
+              <a:ext uri="{FF2B5EF4-FFF2-40B4-BE49-F238E27FC236}">
+                <a16:creationId xmlns:a16="http://schemas.microsoft.com/office/drawing/2014/main" id="{26CB6E25-05E3-9D11-DFA9-629104B9072B}"/>
+              </a:ext>
+            </a:extLst>
+          </p:cNvPr>
+          <p:cNvCxnSpPr/>
+          <p:nvPr/>
+        </p:nvCxnSpPr>
+        <p:spPr>
+          <a:xfrm>
+            <a:off x="320040" y="2292972"/>
+            <a:ext cx="11871960" cy="0"/>
+          </a:xfrm>
+          <a:prstGeom prst="line">
+            <a:avLst/>
+          </a:prstGeom>
+        </p:spPr>
+        <p:style>
+          <a:lnRef idx="1">
+            <a:schemeClr val="accent1"/>
+          </a:lnRef>
+          <a:fillRef idx="0">
+            <a:schemeClr val="accent1"/>
+          </a:fillRef>
+          <a:effectRef idx="0">
+            <a:schemeClr val="accent1"/>
+          </a:effectRef>
+          <a:fontRef idx="minor">
+            <a:schemeClr val="tx1"/>
+          </a:fontRef>
+        </p:style>
+      </p:cxnSp>
+      <p:cxnSp>
+        <p:nvCxnSpPr>
+          <p:cNvPr id="130" name="Straight Connector 129">
+            <a:extLst>
+              <a:ext uri="{FF2B5EF4-FFF2-40B4-BE49-F238E27FC236}">
+                <a16:creationId xmlns:a16="http://schemas.microsoft.com/office/drawing/2014/main" id="{E1355CA2-17DB-8598-BE0C-FBA2E0052F69}"/>
+              </a:ext>
+            </a:extLst>
+          </p:cNvPr>
+          <p:cNvCxnSpPr>
+            <a:cxnSpLocks/>
+          </p:cNvCxnSpPr>
+          <p:nvPr/>
+        </p:nvCxnSpPr>
+        <p:spPr>
+          <a:xfrm>
+            <a:off x="320040" y="2498287"/>
+            <a:ext cx="11871960" cy="0"/>
+          </a:xfrm>
+          <a:prstGeom prst="line">
+            <a:avLst/>
+          </a:prstGeom>
+        </p:spPr>
+        <p:style>
+          <a:lnRef idx="1">
+            <a:schemeClr val="accent1"/>
+          </a:lnRef>
+          <a:fillRef idx="0">
+            <a:schemeClr val="accent1"/>
+          </a:fillRef>
+          <a:effectRef idx="0">
+            <a:schemeClr val="accent1"/>
+          </a:effectRef>
+          <a:fontRef idx="minor">
+            <a:schemeClr val="tx1"/>
+          </a:fontRef>
+        </p:style>
+      </p:cxnSp>
+      <p:grpSp>
+        <p:nvGrpSpPr>
+          <p:cNvPr id="139" name="Group 138">
+            <a:extLst>
+              <a:ext uri="{FF2B5EF4-FFF2-40B4-BE49-F238E27FC236}">
+                <a16:creationId xmlns:a16="http://schemas.microsoft.com/office/drawing/2014/main" id="{FEA227B7-0E65-8980-81CC-9D958CF1FD87}"/>
+              </a:ext>
+            </a:extLst>
+          </p:cNvPr>
+          <p:cNvGrpSpPr/>
+          <p:nvPr/>
+        </p:nvGrpSpPr>
+        <p:grpSpPr>
+          <a:xfrm rot="5400000">
+            <a:off x="7529260" y="2248467"/>
+            <a:ext cx="1988184" cy="1501200"/>
+            <a:chOff x="320040" y="417866"/>
+            <a:chExt cx="11871960" cy="1501200"/>
+          </a:xfrm>
+        </p:grpSpPr>
+        <p:grpSp>
+          <p:nvGrpSpPr>
+            <p:cNvPr id="133" name="Group 132">
+              <a:extLst>
+                <a:ext uri="{FF2B5EF4-FFF2-40B4-BE49-F238E27FC236}">
+                  <a16:creationId xmlns:a16="http://schemas.microsoft.com/office/drawing/2014/main" id="{627C6464-B36E-2CB7-6AF7-F91EF6601E15}"/>
+                </a:ext>
+              </a:extLst>
+            </p:cNvPr>
+            <p:cNvGrpSpPr/>
+            <p:nvPr/>
+          </p:nvGrpSpPr>
+          <p:grpSpPr>
+            <a:xfrm>
+              <a:off x="320040" y="1713751"/>
+              <a:ext cx="11871960" cy="205315"/>
+              <a:chOff x="320040" y="3588857"/>
+              <a:chExt cx="11871960" cy="205315"/>
+            </a:xfrm>
+          </p:grpSpPr>
+          <p:cxnSp>
+            <p:nvCxnSpPr>
+              <p:cNvPr id="134" name="Straight Connector 133">
+                <a:extLst>
+                  <a:ext uri="{FF2B5EF4-FFF2-40B4-BE49-F238E27FC236}">
+                    <a16:creationId xmlns:a16="http://schemas.microsoft.com/office/drawing/2014/main" id="{95354E6E-AF6F-CF76-8170-61DACE657B68}"/>
+                  </a:ext>
+                </a:extLst>
+              </p:cNvPr>
+              <p:cNvCxnSpPr/>
+              <p:nvPr/>
+            </p:nvCxnSpPr>
+            <p:spPr>
+              <a:xfrm>
+                <a:off x="320040" y="3588857"/>
+                <a:ext cx="11871960" cy="0"/>
+              </a:xfrm>
+              <a:prstGeom prst="line">
+                <a:avLst/>
+              </a:prstGeom>
+            </p:spPr>
+            <p:style>
+              <a:lnRef idx="1">
+                <a:schemeClr val="accent1"/>
+              </a:lnRef>
+              <a:fillRef idx="0">
+                <a:schemeClr val="accent1"/>
+              </a:fillRef>
+              <a:effectRef idx="0">
+                <a:schemeClr val="accent1"/>
+              </a:effectRef>
+              <a:fontRef idx="minor">
+                <a:schemeClr val="tx1"/>
+              </a:fontRef>
+            </p:style>
+          </p:cxnSp>
+          <p:cxnSp>
+            <p:nvCxnSpPr>
+              <p:cNvPr id="135" name="Straight Connector 134">
+                <a:extLst>
+                  <a:ext uri="{FF2B5EF4-FFF2-40B4-BE49-F238E27FC236}">
+                    <a16:creationId xmlns:a16="http://schemas.microsoft.com/office/drawing/2014/main" id="{896406BF-D05D-E2E4-3FD8-BCA7EF05F385}"/>
+                  </a:ext>
+                </a:extLst>
+              </p:cNvPr>
+              <p:cNvCxnSpPr>
+                <a:cxnSpLocks/>
+              </p:cNvCxnSpPr>
+              <p:nvPr/>
+            </p:nvCxnSpPr>
+            <p:spPr>
+              <a:xfrm>
+                <a:off x="320040" y="3794172"/>
+                <a:ext cx="11871960" cy="0"/>
+              </a:xfrm>
+              <a:prstGeom prst="line">
+                <a:avLst/>
+              </a:prstGeom>
+            </p:spPr>
+            <p:style>
+              <a:lnRef idx="1">
+                <a:schemeClr val="accent1"/>
+              </a:lnRef>
+              <a:fillRef idx="0">
+                <a:schemeClr val="accent1"/>
+              </a:fillRef>
+              <a:effectRef idx="0">
+                <a:schemeClr val="accent1"/>
+              </a:effectRef>
+              <a:fontRef idx="minor">
+                <a:schemeClr val="tx1"/>
+              </a:fontRef>
+            </p:style>
+          </p:cxnSp>
+        </p:grpSp>
+        <p:grpSp>
+          <p:nvGrpSpPr>
+            <p:cNvPr id="136" name="Group 135">
+              <a:extLst>
+                <a:ext uri="{FF2B5EF4-FFF2-40B4-BE49-F238E27FC236}">
+                  <a16:creationId xmlns:a16="http://schemas.microsoft.com/office/drawing/2014/main" id="{1A3A6D4C-F472-2A99-02E3-378C8FAE62F1}"/>
+                </a:ext>
+              </a:extLst>
+            </p:cNvPr>
+            <p:cNvGrpSpPr/>
+            <p:nvPr/>
+          </p:nvGrpSpPr>
+          <p:grpSpPr>
+            <a:xfrm>
+              <a:off x="320040" y="417866"/>
+              <a:ext cx="11871960" cy="205315"/>
+              <a:chOff x="320040" y="583635"/>
+              <a:chExt cx="11871960" cy="205315"/>
+            </a:xfrm>
+          </p:grpSpPr>
+          <p:cxnSp>
+            <p:nvCxnSpPr>
+              <p:cNvPr id="137" name="Straight Connector 136">
+                <a:extLst>
+                  <a:ext uri="{FF2B5EF4-FFF2-40B4-BE49-F238E27FC236}">
+                    <a16:creationId xmlns:a16="http://schemas.microsoft.com/office/drawing/2014/main" id="{3DDD736E-5934-9CA5-6F63-4C782A887D55}"/>
+                  </a:ext>
+                </a:extLst>
+              </p:cNvPr>
+              <p:cNvCxnSpPr/>
+              <p:nvPr/>
+            </p:nvCxnSpPr>
+            <p:spPr>
+              <a:xfrm>
+                <a:off x="320040" y="583635"/>
+                <a:ext cx="11871960" cy="0"/>
+              </a:xfrm>
+              <a:prstGeom prst="line">
+                <a:avLst/>
+              </a:prstGeom>
+            </p:spPr>
+            <p:style>
+              <a:lnRef idx="1">
+                <a:schemeClr val="accent1"/>
+              </a:lnRef>
+              <a:fillRef idx="0">
+                <a:schemeClr val="accent1"/>
+              </a:fillRef>
+              <a:effectRef idx="0">
+                <a:schemeClr val="accent1"/>
+              </a:effectRef>
+              <a:fontRef idx="minor">
+                <a:schemeClr val="tx1"/>
+              </a:fontRef>
+            </p:style>
+          </p:cxnSp>
+          <p:cxnSp>
+            <p:nvCxnSpPr>
+              <p:cNvPr id="138" name="Straight Connector 137">
+                <a:extLst>
+                  <a:ext uri="{FF2B5EF4-FFF2-40B4-BE49-F238E27FC236}">
+                    <a16:creationId xmlns:a16="http://schemas.microsoft.com/office/drawing/2014/main" id="{A4AE05B8-AEC1-993F-38CC-25F5DA455467}"/>
+                  </a:ext>
+                </a:extLst>
+              </p:cNvPr>
+              <p:cNvCxnSpPr>
+                <a:cxnSpLocks/>
+              </p:cNvCxnSpPr>
+              <p:nvPr/>
+            </p:nvCxnSpPr>
+            <p:spPr>
+              <a:xfrm>
+                <a:off x="320040" y="788950"/>
+                <a:ext cx="11871960" cy="0"/>
+              </a:xfrm>
+              <a:prstGeom prst="line">
+                <a:avLst/>
+              </a:prstGeom>
+            </p:spPr>
+            <p:style>
+              <a:lnRef idx="1">
+                <a:schemeClr val="accent1"/>
+              </a:lnRef>
+              <a:fillRef idx="0">
+                <a:schemeClr val="accent1"/>
+              </a:fillRef>
+              <a:effectRef idx="0">
+                <a:schemeClr val="accent1"/>
+              </a:effectRef>
+              <a:fontRef idx="minor">
+                <a:schemeClr val="tx1"/>
+              </a:fontRef>
+            </p:style>
+          </p:cxnSp>
+        </p:grpSp>
+      </p:grpSp>
+      <p:sp>
+        <p:nvSpPr>
+          <p:cNvPr id="140" name="Freeform: Shape 139">
+            <a:extLst>
+              <a:ext uri="{FF2B5EF4-FFF2-40B4-BE49-F238E27FC236}">
+                <a16:creationId xmlns:a16="http://schemas.microsoft.com/office/drawing/2014/main" id="{8420C82A-A47C-5964-E188-F341E58AA7C8}"/>
+              </a:ext>
+            </a:extLst>
+          </p:cNvPr>
+          <p:cNvSpPr/>
+          <p:nvPr/>
+        </p:nvSpPr>
+        <p:spPr>
+          <a:xfrm>
+            <a:off x="6162961" y="3213557"/>
+            <a:ext cx="375300" cy="375300"/>
+          </a:xfrm>
+          <a:custGeom>
+            <a:avLst/>
+            <a:gdLst>
+              <a:gd name="csX0" fmla="*/ 62550 w 375300"/>
+              <a:gd name="csY0" fmla="*/ 0 h 375300"/>
+              <a:gd name="csX1" fmla="*/ 125100 w 375300"/>
+              <a:gd name="csY1" fmla="*/ 62550 h 375300"/>
+              <a:gd name="csX2" fmla="*/ 125100 w 375300"/>
+              <a:gd name="csY2" fmla="*/ 161742 h 375300"/>
+              <a:gd name="csX3" fmla="*/ 268520 w 375300"/>
+              <a:gd name="csY3" fmla="*/ 18321 h 375300"/>
+              <a:gd name="csX4" fmla="*/ 356979 w 375300"/>
+              <a:gd name="csY4" fmla="*/ 18321 h 375300"/>
+              <a:gd name="csX5" fmla="*/ 356979 w 375300"/>
+              <a:gd name="csY5" fmla="*/ 106779 h 375300"/>
+              <a:gd name="csX6" fmla="*/ 213559 w 375300"/>
+              <a:gd name="csY6" fmla="*/ 250200 h 375300"/>
+              <a:gd name="csX7" fmla="*/ 312750 w 375300"/>
+              <a:gd name="csY7" fmla="*/ 250200 h 375300"/>
+              <a:gd name="csX8" fmla="*/ 375300 w 375300"/>
+              <a:gd name="csY8" fmla="*/ 312750 h 375300"/>
+              <a:gd name="csX9" fmla="*/ 312750 w 375300"/>
+              <a:gd name="csY9" fmla="*/ 375300 h 375300"/>
+              <a:gd name="csX10" fmla="*/ 62550 w 375300"/>
+              <a:gd name="csY10" fmla="*/ 375300 h 375300"/>
+              <a:gd name="csX11" fmla="*/ 18320 w 375300"/>
+              <a:gd name="csY11" fmla="*/ 356979 h 375300"/>
+              <a:gd name="csX12" fmla="*/ 0 w 375300"/>
+              <a:gd name="csY12" fmla="*/ 312750 h 375300"/>
+              <a:gd name="csX13" fmla="*/ 0 w 375300"/>
+              <a:gd name="csY13" fmla="*/ 62550 h 375300"/>
+              <a:gd name="csX14" fmla="*/ 62550 w 375300"/>
+              <a:gd name="csY14" fmla="*/ 0 h 375300"/>
+            </a:gdLst>
+            <a:ahLst/>
+            <a:cxnLst>
+              <a:cxn ang="0">
+                <a:pos x="csX0" y="csY0"/>
+              </a:cxn>
+              <a:cxn ang="0">
+                <a:pos x="csX1" y="csY1"/>
+              </a:cxn>
+              <a:cxn ang="0">
+                <a:pos x="csX2" y="csY2"/>
+              </a:cxn>
+              <a:cxn ang="0">
+                <a:pos x="csX3" y="csY3"/>
+              </a:cxn>
+              <a:cxn ang="0">
+                <a:pos x="csX4" y="csY4"/>
+              </a:cxn>
+              <a:cxn ang="0">
+                <a:pos x="csX5" y="csY5"/>
+              </a:cxn>
+              <a:cxn ang="0">
+                <a:pos x="csX6" y="csY6"/>
+              </a:cxn>
+              <a:cxn ang="0">
+                <a:pos x="csX7" y="csY7"/>
+              </a:cxn>
+              <a:cxn ang="0">
+                <a:pos x="csX8" y="csY8"/>
+              </a:cxn>
+              <a:cxn ang="0">
+                <a:pos x="csX9" y="csY9"/>
+              </a:cxn>
+              <a:cxn ang="0">
+                <a:pos x="csX10" y="csY10"/>
+              </a:cxn>
+              <a:cxn ang="0">
+                <a:pos x="csX11" y="csY11"/>
+              </a:cxn>
+              <a:cxn ang="0">
+                <a:pos x="csX12" y="csY12"/>
+              </a:cxn>
+              <a:cxn ang="0">
+                <a:pos x="csX13" y="csY13"/>
+              </a:cxn>
+              <a:cxn ang="0">
+                <a:pos x="csX14" y="csY14"/>
+              </a:cxn>
+            </a:cxnLst>
+            <a:rect l="l" t="t" r="r" b="b"/>
+            <a:pathLst>
+              <a:path w="375300" h="375300">
+                <a:moveTo>
+                  <a:pt x="62550" y="0"/>
+                </a:moveTo>
+                <a:cubicBezTo>
+                  <a:pt x="97096" y="0"/>
+                  <a:pt x="125100" y="28004"/>
+                  <a:pt x="125100" y="62550"/>
+                </a:cubicBezTo>
+                <a:lnTo>
+                  <a:pt x="125100" y="161742"/>
+                </a:lnTo>
+                <a:lnTo>
+                  <a:pt x="268520" y="18321"/>
+                </a:lnTo>
+                <a:cubicBezTo>
+                  <a:pt x="292948" y="-6105"/>
+                  <a:pt x="332553" y="-6105"/>
+                  <a:pt x="356979" y="18321"/>
+                </a:cubicBezTo>
+                <a:cubicBezTo>
+                  <a:pt x="381405" y="42747"/>
+                  <a:pt x="381405" y="82353"/>
+                  <a:pt x="356979" y="106779"/>
+                </a:cubicBezTo>
+                <a:lnTo>
+                  <a:pt x="213559" y="250200"/>
+                </a:lnTo>
+                <a:lnTo>
+                  <a:pt x="312750" y="250200"/>
+                </a:lnTo>
+                <a:cubicBezTo>
+                  <a:pt x="347296" y="250200"/>
+                  <a:pt x="375300" y="278204"/>
+                  <a:pt x="375300" y="312750"/>
+                </a:cubicBezTo>
+                <a:cubicBezTo>
+                  <a:pt x="375300" y="347296"/>
+                  <a:pt x="347296" y="375300"/>
+                  <a:pt x="312750" y="375300"/>
+                </a:cubicBezTo>
+                <a:lnTo>
+                  <a:pt x="62550" y="375300"/>
+                </a:lnTo>
+                <a:cubicBezTo>
+                  <a:pt x="45960" y="375300"/>
+                  <a:pt x="30051" y="368707"/>
+                  <a:pt x="18320" y="356979"/>
+                </a:cubicBezTo>
+                <a:cubicBezTo>
+                  <a:pt x="6590" y="345251"/>
+                  <a:pt x="0" y="329338"/>
+                  <a:pt x="0" y="312750"/>
+                </a:cubicBezTo>
+                <a:lnTo>
+                  <a:pt x="0" y="62550"/>
+                </a:lnTo>
+                <a:cubicBezTo>
+                  <a:pt x="0" y="28004"/>
+                  <a:pt x="28005" y="0"/>
+                  <a:pt x="62550" y="0"/>
+                </a:cubicBezTo>
+                <a:close/>
+              </a:path>
+            </a:pathLst>
+          </a:custGeom>
+          <a:solidFill>
+            <a:srgbClr val="111111"/>
+          </a:solidFill>
+          <a:ln w="62309" cap="flat">
+            <a:noFill/>
+            <a:prstDash val="solid"/>
+            <a:miter/>
+          </a:ln>
+        </p:spPr>
+        <p:txBody>
+          <a:bodyPr wrap="square">
+            <a:noAutofit/>
+          </a:bodyPr>
+          <a:lstStyle/>
+          <a:p>
+            <a:endParaRPr lang="en-US"/>
+          </a:p>
+        </p:txBody>
+      </p:sp>
+      <p:sp>
+        <p:nvSpPr>
+          <p:cNvPr id="141" name="Freeform: Shape 140">
+            <a:extLst>
+              <a:ext uri="{FF2B5EF4-FFF2-40B4-BE49-F238E27FC236}">
+                <a16:creationId xmlns:a16="http://schemas.microsoft.com/office/drawing/2014/main" id="{122442FC-937A-44FF-3326-81A5369ED1ED}"/>
+              </a:ext>
+            </a:extLst>
+          </p:cNvPr>
+          <p:cNvSpPr/>
+          <p:nvPr/>
+        </p:nvSpPr>
+        <p:spPr>
+          <a:xfrm>
+            <a:off x="6878231" y="2498287"/>
+            <a:ext cx="375300" cy="375300"/>
+          </a:xfrm>
+          <a:custGeom>
+            <a:avLst/>
+            <a:gdLst>
+              <a:gd name="csX0" fmla="*/ 62550 w 375300"/>
+              <a:gd name="csY0" fmla="*/ 0 h 375300"/>
+              <a:gd name="csX1" fmla="*/ 312750 w 375300"/>
+              <a:gd name="csY1" fmla="*/ 0 h 375300"/>
+              <a:gd name="csX2" fmla="*/ 375300 w 375300"/>
+              <a:gd name="csY2" fmla="*/ 62550 h 375300"/>
+              <a:gd name="csX3" fmla="*/ 375300 w 375300"/>
+              <a:gd name="csY3" fmla="*/ 312750 h 375300"/>
+              <a:gd name="csX4" fmla="*/ 312750 w 375300"/>
+              <a:gd name="csY4" fmla="*/ 375300 h 375300"/>
+              <a:gd name="csX5" fmla="*/ 250200 w 375300"/>
+              <a:gd name="csY5" fmla="*/ 312750 h 375300"/>
+              <a:gd name="csX6" fmla="*/ 250200 w 375300"/>
+              <a:gd name="csY6" fmla="*/ 213559 h 375300"/>
+              <a:gd name="csX7" fmla="*/ 106779 w 375300"/>
+              <a:gd name="csY7" fmla="*/ 356979 h 375300"/>
+              <a:gd name="csX8" fmla="*/ 18321 w 375300"/>
+              <a:gd name="csY8" fmla="*/ 356979 h 375300"/>
+              <a:gd name="csX9" fmla="*/ 18321 w 375300"/>
+              <a:gd name="csY9" fmla="*/ 268520 h 375300"/>
+              <a:gd name="csX10" fmla="*/ 161742 w 375300"/>
+              <a:gd name="csY10" fmla="*/ 125100 h 375300"/>
+              <a:gd name="csX11" fmla="*/ 62550 w 375300"/>
+              <a:gd name="csY11" fmla="*/ 125100 h 375300"/>
+              <a:gd name="csX12" fmla="*/ 0 w 375300"/>
+              <a:gd name="csY12" fmla="*/ 62550 h 375300"/>
+              <a:gd name="csX13" fmla="*/ 62550 w 375300"/>
+              <a:gd name="csY13" fmla="*/ 0 h 375300"/>
+            </a:gdLst>
+            <a:ahLst/>
+            <a:cxnLst>
+              <a:cxn ang="0">
+                <a:pos x="csX0" y="csY0"/>
+              </a:cxn>
+              <a:cxn ang="0">
+                <a:pos x="csX1" y="csY1"/>
+              </a:cxn>
+              <a:cxn ang="0">
+                <a:pos x="csX2" y="csY2"/>
+              </a:cxn>
+              <a:cxn ang="0">
+                <a:pos x="csX3" y="csY3"/>
+              </a:cxn>
+              <a:cxn ang="0">
+                <a:pos x="csX4" y="csY4"/>
+              </a:cxn>
+              <a:cxn ang="0">
+                <a:pos x="csX5" y="csY5"/>
+              </a:cxn>
+              <a:cxn ang="0">
+                <a:pos x="csX6" y="csY6"/>
+              </a:cxn>
+              <a:cxn ang="0">
+                <a:pos x="csX7" y="csY7"/>
+              </a:cxn>
+              <a:cxn ang="0">
+                <a:pos x="csX8" y="csY8"/>
+              </a:cxn>
+              <a:cxn ang="0">
+                <a:pos x="csX9" y="csY9"/>
+              </a:cxn>
+              <a:cxn ang="0">
+                <a:pos x="csX10" y="csY10"/>
+              </a:cxn>
+              <a:cxn ang="0">
+                <a:pos x="csX11" y="csY11"/>
+              </a:cxn>
+              <a:cxn ang="0">
+                <a:pos x="csX12" y="csY12"/>
+              </a:cxn>
+              <a:cxn ang="0">
+                <a:pos x="csX13" y="csY13"/>
+              </a:cxn>
+            </a:cxnLst>
+            <a:rect l="l" t="t" r="r" b="b"/>
+            <a:pathLst>
+              <a:path w="375300" h="375300">
+                <a:moveTo>
+                  <a:pt x="62550" y="0"/>
+                </a:moveTo>
+                <a:lnTo>
+                  <a:pt x="312750" y="0"/>
+                </a:lnTo>
+                <a:cubicBezTo>
+                  <a:pt x="347296" y="0"/>
+                  <a:pt x="375300" y="28005"/>
+                  <a:pt x="375300" y="62550"/>
+                </a:cubicBezTo>
+                <a:lnTo>
+                  <a:pt x="375300" y="312750"/>
+                </a:lnTo>
+                <a:cubicBezTo>
+                  <a:pt x="375300" y="347296"/>
+                  <a:pt x="347296" y="375300"/>
+                  <a:pt x="312750" y="375300"/>
+                </a:cubicBezTo>
+                <a:cubicBezTo>
+                  <a:pt x="278204" y="375300"/>
+                  <a:pt x="250200" y="347296"/>
+                  <a:pt x="250200" y="312750"/>
+                </a:cubicBezTo>
+                <a:lnTo>
+                  <a:pt x="250200" y="213559"/>
+                </a:lnTo>
+                <a:lnTo>
+                  <a:pt x="106779" y="356979"/>
+                </a:lnTo>
+                <a:cubicBezTo>
+                  <a:pt x="82353" y="381405"/>
+                  <a:pt x="42747" y="381405"/>
+                  <a:pt x="18321" y="356979"/>
+                </a:cubicBezTo>
+                <a:cubicBezTo>
+                  <a:pt x="-6105" y="332553"/>
+                  <a:pt x="-6105" y="292948"/>
+                  <a:pt x="18321" y="268520"/>
+                </a:cubicBezTo>
+                <a:lnTo>
+                  <a:pt x="161742" y="125100"/>
+                </a:lnTo>
+                <a:lnTo>
+                  <a:pt x="62550" y="125100"/>
+                </a:lnTo>
+                <a:cubicBezTo>
+                  <a:pt x="28004" y="125100"/>
+                  <a:pt x="0" y="97096"/>
+                  <a:pt x="0" y="62550"/>
+                </a:cubicBezTo>
+                <a:cubicBezTo>
+                  <a:pt x="0" y="28005"/>
+                  <a:pt x="28004" y="0"/>
+                  <a:pt x="62550" y="0"/>
+                </a:cubicBezTo>
+                <a:close/>
+              </a:path>
+            </a:pathLst>
+          </a:custGeom>
+          <a:solidFill>
+            <a:srgbClr val="111111"/>
+          </a:solidFill>
+          <a:ln w="62309" cap="flat">
+            <a:noFill/>
+            <a:prstDash val="solid"/>
+            <a:miter/>
+          </a:ln>
+        </p:spPr>
+        <p:txBody>
+          <a:bodyPr wrap="square">
+            <a:noAutofit/>
+          </a:bodyPr>
+          <a:lstStyle/>
+          <a:p>
+            <a:endParaRPr lang="en-US"/>
+          </a:p>
+        </p:txBody>
+      </p:sp>
+      <p:pic>
+        <p:nvPicPr>
+          <p:cNvPr id="142" name="Graphic 141">
+            <a:extLst>
+              <a:ext uri="{FF2B5EF4-FFF2-40B4-BE49-F238E27FC236}">
+                <a16:creationId xmlns:a16="http://schemas.microsoft.com/office/drawing/2014/main" id="{4AC9E524-38F6-5248-A583-6A25F38C1304}"/>
+              </a:ext>
+            </a:extLst>
+          </p:cNvPr>
+          <p:cNvPicPr>
+            <a:picLocks noChangeAspect="1"/>
+          </p:cNvPicPr>
+          <p:nvPr/>
+        </p:nvPicPr>
+        <p:blipFill>
+          <a:blip>
+            <a:extLst>
+              <a:ext uri="{96DAC541-7B7A-43D3-8B79-37D633B846F1}">
+                <asvg:svgBlip xmlns:asvg="http://schemas.microsoft.com/office/drawing/2016/SVG/main" r:embed="rId2"/>
+              </a:ext>
+            </a:extLst>
+          </a:blip>
+          <a:srcRect/>
+          <a:stretch>
+            <a:fillRect/>
+          </a:stretch>
+        </p:blipFill>
+        <p:spPr>
+          <a:xfrm>
+            <a:off x="5957644" y="2292972"/>
+            <a:ext cx="1501200" cy="1501200"/>
+          </a:xfrm>
+          <a:custGeom>
+            <a:avLst/>
+            <a:gdLst>
+              <a:gd name="csX0" fmla="*/ 259709 w 1501200"/>
+              <a:gd name="csY0" fmla="*/ 198558 h 1501200"/>
+              <a:gd name="csX1" fmla="*/ 259709 w 1501200"/>
+              <a:gd name="csY1" fmla="*/ 1255568 h 1501200"/>
+              <a:gd name="csX2" fmla="*/ 1274777 w 1501200"/>
+              <a:gd name="csY2" fmla="*/ 1255568 h 1501200"/>
+              <a:gd name="csX3" fmla="*/ 1274777 w 1501200"/>
+              <a:gd name="csY3" fmla="*/ 198558 h 1501200"/>
+              <a:gd name="csX4" fmla="*/ 0 w 1501200"/>
+              <a:gd name="csY4" fmla="*/ 0 h 1501200"/>
+              <a:gd name="csX5" fmla="*/ 1501200 w 1501200"/>
+              <a:gd name="csY5" fmla="*/ 0 h 1501200"/>
+              <a:gd name="csX6" fmla="*/ 1501200 w 1501200"/>
+              <a:gd name="csY6" fmla="*/ 1501200 h 1501200"/>
+              <a:gd name="csX7" fmla="*/ 0 w 1501200"/>
+              <a:gd name="csY7" fmla="*/ 1501200 h 1501200"/>
+            </a:gdLst>
+            <a:ahLst/>
+            <a:cxnLst>
+              <a:cxn ang="0">
+                <a:pos x="csX0" y="csY0"/>
+              </a:cxn>
+              <a:cxn ang="0">
+                <a:pos x="csX1" y="csY1"/>
+              </a:cxn>
+              <a:cxn ang="0">
+                <a:pos x="csX2" y="csY2"/>
+              </a:cxn>
+              <a:cxn ang="0">
+                <a:pos x="csX3" y="csY3"/>
+              </a:cxn>
+              <a:cxn ang="0">
+                <a:pos x="csX4" y="csY4"/>
+              </a:cxn>
+              <a:cxn ang="0">
+                <a:pos x="csX5" y="csY5"/>
+              </a:cxn>
+              <a:cxn ang="0">
+                <a:pos x="csX6" y="csY6"/>
+              </a:cxn>
+              <a:cxn ang="0">
+                <a:pos x="csX7" y="csY7"/>
+              </a:cxn>
+            </a:cxnLst>
+            <a:rect l="l" t="t" r="r" b="b"/>
+            <a:pathLst>
+              <a:path w="1501200" h="1501200">
+                <a:moveTo>
+                  <a:pt x="259709" y="198558"/>
+                </a:moveTo>
+                <a:lnTo>
+                  <a:pt x="259709" y="1255568"/>
+                </a:lnTo>
+                <a:lnTo>
+                  <a:pt x="1274777" y="1255568"/>
+                </a:lnTo>
+                <a:lnTo>
+                  <a:pt x="1274777" y="198558"/>
+                </a:lnTo>
+                <a:close/>
+                <a:moveTo>
+                  <a:pt x="0" y="0"/>
+                </a:moveTo>
+                <a:lnTo>
+                  <a:pt x="1501200" y="0"/>
+                </a:lnTo>
+                <a:lnTo>
+                  <a:pt x="1501200" y="1501200"/>
+                </a:lnTo>
+                <a:lnTo>
+                  <a:pt x="0" y="1501200"/>
+                </a:lnTo>
+                <a:close/>
+              </a:path>
+            </a:pathLst>
+          </a:custGeom>
+        </p:spPr>
+      </p:pic>
+      <p:cxnSp>
+        <p:nvCxnSpPr>
+          <p:cNvPr id="146" name="Straight Connector 145">
+            <a:extLst>
+              <a:ext uri="{FF2B5EF4-FFF2-40B4-BE49-F238E27FC236}">
+                <a16:creationId xmlns:a16="http://schemas.microsoft.com/office/drawing/2014/main" id="{AFAD9AE9-BBF5-E4D3-3445-CCDC4041F25A}"/>
+              </a:ext>
+            </a:extLst>
+          </p:cNvPr>
+          <p:cNvCxnSpPr>
+            <a:cxnSpLocks/>
+          </p:cNvCxnSpPr>
+          <p:nvPr/>
+        </p:nvCxnSpPr>
+        <p:spPr>
+          <a:xfrm>
+            <a:off x="6708244" y="1468073"/>
+            <a:ext cx="0" cy="2592199"/>
+          </a:xfrm>
+          <a:prstGeom prst="line">
+            <a:avLst/>
+          </a:prstGeom>
+        </p:spPr>
+        <p:style>
+          <a:lnRef idx="1">
+            <a:schemeClr val="accent1"/>
+          </a:lnRef>
+          <a:fillRef idx="0">
+            <a:schemeClr val="accent1"/>
+          </a:fillRef>
+          <a:effectRef idx="0">
+            <a:schemeClr val="accent1"/>
+          </a:effectRef>
+          <a:fontRef idx="minor">
+            <a:schemeClr val="tx1"/>
+          </a:fontRef>
+        </p:style>
+      </p:cxnSp>
+      <p:cxnSp>
+        <p:nvCxnSpPr>
+          <p:cNvPr id="152" name="Straight Connector 151">
+            <a:extLst>
+              <a:ext uri="{FF2B5EF4-FFF2-40B4-BE49-F238E27FC236}">
+                <a16:creationId xmlns:a16="http://schemas.microsoft.com/office/drawing/2014/main" id="{092C06E1-53BD-B0CF-F174-54F1480A9961}"/>
+              </a:ext>
+            </a:extLst>
+          </p:cNvPr>
+          <p:cNvCxnSpPr>
+            <a:cxnSpLocks/>
+          </p:cNvCxnSpPr>
+          <p:nvPr/>
+        </p:nvCxnSpPr>
+        <p:spPr>
+          <a:xfrm rot="5400000">
+            <a:off x="5168869" y="2999068"/>
+            <a:ext cx="1988184" cy="0"/>
+          </a:xfrm>
+          <a:prstGeom prst="line">
+            <a:avLst/>
+          </a:prstGeom>
+        </p:spPr>
+        <p:style>
+          <a:lnRef idx="1">
+            <a:schemeClr val="accent1"/>
+          </a:lnRef>
+          <a:fillRef idx="0">
+            <a:schemeClr val="accent1"/>
+          </a:fillRef>
+          <a:effectRef idx="0">
+            <a:schemeClr val="accent1"/>
+          </a:effectRef>
+          <a:fontRef idx="minor">
+            <a:schemeClr val="tx1"/>
+          </a:fontRef>
+        </p:style>
+      </p:cxnSp>
+      <p:cxnSp>
+        <p:nvCxnSpPr>
+          <p:cNvPr id="153" name="Straight Connector 152">
+            <a:extLst>
+              <a:ext uri="{FF2B5EF4-FFF2-40B4-BE49-F238E27FC236}">
+                <a16:creationId xmlns:a16="http://schemas.microsoft.com/office/drawing/2014/main" id="{D9B5BE72-B739-2F97-FA5B-85E5B5BB5C76}"/>
+              </a:ext>
+            </a:extLst>
+          </p:cNvPr>
+          <p:cNvCxnSpPr>
+            <a:cxnSpLocks/>
+          </p:cNvCxnSpPr>
+          <p:nvPr/>
+        </p:nvCxnSpPr>
+        <p:spPr>
+          <a:xfrm rot="5400000">
+            <a:off x="4963554" y="2999068"/>
+            <a:ext cx="1988184" cy="0"/>
+          </a:xfrm>
+          <a:prstGeom prst="line">
+            <a:avLst/>
+          </a:prstGeom>
+        </p:spPr>
+        <p:style>
+          <a:lnRef idx="1">
+            <a:schemeClr val="accent1"/>
+          </a:lnRef>
+          <a:fillRef idx="0">
+            <a:schemeClr val="accent1"/>
+          </a:fillRef>
+          <a:effectRef idx="0">
+            <a:schemeClr val="accent1"/>
+          </a:effectRef>
+          <a:fontRef idx="minor">
+            <a:schemeClr val="tx1"/>
+          </a:fontRef>
+        </p:style>
+      </p:cxnSp>
+      <p:cxnSp>
+        <p:nvCxnSpPr>
+          <p:cNvPr id="150" name="Straight Connector 149">
+            <a:extLst>
+              <a:ext uri="{FF2B5EF4-FFF2-40B4-BE49-F238E27FC236}">
+                <a16:creationId xmlns:a16="http://schemas.microsoft.com/office/drawing/2014/main" id="{051C2213-6ADE-565D-AD08-0C9B267F5229}"/>
+              </a:ext>
+            </a:extLst>
+          </p:cNvPr>
+          <p:cNvCxnSpPr/>
+          <p:nvPr/>
+        </p:nvCxnSpPr>
+        <p:spPr>
+          <a:xfrm rot="5400000">
+            <a:off x="6464754" y="2999068"/>
+            <a:ext cx="1988184" cy="0"/>
+          </a:xfrm>
+          <a:prstGeom prst="line">
+            <a:avLst/>
+          </a:prstGeom>
+        </p:spPr>
+        <p:style>
+          <a:lnRef idx="1">
+            <a:schemeClr val="accent1"/>
+          </a:lnRef>
+          <a:fillRef idx="0">
+            <a:schemeClr val="accent1"/>
+          </a:fillRef>
+          <a:effectRef idx="0">
+            <a:schemeClr val="accent1"/>
+          </a:effectRef>
+          <a:fontRef idx="minor">
+            <a:schemeClr val="tx1"/>
+          </a:fontRef>
+        </p:style>
+      </p:cxnSp>
+      <p:cxnSp>
+        <p:nvCxnSpPr>
+          <p:cNvPr id="151" name="Straight Connector 150">
+            <a:extLst>
+              <a:ext uri="{FF2B5EF4-FFF2-40B4-BE49-F238E27FC236}">
+                <a16:creationId xmlns:a16="http://schemas.microsoft.com/office/drawing/2014/main" id="{F65DC6DF-3B37-1F43-5930-717C288A15F0}"/>
+              </a:ext>
+            </a:extLst>
+          </p:cNvPr>
+          <p:cNvCxnSpPr>
+            <a:cxnSpLocks/>
+          </p:cNvCxnSpPr>
+          <p:nvPr/>
+        </p:nvCxnSpPr>
+        <p:spPr>
+          <a:xfrm rot="5400000">
+            <a:off x="6259439" y="2999068"/>
+            <a:ext cx="1988184" cy="0"/>
+          </a:xfrm>
+          <a:prstGeom prst="line">
+            <a:avLst/>
+          </a:prstGeom>
+        </p:spPr>
+        <p:style>
+          <a:lnRef idx="1">
+            <a:schemeClr val="accent1"/>
+          </a:lnRef>
+          <a:fillRef idx="0">
+            <a:schemeClr val="accent1"/>
+          </a:fillRef>
+          <a:effectRef idx="0">
+            <a:schemeClr val="accent1"/>
+          </a:effectRef>
+          <a:fontRef idx="minor">
+            <a:schemeClr val="tx1"/>
+          </a:fontRef>
+        </p:style>
+      </p:cxnSp>
     </p:spTree>
     <p:extLst>
       <p:ext uri="{BB962C8B-B14F-4D97-AF65-F5344CB8AC3E}">

</xml_diff>

<commit_message>
Refactor SVG icons and update sprite definitions
- Updated the 'screenNormal' icon in Icons_UI/UI_Toolbar/screenNormal.svg for improved rendering and consistency.
- Modified the 'screenFull' icon in Icons_UI/sprites-ui.svg to enhance visual clarity and maintain design standards.
- Added new definitions for 'screenFull' and 'screenNormal' in the sprite file, ensuring they align with the updated SVGs.
- Introduced a temporary PowerPoint file in Icons_UI directory, possibly for design discussions or presentations.
</commit_message>
<xml_diff>
--- a/Icons_UI/Icons_UI.pptx
+++ b/Icons_UI/Icons_UI.pptx
@@ -26222,7 +26222,7 @@
         </p:nvGrpSpPr>
         <p:grpSpPr>
           <a:xfrm>
-            <a:off x="649852" y="2292971"/>
+            <a:off x="211702" y="2292971"/>
             <a:ext cx="2962440" cy="1501199"/>
             <a:chOff x="5643562" y="3199729"/>
             <a:chExt cx="904875" cy="458540"/>
@@ -29806,668 +29806,6 @@
           </a:p>
         </p:txBody>
       </p:sp>
-      <p:sp>
-        <p:nvSpPr>
-          <p:cNvPr id="26" name="Freeform: Shape 25">
-            <a:extLst>
-              <a:ext uri="{FF2B5EF4-FFF2-40B4-BE49-F238E27FC236}">
-                <a16:creationId xmlns:a16="http://schemas.microsoft.com/office/drawing/2014/main" id="{CE05D37B-BC33-5991-7BB4-716E8DAB7952}"/>
-              </a:ext>
-            </a:extLst>
-          </p:cNvPr>
-          <p:cNvSpPr/>
-          <p:nvPr/>
-        </p:nvSpPr>
-        <p:spPr>
-          <a:xfrm flipH="1" flipV="1">
-            <a:off x="8148051" y="3043572"/>
-            <a:ext cx="375300" cy="375300"/>
-          </a:xfrm>
-          <a:custGeom>
-            <a:avLst/>
-            <a:gdLst>
-              <a:gd name="csX0" fmla="*/ 62550 w 375300"/>
-              <a:gd name="csY0" fmla="*/ 0 h 375300"/>
-              <a:gd name="csX1" fmla="*/ 125100 w 375300"/>
-              <a:gd name="csY1" fmla="*/ 62550 h 375300"/>
-              <a:gd name="csX2" fmla="*/ 125100 w 375300"/>
-              <a:gd name="csY2" fmla="*/ 161742 h 375300"/>
-              <a:gd name="csX3" fmla="*/ 268520 w 375300"/>
-              <a:gd name="csY3" fmla="*/ 18321 h 375300"/>
-              <a:gd name="csX4" fmla="*/ 356979 w 375300"/>
-              <a:gd name="csY4" fmla="*/ 18321 h 375300"/>
-              <a:gd name="csX5" fmla="*/ 356979 w 375300"/>
-              <a:gd name="csY5" fmla="*/ 106779 h 375300"/>
-              <a:gd name="csX6" fmla="*/ 213559 w 375300"/>
-              <a:gd name="csY6" fmla="*/ 250200 h 375300"/>
-              <a:gd name="csX7" fmla="*/ 312750 w 375300"/>
-              <a:gd name="csY7" fmla="*/ 250200 h 375300"/>
-              <a:gd name="csX8" fmla="*/ 375300 w 375300"/>
-              <a:gd name="csY8" fmla="*/ 312750 h 375300"/>
-              <a:gd name="csX9" fmla="*/ 312750 w 375300"/>
-              <a:gd name="csY9" fmla="*/ 375300 h 375300"/>
-              <a:gd name="csX10" fmla="*/ 62550 w 375300"/>
-              <a:gd name="csY10" fmla="*/ 375300 h 375300"/>
-              <a:gd name="csX11" fmla="*/ 18320 w 375300"/>
-              <a:gd name="csY11" fmla="*/ 356979 h 375300"/>
-              <a:gd name="csX12" fmla="*/ 0 w 375300"/>
-              <a:gd name="csY12" fmla="*/ 312750 h 375300"/>
-              <a:gd name="csX13" fmla="*/ 0 w 375300"/>
-              <a:gd name="csY13" fmla="*/ 62550 h 375300"/>
-              <a:gd name="csX14" fmla="*/ 62550 w 375300"/>
-              <a:gd name="csY14" fmla="*/ 0 h 375300"/>
-            </a:gdLst>
-            <a:ahLst/>
-            <a:cxnLst>
-              <a:cxn ang="0">
-                <a:pos x="csX0" y="csY0"/>
-              </a:cxn>
-              <a:cxn ang="0">
-                <a:pos x="csX1" y="csY1"/>
-              </a:cxn>
-              <a:cxn ang="0">
-                <a:pos x="csX2" y="csY2"/>
-              </a:cxn>
-              <a:cxn ang="0">
-                <a:pos x="csX3" y="csY3"/>
-              </a:cxn>
-              <a:cxn ang="0">
-                <a:pos x="csX4" y="csY4"/>
-              </a:cxn>
-              <a:cxn ang="0">
-                <a:pos x="csX5" y="csY5"/>
-              </a:cxn>
-              <a:cxn ang="0">
-                <a:pos x="csX6" y="csY6"/>
-              </a:cxn>
-              <a:cxn ang="0">
-                <a:pos x="csX7" y="csY7"/>
-              </a:cxn>
-              <a:cxn ang="0">
-                <a:pos x="csX8" y="csY8"/>
-              </a:cxn>
-              <a:cxn ang="0">
-                <a:pos x="csX9" y="csY9"/>
-              </a:cxn>
-              <a:cxn ang="0">
-                <a:pos x="csX10" y="csY10"/>
-              </a:cxn>
-              <a:cxn ang="0">
-                <a:pos x="csX11" y="csY11"/>
-              </a:cxn>
-              <a:cxn ang="0">
-                <a:pos x="csX12" y="csY12"/>
-              </a:cxn>
-              <a:cxn ang="0">
-                <a:pos x="csX13" y="csY13"/>
-              </a:cxn>
-              <a:cxn ang="0">
-                <a:pos x="csX14" y="csY14"/>
-              </a:cxn>
-            </a:cxnLst>
-            <a:rect l="l" t="t" r="r" b="b"/>
-            <a:pathLst>
-              <a:path w="375300" h="375300">
-                <a:moveTo>
-                  <a:pt x="62550" y="0"/>
-                </a:moveTo>
-                <a:cubicBezTo>
-                  <a:pt x="97096" y="0"/>
-                  <a:pt x="125100" y="28004"/>
-                  <a:pt x="125100" y="62550"/>
-                </a:cubicBezTo>
-                <a:lnTo>
-                  <a:pt x="125100" y="161742"/>
-                </a:lnTo>
-                <a:lnTo>
-                  <a:pt x="268520" y="18321"/>
-                </a:lnTo>
-                <a:cubicBezTo>
-                  <a:pt x="292948" y="-6105"/>
-                  <a:pt x="332553" y="-6105"/>
-                  <a:pt x="356979" y="18321"/>
-                </a:cubicBezTo>
-                <a:cubicBezTo>
-                  <a:pt x="381405" y="42747"/>
-                  <a:pt x="381405" y="82353"/>
-                  <a:pt x="356979" y="106779"/>
-                </a:cubicBezTo>
-                <a:lnTo>
-                  <a:pt x="213559" y="250200"/>
-                </a:lnTo>
-                <a:lnTo>
-                  <a:pt x="312750" y="250200"/>
-                </a:lnTo>
-                <a:cubicBezTo>
-                  <a:pt x="347296" y="250200"/>
-                  <a:pt x="375300" y="278204"/>
-                  <a:pt x="375300" y="312750"/>
-                </a:cubicBezTo>
-                <a:cubicBezTo>
-                  <a:pt x="375300" y="347296"/>
-                  <a:pt x="347296" y="375300"/>
-                  <a:pt x="312750" y="375300"/>
-                </a:cubicBezTo>
-                <a:lnTo>
-                  <a:pt x="62550" y="375300"/>
-                </a:lnTo>
-                <a:cubicBezTo>
-                  <a:pt x="45960" y="375300"/>
-                  <a:pt x="30051" y="368707"/>
-                  <a:pt x="18320" y="356979"/>
-                </a:cubicBezTo>
-                <a:cubicBezTo>
-                  <a:pt x="6590" y="345251"/>
-                  <a:pt x="0" y="329338"/>
-                  <a:pt x="0" y="312750"/>
-                </a:cubicBezTo>
-                <a:lnTo>
-                  <a:pt x="0" y="62550"/>
-                </a:lnTo>
-                <a:cubicBezTo>
-                  <a:pt x="0" y="28004"/>
-                  <a:pt x="28005" y="0"/>
-                  <a:pt x="62550" y="0"/>
-                </a:cubicBezTo>
-                <a:close/>
-              </a:path>
-            </a:pathLst>
-          </a:custGeom>
-          <a:solidFill>
-            <a:srgbClr val="111111"/>
-          </a:solidFill>
-          <a:ln w="62309" cap="flat">
-            <a:noFill/>
-            <a:prstDash val="solid"/>
-            <a:miter/>
-          </a:ln>
-        </p:spPr>
-        <p:txBody>
-          <a:bodyPr wrap="square">
-            <a:noAutofit/>
-          </a:bodyPr>
-          <a:lstStyle/>
-          <a:p>
-            <a:endParaRPr lang="en-US"/>
-          </a:p>
-        </p:txBody>
-      </p:sp>
-      <p:pic>
-        <p:nvPicPr>
-          <p:cNvPr id="28" name="Graphic 27">
-            <a:extLst>
-              <a:ext uri="{FF2B5EF4-FFF2-40B4-BE49-F238E27FC236}">
-                <a16:creationId xmlns:a16="http://schemas.microsoft.com/office/drawing/2014/main" id="{C052CD62-B1BA-0219-EE6A-89BA8E32B50A}"/>
-              </a:ext>
-            </a:extLst>
-          </p:cNvPr>
-          <p:cNvPicPr>
-            <a:picLocks noChangeAspect="1"/>
-          </p:cNvPicPr>
-          <p:nvPr/>
-        </p:nvPicPr>
-        <p:blipFill>
-          <a:blip>
-            <a:extLst>
-              <a:ext uri="{96DAC541-7B7A-43D3-8B79-37D633B846F1}">
-                <asvg:svgBlip xmlns:asvg="http://schemas.microsoft.com/office/drawing/2016/SVG/main" r:embed="rId2"/>
-              </a:ext>
-            </a:extLst>
-          </a:blip>
-          <a:stretch>
-            <a:fillRect/>
-          </a:stretch>
-        </p:blipFill>
-        <p:spPr>
-          <a:xfrm>
-            <a:off x="4190649" y="2292972"/>
-            <a:ext cx="1501200" cy="1501200"/>
-          </a:xfrm>
-          <a:prstGeom prst="rect">
-            <a:avLst/>
-          </a:prstGeom>
-        </p:spPr>
-      </p:pic>
-      <p:pic>
-        <p:nvPicPr>
-          <p:cNvPr id="29" name="Graphic 28">
-            <a:extLst>
-              <a:ext uri="{FF2B5EF4-FFF2-40B4-BE49-F238E27FC236}">
-                <a16:creationId xmlns:a16="http://schemas.microsoft.com/office/drawing/2014/main" id="{3A9D4A42-391F-24C1-32A7-AAAAEC9A46AE}"/>
-              </a:ext>
-            </a:extLst>
-          </p:cNvPr>
-          <p:cNvPicPr>
-            <a:picLocks noChangeAspect="1"/>
-          </p:cNvPicPr>
-          <p:nvPr/>
-        </p:nvPicPr>
-        <p:blipFill>
-          <a:blip>
-            <a:extLst>
-              <a:ext uri="{96DAC541-7B7A-43D3-8B79-37D633B846F1}">
-                <asvg:svgBlip xmlns:asvg="http://schemas.microsoft.com/office/drawing/2016/SVG/main" r:embed="rId2"/>
-              </a:ext>
-            </a:extLst>
-          </a:blip>
-          <a:srcRect/>
-          <a:stretch>
-            <a:fillRect/>
-          </a:stretch>
-        </p:blipFill>
-        <p:spPr>
-          <a:xfrm>
-            <a:off x="10534520" y="2292972"/>
-            <a:ext cx="1501200" cy="1501200"/>
-          </a:xfrm>
-          <a:custGeom>
-            <a:avLst/>
-            <a:gdLst>
-              <a:gd name="csX0" fmla="*/ 259709 w 1501200"/>
-              <a:gd name="csY0" fmla="*/ 198558 h 1501200"/>
-              <a:gd name="csX1" fmla="*/ 259709 w 1501200"/>
-              <a:gd name="csY1" fmla="*/ 1255568 h 1501200"/>
-              <a:gd name="csX2" fmla="*/ 1274777 w 1501200"/>
-              <a:gd name="csY2" fmla="*/ 1255568 h 1501200"/>
-              <a:gd name="csX3" fmla="*/ 1274777 w 1501200"/>
-              <a:gd name="csY3" fmla="*/ 198558 h 1501200"/>
-              <a:gd name="csX4" fmla="*/ 0 w 1501200"/>
-              <a:gd name="csY4" fmla="*/ 0 h 1501200"/>
-              <a:gd name="csX5" fmla="*/ 1501200 w 1501200"/>
-              <a:gd name="csY5" fmla="*/ 0 h 1501200"/>
-              <a:gd name="csX6" fmla="*/ 1501200 w 1501200"/>
-              <a:gd name="csY6" fmla="*/ 1501200 h 1501200"/>
-              <a:gd name="csX7" fmla="*/ 0 w 1501200"/>
-              <a:gd name="csY7" fmla="*/ 1501200 h 1501200"/>
-            </a:gdLst>
-            <a:ahLst/>
-            <a:cxnLst>
-              <a:cxn ang="0">
-                <a:pos x="csX0" y="csY0"/>
-              </a:cxn>
-              <a:cxn ang="0">
-                <a:pos x="csX1" y="csY1"/>
-              </a:cxn>
-              <a:cxn ang="0">
-                <a:pos x="csX2" y="csY2"/>
-              </a:cxn>
-              <a:cxn ang="0">
-                <a:pos x="csX3" y="csY3"/>
-              </a:cxn>
-              <a:cxn ang="0">
-                <a:pos x="csX4" y="csY4"/>
-              </a:cxn>
-              <a:cxn ang="0">
-                <a:pos x="csX5" y="csY5"/>
-              </a:cxn>
-              <a:cxn ang="0">
-                <a:pos x="csX6" y="csY6"/>
-              </a:cxn>
-              <a:cxn ang="0">
-                <a:pos x="csX7" y="csY7"/>
-              </a:cxn>
-            </a:cxnLst>
-            <a:rect l="l" t="t" r="r" b="b"/>
-            <a:pathLst>
-              <a:path w="1501200" h="1501200">
-                <a:moveTo>
-                  <a:pt x="259709" y="198558"/>
-                </a:moveTo>
-                <a:lnTo>
-                  <a:pt x="259709" y="1255568"/>
-                </a:lnTo>
-                <a:lnTo>
-                  <a:pt x="1274777" y="1255568"/>
-                </a:lnTo>
-                <a:lnTo>
-                  <a:pt x="1274777" y="198558"/>
-                </a:lnTo>
-                <a:close/>
-                <a:moveTo>
-                  <a:pt x="0" y="0"/>
-                </a:moveTo>
-                <a:lnTo>
-                  <a:pt x="1501200" y="0"/>
-                </a:lnTo>
-                <a:lnTo>
-                  <a:pt x="1501200" y="1501200"/>
-                </a:lnTo>
-                <a:lnTo>
-                  <a:pt x="0" y="1501200"/>
-                </a:lnTo>
-                <a:close/>
-              </a:path>
-            </a:pathLst>
-          </a:custGeom>
-        </p:spPr>
-      </p:pic>
-      <p:sp>
-        <p:nvSpPr>
-          <p:cNvPr id="27" name="Freeform: Shape 26">
-            <a:extLst>
-              <a:ext uri="{FF2B5EF4-FFF2-40B4-BE49-F238E27FC236}">
-                <a16:creationId xmlns:a16="http://schemas.microsoft.com/office/drawing/2014/main" id="{3CB6CA25-9D01-6918-B58E-031C96F085ED}"/>
-              </a:ext>
-            </a:extLst>
-          </p:cNvPr>
-          <p:cNvSpPr/>
-          <p:nvPr/>
-        </p:nvSpPr>
-        <p:spPr>
-          <a:xfrm flipH="1" flipV="1">
-            <a:off x="8523351" y="2668272"/>
-            <a:ext cx="375300" cy="375300"/>
-          </a:xfrm>
-          <a:custGeom>
-            <a:avLst/>
-            <a:gdLst>
-              <a:gd name="csX0" fmla="*/ 62550 w 375300"/>
-              <a:gd name="csY0" fmla="*/ 0 h 375300"/>
-              <a:gd name="csX1" fmla="*/ 312750 w 375300"/>
-              <a:gd name="csY1" fmla="*/ 0 h 375300"/>
-              <a:gd name="csX2" fmla="*/ 375300 w 375300"/>
-              <a:gd name="csY2" fmla="*/ 62550 h 375300"/>
-              <a:gd name="csX3" fmla="*/ 375300 w 375300"/>
-              <a:gd name="csY3" fmla="*/ 312750 h 375300"/>
-              <a:gd name="csX4" fmla="*/ 312750 w 375300"/>
-              <a:gd name="csY4" fmla="*/ 375300 h 375300"/>
-              <a:gd name="csX5" fmla="*/ 250200 w 375300"/>
-              <a:gd name="csY5" fmla="*/ 312750 h 375300"/>
-              <a:gd name="csX6" fmla="*/ 250200 w 375300"/>
-              <a:gd name="csY6" fmla="*/ 213559 h 375300"/>
-              <a:gd name="csX7" fmla="*/ 106779 w 375300"/>
-              <a:gd name="csY7" fmla="*/ 356979 h 375300"/>
-              <a:gd name="csX8" fmla="*/ 18321 w 375300"/>
-              <a:gd name="csY8" fmla="*/ 356979 h 375300"/>
-              <a:gd name="csX9" fmla="*/ 18321 w 375300"/>
-              <a:gd name="csY9" fmla="*/ 268520 h 375300"/>
-              <a:gd name="csX10" fmla="*/ 161742 w 375300"/>
-              <a:gd name="csY10" fmla="*/ 125100 h 375300"/>
-              <a:gd name="csX11" fmla="*/ 62550 w 375300"/>
-              <a:gd name="csY11" fmla="*/ 125100 h 375300"/>
-              <a:gd name="csX12" fmla="*/ 0 w 375300"/>
-              <a:gd name="csY12" fmla="*/ 62550 h 375300"/>
-              <a:gd name="csX13" fmla="*/ 62550 w 375300"/>
-              <a:gd name="csY13" fmla="*/ 0 h 375300"/>
-            </a:gdLst>
-            <a:ahLst/>
-            <a:cxnLst>
-              <a:cxn ang="0">
-                <a:pos x="csX0" y="csY0"/>
-              </a:cxn>
-              <a:cxn ang="0">
-                <a:pos x="csX1" y="csY1"/>
-              </a:cxn>
-              <a:cxn ang="0">
-                <a:pos x="csX2" y="csY2"/>
-              </a:cxn>
-              <a:cxn ang="0">
-                <a:pos x="csX3" y="csY3"/>
-              </a:cxn>
-              <a:cxn ang="0">
-                <a:pos x="csX4" y="csY4"/>
-              </a:cxn>
-              <a:cxn ang="0">
-                <a:pos x="csX5" y="csY5"/>
-              </a:cxn>
-              <a:cxn ang="0">
-                <a:pos x="csX6" y="csY6"/>
-              </a:cxn>
-              <a:cxn ang="0">
-                <a:pos x="csX7" y="csY7"/>
-              </a:cxn>
-              <a:cxn ang="0">
-                <a:pos x="csX8" y="csY8"/>
-              </a:cxn>
-              <a:cxn ang="0">
-                <a:pos x="csX9" y="csY9"/>
-              </a:cxn>
-              <a:cxn ang="0">
-                <a:pos x="csX10" y="csY10"/>
-              </a:cxn>
-              <a:cxn ang="0">
-                <a:pos x="csX11" y="csY11"/>
-              </a:cxn>
-              <a:cxn ang="0">
-                <a:pos x="csX12" y="csY12"/>
-              </a:cxn>
-              <a:cxn ang="0">
-                <a:pos x="csX13" y="csY13"/>
-              </a:cxn>
-            </a:cxnLst>
-            <a:rect l="l" t="t" r="r" b="b"/>
-            <a:pathLst>
-              <a:path w="375300" h="375300">
-                <a:moveTo>
-                  <a:pt x="62550" y="0"/>
-                </a:moveTo>
-                <a:lnTo>
-                  <a:pt x="312750" y="0"/>
-                </a:lnTo>
-                <a:cubicBezTo>
-                  <a:pt x="347296" y="0"/>
-                  <a:pt x="375300" y="28005"/>
-                  <a:pt x="375300" y="62550"/>
-                </a:cubicBezTo>
-                <a:lnTo>
-                  <a:pt x="375300" y="312750"/>
-                </a:lnTo>
-                <a:cubicBezTo>
-                  <a:pt x="375300" y="347296"/>
-                  <a:pt x="347296" y="375300"/>
-                  <a:pt x="312750" y="375300"/>
-                </a:cubicBezTo>
-                <a:cubicBezTo>
-                  <a:pt x="278204" y="375300"/>
-                  <a:pt x="250200" y="347296"/>
-                  <a:pt x="250200" y="312750"/>
-                </a:cubicBezTo>
-                <a:lnTo>
-                  <a:pt x="250200" y="213559"/>
-                </a:lnTo>
-                <a:lnTo>
-                  <a:pt x="106779" y="356979"/>
-                </a:lnTo>
-                <a:cubicBezTo>
-                  <a:pt x="82353" y="381405"/>
-                  <a:pt x="42747" y="381405"/>
-                  <a:pt x="18321" y="356979"/>
-                </a:cubicBezTo>
-                <a:cubicBezTo>
-                  <a:pt x="-6105" y="332553"/>
-                  <a:pt x="-6105" y="292948"/>
-                  <a:pt x="18321" y="268520"/>
-                </a:cubicBezTo>
-                <a:lnTo>
-                  <a:pt x="161742" y="125100"/>
-                </a:lnTo>
-                <a:lnTo>
-                  <a:pt x="62550" y="125100"/>
-                </a:lnTo>
-                <a:cubicBezTo>
-                  <a:pt x="28004" y="125100"/>
-                  <a:pt x="0" y="97096"/>
-                  <a:pt x="0" y="62550"/>
-                </a:cubicBezTo>
-                <a:cubicBezTo>
-                  <a:pt x="0" y="28005"/>
-                  <a:pt x="28004" y="0"/>
-                  <a:pt x="62550" y="0"/>
-                </a:cubicBezTo>
-                <a:close/>
-              </a:path>
-            </a:pathLst>
-          </a:custGeom>
-          <a:solidFill>
-            <a:srgbClr val="111111"/>
-          </a:solidFill>
-          <a:ln w="62309" cap="flat">
-            <a:noFill/>
-            <a:prstDash val="solid"/>
-            <a:miter/>
-          </a:ln>
-        </p:spPr>
-        <p:txBody>
-          <a:bodyPr wrap="square">
-            <a:noAutofit/>
-          </a:bodyPr>
-          <a:lstStyle/>
-          <a:p>
-            <a:endParaRPr lang="en-US"/>
-          </a:p>
-        </p:txBody>
-      </p:sp>
-      <p:pic>
-        <p:nvPicPr>
-          <p:cNvPr id="46" name="Graphic 45">
-            <a:extLst>
-              <a:ext uri="{FF2B5EF4-FFF2-40B4-BE49-F238E27FC236}">
-                <a16:creationId xmlns:a16="http://schemas.microsoft.com/office/drawing/2014/main" id="{5CE7CD63-D383-D607-7E98-5F8B624E0AFC}"/>
-              </a:ext>
-            </a:extLst>
-          </p:cNvPr>
-          <p:cNvPicPr>
-            <a:picLocks noChangeAspect="1"/>
-          </p:cNvPicPr>
-          <p:nvPr/>
-        </p:nvPicPr>
-        <p:blipFill>
-          <a:blip>
-            <a:extLst>
-              <a:ext uri="{96DAC541-7B7A-43D3-8B79-37D633B846F1}">
-                <asvg:svgBlip xmlns:asvg="http://schemas.microsoft.com/office/drawing/2016/SVG/main" r:embed="rId2"/>
-              </a:ext>
-            </a:extLst>
-          </a:blip>
-          <a:srcRect/>
-          <a:stretch>
-            <a:fillRect/>
-          </a:stretch>
-        </p:blipFill>
-        <p:spPr>
-          <a:xfrm>
-            <a:off x="7772751" y="2292972"/>
-            <a:ext cx="1501200" cy="1501200"/>
-          </a:xfrm>
-          <a:custGeom>
-            <a:avLst/>
-            <a:gdLst>
-              <a:gd name="csX0" fmla="*/ 259709 w 1501200"/>
-              <a:gd name="csY0" fmla="*/ 198558 h 1501200"/>
-              <a:gd name="csX1" fmla="*/ 259709 w 1501200"/>
-              <a:gd name="csY1" fmla="*/ 1255568 h 1501200"/>
-              <a:gd name="csX2" fmla="*/ 1274777 w 1501200"/>
-              <a:gd name="csY2" fmla="*/ 1255568 h 1501200"/>
-              <a:gd name="csX3" fmla="*/ 1274777 w 1501200"/>
-              <a:gd name="csY3" fmla="*/ 198558 h 1501200"/>
-              <a:gd name="csX4" fmla="*/ 0 w 1501200"/>
-              <a:gd name="csY4" fmla="*/ 0 h 1501200"/>
-              <a:gd name="csX5" fmla="*/ 1501200 w 1501200"/>
-              <a:gd name="csY5" fmla="*/ 0 h 1501200"/>
-              <a:gd name="csX6" fmla="*/ 1501200 w 1501200"/>
-              <a:gd name="csY6" fmla="*/ 1501200 h 1501200"/>
-              <a:gd name="csX7" fmla="*/ 0 w 1501200"/>
-              <a:gd name="csY7" fmla="*/ 1501200 h 1501200"/>
-            </a:gdLst>
-            <a:ahLst/>
-            <a:cxnLst>
-              <a:cxn ang="0">
-                <a:pos x="csX0" y="csY0"/>
-              </a:cxn>
-              <a:cxn ang="0">
-                <a:pos x="csX1" y="csY1"/>
-              </a:cxn>
-              <a:cxn ang="0">
-                <a:pos x="csX2" y="csY2"/>
-              </a:cxn>
-              <a:cxn ang="0">
-                <a:pos x="csX3" y="csY3"/>
-              </a:cxn>
-              <a:cxn ang="0">
-                <a:pos x="csX4" y="csY4"/>
-              </a:cxn>
-              <a:cxn ang="0">
-                <a:pos x="csX5" y="csY5"/>
-              </a:cxn>
-              <a:cxn ang="0">
-                <a:pos x="csX6" y="csY6"/>
-              </a:cxn>
-              <a:cxn ang="0">
-                <a:pos x="csX7" y="csY7"/>
-              </a:cxn>
-            </a:cxnLst>
-            <a:rect l="l" t="t" r="r" b="b"/>
-            <a:pathLst>
-              <a:path w="1501200" h="1501200">
-                <a:moveTo>
-                  <a:pt x="259709" y="198558"/>
-                </a:moveTo>
-                <a:lnTo>
-                  <a:pt x="259709" y="1255568"/>
-                </a:lnTo>
-                <a:lnTo>
-                  <a:pt x="1274777" y="1255568"/>
-                </a:lnTo>
-                <a:lnTo>
-                  <a:pt x="1274777" y="198558"/>
-                </a:lnTo>
-                <a:close/>
-                <a:moveTo>
-                  <a:pt x="0" y="0"/>
-                </a:moveTo>
-                <a:lnTo>
-                  <a:pt x="1501200" y="0"/>
-                </a:lnTo>
-                <a:lnTo>
-                  <a:pt x="1501200" y="1501200"/>
-                </a:lnTo>
-                <a:lnTo>
-                  <a:pt x="0" y="1501200"/>
-                </a:lnTo>
-                <a:close/>
-              </a:path>
-            </a:pathLst>
-          </a:custGeom>
-        </p:spPr>
-      </p:pic>
-      <p:cxnSp>
-        <p:nvCxnSpPr>
-          <p:cNvPr id="49" name="Straight Connector 48">
-            <a:extLst>
-              <a:ext uri="{FF2B5EF4-FFF2-40B4-BE49-F238E27FC236}">
-                <a16:creationId xmlns:a16="http://schemas.microsoft.com/office/drawing/2014/main" id="{B43086F4-ECAD-E641-E1CB-3347980FA2F8}"/>
-              </a:ext>
-            </a:extLst>
-          </p:cNvPr>
-          <p:cNvCxnSpPr>
-            <a:cxnSpLocks/>
-          </p:cNvCxnSpPr>
-          <p:nvPr/>
-        </p:nvCxnSpPr>
-        <p:spPr>
-          <a:xfrm>
-            <a:off x="8523351" y="1468073"/>
-            <a:ext cx="0" cy="2592199"/>
-          </a:xfrm>
-          <a:prstGeom prst="line">
-            <a:avLst/>
-          </a:prstGeom>
-        </p:spPr>
-        <p:style>
-          <a:lnRef idx="1">
-            <a:schemeClr val="accent1"/>
-          </a:lnRef>
-          <a:fillRef idx="0">
-            <a:schemeClr val="accent1"/>
-          </a:fillRef>
-          <a:effectRef idx="0">
-            <a:schemeClr val="accent1"/>
-          </a:effectRef>
-          <a:fontRef idx="minor">
-            <a:schemeClr val="tx1"/>
-          </a:fontRef>
-        </p:style>
-      </p:cxnSp>
       <p:cxnSp>
         <p:nvCxnSpPr>
           <p:cNvPr id="11" name="Straight Connector 10">
@@ -30582,42 +29920,6 @@
       </p:cxnSp>
       <p:cxnSp>
         <p:nvCxnSpPr>
-          <p:cNvPr id="129" name="Straight Connector 128">
-            <a:extLst>
-              <a:ext uri="{FF2B5EF4-FFF2-40B4-BE49-F238E27FC236}">
-                <a16:creationId xmlns:a16="http://schemas.microsoft.com/office/drawing/2014/main" id="{26CB6E25-05E3-9D11-DFA9-629104B9072B}"/>
-              </a:ext>
-            </a:extLst>
-          </p:cNvPr>
-          <p:cNvCxnSpPr/>
-          <p:nvPr/>
-        </p:nvCxnSpPr>
-        <p:spPr>
-          <a:xfrm>
-            <a:off x="320040" y="2292972"/>
-            <a:ext cx="11871960" cy="0"/>
-          </a:xfrm>
-          <a:prstGeom prst="line">
-            <a:avLst/>
-          </a:prstGeom>
-        </p:spPr>
-        <p:style>
-          <a:lnRef idx="1">
-            <a:schemeClr val="accent1"/>
-          </a:lnRef>
-          <a:fillRef idx="0">
-            <a:schemeClr val="accent1"/>
-          </a:fillRef>
-          <a:effectRef idx="0">
-            <a:schemeClr val="accent1"/>
-          </a:effectRef>
-          <a:fontRef idx="minor">
-            <a:schemeClr val="tx1"/>
-          </a:fontRef>
-        </p:style>
-      </p:cxnSp>
-      <p:cxnSp>
-        <p:nvCxnSpPr>
           <p:cNvPr id="130" name="Straight Connector 129">
             <a:extLst>
               <a:ext uri="{FF2B5EF4-FFF2-40B4-BE49-F238E27FC236}">
@@ -30654,223 +29956,48 @@
           </a:fontRef>
         </p:style>
       </p:cxnSp>
-      <p:grpSp>
-        <p:nvGrpSpPr>
-          <p:cNvPr id="139" name="Group 138">
+      <p:cxnSp>
+        <p:nvCxnSpPr>
+          <p:cNvPr id="129" name="Straight Connector 128">
             <a:extLst>
               <a:ext uri="{FF2B5EF4-FFF2-40B4-BE49-F238E27FC236}">
-                <a16:creationId xmlns:a16="http://schemas.microsoft.com/office/drawing/2014/main" id="{FEA227B7-0E65-8980-81CC-9D958CF1FD87}"/>
+                <a16:creationId xmlns:a16="http://schemas.microsoft.com/office/drawing/2014/main" id="{26CB6E25-05E3-9D11-DFA9-629104B9072B}"/>
               </a:ext>
             </a:extLst>
           </p:cNvPr>
-          <p:cNvGrpSpPr/>
+          <p:cNvCxnSpPr/>
           <p:nvPr/>
-        </p:nvGrpSpPr>
-        <p:grpSpPr>
-          <a:xfrm rot="5400000">
-            <a:off x="7529260" y="2248467"/>
-            <a:ext cx="1988184" cy="1501200"/>
-            <a:chOff x="320040" y="417866"/>
-            <a:chExt cx="11871960" cy="1501200"/>
+        </p:nvCxnSpPr>
+        <p:spPr>
+          <a:xfrm>
+            <a:off x="320040" y="2292972"/>
+            <a:ext cx="11871960" cy="0"/>
           </a:xfrm>
-        </p:grpSpPr>
-        <p:grpSp>
-          <p:nvGrpSpPr>
-            <p:cNvPr id="133" name="Group 132">
-              <a:extLst>
-                <a:ext uri="{FF2B5EF4-FFF2-40B4-BE49-F238E27FC236}">
-                  <a16:creationId xmlns:a16="http://schemas.microsoft.com/office/drawing/2014/main" id="{627C6464-B36E-2CB7-6AF7-F91EF6601E15}"/>
-                </a:ext>
-              </a:extLst>
-            </p:cNvPr>
-            <p:cNvGrpSpPr/>
-            <p:nvPr/>
-          </p:nvGrpSpPr>
-          <p:grpSpPr>
-            <a:xfrm>
-              <a:off x="320040" y="1713751"/>
-              <a:ext cx="11871960" cy="205315"/>
-              <a:chOff x="320040" y="3588857"/>
-              <a:chExt cx="11871960" cy="205315"/>
-            </a:xfrm>
-          </p:grpSpPr>
-          <p:cxnSp>
-            <p:nvCxnSpPr>
-              <p:cNvPr id="134" name="Straight Connector 133">
-                <a:extLst>
-                  <a:ext uri="{FF2B5EF4-FFF2-40B4-BE49-F238E27FC236}">
-                    <a16:creationId xmlns:a16="http://schemas.microsoft.com/office/drawing/2014/main" id="{95354E6E-AF6F-CF76-8170-61DACE657B68}"/>
-                  </a:ext>
-                </a:extLst>
-              </p:cNvPr>
-              <p:cNvCxnSpPr/>
-              <p:nvPr/>
-            </p:nvCxnSpPr>
-            <p:spPr>
-              <a:xfrm>
-                <a:off x="320040" y="3588857"/>
-                <a:ext cx="11871960" cy="0"/>
-              </a:xfrm>
-              <a:prstGeom prst="line">
-                <a:avLst/>
-              </a:prstGeom>
-            </p:spPr>
-            <p:style>
-              <a:lnRef idx="1">
-                <a:schemeClr val="accent1"/>
-              </a:lnRef>
-              <a:fillRef idx="0">
-                <a:schemeClr val="accent1"/>
-              </a:fillRef>
-              <a:effectRef idx="0">
-                <a:schemeClr val="accent1"/>
-              </a:effectRef>
-              <a:fontRef idx="minor">
-                <a:schemeClr val="tx1"/>
-              </a:fontRef>
-            </p:style>
-          </p:cxnSp>
-          <p:cxnSp>
-            <p:nvCxnSpPr>
-              <p:cNvPr id="135" name="Straight Connector 134">
-                <a:extLst>
-                  <a:ext uri="{FF2B5EF4-FFF2-40B4-BE49-F238E27FC236}">
-                    <a16:creationId xmlns:a16="http://schemas.microsoft.com/office/drawing/2014/main" id="{896406BF-D05D-E2E4-3FD8-BCA7EF05F385}"/>
-                  </a:ext>
-                </a:extLst>
-              </p:cNvPr>
-              <p:cNvCxnSpPr>
-                <a:cxnSpLocks/>
-              </p:cNvCxnSpPr>
-              <p:nvPr/>
-            </p:nvCxnSpPr>
-            <p:spPr>
-              <a:xfrm>
-                <a:off x="320040" y="3794172"/>
-                <a:ext cx="11871960" cy="0"/>
-              </a:xfrm>
-              <a:prstGeom prst="line">
-                <a:avLst/>
-              </a:prstGeom>
-            </p:spPr>
-            <p:style>
-              <a:lnRef idx="1">
-                <a:schemeClr val="accent1"/>
-              </a:lnRef>
-              <a:fillRef idx="0">
-                <a:schemeClr val="accent1"/>
-              </a:fillRef>
-              <a:effectRef idx="0">
-                <a:schemeClr val="accent1"/>
-              </a:effectRef>
-              <a:fontRef idx="minor">
-                <a:schemeClr val="tx1"/>
-              </a:fontRef>
-            </p:style>
-          </p:cxnSp>
-        </p:grpSp>
-        <p:grpSp>
-          <p:nvGrpSpPr>
-            <p:cNvPr id="136" name="Group 135">
-              <a:extLst>
-                <a:ext uri="{FF2B5EF4-FFF2-40B4-BE49-F238E27FC236}">
-                  <a16:creationId xmlns:a16="http://schemas.microsoft.com/office/drawing/2014/main" id="{1A3A6D4C-F472-2A99-02E3-378C8FAE62F1}"/>
-                </a:ext>
-              </a:extLst>
-            </p:cNvPr>
-            <p:cNvGrpSpPr/>
-            <p:nvPr/>
-          </p:nvGrpSpPr>
-          <p:grpSpPr>
-            <a:xfrm>
-              <a:off x="320040" y="417866"/>
-              <a:ext cx="11871960" cy="205315"/>
-              <a:chOff x="320040" y="583635"/>
-              <a:chExt cx="11871960" cy="205315"/>
-            </a:xfrm>
-          </p:grpSpPr>
-          <p:cxnSp>
-            <p:nvCxnSpPr>
-              <p:cNvPr id="137" name="Straight Connector 136">
-                <a:extLst>
-                  <a:ext uri="{FF2B5EF4-FFF2-40B4-BE49-F238E27FC236}">
-                    <a16:creationId xmlns:a16="http://schemas.microsoft.com/office/drawing/2014/main" id="{3DDD736E-5934-9CA5-6F63-4C782A887D55}"/>
-                  </a:ext>
-                </a:extLst>
-              </p:cNvPr>
-              <p:cNvCxnSpPr/>
-              <p:nvPr/>
-            </p:nvCxnSpPr>
-            <p:spPr>
-              <a:xfrm>
-                <a:off x="320040" y="583635"/>
-                <a:ext cx="11871960" cy="0"/>
-              </a:xfrm>
-              <a:prstGeom prst="line">
-                <a:avLst/>
-              </a:prstGeom>
-            </p:spPr>
-            <p:style>
-              <a:lnRef idx="1">
-                <a:schemeClr val="accent1"/>
-              </a:lnRef>
-              <a:fillRef idx="0">
-                <a:schemeClr val="accent1"/>
-              </a:fillRef>
-              <a:effectRef idx="0">
-                <a:schemeClr val="accent1"/>
-              </a:effectRef>
-              <a:fontRef idx="minor">
-                <a:schemeClr val="tx1"/>
-              </a:fontRef>
-            </p:style>
-          </p:cxnSp>
-          <p:cxnSp>
-            <p:nvCxnSpPr>
-              <p:cNvPr id="138" name="Straight Connector 137">
-                <a:extLst>
-                  <a:ext uri="{FF2B5EF4-FFF2-40B4-BE49-F238E27FC236}">
-                    <a16:creationId xmlns:a16="http://schemas.microsoft.com/office/drawing/2014/main" id="{A4AE05B8-AEC1-993F-38CC-25F5DA455467}"/>
-                  </a:ext>
-                </a:extLst>
-              </p:cNvPr>
-              <p:cNvCxnSpPr>
-                <a:cxnSpLocks/>
-              </p:cNvCxnSpPr>
-              <p:nvPr/>
-            </p:nvCxnSpPr>
-            <p:spPr>
-              <a:xfrm>
-                <a:off x="320040" y="788950"/>
-                <a:ext cx="11871960" cy="0"/>
-              </a:xfrm>
-              <a:prstGeom prst="line">
-                <a:avLst/>
-              </a:prstGeom>
-            </p:spPr>
-            <p:style>
-              <a:lnRef idx="1">
-                <a:schemeClr val="accent1"/>
-              </a:lnRef>
-              <a:fillRef idx="0">
-                <a:schemeClr val="accent1"/>
-              </a:fillRef>
-              <a:effectRef idx="0">
-                <a:schemeClr val="accent1"/>
-              </a:effectRef>
-              <a:fontRef idx="minor">
-                <a:schemeClr val="tx1"/>
-              </a:fontRef>
-            </p:style>
-          </p:cxnSp>
-        </p:grpSp>
-      </p:grpSp>
+          <a:prstGeom prst="line">
+            <a:avLst/>
+          </a:prstGeom>
+        </p:spPr>
+        <p:style>
+          <a:lnRef idx="1">
+            <a:schemeClr val="accent1"/>
+          </a:lnRef>
+          <a:fillRef idx="0">
+            <a:schemeClr val="accent1"/>
+          </a:fillRef>
+          <a:effectRef idx="0">
+            <a:schemeClr val="accent1"/>
+          </a:effectRef>
+          <a:fontRef idx="minor">
+            <a:schemeClr val="tx1"/>
+          </a:fontRef>
+        </p:style>
+      </p:cxnSp>
       <p:sp>
         <p:nvSpPr>
-          <p:cNvPr id="140" name="Freeform: Shape 139">
+          <p:cNvPr id="23" name="Freeform: Shape 22">
             <a:extLst>
               <a:ext uri="{FF2B5EF4-FFF2-40B4-BE49-F238E27FC236}">
-                <a16:creationId xmlns:a16="http://schemas.microsoft.com/office/drawing/2014/main" id="{8420C82A-A47C-5964-E188-F341E58AA7C8}"/>
+                <a16:creationId xmlns:a16="http://schemas.microsoft.com/office/drawing/2014/main" id="{6488E39B-5FB0-375E-D1A0-F5B1B0B0C225}"/>
               </a:ext>
             </a:extLst>
           </p:cNvPr>
@@ -30879,7 +30006,443 @@
         </p:nvSpPr>
         <p:spPr>
           <a:xfrm>
-            <a:off x="6162961" y="3213557"/>
+            <a:off x="8764901" y="281817"/>
+            <a:ext cx="1501200" cy="1501200"/>
+          </a:xfrm>
+          <a:custGeom>
+            <a:avLst/>
+            <a:gdLst>
+              <a:gd name="csX0" fmla="*/ 364722 w 1501200"/>
+              <a:gd name="csY0" fmla="*/ 128718 h 1501200"/>
+              <a:gd name="csX1" fmla="*/ 128718 w 1501200"/>
+              <a:gd name="csY1" fmla="*/ 364722 h 1501200"/>
+              <a:gd name="csX2" fmla="*/ 128718 w 1501200"/>
+              <a:gd name="csY2" fmla="*/ 1136478 h 1501200"/>
+              <a:gd name="csX3" fmla="*/ 364722 w 1501200"/>
+              <a:gd name="csY3" fmla="*/ 1372482 h 1501200"/>
+              <a:gd name="csX4" fmla="*/ 1136478 w 1501200"/>
+              <a:gd name="csY4" fmla="*/ 1372482 h 1501200"/>
+              <a:gd name="csX5" fmla="*/ 1372482 w 1501200"/>
+              <a:gd name="csY5" fmla="*/ 1136478 h 1501200"/>
+              <a:gd name="csX6" fmla="*/ 1372482 w 1501200"/>
+              <a:gd name="csY6" fmla="*/ 364722 h 1501200"/>
+              <a:gd name="csX7" fmla="*/ 1136478 w 1501200"/>
+              <a:gd name="csY7" fmla="*/ 128718 h 1501200"/>
+              <a:gd name="csX8" fmla="*/ 388315 w 1501200"/>
+              <a:gd name="csY8" fmla="*/ 0 h 1501200"/>
+              <a:gd name="csX9" fmla="*/ 1112885 w 1501200"/>
+              <a:gd name="csY9" fmla="*/ 0 h 1501200"/>
+              <a:gd name="csX10" fmla="*/ 1501200 w 1501200"/>
+              <a:gd name="csY10" fmla="*/ 388315 h 1501200"/>
+              <a:gd name="csX11" fmla="*/ 1501200 w 1501200"/>
+              <a:gd name="csY11" fmla="*/ 1112885 h 1501200"/>
+              <a:gd name="csX12" fmla="*/ 1112885 w 1501200"/>
+              <a:gd name="csY12" fmla="*/ 1501200 h 1501200"/>
+              <a:gd name="csX13" fmla="*/ 388315 w 1501200"/>
+              <a:gd name="csY13" fmla="*/ 1501200 h 1501200"/>
+              <a:gd name="csX14" fmla="*/ 0 w 1501200"/>
+              <a:gd name="csY14" fmla="*/ 1112885 h 1501200"/>
+              <a:gd name="csX15" fmla="*/ 0 w 1501200"/>
+              <a:gd name="csY15" fmla="*/ 388315 h 1501200"/>
+              <a:gd name="csX16" fmla="*/ 388315 w 1501200"/>
+              <a:gd name="csY16" fmla="*/ 0 h 1501200"/>
+            </a:gdLst>
+            <a:ahLst/>
+            <a:cxnLst>
+              <a:cxn ang="0">
+                <a:pos x="csX0" y="csY0"/>
+              </a:cxn>
+              <a:cxn ang="0">
+                <a:pos x="csX1" y="csY1"/>
+              </a:cxn>
+              <a:cxn ang="0">
+                <a:pos x="csX2" y="csY2"/>
+              </a:cxn>
+              <a:cxn ang="0">
+                <a:pos x="csX3" y="csY3"/>
+              </a:cxn>
+              <a:cxn ang="0">
+                <a:pos x="csX4" y="csY4"/>
+              </a:cxn>
+              <a:cxn ang="0">
+                <a:pos x="csX5" y="csY5"/>
+              </a:cxn>
+              <a:cxn ang="0">
+                <a:pos x="csX6" y="csY6"/>
+              </a:cxn>
+              <a:cxn ang="0">
+                <a:pos x="csX7" y="csY7"/>
+              </a:cxn>
+              <a:cxn ang="0">
+                <a:pos x="csX8" y="csY8"/>
+              </a:cxn>
+              <a:cxn ang="0">
+                <a:pos x="csX9" y="csY9"/>
+              </a:cxn>
+              <a:cxn ang="0">
+                <a:pos x="csX10" y="csY10"/>
+              </a:cxn>
+              <a:cxn ang="0">
+                <a:pos x="csX11" y="csY11"/>
+              </a:cxn>
+              <a:cxn ang="0">
+                <a:pos x="csX12" y="csY12"/>
+              </a:cxn>
+              <a:cxn ang="0">
+                <a:pos x="csX13" y="csY13"/>
+              </a:cxn>
+              <a:cxn ang="0">
+                <a:pos x="csX14" y="csY14"/>
+              </a:cxn>
+              <a:cxn ang="0">
+                <a:pos x="csX15" y="csY15"/>
+              </a:cxn>
+              <a:cxn ang="0">
+                <a:pos x="csX16" y="csY16"/>
+              </a:cxn>
+            </a:cxnLst>
+            <a:rect l="l" t="t" r="r" b="b"/>
+            <a:pathLst>
+              <a:path w="1501200" h="1501200">
+                <a:moveTo>
+                  <a:pt x="364722" y="128718"/>
+                </a:moveTo>
+                <a:cubicBezTo>
+                  <a:pt x="234381" y="128718"/>
+                  <a:pt x="128718" y="234381"/>
+                  <a:pt x="128718" y="364722"/>
+                </a:cubicBezTo>
+                <a:lnTo>
+                  <a:pt x="128718" y="1136478"/>
+                </a:lnTo>
+                <a:cubicBezTo>
+                  <a:pt x="128718" y="1266819"/>
+                  <a:pt x="234381" y="1372482"/>
+                  <a:pt x="364722" y="1372482"/>
+                </a:cubicBezTo>
+                <a:lnTo>
+                  <a:pt x="1136478" y="1372482"/>
+                </a:lnTo>
+                <a:cubicBezTo>
+                  <a:pt x="1266819" y="1372482"/>
+                  <a:pt x="1372482" y="1266819"/>
+                  <a:pt x="1372482" y="1136478"/>
+                </a:cubicBezTo>
+                <a:lnTo>
+                  <a:pt x="1372482" y="364722"/>
+                </a:lnTo>
+                <a:cubicBezTo>
+                  <a:pt x="1372482" y="234381"/>
+                  <a:pt x="1266819" y="128718"/>
+                  <a:pt x="1136478" y="128718"/>
+                </a:cubicBezTo>
+                <a:close/>
+                <a:moveTo>
+                  <a:pt x="388315" y="0"/>
+                </a:moveTo>
+                <a:lnTo>
+                  <a:pt x="1112885" y="0"/>
+                </a:lnTo>
+                <a:cubicBezTo>
+                  <a:pt x="1327345" y="0"/>
+                  <a:pt x="1501200" y="173855"/>
+                  <a:pt x="1501200" y="388315"/>
+                </a:cubicBezTo>
+                <a:lnTo>
+                  <a:pt x="1501200" y="1112885"/>
+                </a:lnTo>
+                <a:cubicBezTo>
+                  <a:pt x="1501200" y="1327345"/>
+                  <a:pt x="1327345" y="1501200"/>
+                  <a:pt x="1112885" y="1501200"/>
+                </a:cubicBezTo>
+                <a:lnTo>
+                  <a:pt x="388315" y="1501200"/>
+                </a:lnTo>
+                <a:cubicBezTo>
+                  <a:pt x="173855" y="1501200"/>
+                  <a:pt x="0" y="1327345"/>
+                  <a:pt x="0" y="1112885"/>
+                </a:cubicBezTo>
+                <a:lnTo>
+                  <a:pt x="0" y="388315"/>
+                </a:lnTo>
+                <a:cubicBezTo>
+                  <a:pt x="0" y="173855"/>
+                  <a:pt x="173855" y="0"/>
+                  <a:pt x="388315" y="0"/>
+                </a:cubicBezTo>
+                <a:close/>
+              </a:path>
+            </a:pathLst>
+          </a:custGeom>
+          <a:solidFill>
+            <a:schemeClr val="tx1"/>
+          </a:solidFill>
+          <a:ln>
+            <a:noFill/>
+          </a:ln>
+        </p:spPr>
+        <p:style>
+          <a:lnRef idx="2">
+            <a:schemeClr val="accent1">
+              <a:shade val="15000"/>
+            </a:schemeClr>
+          </a:lnRef>
+          <a:fillRef idx="1">
+            <a:schemeClr val="accent1"/>
+          </a:fillRef>
+          <a:effectRef idx="0">
+            <a:schemeClr val="accent1"/>
+          </a:effectRef>
+          <a:fontRef idx="minor">
+            <a:schemeClr val="lt1"/>
+          </a:fontRef>
+        </p:style>
+        <p:txBody>
+          <a:bodyPr wrap="square" rtlCol="0" anchor="ctr">
+            <a:noAutofit/>
+          </a:bodyPr>
+          <a:lstStyle/>
+          <a:p>
+            <a:pPr algn="ctr"/>
+            <a:endParaRPr lang="en-US"/>
+          </a:p>
+        </p:txBody>
+      </p:sp>
+      <p:sp>
+        <p:nvSpPr>
+          <p:cNvPr id="24" name="Freeform: Shape 23">
+            <a:extLst>
+              <a:ext uri="{FF2B5EF4-FFF2-40B4-BE49-F238E27FC236}">
+                <a16:creationId xmlns:a16="http://schemas.microsoft.com/office/drawing/2014/main" id="{7F824F3E-F600-C178-72FA-02EAA25E1518}"/>
+              </a:ext>
+            </a:extLst>
+          </p:cNvPr>
+          <p:cNvSpPr/>
+          <p:nvPr/>
+        </p:nvSpPr>
+        <p:spPr>
+          <a:xfrm>
+            <a:off x="10580008" y="281817"/>
+            <a:ext cx="1501200" cy="1501200"/>
+          </a:xfrm>
+          <a:custGeom>
+            <a:avLst/>
+            <a:gdLst>
+              <a:gd name="csX0" fmla="*/ 364722 w 1501200"/>
+              <a:gd name="csY0" fmla="*/ 128718 h 1501200"/>
+              <a:gd name="csX1" fmla="*/ 128718 w 1501200"/>
+              <a:gd name="csY1" fmla="*/ 364722 h 1501200"/>
+              <a:gd name="csX2" fmla="*/ 128718 w 1501200"/>
+              <a:gd name="csY2" fmla="*/ 1136478 h 1501200"/>
+              <a:gd name="csX3" fmla="*/ 364722 w 1501200"/>
+              <a:gd name="csY3" fmla="*/ 1372482 h 1501200"/>
+              <a:gd name="csX4" fmla="*/ 1136478 w 1501200"/>
+              <a:gd name="csY4" fmla="*/ 1372482 h 1501200"/>
+              <a:gd name="csX5" fmla="*/ 1372482 w 1501200"/>
+              <a:gd name="csY5" fmla="*/ 1136478 h 1501200"/>
+              <a:gd name="csX6" fmla="*/ 1372482 w 1501200"/>
+              <a:gd name="csY6" fmla="*/ 364722 h 1501200"/>
+              <a:gd name="csX7" fmla="*/ 1136478 w 1501200"/>
+              <a:gd name="csY7" fmla="*/ 128718 h 1501200"/>
+              <a:gd name="csX8" fmla="*/ 388315 w 1501200"/>
+              <a:gd name="csY8" fmla="*/ 0 h 1501200"/>
+              <a:gd name="csX9" fmla="*/ 1112885 w 1501200"/>
+              <a:gd name="csY9" fmla="*/ 0 h 1501200"/>
+              <a:gd name="csX10" fmla="*/ 1501200 w 1501200"/>
+              <a:gd name="csY10" fmla="*/ 388315 h 1501200"/>
+              <a:gd name="csX11" fmla="*/ 1501200 w 1501200"/>
+              <a:gd name="csY11" fmla="*/ 1112885 h 1501200"/>
+              <a:gd name="csX12" fmla="*/ 1112885 w 1501200"/>
+              <a:gd name="csY12" fmla="*/ 1501200 h 1501200"/>
+              <a:gd name="csX13" fmla="*/ 388315 w 1501200"/>
+              <a:gd name="csY13" fmla="*/ 1501200 h 1501200"/>
+              <a:gd name="csX14" fmla="*/ 0 w 1501200"/>
+              <a:gd name="csY14" fmla="*/ 1112885 h 1501200"/>
+              <a:gd name="csX15" fmla="*/ 0 w 1501200"/>
+              <a:gd name="csY15" fmla="*/ 388315 h 1501200"/>
+              <a:gd name="csX16" fmla="*/ 388315 w 1501200"/>
+              <a:gd name="csY16" fmla="*/ 0 h 1501200"/>
+            </a:gdLst>
+            <a:ahLst/>
+            <a:cxnLst>
+              <a:cxn ang="0">
+                <a:pos x="csX0" y="csY0"/>
+              </a:cxn>
+              <a:cxn ang="0">
+                <a:pos x="csX1" y="csY1"/>
+              </a:cxn>
+              <a:cxn ang="0">
+                <a:pos x="csX2" y="csY2"/>
+              </a:cxn>
+              <a:cxn ang="0">
+                <a:pos x="csX3" y="csY3"/>
+              </a:cxn>
+              <a:cxn ang="0">
+                <a:pos x="csX4" y="csY4"/>
+              </a:cxn>
+              <a:cxn ang="0">
+                <a:pos x="csX5" y="csY5"/>
+              </a:cxn>
+              <a:cxn ang="0">
+                <a:pos x="csX6" y="csY6"/>
+              </a:cxn>
+              <a:cxn ang="0">
+                <a:pos x="csX7" y="csY7"/>
+              </a:cxn>
+              <a:cxn ang="0">
+                <a:pos x="csX8" y="csY8"/>
+              </a:cxn>
+              <a:cxn ang="0">
+                <a:pos x="csX9" y="csY9"/>
+              </a:cxn>
+              <a:cxn ang="0">
+                <a:pos x="csX10" y="csY10"/>
+              </a:cxn>
+              <a:cxn ang="0">
+                <a:pos x="csX11" y="csY11"/>
+              </a:cxn>
+              <a:cxn ang="0">
+                <a:pos x="csX12" y="csY12"/>
+              </a:cxn>
+              <a:cxn ang="0">
+                <a:pos x="csX13" y="csY13"/>
+              </a:cxn>
+              <a:cxn ang="0">
+                <a:pos x="csX14" y="csY14"/>
+              </a:cxn>
+              <a:cxn ang="0">
+                <a:pos x="csX15" y="csY15"/>
+              </a:cxn>
+              <a:cxn ang="0">
+                <a:pos x="csX16" y="csY16"/>
+              </a:cxn>
+            </a:cxnLst>
+            <a:rect l="l" t="t" r="r" b="b"/>
+            <a:pathLst>
+              <a:path w="1501200" h="1501200">
+                <a:moveTo>
+                  <a:pt x="364722" y="128718"/>
+                </a:moveTo>
+                <a:cubicBezTo>
+                  <a:pt x="234381" y="128718"/>
+                  <a:pt x="128718" y="234381"/>
+                  <a:pt x="128718" y="364722"/>
+                </a:cubicBezTo>
+                <a:lnTo>
+                  <a:pt x="128718" y="1136478"/>
+                </a:lnTo>
+                <a:cubicBezTo>
+                  <a:pt x="128718" y="1266819"/>
+                  <a:pt x="234381" y="1372482"/>
+                  <a:pt x="364722" y="1372482"/>
+                </a:cubicBezTo>
+                <a:lnTo>
+                  <a:pt x="1136478" y="1372482"/>
+                </a:lnTo>
+                <a:cubicBezTo>
+                  <a:pt x="1266819" y="1372482"/>
+                  <a:pt x="1372482" y="1266819"/>
+                  <a:pt x="1372482" y="1136478"/>
+                </a:cubicBezTo>
+                <a:lnTo>
+                  <a:pt x="1372482" y="364722"/>
+                </a:lnTo>
+                <a:cubicBezTo>
+                  <a:pt x="1372482" y="234381"/>
+                  <a:pt x="1266819" y="128718"/>
+                  <a:pt x="1136478" y="128718"/>
+                </a:cubicBezTo>
+                <a:close/>
+                <a:moveTo>
+                  <a:pt x="388315" y="0"/>
+                </a:moveTo>
+                <a:lnTo>
+                  <a:pt x="1112885" y="0"/>
+                </a:lnTo>
+                <a:cubicBezTo>
+                  <a:pt x="1327345" y="0"/>
+                  <a:pt x="1501200" y="173855"/>
+                  <a:pt x="1501200" y="388315"/>
+                </a:cubicBezTo>
+                <a:lnTo>
+                  <a:pt x="1501200" y="1112885"/>
+                </a:lnTo>
+                <a:cubicBezTo>
+                  <a:pt x="1501200" y="1327345"/>
+                  <a:pt x="1327345" y="1501200"/>
+                  <a:pt x="1112885" y="1501200"/>
+                </a:cubicBezTo>
+                <a:lnTo>
+                  <a:pt x="388315" y="1501200"/>
+                </a:lnTo>
+                <a:cubicBezTo>
+                  <a:pt x="173855" y="1501200"/>
+                  <a:pt x="0" y="1327345"/>
+                  <a:pt x="0" y="1112885"/>
+                </a:cubicBezTo>
+                <a:lnTo>
+                  <a:pt x="0" y="388315"/>
+                </a:lnTo>
+                <a:cubicBezTo>
+                  <a:pt x="0" y="173855"/>
+                  <a:pt x="173855" y="0"/>
+                  <a:pt x="388315" y="0"/>
+                </a:cubicBezTo>
+                <a:close/>
+              </a:path>
+            </a:pathLst>
+          </a:custGeom>
+          <a:solidFill>
+            <a:schemeClr val="tx1"/>
+          </a:solidFill>
+          <a:ln>
+            <a:noFill/>
+          </a:ln>
+        </p:spPr>
+        <p:style>
+          <a:lnRef idx="2">
+            <a:schemeClr val="accent1">
+              <a:shade val="15000"/>
+            </a:schemeClr>
+          </a:lnRef>
+          <a:fillRef idx="1">
+            <a:schemeClr val="accent1"/>
+          </a:fillRef>
+          <a:effectRef idx="0">
+            <a:schemeClr val="accent1"/>
+          </a:effectRef>
+          <a:fontRef idx="minor">
+            <a:schemeClr val="lt1"/>
+          </a:fontRef>
+        </p:style>
+        <p:txBody>
+          <a:bodyPr wrap="square" rtlCol="0" anchor="ctr">
+            <a:noAutofit/>
+          </a:bodyPr>
+          <a:lstStyle/>
+          <a:p>
+            <a:pPr algn="ctr"/>
+            <a:endParaRPr lang="en-US"/>
+          </a:p>
+        </p:txBody>
+      </p:sp>
+      <p:sp>
+        <p:nvSpPr>
+          <p:cNvPr id="25" name="Freeform: Shape 24">
+            <a:extLst>
+              <a:ext uri="{FF2B5EF4-FFF2-40B4-BE49-F238E27FC236}">
+                <a16:creationId xmlns:a16="http://schemas.microsoft.com/office/drawing/2014/main" id="{9679DAB4-22EB-2FBC-2CFC-BB2B752CC48F}"/>
+              </a:ext>
+            </a:extLst>
+          </p:cNvPr>
+          <p:cNvSpPr/>
+          <p:nvPr/>
+        </p:nvSpPr>
+        <p:spPr>
+          <a:xfrm flipH="1" flipV="1">
+            <a:off x="10955308" y="1032417"/>
             <a:ext cx="375300" cy="375300"/>
           </a:xfrm>
           <a:custGeom>
@@ -31053,10 +30616,10 @@
       </p:sp>
       <p:sp>
         <p:nvSpPr>
-          <p:cNvPr id="141" name="Freeform: Shape 140">
+          <p:cNvPr id="30" name="Freeform: Shape 29">
             <a:extLst>
               <a:ext uri="{FF2B5EF4-FFF2-40B4-BE49-F238E27FC236}">
-                <a16:creationId xmlns:a16="http://schemas.microsoft.com/office/drawing/2014/main" id="{122442FC-937A-44FF-3326-81A5369ED1ED}"/>
+                <a16:creationId xmlns:a16="http://schemas.microsoft.com/office/drawing/2014/main" id="{09D62348-6A3C-B71F-D0B7-A7689CBC967C}"/>
               </a:ext>
             </a:extLst>
           </p:cNvPr>
@@ -31064,8 +30627,8 @@
           <p:nvPr/>
         </p:nvSpPr>
         <p:spPr>
-          <a:xfrm>
-            <a:off x="6878231" y="2498287"/>
+          <a:xfrm flipH="1" flipV="1">
+            <a:off x="11330608" y="657117"/>
             <a:ext cx="375300" cy="375300"/>
           </a:xfrm>
           <a:custGeom>
@@ -31227,57 +30790,56 @@
           </a:p>
         </p:txBody>
       </p:sp>
-      <p:pic>
-        <p:nvPicPr>
-          <p:cNvPr id="142" name="Graphic 141">
+      <p:sp>
+        <p:nvSpPr>
+          <p:cNvPr id="31" name="Freeform: Shape 30">
             <a:extLst>
               <a:ext uri="{FF2B5EF4-FFF2-40B4-BE49-F238E27FC236}">
-                <a16:creationId xmlns:a16="http://schemas.microsoft.com/office/drawing/2014/main" id="{4AC9E524-38F6-5248-A583-6A25F38C1304}"/>
+                <a16:creationId xmlns:a16="http://schemas.microsoft.com/office/drawing/2014/main" id="{10E0D305-D7D8-21C4-46CC-04CD8240D096}"/>
               </a:ext>
             </a:extLst>
           </p:cNvPr>
-          <p:cNvPicPr>
-            <a:picLocks noChangeAspect="1"/>
-          </p:cNvPicPr>
+          <p:cNvSpPr/>
           <p:nvPr/>
-        </p:nvPicPr>
-        <p:blipFill>
-          <a:blip>
-            <a:extLst>
-              <a:ext uri="{96DAC541-7B7A-43D3-8B79-37D633B846F1}">
-                <asvg:svgBlip xmlns:asvg="http://schemas.microsoft.com/office/drawing/2016/SVG/main" r:embed="rId2"/>
-              </a:ext>
-            </a:extLst>
-          </a:blip>
-          <a:srcRect/>
-          <a:stretch>
-            <a:fillRect/>
-          </a:stretch>
-        </p:blipFill>
+        </p:nvSpPr>
         <p:spPr>
           <a:xfrm>
-            <a:off x="5957644" y="2292972"/>
-            <a:ext cx="1501200" cy="1501200"/>
+            <a:off x="8970218" y="1202402"/>
+            <a:ext cx="375300" cy="375300"/>
           </a:xfrm>
           <a:custGeom>
             <a:avLst/>
             <a:gdLst>
-              <a:gd name="csX0" fmla="*/ 259709 w 1501200"/>
-              <a:gd name="csY0" fmla="*/ 198558 h 1501200"/>
-              <a:gd name="csX1" fmla="*/ 259709 w 1501200"/>
-              <a:gd name="csY1" fmla="*/ 1255568 h 1501200"/>
-              <a:gd name="csX2" fmla="*/ 1274777 w 1501200"/>
-              <a:gd name="csY2" fmla="*/ 1255568 h 1501200"/>
-              <a:gd name="csX3" fmla="*/ 1274777 w 1501200"/>
-              <a:gd name="csY3" fmla="*/ 198558 h 1501200"/>
-              <a:gd name="csX4" fmla="*/ 0 w 1501200"/>
-              <a:gd name="csY4" fmla="*/ 0 h 1501200"/>
-              <a:gd name="csX5" fmla="*/ 1501200 w 1501200"/>
-              <a:gd name="csY5" fmla="*/ 0 h 1501200"/>
-              <a:gd name="csX6" fmla="*/ 1501200 w 1501200"/>
-              <a:gd name="csY6" fmla="*/ 1501200 h 1501200"/>
-              <a:gd name="csX7" fmla="*/ 0 w 1501200"/>
-              <a:gd name="csY7" fmla="*/ 1501200 h 1501200"/>
+              <a:gd name="csX0" fmla="*/ 62550 w 375300"/>
+              <a:gd name="csY0" fmla="*/ 0 h 375300"/>
+              <a:gd name="csX1" fmla="*/ 125100 w 375300"/>
+              <a:gd name="csY1" fmla="*/ 62550 h 375300"/>
+              <a:gd name="csX2" fmla="*/ 125100 w 375300"/>
+              <a:gd name="csY2" fmla="*/ 161742 h 375300"/>
+              <a:gd name="csX3" fmla="*/ 268520 w 375300"/>
+              <a:gd name="csY3" fmla="*/ 18321 h 375300"/>
+              <a:gd name="csX4" fmla="*/ 356979 w 375300"/>
+              <a:gd name="csY4" fmla="*/ 18321 h 375300"/>
+              <a:gd name="csX5" fmla="*/ 356979 w 375300"/>
+              <a:gd name="csY5" fmla="*/ 106779 h 375300"/>
+              <a:gd name="csX6" fmla="*/ 213559 w 375300"/>
+              <a:gd name="csY6" fmla="*/ 250200 h 375300"/>
+              <a:gd name="csX7" fmla="*/ 312750 w 375300"/>
+              <a:gd name="csY7" fmla="*/ 250200 h 375300"/>
+              <a:gd name="csX8" fmla="*/ 375300 w 375300"/>
+              <a:gd name="csY8" fmla="*/ 312750 h 375300"/>
+              <a:gd name="csX9" fmla="*/ 312750 w 375300"/>
+              <a:gd name="csY9" fmla="*/ 375300 h 375300"/>
+              <a:gd name="csX10" fmla="*/ 62550 w 375300"/>
+              <a:gd name="csY10" fmla="*/ 375300 h 375300"/>
+              <a:gd name="csX11" fmla="*/ 18320 w 375300"/>
+              <a:gd name="csY11" fmla="*/ 356979 h 375300"/>
+              <a:gd name="csX12" fmla="*/ 0 w 375300"/>
+              <a:gd name="csY12" fmla="*/ 312750 h 375300"/>
+              <a:gd name="csX13" fmla="*/ 0 w 375300"/>
+              <a:gd name="csY13" fmla="*/ 62550 h 375300"/>
+              <a:gd name="csX14" fmla="*/ 62550 w 375300"/>
+              <a:gd name="csY14" fmla="*/ 0 h 375300"/>
             </a:gdLst>
             <a:ahLst/>
             <a:cxnLst>
@@ -31305,229 +30867,291 @@
               <a:cxn ang="0">
                 <a:pos x="csX7" y="csY7"/>
               </a:cxn>
+              <a:cxn ang="0">
+                <a:pos x="csX8" y="csY8"/>
+              </a:cxn>
+              <a:cxn ang="0">
+                <a:pos x="csX9" y="csY9"/>
+              </a:cxn>
+              <a:cxn ang="0">
+                <a:pos x="csX10" y="csY10"/>
+              </a:cxn>
+              <a:cxn ang="0">
+                <a:pos x="csX11" y="csY11"/>
+              </a:cxn>
+              <a:cxn ang="0">
+                <a:pos x="csX12" y="csY12"/>
+              </a:cxn>
+              <a:cxn ang="0">
+                <a:pos x="csX13" y="csY13"/>
+              </a:cxn>
+              <a:cxn ang="0">
+                <a:pos x="csX14" y="csY14"/>
+              </a:cxn>
             </a:cxnLst>
             <a:rect l="l" t="t" r="r" b="b"/>
             <a:pathLst>
-              <a:path w="1501200" h="1501200">
+              <a:path w="375300" h="375300">
                 <a:moveTo>
-                  <a:pt x="259709" y="198558"/>
+                  <a:pt x="62550" y="0"/>
                 </a:moveTo>
-                <a:lnTo>
-                  <a:pt x="259709" y="1255568"/>
-                </a:lnTo>
-                <a:lnTo>
-                  <a:pt x="1274777" y="1255568"/>
-                </a:lnTo>
-                <a:lnTo>
-                  <a:pt x="1274777" y="198558"/>
-                </a:lnTo>
-                <a:close/>
-                <a:moveTo>
-                  <a:pt x="0" y="0"/>
-                </a:moveTo>
-                <a:lnTo>
-                  <a:pt x="1501200" y="0"/>
-                </a:lnTo>
-                <a:lnTo>
-                  <a:pt x="1501200" y="1501200"/>
-                </a:lnTo>
-                <a:lnTo>
-                  <a:pt x="0" y="1501200"/>
-                </a:lnTo>
+                <a:cubicBezTo>
+                  <a:pt x="97096" y="0"/>
+                  <a:pt x="125100" y="28004"/>
+                  <a:pt x="125100" y="62550"/>
+                </a:cubicBezTo>
+                <a:lnTo>
+                  <a:pt x="125100" y="161742"/>
+                </a:lnTo>
+                <a:lnTo>
+                  <a:pt x="268520" y="18321"/>
+                </a:lnTo>
+                <a:cubicBezTo>
+                  <a:pt x="292948" y="-6105"/>
+                  <a:pt x="332553" y="-6105"/>
+                  <a:pt x="356979" y="18321"/>
+                </a:cubicBezTo>
+                <a:cubicBezTo>
+                  <a:pt x="381405" y="42747"/>
+                  <a:pt x="381405" y="82353"/>
+                  <a:pt x="356979" y="106779"/>
+                </a:cubicBezTo>
+                <a:lnTo>
+                  <a:pt x="213559" y="250200"/>
+                </a:lnTo>
+                <a:lnTo>
+                  <a:pt x="312750" y="250200"/>
+                </a:lnTo>
+                <a:cubicBezTo>
+                  <a:pt x="347296" y="250200"/>
+                  <a:pt x="375300" y="278204"/>
+                  <a:pt x="375300" y="312750"/>
+                </a:cubicBezTo>
+                <a:cubicBezTo>
+                  <a:pt x="375300" y="347296"/>
+                  <a:pt x="347296" y="375300"/>
+                  <a:pt x="312750" y="375300"/>
+                </a:cubicBezTo>
+                <a:lnTo>
+                  <a:pt x="62550" y="375300"/>
+                </a:lnTo>
+                <a:cubicBezTo>
+                  <a:pt x="45960" y="375300"/>
+                  <a:pt x="30051" y="368707"/>
+                  <a:pt x="18320" y="356979"/>
+                </a:cubicBezTo>
+                <a:cubicBezTo>
+                  <a:pt x="6590" y="345251"/>
+                  <a:pt x="0" y="329338"/>
+                  <a:pt x="0" y="312750"/>
+                </a:cubicBezTo>
+                <a:lnTo>
+                  <a:pt x="0" y="62550"/>
+                </a:lnTo>
+                <a:cubicBezTo>
+                  <a:pt x="0" y="28004"/>
+                  <a:pt x="28005" y="0"/>
+                  <a:pt x="62550" y="0"/>
+                </a:cubicBezTo>
                 <a:close/>
               </a:path>
             </a:pathLst>
           </a:custGeom>
+          <a:solidFill>
+            <a:srgbClr val="111111"/>
+          </a:solidFill>
+          <a:ln w="62309" cap="flat">
+            <a:noFill/>
+            <a:prstDash val="solid"/>
+            <a:miter/>
+          </a:ln>
         </p:spPr>
-      </p:pic>
-      <p:cxnSp>
-        <p:nvCxnSpPr>
-          <p:cNvPr id="146" name="Straight Connector 145">
+        <p:txBody>
+          <a:bodyPr wrap="square">
+            <a:noAutofit/>
+          </a:bodyPr>
+          <a:lstStyle/>
+          <a:p>
+            <a:endParaRPr lang="en-US"/>
+          </a:p>
+        </p:txBody>
+      </p:sp>
+      <p:sp>
+        <p:nvSpPr>
+          <p:cNvPr id="32" name="Freeform: Shape 31">
             <a:extLst>
               <a:ext uri="{FF2B5EF4-FFF2-40B4-BE49-F238E27FC236}">
-                <a16:creationId xmlns:a16="http://schemas.microsoft.com/office/drawing/2014/main" id="{AFAD9AE9-BBF5-E4D3-3445-CCDC4041F25A}"/>
+                <a16:creationId xmlns:a16="http://schemas.microsoft.com/office/drawing/2014/main" id="{6952547F-9D33-6E9D-7497-BA69F800B495}"/>
               </a:ext>
             </a:extLst>
           </p:cNvPr>
-          <p:cNvCxnSpPr>
-            <a:cxnSpLocks/>
-          </p:cNvCxnSpPr>
+          <p:cNvSpPr/>
           <p:nvPr/>
-        </p:nvCxnSpPr>
+        </p:nvSpPr>
         <p:spPr>
           <a:xfrm>
-            <a:off x="6708244" y="1468073"/>
-            <a:ext cx="0" cy="2592199"/>
+            <a:off x="9685488" y="487132"/>
+            <a:ext cx="375300" cy="375300"/>
           </a:xfrm>
-          <a:prstGeom prst="line">
+          <a:custGeom>
             <a:avLst/>
-          </a:prstGeom>
+            <a:gdLst>
+              <a:gd name="csX0" fmla="*/ 62550 w 375300"/>
+              <a:gd name="csY0" fmla="*/ 0 h 375300"/>
+              <a:gd name="csX1" fmla="*/ 312750 w 375300"/>
+              <a:gd name="csY1" fmla="*/ 0 h 375300"/>
+              <a:gd name="csX2" fmla="*/ 375300 w 375300"/>
+              <a:gd name="csY2" fmla="*/ 62550 h 375300"/>
+              <a:gd name="csX3" fmla="*/ 375300 w 375300"/>
+              <a:gd name="csY3" fmla="*/ 312750 h 375300"/>
+              <a:gd name="csX4" fmla="*/ 312750 w 375300"/>
+              <a:gd name="csY4" fmla="*/ 375300 h 375300"/>
+              <a:gd name="csX5" fmla="*/ 250200 w 375300"/>
+              <a:gd name="csY5" fmla="*/ 312750 h 375300"/>
+              <a:gd name="csX6" fmla="*/ 250200 w 375300"/>
+              <a:gd name="csY6" fmla="*/ 213559 h 375300"/>
+              <a:gd name="csX7" fmla="*/ 106779 w 375300"/>
+              <a:gd name="csY7" fmla="*/ 356979 h 375300"/>
+              <a:gd name="csX8" fmla="*/ 18321 w 375300"/>
+              <a:gd name="csY8" fmla="*/ 356979 h 375300"/>
+              <a:gd name="csX9" fmla="*/ 18321 w 375300"/>
+              <a:gd name="csY9" fmla="*/ 268520 h 375300"/>
+              <a:gd name="csX10" fmla="*/ 161742 w 375300"/>
+              <a:gd name="csY10" fmla="*/ 125100 h 375300"/>
+              <a:gd name="csX11" fmla="*/ 62550 w 375300"/>
+              <a:gd name="csY11" fmla="*/ 125100 h 375300"/>
+              <a:gd name="csX12" fmla="*/ 0 w 375300"/>
+              <a:gd name="csY12" fmla="*/ 62550 h 375300"/>
+              <a:gd name="csX13" fmla="*/ 62550 w 375300"/>
+              <a:gd name="csY13" fmla="*/ 0 h 375300"/>
+            </a:gdLst>
+            <a:ahLst/>
+            <a:cxnLst>
+              <a:cxn ang="0">
+                <a:pos x="csX0" y="csY0"/>
+              </a:cxn>
+              <a:cxn ang="0">
+                <a:pos x="csX1" y="csY1"/>
+              </a:cxn>
+              <a:cxn ang="0">
+                <a:pos x="csX2" y="csY2"/>
+              </a:cxn>
+              <a:cxn ang="0">
+                <a:pos x="csX3" y="csY3"/>
+              </a:cxn>
+              <a:cxn ang="0">
+                <a:pos x="csX4" y="csY4"/>
+              </a:cxn>
+              <a:cxn ang="0">
+                <a:pos x="csX5" y="csY5"/>
+              </a:cxn>
+              <a:cxn ang="0">
+                <a:pos x="csX6" y="csY6"/>
+              </a:cxn>
+              <a:cxn ang="0">
+                <a:pos x="csX7" y="csY7"/>
+              </a:cxn>
+              <a:cxn ang="0">
+                <a:pos x="csX8" y="csY8"/>
+              </a:cxn>
+              <a:cxn ang="0">
+                <a:pos x="csX9" y="csY9"/>
+              </a:cxn>
+              <a:cxn ang="0">
+                <a:pos x="csX10" y="csY10"/>
+              </a:cxn>
+              <a:cxn ang="0">
+                <a:pos x="csX11" y="csY11"/>
+              </a:cxn>
+              <a:cxn ang="0">
+                <a:pos x="csX12" y="csY12"/>
+              </a:cxn>
+              <a:cxn ang="0">
+                <a:pos x="csX13" y="csY13"/>
+              </a:cxn>
+            </a:cxnLst>
+            <a:rect l="l" t="t" r="r" b="b"/>
+            <a:pathLst>
+              <a:path w="375300" h="375300">
+                <a:moveTo>
+                  <a:pt x="62550" y="0"/>
+                </a:moveTo>
+                <a:lnTo>
+                  <a:pt x="312750" y="0"/>
+                </a:lnTo>
+                <a:cubicBezTo>
+                  <a:pt x="347296" y="0"/>
+                  <a:pt x="375300" y="28005"/>
+                  <a:pt x="375300" y="62550"/>
+                </a:cubicBezTo>
+                <a:lnTo>
+                  <a:pt x="375300" y="312750"/>
+                </a:lnTo>
+                <a:cubicBezTo>
+                  <a:pt x="375300" y="347296"/>
+                  <a:pt x="347296" y="375300"/>
+                  <a:pt x="312750" y="375300"/>
+                </a:cubicBezTo>
+                <a:cubicBezTo>
+                  <a:pt x="278204" y="375300"/>
+                  <a:pt x="250200" y="347296"/>
+                  <a:pt x="250200" y="312750"/>
+                </a:cubicBezTo>
+                <a:lnTo>
+                  <a:pt x="250200" y="213559"/>
+                </a:lnTo>
+                <a:lnTo>
+                  <a:pt x="106779" y="356979"/>
+                </a:lnTo>
+                <a:cubicBezTo>
+                  <a:pt x="82353" y="381405"/>
+                  <a:pt x="42747" y="381405"/>
+                  <a:pt x="18321" y="356979"/>
+                </a:cubicBezTo>
+                <a:cubicBezTo>
+                  <a:pt x="-6105" y="332553"/>
+                  <a:pt x="-6105" y="292948"/>
+                  <a:pt x="18321" y="268520"/>
+                </a:cubicBezTo>
+                <a:lnTo>
+                  <a:pt x="161742" y="125100"/>
+                </a:lnTo>
+                <a:lnTo>
+                  <a:pt x="62550" y="125100"/>
+                </a:lnTo>
+                <a:cubicBezTo>
+                  <a:pt x="28004" y="125100"/>
+                  <a:pt x="0" y="97096"/>
+                  <a:pt x="0" y="62550"/>
+                </a:cubicBezTo>
+                <a:cubicBezTo>
+                  <a:pt x="0" y="28005"/>
+                  <a:pt x="28004" y="0"/>
+                  <a:pt x="62550" y="0"/>
+                </a:cubicBezTo>
+                <a:close/>
+              </a:path>
+            </a:pathLst>
+          </a:custGeom>
+          <a:solidFill>
+            <a:srgbClr val="111111"/>
+          </a:solidFill>
+          <a:ln w="62309" cap="flat">
+            <a:noFill/>
+            <a:prstDash val="solid"/>
+            <a:miter/>
+          </a:ln>
         </p:spPr>
-        <p:style>
-          <a:lnRef idx="1">
-            <a:schemeClr val="accent1"/>
-          </a:lnRef>
-          <a:fillRef idx="0">
-            <a:schemeClr val="accent1"/>
-          </a:fillRef>
-          <a:effectRef idx="0">
-            <a:schemeClr val="accent1"/>
-          </a:effectRef>
-          <a:fontRef idx="minor">
-            <a:schemeClr val="tx1"/>
-          </a:fontRef>
-        </p:style>
-      </p:cxnSp>
-      <p:cxnSp>
-        <p:nvCxnSpPr>
-          <p:cNvPr id="152" name="Straight Connector 151">
-            <a:extLst>
-              <a:ext uri="{FF2B5EF4-FFF2-40B4-BE49-F238E27FC236}">
-                <a16:creationId xmlns:a16="http://schemas.microsoft.com/office/drawing/2014/main" id="{092C06E1-53BD-B0CF-F174-54F1480A9961}"/>
-              </a:ext>
-            </a:extLst>
-          </p:cNvPr>
-          <p:cNvCxnSpPr>
-            <a:cxnSpLocks/>
-          </p:cNvCxnSpPr>
-          <p:nvPr/>
-        </p:nvCxnSpPr>
-        <p:spPr>
-          <a:xfrm rot="5400000">
-            <a:off x="5168869" y="2999068"/>
-            <a:ext cx="1988184" cy="0"/>
-          </a:xfrm>
-          <a:prstGeom prst="line">
-            <a:avLst/>
-          </a:prstGeom>
-        </p:spPr>
-        <p:style>
-          <a:lnRef idx="1">
-            <a:schemeClr val="accent1"/>
-          </a:lnRef>
-          <a:fillRef idx="0">
-            <a:schemeClr val="accent1"/>
-          </a:fillRef>
-          <a:effectRef idx="0">
-            <a:schemeClr val="accent1"/>
-          </a:effectRef>
-          <a:fontRef idx="minor">
-            <a:schemeClr val="tx1"/>
-          </a:fontRef>
-        </p:style>
-      </p:cxnSp>
-      <p:cxnSp>
-        <p:nvCxnSpPr>
-          <p:cNvPr id="153" name="Straight Connector 152">
-            <a:extLst>
-              <a:ext uri="{FF2B5EF4-FFF2-40B4-BE49-F238E27FC236}">
-                <a16:creationId xmlns:a16="http://schemas.microsoft.com/office/drawing/2014/main" id="{D9B5BE72-B739-2F97-FA5B-85E5B5BB5C76}"/>
-              </a:ext>
-            </a:extLst>
-          </p:cNvPr>
-          <p:cNvCxnSpPr>
-            <a:cxnSpLocks/>
-          </p:cNvCxnSpPr>
-          <p:nvPr/>
-        </p:nvCxnSpPr>
-        <p:spPr>
-          <a:xfrm rot="5400000">
-            <a:off x="4963554" y="2999068"/>
-            <a:ext cx="1988184" cy="0"/>
-          </a:xfrm>
-          <a:prstGeom prst="line">
-            <a:avLst/>
-          </a:prstGeom>
-        </p:spPr>
-        <p:style>
-          <a:lnRef idx="1">
-            <a:schemeClr val="accent1"/>
-          </a:lnRef>
-          <a:fillRef idx="0">
-            <a:schemeClr val="accent1"/>
-          </a:fillRef>
-          <a:effectRef idx="0">
-            <a:schemeClr val="accent1"/>
-          </a:effectRef>
-          <a:fontRef idx="minor">
-            <a:schemeClr val="tx1"/>
-          </a:fontRef>
-        </p:style>
-      </p:cxnSp>
-      <p:cxnSp>
-        <p:nvCxnSpPr>
-          <p:cNvPr id="150" name="Straight Connector 149">
-            <a:extLst>
-              <a:ext uri="{FF2B5EF4-FFF2-40B4-BE49-F238E27FC236}">
-                <a16:creationId xmlns:a16="http://schemas.microsoft.com/office/drawing/2014/main" id="{051C2213-6ADE-565D-AD08-0C9B267F5229}"/>
-              </a:ext>
-            </a:extLst>
-          </p:cNvPr>
-          <p:cNvCxnSpPr/>
-          <p:nvPr/>
-        </p:nvCxnSpPr>
-        <p:spPr>
-          <a:xfrm rot="5400000">
-            <a:off x="6464754" y="2999068"/>
-            <a:ext cx="1988184" cy="0"/>
-          </a:xfrm>
-          <a:prstGeom prst="line">
-            <a:avLst/>
-          </a:prstGeom>
-        </p:spPr>
-        <p:style>
-          <a:lnRef idx="1">
-            <a:schemeClr val="accent1"/>
-          </a:lnRef>
-          <a:fillRef idx="0">
-            <a:schemeClr val="accent1"/>
-          </a:fillRef>
-          <a:effectRef idx="0">
-            <a:schemeClr val="accent1"/>
-          </a:effectRef>
-          <a:fontRef idx="minor">
-            <a:schemeClr val="tx1"/>
-          </a:fontRef>
-        </p:style>
-      </p:cxnSp>
-      <p:cxnSp>
-        <p:nvCxnSpPr>
-          <p:cNvPr id="151" name="Straight Connector 150">
-            <a:extLst>
-              <a:ext uri="{FF2B5EF4-FFF2-40B4-BE49-F238E27FC236}">
-                <a16:creationId xmlns:a16="http://schemas.microsoft.com/office/drawing/2014/main" id="{F65DC6DF-3B37-1F43-5930-717C288A15F0}"/>
-              </a:ext>
-            </a:extLst>
-          </p:cNvPr>
-          <p:cNvCxnSpPr>
-            <a:cxnSpLocks/>
-          </p:cNvCxnSpPr>
-          <p:nvPr/>
-        </p:nvCxnSpPr>
-        <p:spPr>
-          <a:xfrm rot="5400000">
-            <a:off x="6259439" y="2999068"/>
-            <a:ext cx="1988184" cy="0"/>
-          </a:xfrm>
-          <a:prstGeom prst="line">
-            <a:avLst/>
-          </a:prstGeom>
-        </p:spPr>
-        <p:style>
-          <a:lnRef idx="1">
-            <a:schemeClr val="accent1"/>
-          </a:lnRef>
-          <a:fillRef idx="0">
-            <a:schemeClr val="accent1"/>
-          </a:fillRef>
-          <a:effectRef idx="0">
-            <a:schemeClr val="accent1"/>
-          </a:effectRef>
-          <a:fontRef idx="minor">
-            <a:schemeClr val="tx1"/>
-          </a:fontRef>
-        </p:style>
-      </p:cxnSp>
+        <p:txBody>
+          <a:bodyPr wrap="square">
+            <a:noAutofit/>
+          </a:bodyPr>
+          <a:lstStyle/>
+          <a:p>
+            <a:endParaRPr lang="en-US"/>
+          </a:p>
+        </p:txBody>
+      </p:sp>
     </p:spTree>
     <p:extLst>
       <p:ext uri="{BB962C8B-B14F-4D97-AF65-F5344CB8AC3E}">

</xml_diff>

<commit_message>
Add new SVG icons for UI_Academies and UI_EditTools
- Added alphabet.svg icon for UI_Academies.
- Added backpack.svg icon for UI_Academies.
- Added book.svg icon for UI_Academies.
- Added graduation.svg icon for UI_Academies.
- Added download.svg icon for UI_EditTools.
- Added upload.svg icon for UI_EditTools.
- Updated Icons_UI.pptx to reflect new icons.
</commit_message>
<xml_diff>
--- a/Icons_UI/Icons_UI.pptx
+++ b/Icons_UI/Icons_UI.pptx
@@ -9,8 +9,7 @@
     <p:sldId id="257" r:id="rId3"/>
     <p:sldId id="256" r:id="rId4"/>
     <p:sldId id="259" r:id="rId5"/>
-    <p:sldId id="260" r:id="rId6"/>
-    <p:sldId id="261" r:id="rId7"/>
+    <p:sldId id="261" r:id="rId6"/>
   </p:sldIdLst>
   <p:sldSz cx="12192000" cy="6858000"/>
   <p:notesSz cx="6858000" cy="9144000"/>
@@ -26067,36 +26066,6 @@
   <p:cSld>
     <p:spTree>
       <p:nvGrpSpPr>
-        <p:cNvPr id="1" name=""/>
-        <p:cNvGrpSpPr/>
-        <p:nvPr/>
-      </p:nvGrpSpPr>
-      <p:grpSpPr>
-        <a:xfrm>
-          <a:off x="0" y="0"/>
-          <a:ext cx="0" cy="0"/>
-          <a:chOff x="0" y="0"/>
-          <a:chExt cx="0" cy="0"/>
-        </a:xfrm>
-      </p:grpSpPr>
-    </p:spTree>
-    <p:extLst>
-      <p:ext uri="{BB962C8B-B14F-4D97-AF65-F5344CB8AC3E}">
-        <p14:creationId xmlns:p14="http://schemas.microsoft.com/office/powerpoint/2010/main" val="628180008"/>
-      </p:ext>
-    </p:extLst>
-  </p:cSld>
-  <p:clrMapOvr>
-    <a:masterClrMapping/>
-  </p:clrMapOvr>
-</p:sld>
-</file>
-
-<file path=ppt/slides/slide6.xml><?xml version="1.0" encoding="utf-8"?>
-<p:sld xmlns:a="http://schemas.openxmlformats.org/drawingml/2006/main" xmlns:r="http://schemas.openxmlformats.org/officeDocument/2006/relationships" xmlns:p="http://schemas.openxmlformats.org/presentationml/2006/main">
-  <p:cSld>
-    <p:spTree>
-      <p:nvGrpSpPr>
         <p:cNvPr id="1" name="">
           <a:extLst>
             <a:ext uri="{FF2B5EF4-FFF2-40B4-BE49-F238E27FC236}">
@@ -28467,7 +28436,7 @@
         </p:nvSpPr>
         <p:spPr>
           <a:xfrm>
-            <a:off x="5319134" y="4211901"/>
+            <a:off x="4009382" y="4212492"/>
             <a:ext cx="2962440" cy="1501201"/>
           </a:xfrm>
           <a:custGeom>
@@ -31152,6 +31121,838 @@
           </a:p>
         </p:txBody>
       </p:sp>
+      <p:sp>
+        <p:nvSpPr>
+          <p:cNvPr id="41" name="Freeform: Shape 40">
+            <a:extLst>
+              <a:ext uri="{FF2B5EF4-FFF2-40B4-BE49-F238E27FC236}">
+                <a16:creationId xmlns:a16="http://schemas.microsoft.com/office/drawing/2014/main" id="{55451AF8-0D65-A525-4682-B58772A058D3}"/>
+              </a:ext>
+            </a:extLst>
+          </p:cNvPr>
+          <p:cNvSpPr/>
+          <p:nvPr/>
+        </p:nvSpPr>
+        <p:spPr>
+          <a:xfrm flipV="1">
+            <a:off x="8906441" y="4212493"/>
+            <a:ext cx="1433739" cy="1501201"/>
+          </a:xfrm>
+          <a:custGeom>
+            <a:avLst/>
+            <a:gdLst>
+              <a:gd name="csX0" fmla="*/ 651700 w 1433739"/>
+              <a:gd name="csY0" fmla="*/ 1084065 h 1501201"/>
+              <a:gd name="csX1" fmla="*/ 782040 w 1433739"/>
+              <a:gd name="csY1" fmla="*/ 1084065 h 1501201"/>
+              <a:gd name="csX2" fmla="*/ 782040 w 1433739"/>
+              <a:gd name="csY2" fmla="*/ 221902 h 1501201"/>
+              <a:gd name="csX3" fmla="*/ 866298 w 1433739"/>
+              <a:gd name="csY3" fmla="*/ 305933 h 1501201"/>
+              <a:gd name="csX4" fmla="*/ 958462 w 1433739"/>
+              <a:gd name="csY4" fmla="*/ 214019 h 1501201"/>
+              <a:gd name="csX5" fmla="*/ 762952 w 1433739"/>
+              <a:gd name="csY5" fmla="*/ 19036 h 1501201"/>
+              <a:gd name="csX6" fmla="*/ 670788 w 1433739"/>
+              <a:gd name="csY6" fmla="*/ 19036 h 1501201"/>
+              <a:gd name="csX7" fmla="*/ 475279 w 1433739"/>
+              <a:gd name="csY7" fmla="*/ 214019 h 1501201"/>
+              <a:gd name="csX8" fmla="*/ 567443 w 1433739"/>
+              <a:gd name="csY8" fmla="*/ 305933 h 1501201"/>
+              <a:gd name="csX9" fmla="*/ 651700 w 1433739"/>
+              <a:gd name="csY9" fmla="*/ 221903 h 1501201"/>
+              <a:gd name="csX10" fmla="*/ 655773 w 1433739"/>
+              <a:gd name="csY10" fmla="*/ 1501201 h 1501201"/>
+              <a:gd name="csX11" fmla="*/ 1034984 w 1433739"/>
+              <a:gd name="csY11" fmla="*/ 1288886 h 1501201"/>
+              <a:gd name="csX12" fmla="*/ 1063086 w 1433739"/>
+              <a:gd name="csY12" fmla="*/ 1289970 h 1501201"/>
+              <a:gd name="csX13" fmla="*/ 1433739 w 1433739"/>
+              <a:gd name="csY13" fmla="*/ 908129 h 1501201"/>
+              <a:gd name="csX14" fmla="*/ 1195830 w 1433739"/>
+              <a:gd name="csY14" fmla="*/ 551518 h 1501201"/>
+              <a:gd name="csX15" fmla="*/ 1083451 w 1433739"/>
+              <a:gd name="csY15" fmla="*/ 526288 h 1501201"/>
+              <a:gd name="csX16" fmla="*/ 920287 w 1433739"/>
+              <a:gd name="csY16" fmla="*/ 526288 h 1501201"/>
+              <a:gd name="csX17" fmla="*/ 920287 w 1433739"/>
+              <a:gd name="csY17" fmla="*/ 656276 h 1501201"/>
+              <a:gd name="csX18" fmla="*/ 1083451 w 1433739"/>
+              <a:gd name="csY18" fmla="*/ 656277 h 1501201"/>
+              <a:gd name="csX19" fmla="*/ 1141231 w 1433739"/>
+              <a:gd name="csY19" fmla="*/ 669568 h 1501201"/>
+              <a:gd name="csX20" fmla="*/ 1146229 w 1433739"/>
+              <a:gd name="csY20" fmla="*/ 671745 h 1501201"/>
+              <a:gd name="csX21" fmla="*/ 1303399 w 1433739"/>
+              <a:gd name="csY21" fmla="*/ 908129 h 1501201"/>
+              <a:gd name="csX22" fmla="*/ 1063086 w 1433739"/>
+              <a:gd name="csY22" fmla="*/ 1159982 h 1501201"/>
+              <a:gd name="csX23" fmla="*/ 1013954 w 1433739"/>
+              <a:gd name="csY23" fmla="*/ 1154725 h 1501201"/>
+              <a:gd name="csX24" fmla="*/ 941654 w 1433739"/>
+              <a:gd name="csY24" fmla="*/ 1189407 h 1501201"/>
+              <a:gd name="csX25" fmla="*/ 655773 w 1433739"/>
+              <a:gd name="csY25" fmla="*/ 1371213 h 1501201"/>
+              <a:gd name="csX26" fmla="*/ 333996 w 1433739"/>
+              <a:gd name="csY26" fmla="*/ 1034868 h 1501201"/>
+              <a:gd name="csX27" fmla="*/ 334442 w 1433739"/>
+              <a:gd name="csY27" fmla="*/ 1016981 h 1501201"/>
+              <a:gd name="csX28" fmla="*/ 316568 w 1433739"/>
+              <a:gd name="csY28" fmla="*/ 968944 h 1501201"/>
+              <a:gd name="csX29" fmla="*/ 269352 w 1433739"/>
+              <a:gd name="csY29" fmla="*/ 948750 h 1501201"/>
+              <a:gd name="csX30" fmla="*/ 268826 w 1433739"/>
+              <a:gd name="csY30" fmla="*/ 948750 h 1501201"/>
+              <a:gd name="csX31" fmla="*/ 130340 w 1433739"/>
+              <a:gd name="csY31" fmla="*/ 802514 h 1501201"/>
+              <a:gd name="csX32" fmla="*/ 268826 w 1433739"/>
+              <a:gd name="csY32" fmla="*/ 656277 h 1501201"/>
+              <a:gd name="csX33" fmla="*/ 513452 w 1433739"/>
+              <a:gd name="csY33" fmla="*/ 656276 h 1501201"/>
+              <a:gd name="csX34" fmla="*/ 513452 w 1433739"/>
+              <a:gd name="csY34" fmla="*/ 526288 h 1501201"/>
+              <a:gd name="csX35" fmla="*/ 268826 w 1433739"/>
+              <a:gd name="csY35" fmla="*/ 526288 h 1501201"/>
+              <a:gd name="csX36" fmla="*/ 0 w 1433739"/>
+              <a:gd name="csY36" fmla="*/ 802514 h 1501201"/>
+              <a:gd name="csX37" fmla="*/ 204998 w 1433739"/>
+              <a:gd name="csY37" fmla="*/ 1070962 h 1501201"/>
+              <a:gd name="csX38" fmla="*/ 655773 w 1433739"/>
+              <a:gd name="csY38" fmla="*/ 1501201 h 1501201"/>
+            </a:gdLst>
+            <a:ahLst/>
+            <a:cxnLst>
+              <a:cxn ang="0">
+                <a:pos x="csX0" y="csY0"/>
+              </a:cxn>
+              <a:cxn ang="0">
+                <a:pos x="csX1" y="csY1"/>
+              </a:cxn>
+              <a:cxn ang="0">
+                <a:pos x="csX2" y="csY2"/>
+              </a:cxn>
+              <a:cxn ang="0">
+                <a:pos x="csX3" y="csY3"/>
+              </a:cxn>
+              <a:cxn ang="0">
+                <a:pos x="csX4" y="csY4"/>
+              </a:cxn>
+              <a:cxn ang="0">
+                <a:pos x="csX5" y="csY5"/>
+              </a:cxn>
+              <a:cxn ang="0">
+                <a:pos x="csX6" y="csY6"/>
+              </a:cxn>
+              <a:cxn ang="0">
+                <a:pos x="csX7" y="csY7"/>
+              </a:cxn>
+              <a:cxn ang="0">
+                <a:pos x="csX8" y="csY8"/>
+              </a:cxn>
+              <a:cxn ang="0">
+                <a:pos x="csX9" y="csY9"/>
+              </a:cxn>
+              <a:cxn ang="0">
+                <a:pos x="csX10" y="csY10"/>
+              </a:cxn>
+              <a:cxn ang="0">
+                <a:pos x="csX11" y="csY11"/>
+              </a:cxn>
+              <a:cxn ang="0">
+                <a:pos x="csX12" y="csY12"/>
+              </a:cxn>
+              <a:cxn ang="0">
+                <a:pos x="csX13" y="csY13"/>
+              </a:cxn>
+              <a:cxn ang="0">
+                <a:pos x="csX14" y="csY14"/>
+              </a:cxn>
+              <a:cxn ang="0">
+                <a:pos x="csX15" y="csY15"/>
+              </a:cxn>
+              <a:cxn ang="0">
+                <a:pos x="csX16" y="csY16"/>
+              </a:cxn>
+              <a:cxn ang="0">
+                <a:pos x="csX17" y="csY17"/>
+              </a:cxn>
+              <a:cxn ang="0">
+                <a:pos x="csX18" y="csY18"/>
+              </a:cxn>
+              <a:cxn ang="0">
+                <a:pos x="csX19" y="csY19"/>
+              </a:cxn>
+              <a:cxn ang="0">
+                <a:pos x="csX20" y="csY20"/>
+              </a:cxn>
+              <a:cxn ang="0">
+                <a:pos x="csX21" y="csY21"/>
+              </a:cxn>
+              <a:cxn ang="0">
+                <a:pos x="csX22" y="csY22"/>
+              </a:cxn>
+              <a:cxn ang="0">
+                <a:pos x="csX23" y="csY23"/>
+              </a:cxn>
+              <a:cxn ang="0">
+                <a:pos x="csX24" y="csY24"/>
+              </a:cxn>
+              <a:cxn ang="0">
+                <a:pos x="csX25" y="csY25"/>
+              </a:cxn>
+              <a:cxn ang="0">
+                <a:pos x="csX26" y="csY26"/>
+              </a:cxn>
+              <a:cxn ang="0">
+                <a:pos x="csX27" y="csY27"/>
+              </a:cxn>
+              <a:cxn ang="0">
+                <a:pos x="csX28" y="csY28"/>
+              </a:cxn>
+              <a:cxn ang="0">
+                <a:pos x="csX29" y="csY29"/>
+              </a:cxn>
+              <a:cxn ang="0">
+                <a:pos x="csX30" y="csY30"/>
+              </a:cxn>
+              <a:cxn ang="0">
+                <a:pos x="csX31" y="csY31"/>
+              </a:cxn>
+              <a:cxn ang="0">
+                <a:pos x="csX32" y="csY32"/>
+              </a:cxn>
+              <a:cxn ang="0">
+                <a:pos x="csX33" y="csY33"/>
+              </a:cxn>
+              <a:cxn ang="0">
+                <a:pos x="csX34" y="csY34"/>
+              </a:cxn>
+              <a:cxn ang="0">
+                <a:pos x="csX35" y="csY35"/>
+              </a:cxn>
+              <a:cxn ang="0">
+                <a:pos x="csX36" y="csY36"/>
+              </a:cxn>
+              <a:cxn ang="0">
+                <a:pos x="csX37" y="csY37"/>
+              </a:cxn>
+              <a:cxn ang="0">
+                <a:pos x="csX38" y="csY38"/>
+              </a:cxn>
+            </a:cxnLst>
+            <a:rect l="l" t="t" r="r" b="b"/>
+            <a:pathLst>
+              <a:path w="1433739" h="1501201">
+                <a:moveTo>
+                  <a:pt x="651700" y="1084065"/>
+                </a:moveTo>
+                <a:lnTo>
+                  <a:pt x="782040" y="1084065"/>
+                </a:lnTo>
+                <a:lnTo>
+                  <a:pt x="782040" y="221902"/>
+                </a:lnTo>
+                <a:lnTo>
+                  <a:pt x="866298" y="305933"/>
+                </a:lnTo>
+                <a:lnTo>
+                  <a:pt x="958462" y="214019"/>
+                </a:lnTo>
+                <a:lnTo>
+                  <a:pt x="762952" y="19036"/>
+                </a:lnTo>
+                <a:cubicBezTo>
+                  <a:pt x="737503" y="-6345"/>
+                  <a:pt x="696237" y="-6345"/>
+                  <a:pt x="670788" y="19036"/>
+                </a:cubicBezTo>
+                <a:lnTo>
+                  <a:pt x="475279" y="214019"/>
+                </a:lnTo>
+                <a:lnTo>
+                  <a:pt x="567443" y="305933"/>
+                </a:lnTo>
+                <a:lnTo>
+                  <a:pt x="651700" y="221903"/>
+                </a:lnTo>
+                <a:close/>
+                <a:moveTo>
+                  <a:pt x="655773" y="1501201"/>
+                </a:moveTo>
+                <a:cubicBezTo>
+                  <a:pt x="815538" y="1501201"/>
+                  <a:pt x="954812" y="1415933"/>
+                  <a:pt x="1034984" y="1288886"/>
+                </a:cubicBezTo>
+                <a:cubicBezTo>
+                  <a:pt x="1044264" y="1289605"/>
+                  <a:pt x="1053642" y="1289970"/>
+                  <a:pt x="1063086" y="1289970"/>
+                </a:cubicBezTo>
+                <a:cubicBezTo>
+                  <a:pt x="1270175" y="1289970"/>
+                  <a:pt x="1433739" y="1116587"/>
+                  <a:pt x="1433739" y="908129"/>
+                </a:cubicBezTo>
+                <a:cubicBezTo>
+                  <a:pt x="1433739" y="746560"/>
+                  <a:pt x="1336023" y="606919"/>
+                  <a:pt x="1195830" y="551518"/>
+                </a:cubicBezTo>
+                <a:cubicBezTo>
+                  <a:pt x="1161616" y="535329"/>
+                  <a:pt x="1123505" y="526288"/>
+                  <a:pt x="1083451" y="526288"/>
+                </a:cubicBezTo>
+                <a:lnTo>
+                  <a:pt x="920287" y="526288"/>
+                </a:lnTo>
+                <a:lnTo>
+                  <a:pt x="920287" y="656276"/>
+                </a:lnTo>
+                <a:lnTo>
+                  <a:pt x="1083451" y="656277"/>
+                </a:lnTo>
+                <a:cubicBezTo>
+                  <a:pt x="1104142" y="656277"/>
+                  <a:pt x="1123654" y="661027"/>
+                  <a:pt x="1141231" y="669568"/>
+                </a:cubicBezTo>
+                <a:cubicBezTo>
+                  <a:pt x="1142860" y="670361"/>
+                  <a:pt x="1144528" y="671089"/>
+                  <a:pt x="1146229" y="671745"/>
+                </a:cubicBezTo>
+                <a:cubicBezTo>
+                  <a:pt x="1236900" y="706803"/>
+                  <a:pt x="1303399" y="798529"/>
+                  <a:pt x="1303399" y="908129"/>
+                </a:cubicBezTo>
+                <a:cubicBezTo>
+                  <a:pt x="1303399" y="1049649"/>
+                  <a:pt x="1193418" y="1159982"/>
+                  <a:pt x="1063086" y="1159982"/>
+                </a:cubicBezTo>
+                <a:cubicBezTo>
+                  <a:pt x="1046187" y="1159982"/>
+                  <a:pt x="1029764" y="1158164"/>
+                  <a:pt x="1013954" y="1154725"/>
+                </a:cubicBezTo>
+                <a:cubicBezTo>
+                  <a:pt x="984731" y="1148368"/>
+                  <a:pt x="954917" y="1162669"/>
+                  <a:pt x="941654" y="1189407"/>
+                </a:cubicBezTo>
+                <a:cubicBezTo>
+                  <a:pt x="887550" y="1298479"/>
+                  <a:pt x="779068" y="1371213"/>
+                  <a:pt x="655773" y="1371213"/>
+                </a:cubicBezTo>
+                <a:cubicBezTo>
+                  <a:pt x="480446" y="1371213"/>
+                  <a:pt x="333996" y="1223052"/>
+                  <a:pt x="333996" y="1034868"/>
+                </a:cubicBezTo>
+                <a:cubicBezTo>
+                  <a:pt x="333996" y="1028862"/>
+                  <a:pt x="334145" y="1022898"/>
+                  <a:pt x="334442" y="1016981"/>
+                </a:cubicBezTo>
+                <a:cubicBezTo>
+                  <a:pt x="335331" y="999204"/>
+                  <a:pt x="328870" y="981841"/>
+                  <a:pt x="316568" y="968944"/>
+                </a:cubicBezTo>
+                <a:cubicBezTo>
+                  <a:pt x="304267" y="956049"/>
+                  <a:pt x="287200" y="948750"/>
+                  <a:pt x="269352" y="948750"/>
+                </a:cubicBezTo>
+                <a:lnTo>
+                  <a:pt x="268826" y="948750"/>
+                </a:lnTo>
+                <a:cubicBezTo>
+                  <a:pt x="194728" y="948750"/>
+                  <a:pt x="130340" y="885706"/>
+                  <a:pt x="130340" y="802514"/>
+                </a:cubicBezTo>
+                <a:cubicBezTo>
+                  <a:pt x="130340" y="719320"/>
+                  <a:pt x="194728" y="656277"/>
+                  <a:pt x="268826" y="656277"/>
+                </a:cubicBezTo>
+                <a:lnTo>
+                  <a:pt x="513452" y="656276"/>
+                </a:lnTo>
+                <a:lnTo>
+                  <a:pt x="513452" y="526288"/>
+                </a:lnTo>
+                <a:lnTo>
+                  <a:pt x="268826" y="526288"/>
+                </a:lnTo>
+                <a:cubicBezTo>
+                  <a:pt x="117971" y="526288"/>
+                  <a:pt x="0" y="652383"/>
+                  <a:pt x="0" y="802514"/>
+                </a:cubicBezTo>
+                <a:cubicBezTo>
+                  <a:pt x="0" y="930681"/>
+                  <a:pt x="85980" y="1041331"/>
+                  <a:pt x="204998" y="1070962"/>
+                </a:cubicBezTo>
+                <a:cubicBezTo>
+                  <a:pt x="222807" y="1309609"/>
+                  <a:pt x="415683" y="1501201"/>
+                  <a:pt x="655773" y="1501201"/>
+                </a:cubicBezTo>
+                <a:close/>
+              </a:path>
+            </a:pathLst>
+          </a:custGeom>
+          <a:solidFill>
+            <a:schemeClr val="tx1"/>
+          </a:solidFill>
+          <a:ln w="62309" cap="flat">
+            <a:noFill/>
+            <a:prstDash val="solid"/>
+            <a:miter/>
+          </a:ln>
+        </p:spPr>
+        <p:txBody>
+          <a:bodyPr wrap="square">
+            <a:noAutofit/>
+          </a:bodyPr>
+          <a:lstStyle/>
+          <a:p>
+            <a:endParaRPr lang="en-US"/>
+          </a:p>
+        </p:txBody>
+      </p:sp>
+      <p:sp>
+        <p:nvSpPr>
+          <p:cNvPr id="40" name="Freeform: Shape 39">
+            <a:extLst>
+              <a:ext uri="{FF2B5EF4-FFF2-40B4-BE49-F238E27FC236}">
+                <a16:creationId xmlns:a16="http://schemas.microsoft.com/office/drawing/2014/main" id="{0ED30121-02D2-249A-42A8-26CFD9F316A8}"/>
+              </a:ext>
+            </a:extLst>
+          </p:cNvPr>
+          <p:cNvSpPr/>
+          <p:nvPr/>
+        </p:nvSpPr>
+        <p:spPr>
+          <a:xfrm>
+            <a:off x="7263378" y="4212493"/>
+            <a:ext cx="1433739" cy="1501201"/>
+          </a:xfrm>
+          <a:custGeom>
+            <a:avLst/>
+            <a:gdLst>
+              <a:gd name="csX0" fmla="*/ 716870 w 1433739"/>
+              <a:gd name="csY0" fmla="*/ 417137 h 1501201"/>
+              <a:gd name="csX1" fmla="*/ 762952 w 1433739"/>
+              <a:gd name="csY1" fmla="*/ 436173 h 1501201"/>
+              <a:gd name="csX2" fmla="*/ 958462 w 1433739"/>
+              <a:gd name="csY2" fmla="*/ 631156 h 1501201"/>
+              <a:gd name="csX3" fmla="*/ 866298 w 1433739"/>
+              <a:gd name="csY3" fmla="*/ 723070 h 1501201"/>
+              <a:gd name="csX4" fmla="*/ 782040 w 1433739"/>
+              <a:gd name="csY4" fmla="*/ 639040 h 1501201"/>
+              <a:gd name="csX5" fmla="*/ 782040 w 1433739"/>
+              <a:gd name="csY5" fmla="*/ 1501201 h 1501201"/>
+              <a:gd name="csX6" fmla="*/ 651700 w 1433739"/>
+              <a:gd name="csY6" fmla="*/ 1501201 h 1501201"/>
+              <a:gd name="csX7" fmla="*/ 651700 w 1433739"/>
+              <a:gd name="csY7" fmla="*/ 639040 h 1501201"/>
+              <a:gd name="csX8" fmla="*/ 567443 w 1433739"/>
+              <a:gd name="csY8" fmla="*/ 723070 h 1501201"/>
+              <a:gd name="csX9" fmla="*/ 475279 w 1433739"/>
+              <a:gd name="csY9" fmla="*/ 631156 h 1501201"/>
+              <a:gd name="csX10" fmla="*/ 670788 w 1433739"/>
+              <a:gd name="csY10" fmla="*/ 436173 h 1501201"/>
+              <a:gd name="csX11" fmla="*/ 716870 w 1433739"/>
+              <a:gd name="csY11" fmla="*/ 417137 h 1501201"/>
+              <a:gd name="csX12" fmla="*/ 655773 w 1433739"/>
+              <a:gd name="csY12" fmla="*/ 0 h 1501201"/>
+              <a:gd name="csX13" fmla="*/ 1034984 w 1433739"/>
+              <a:gd name="csY13" fmla="*/ 212315 h 1501201"/>
+              <a:gd name="csX14" fmla="*/ 1063086 w 1433739"/>
+              <a:gd name="csY14" fmla="*/ 211231 h 1501201"/>
+              <a:gd name="csX15" fmla="*/ 1433739 w 1433739"/>
+              <a:gd name="csY15" fmla="*/ 593072 h 1501201"/>
+              <a:gd name="csX16" fmla="*/ 1195830 w 1433739"/>
+              <a:gd name="csY16" fmla="*/ 949683 h 1501201"/>
+              <a:gd name="csX17" fmla="*/ 1083451 w 1433739"/>
+              <a:gd name="csY17" fmla="*/ 974913 h 1501201"/>
+              <a:gd name="csX18" fmla="*/ 920287 w 1433739"/>
+              <a:gd name="csY18" fmla="*/ 974913 h 1501201"/>
+              <a:gd name="csX19" fmla="*/ 920287 w 1433739"/>
+              <a:gd name="csY19" fmla="*/ 844925 h 1501201"/>
+              <a:gd name="csX20" fmla="*/ 1083451 w 1433739"/>
+              <a:gd name="csY20" fmla="*/ 844924 h 1501201"/>
+              <a:gd name="csX21" fmla="*/ 1141231 w 1433739"/>
+              <a:gd name="csY21" fmla="*/ 831633 h 1501201"/>
+              <a:gd name="csX22" fmla="*/ 1146229 w 1433739"/>
+              <a:gd name="csY22" fmla="*/ 829456 h 1501201"/>
+              <a:gd name="csX23" fmla="*/ 1303399 w 1433739"/>
+              <a:gd name="csY23" fmla="*/ 593072 h 1501201"/>
+              <a:gd name="csX24" fmla="*/ 1063086 w 1433739"/>
+              <a:gd name="csY24" fmla="*/ 341219 h 1501201"/>
+              <a:gd name="csX25" fmla="*/ 1013954 w 1433739"/>
+              <a:gd name="csY25" fmla="*/ 346476 h 1501201"/>
+              <a:gd name="csX26" fmla="*/ 941654 w 1433739"/>
+              <a:gd name="csY26" fmla="*/ 311794 h 1501201"/>
+              <a:gd name="csX27" fmla="*/ 655773 w 1433739"/>
+              <a:gd name="csY27" fmla="*/ 129988 h 1501201"/>
+              <a:gd name="csX28" fmla="*/ 333996 w 1433739"/>
+              <a:gd name="csY28" fmla="*/ 466333 h 1501201"/>
+              <a:gd name="csX29" fmla="*/ 334442 w 1433739"/>
+              <a:gd name="csY29" fmla="*/ 484220 h 1501201"/>
+              <a:gd name="csX30" fmla="*/ 316568 w 1433739"/>
+              <a:gd name="csY30" fmla="*/ 532257 h 1501201"/>
+              <a:gd name="csX31" fmla="*/ 269352 w 1433739"/>
+              <a:gd name="csY31" fmla="*/ 552451 h 1501201"/>
+              <a:gd name="csX32" fmla="*/ 268826 w 1433739"/>
+              <a:gd name="csY32" fmla="*/ 552451 h 1501201"/>
+              <a:gd name="csX33" fmla="*/ 130340 w 1433739"/>
+              <a:gd name="csY33" fmla="*/ 698687 h 1501201"/>
+              <a:gd name="csX34" fmla="*/ 268826 w 1433739"/>
+              <a:gd name="csY34" fmla="*/ 844924 h 1501201"/>
+              <a:gd name="csX35" fmla="*/ 513452 w 1433739"/>
+              <a:gd name="csY35" fmla="*/ 844925 h 1501201"/>
+              <a:gd name="csX36" fmla="*/ 513452 w 1433739"/>
+              <a:gd name="csY36" fmla="*/ 974913 h 1501201"/>
+              <a:gd name="csX37" fmla="*/ 268826 w 1433739"/>
+              <a:gd name="csY37" fmla="*/ 974913 h 1501201"/>
+              <a:gd name="csX38" fmla="*/ 0 w 1433739"/>
+              <a:gd name="csY38" fmla="*/ 698687 h 1501201"/>
+              <a:gd name="csX39" fmla="*/ 204998 w 1433739"/>
+              <a:gd name="csY39" fmla="*/ 430239 h 1501201"/>
+              <a:gd name="csX40" fmla="*/ 655773 w 1433739"/>
+              <a:gd name="csY40" fmla="*/ 0 h 1501201"/>
+            </a:gdLst>
+            <a:ahLst/>
+            <a:cxnLst>
+              <a:cxn ang="0">
+                <a:pos x="csX0" y="csY0"/>
+              </a:cxn>
+              <a:cxn ang="0">
+                <a:pos x="csX1" y="csY1"/>
+              </a:cxn>
+              <a:cxn ang="0">
+                <a:pos x="csX2" y="csY2"/>
+              </a:cxn>
+              <a:cxn ang="0">
+                <a:pos x="csX3" y="csY3"/>
+              </a:cxn>
+              <a:cxn ang="0">
+                <a:pos x="csX4" y="csY4"/>
+              </a:cxn>
+              <a:cxn ang="0">
+                <a:pos x="csX5" y="csY5"/>
+              </a:cxn>
+              <a:cxn ang="0">
+                <a:pos x="csX6" y="csY6"/>
+              </a:cxn>
+              <a:cxn ang="0">
+                <a:pos x="csX7" y="csY7"/>
+              </a:cxn>
+              <a:cxn ang="0">
+                <a:pos x="csX8" y="csY8"/>
+              </a:cxn>
+              <a:cxn ang="0">
+                <a:pos x="csX9" y="csY9"/>
+              </a:cxn>
+              <a:cxn ang="0">
+                <a:pos x="csX10" y="csY10"/>
+              </a:cxn>
+              <a:cxn ang="0">
+                <a:pos x="csX11" y="csY11"/>
+              </a:cxn>
+              <a:cxn ang="0">
+                <a:pos x="csX12" y="csY12"/>
+              </a:cxn>
+              <a:cxn ang="0">
+                <a:pos x="csX13" y="csY13"/>
+              </a:cxn>
+              <a:cxn ang="0">
+                <a:pos x="csX14" y="csY14"/>
+              </a:cxn>
+              <a:cxn ang="0">
+                <a:pos x="csX15" y="csY15"/>
+              </a:cxn>
+              <a:cxn ang="0">
+                <a:pos x="csX16" y="csY16"/>
+              </a:cxn>
+              <a:cxn ang="0">
+                <a:pos x="csX17" y="csY17"/>
+              </a:cxn>
+              <a:cxn ang="0">
+                <a:pos x="csX18" y="csY18"/>
+              </a:cxn>
+              <a:cxn ang="0">
+                <a:pos x="csX19" y="csY19"/>
+              </a:cxn>
+              <a:cxn ang="0">
+                <a:pos x="csX20" y="csY20"/>
+              </a:cxn>
+              <a:cxn ang="0">
+                <a:pos x="csX21" y="csY21"/>
+              </a:cxn>
+              <a:cxn ang="0">
+                <a:pos x="csX22" y="csY22"/>
+              </a:cxn>
+              <a:cxn ang="0">
+                <a:pos x="csX23" y="csY23"/>
+              </a:cxn>
+              <a:cxn ang="0">
+                <a:pos x="csX24" y="csY24"/>
+              </a:cxn>
+              <a:cxn ang="0">
+                <a:pos x="csX25" y="csY25"/>
+              </a:cxn>
+              <a:cxn ang="0">
+                <a:pos x="csX26" y="csY26"/>
+              </a:cxn>
+              <a:cxn ang="0">
+                <a:pos x="csX27" y="csY27"/>
+              </a:cxn>
+              <a:cxn ang="0">
+                <a:pos x="csX28" y="csY28"/>
+              </a:cxn>
+              <a:cxn ang="0">
+                <a:pos x="csX29" y="csY29"/>
+              </a:cxn>
+              <a:cxn ang="0">
+                <a:pos x="csX30" y="csY30"/>
+              </a:cxn>
+              <a:cxn ang="0">
+                <a:pos x="csX31" y="csY31"/>
+              </a:cxn>
+              <a:cxn ang="0">
+                <a:pos x="csX32" y="csY32"/>
+              </a:cxn>
+              <a:cxn ang="0">
+                <a:pos x="csX33" y="csY33"/>
+              </a:cxn>
+              <a:cxn ang="0">
+                <a:pos x="csX34" y="csY34"/>
+              </a:cxn>
+              <a:cxn ang="0">
+                <a:pos x="csX35" y="csY35"/>
+              </a:cxn>
+              <a:cxn ang="0">
+                <a:pos x="csX36" y="csY36"/>
+              </a:cxn>
+              <a:cxn ang="0">
+                <a:pos x="csX37" y="csY37"/>
+              </a:cxn>
+              <a:cxn ang="0">
+                <a:pos x="csX38" y="csY38"/>
+              </a:cxn>
+              <a:cxn ang="0">
+                <a:pos x="csX39" y="csY39"/>
+              </a:cxn>
+              <a:cxn ang="0">
+                <a:pos x="csX40" y="csY40"/>
+              </a:cxn>
+            </a:cxnLst>
+            <a:rect l="l" t="t" r="r" b="b"/>
+            <a:pathLst>
+              <a:path w="1433739" h="1501201">
+                <a:moveTo>
+                  <a:pt x="716870" y="417137"/>
+                </a:moveTo>
+                <a:cubicBezTo>
+                  <a:pt x="733549" y="417137"/>
+                  <a:pt x="750227" y="423483"/>
+                  <a:pt x="762952" y="436173"/>
+                </a:cubicBezTo>
+                <a:lnTo>
+                  <a:pt x="958462" y="631156"/>
+                </a:lnTo>
+                <a:lnTo>
+                  <a:pt x="866298" y="723070"/>
+                </a:lnTo>
+                <a:lnTo>
+                  <a:pt x="782040" y="639040"/>
+                </a:lnTo>
+                <a:lnTo>
+                  <a:pt x="782040" y="1501201"/>
+                </a:lnTo>
+                <a:lnTo>
+                  <a:pt x="651700" y="1501201"/>
+                </a:lnTo>
+                <a:lnTo>
+                  <a:pt x="651700" y="639040"/>
+                </a:lnTo>
+                <a:lnTo>
+                  <a:pt x="567443" y="723070"/>
+                </a:lnTo>
+                <a:lnTo>
+                  <a:pt x="475279" y="631156"/>
+                </a:lnTo>
+                <a:lnTo>
+                  <a:pt x="670788" y="436173"/>
+                </a:lnTo>
+                <a:cubicBezTo>
+                  <a:pt x="683513" y="423483"/>
+                  <a:pt x="700192" y="417137"/>
+                  <a:pt x="716870" y="417137"/>
+                </a:cubicBezTo>
+                <a:close/>
+                <a:moveTo>
+                  <a:pt x="655773" y="0"/>
+                </a:moveTo>
+                <a:cubicBezTo>
+                  <a:pt x="815538" y="0"/>
+                  <a:pt x="954812" y="85268"/>
+                  <a:pt x="1034984" y="212315"/>
+                </a:cubicBezTo>
+                <a:cubicBezTo>
+                  <a:pt x="1044264" y="211596"/>
+                  <a:pt x="1053642" y="211231"/>
+                  <a:pt x="1063086" y="211231"/>
+                </a:cubicBezTo>
+                <a:cubicBezTo>
+                  <a:pt x="1270175" y="211231"/>
+                  <a:pt x="1433739" y="384614"/>
+                  <a:pt x="1433739" y="593072"/>
+                </a:cubicBezTo>
+                <a:cubicBezTo>
+                  <a:pt x="1433739" y="754641"/>
+                  <a:pt x="1336023" y="894282"/>
+                  <a:pt x="1195830" y="949683"/>
+                </a:cubicBezTo>
+                <a:cubicBezTo>
+                  <a:pt x="1161616" y="965872"/>
+                  <a:pt x="1123505" y="974913"/>
+                  <a:pt x="1083451" y="974913"/>
+                </a:cubicBezTo>
+                <a:lnTo>
+                  <a:pt x="920287" y="974913"/>
+                </a:lnTo>
+                <a:lnTo>
+                  <a:pt x="920287" y="844925"/>
+                </a:lnTo>
+                <a:lnTo>
+                  <a:pt x="1083451" y="844924"/>
+                </a:lnTo>
+                <a:cubicBezTo>
+                  <a:pt x="1104142" y="844924"/>
+                  <a:pt x="1123654" y="840174"/>
+                  <a:pt x="1141231" y="831633"/>
+                </a:cubicBezTo>
+                <a:cubicBezTo>
+                  <a:pt x="1142860" y="830840"/>
+                  <a:pt x="1144528" y="830112"/>
+                  <a:pt x="1146229" y="829456"/>
+                </a:cubicBezTo>
+                <a:cubicBezTo>
+                  <a:pt x="1236900" y="794398"/>
+                  <a:pt x="1303399" y="702672"/>
+                  <a:pt x="1303399" y="593072"/>
+                </a:cubicBezTo>
+                <a:cubicBezTo>
+                  <a:pt x="1303399" y="451552"/>
+                  <a:pt x="1193418" y="341219"/>
+                  <a:pt x="1063086" y="341219"/>
+                </a:cubicBezTo>
+                <a:cubicBezTo>
+                  <a:pt x="1046187" y="341219"/>
+                  <a:pt x="1029764" y="343037"/>
+                  <a:pt x="1013954" y="346476"/>
+                </a:cubicBezTo>
+                <a:cubicBezTo>
+                  <a:pt x="984731" y="352833"/>
+                  <a:pt x="954917" y="338532"/>
+                  <a:pt x="941654" y="311794"/>
+                </a:cubicBezTo>
+                <a:cubicBezTo>
+                  <a:pt x="887550" y="202722"/>
+                  <a:pt x="779068" y="129988"/>
+                  <a:pt x="655773" y="129988"/>
+                </a:cubicBezTo>
+                <a:cubicBezTo>
+                  <a:pt x="480446" y="129988"/>
+                  <a:pt x="333996" y="278149"/>
+                  <a:pt x="333996" y="466333"/>
+                </a:cubicBezTo>
+                <a:cubicBezTo>
+                  <a:pt x="333996" y="472339"/>
+                  <a:pt x="334145" y="478303"/>
+                  <a:pt x="334442" y="484220"/>
+                </a:cubicBezTo>
+                <a:cubicBezTo>
+                  <a:pt x="335331" y="501997"/>
+                  <a:pt x="328870" y="519360"/>
+                  <a:pt x="316568" y="532257"/>
+                </a:cubicBezTo>
+                <a:cubicBezTo>
+                  <a:pt x="304267" y="545152"/>
+                  <a:pt x="287200" y="552451"/>
+                  <a:pt x="269352" y="552451"/>
+                </a:cubicBezTo>
+                <a:lnTo>
+                  <a:pt x="268826" y="552451"/>
+                </a:lnTo>
+                <a:cubicBezTo>
+                  <a:pt x="194728" y="552451"/>
+                  <a:pt x="130340" y="615495"/>
+                  <a:pt x="130340" y="698687"/>
+                </a:cubicBezTo>
+                <a:cubicBezTo>
+                  <a:pt x="130340" y="781881"/>
+                  <a:pt x="194728" y="844924"/>
+                  <a:pt x="268826" y="844924"/>
+                </a:cubicBezTo>
+                <a:lnTo>
+                  <a:pt x="513452" y="844925"/>
+                </a:lnTo>
+                <a:lnTo>
+                  <a:pt x="513452" y="974913"/>
+                </a:lnTo>
+                <a:lnTo>
+                  <a:pt x="268826" y="974913"/>
+                </a:lnTo>
+                <a:cubicBezTo>
+                  <a:pt x="117971" y="974913"/>
+                  <a:pt x="0" y="848818"/>
+                  <a:pt x="0" y="698687"/>
+                </a:cubicBezTo>
+                <a:cubicBezTo>
+                  <a:pt x="0" y="570520"/>
+                  <a:pt x="85980" y="459870"/>
+                  <a:pt x="204998" y="430239"/>
+                </a:cubicBezTo>
+                <a:cubicBezTo>
+                  <a:pt x="222807" y="191592"/>
+                  <a:pt x="415683" y="0"/>
+                  <a:pt x="655773" y="0"/>
+                </a:cubicBezTo>
+                <a:close/>
+              </a:path>
+            </a:pathLst>
+          </a:custGeom>
+          <a:solidFill>
+            <a:schemeClr val="tx1"/>
+          </a:solidFill>
+          <a:ln w="62309" cap="flat">
+            <a:noFill/>
+            <a:prstDash val="solid"/>
+            <a:miter/>
+          </a:ln>
+        </p:spPr>
+        <p:txBody>
+          <a:bodyPr wrap="square">
+            <a:noAutofit/>
+          </a:bodyPr>
+          <a:lstStyle/>
+          <a:p>
+            <a:endParaRPr lang="en-US"/>
+          </a:p>
+        </p:txBody>
+      </p:sp>
     </p:spTree>
     <p:extLst>
       <p:ext uri="{BB962C8B-B14F-4D97-AF65-F5344CB8AC3E}">

</xml_diff>

<commit_message>
update dbtm + 1 TM icon(s)
</commit_message>
<xml_diff>
--- a/Icons_UI/Icons_UI.pptx
+++ b/Icons_UI/Icons_UI.pptx
@@ -26046,6 +26046,430 @@
           <a:lstStyle/>
           <a:p>
             <a:pPr algn="ctr"/>
+            <a:endParaRPr lang="en-US"/>
+          </a:p>
+        </p:txBody>
+      </p:sp>
+      <p:sp>
+        <p:nvSpPr>
+          <p:cNvPr id="5" name="Graphic 3">
+            <a:extLst>
+              <a:ext uri="{FF2B5EF4-FFF2-40B4-BE49-F238E27FC236}">
+                <a16:creationId xmlns:a16="http://schemas.microsoft.com/office/drawing/2014/main" id="{A5332B49-81DA-2D0E-EB26-DDE65500F3B0}"/>
+              </a:ext>
+            </a:extLst>
+          </p:cNvPr>
+          <p:cNvSpPr/>
+          <p:nvPr/>
+        </p:nvSpPr>
+        <p:spPr>
+          <a:xfrm>
+            <a:off x="6572738" y="4211901"/>
+            <a:ext cx="1527730" cy="1501200"/>
+          </a:xfrm>
+          <a:custGeom>
+            <a:avLst/>
+            <a:gdLst>
+              <a:gd name="csX0" fmla="*/ 4008944 w 4008943"/>
+              <a:gd name="csY0" fmla="*/ 1167165 h 3916469"/>
+              <a:gd name="csX1" fmla="*/ 4008944 w 4008943"/>
+              <a:gd name="csY1" fmla="*/ 2749696 h 3916469"/>
+              <a:gd name="csX2" fmla="*/ 3709059 w 4008943"/>
+              <a:gd name="csY2" fmla="*/ 3049315 h 3916469"/>
+              <a:gd name="csX3" fmla="*/ 2166704 w 4008943"/>
+              <a:gd name="csY3" fmla="*/ 3049315 h 3916469"/>
+              <a:gd name="csX4" fmla="*/ 2028020 w 4008943"/>
+              <a:gd name="csY4" fmla="*/ 3188170 h 3916469"/>
+              <a:gd name="csX5" fmla="*/ 2028020 w 4008943"/>
+              <a:gd name="csY5" fmla="*/ 3704044 h 3916469"/>
+              <a:gd name="csX6" fmla="*/ 1893327 w 4008943"/>
+              <a:gd name="csY6" fmla="*/ 3901164 h 3916469"/>
+              <a:gd name="csX7" fmla="*/ 1660812 w 4008943"/>
+              <a:gd name="csY7" fmla="*/ 3847100 h 3916469"/>
+              <a:gd name="csX8" fmla="*/ 56136 w 4008943"/>
+              <a:gd name="csY8" fmla="*/ 2101263 h 3916469"/>
+              <a:gd name="csX9" fmla="*/ 56136 w 4008943"/>
+              <a:gd name="csY9" fmla="*/ 1815141 h 3916469"/>
+              <a:gd name="csX10" fmla="*/ 1660812 w 4008943"/>
+              <a:gd name="csY10" fmla="*/ 69304 h 3916469"/>
+              <a:gd name="csX11" fmla="*/ 1813679 w 4008943"/>
+              <a:gd name="csY11" fmla="*/ 0 h 3916469"/>
+              <a:gd name="csX12" fmla="*/ 1893318 w 4008943"/>
+              <a:gd name="csY12" fmla="*/ 15697 h 3916469"/>
+              <a:gd name="csX13" fmla="*/ 2028011 w 4008943"/>
+              <a:gd name="csY13" fmla="*/ 212817 h 3916469"/>
+              <a:gd name="csX14" fmla="*/ 2028011 w 4008943"/>
+              <a:gd name="csY14" fmla="*/ 728243 h 3916469"/>
+              <a:gd name="csX15" fmla="*/ 2166695 w 4008943"/>
+              <a:gd name="csY15" fmla="*/ 867099 h 3916469"/>
+              <a:gd name="csX16" fmla="*/ 3709040 w 4008943"/>
+              <a:gd name="csY16" fmla="*/ 867099 h 3916469"/>
+              <a:gd name="csX17" fmla="*/ 4008944 w 4008943"/>
+              <a:gd name="csY17" fmla="*/ 1167165 h 3916469"/>
+            </a:gdLst>
+            <a:ahLst/>
+            <a:cxnLst>
+              <a:cxn ang="0">
+                <a:pos x="csX0" y="csY0"/>
+              </a:cxn>
+              <a:cxn ang="0">
+                <a:pos x="csX1" y="csY1"/>
+              </a:cxn>
+              <a:cxn ang="0">
+                <a:pos x="csX2" y="csY2"/>
+              </a:cxn>
+              <a:cxn ang="0">
+                <a:pos x="csX3" y="csY3"/>
+              </a:cxn>
+              <a:cxn ang="0">
+                <a:pos x="csX4" y="csY4"/>
+              </a:cxn>
+              <a:cxn ang="0">
+                <a:pos x="csX5" y="csY5"/>
+              </a:cxn>
+              <a:cxn ang="0">
+                <a:pos x="csX6" y="csY6"/>
+              </a:cxn>
+              <a:cxn ang="0">
+                <a:pos x="csX7" y="csY7"/>
+              </a:cxn>
+              <a:cxn ang="0">
+                <a:pos x="csX8" y="csY8"/>
+              </a:cxn>
+              <a:cxn ang="0">
+                <a:pos x="csX9" y="csY9"/>
+              </a:cxn>
+              <a:cxn ang="0">
+                <a:pos x="csX10" y="csY10"/>
+              </a:cxn>
+              <a:cxn ang="0">
+                <a:pos x="csX11" y="csY11"/>
+              </a:cxn>
+              <a:cxn ang="0">
+                <a:pos x="csX12" y="csY12"/>
+              </a:cxn>
+              <a:cxn ang="0">
+                <a:pos x="csX13" y="csY13"/>
+              </a:cxn>
+              <a:cxn ang="0">
+                <a:pos x="csX14" y="csY14"/>
+              </a:cxn>
+              <a:cxn ang="0">
+                <a:pos x="csX15" y="csY15"/>
+              </a:cxn>
+              <a:cxn ang="0">
+                <a:pos x="csX16" y="csY16"/>
+              </a:cxn>
+              <a:cxn ang="0">
+                <a:pos x="csX17" y="csY17"/>
+              </a:cxn>
+            </a:cxnLst>
+            <a:rect l="l" t="t" r="r" b="b"/>
+            <a:pathLst>
+              <a:path w="4008943" h="3916469">
+                <a:moveTo>
+                  <a:pt x="4008944" y="1167165"/>
+                </a:moveTo>
+                <a:lnTo>
+                  <a:pt x="4008944" y="2749696"/>
+                </a:lnTo>
+                <a:cubicBezTo>
+                  <a:pt x="4008944" y="2914936"/>
+                  <a:pt x="3874241" y="3049315"/>
+                  <a:pt x="3709059" y="3049315"/>
+                </a:cubicBezTo>
+                <a:lnTo>
+                  <a:pt x="2166704" y="3049315"/>
+                </a:lnTo>
+                <a:cubicBezTo>
+                  <a:pt x="2090123" y="3049315"/>
+                  <a:pt x="2028020" y="3111627"/>
+                  <a:pt x="2028020" y="3188170"/>
+                </a:cubicBezTo>
+                <a:lnTo>
+                  <a:pt x="2028020" y="3704044"/>
+                </a:lnTo>
+                <a:cubicBezTo>
+                  <a:pt x="2028020" y="3794303"/>
+                  <a:pt x="1977500" y="3868455"/>
+                  <a:pt x="1893327" y="3901164"/>
+                </a:cubicBezTo>
+                <a:cubicBezTo>
+                  <a:pt x="1809288" y="3933825"/>
+                  <a:pt x="1721830" y="3913489"/>
+                  <a:pt x="1660812" y="3847100"/>
+                </a:cubicBezTo>
+                <a:lnTo>
+                  <a:pt x="56136" y="2101263"/>
+                </a:lnTo>
+                <a:cubicBezTo>
+                  <a:pt x="-18712" y="2019834"/>
+                  <a:pt x="-18712" y="1896570"/>
+                  <a:pt x="56136" y="1815141"/>
+                </a:cubicBezTo>
+                <a:lnTo>
+                  <a:pt x="1660812" y="69304"/>
+                </a:lnTo>
+                <a:cubicBezTo>
+                  <a:pt x="1700836" y="25765"/>
+                  <a:pt x="1754319" y="0"/>
+                  <a:pt x="1813679" y="0"/>
+                </a:cubicBezTo>
+                <a:cubicBezTo>
+                  <a:pt x="1841006" y="0"/>
+                  <a:pt x="1867895" y="5829"/>
+                  <a:pt x="1893318" y="15697"/>
+                </a:cubicBezTo>
+                <a:cubicBezTo>
+                  <a:pt x="1977642" y="48406"/>
+                  <a:pt x="2028011" y="122415"/>
+                  <a:pt x="2028011" y="212817"/>
+                </a:cubicBezTo>
+                <a:lnTo>
+                  <a:pt x="2028011" y="728243"/>
+                </a:lnTo>
+                <a:cubicBezTo>
+                  <a:pt x="2028011" y="804786"/>
+                  <a:pt x="2090114" y="867099"/>
+                  <a:pt x="2166695" y="867099"/>
+                </a:cubicBezTo>
+                <a:lnTo>
+                  <a:pt x="3709040" y="867099"/>
+                </a:lnTo>
+                <a:cubicBezTo>
+                  <a:pt x="3874508" y="867099"/>
+                  <a:pt x="4008944" y="1001744"/>
+                  <a:pt x="4008944" y="1167165"/>
+                </a:cubicBezTo>
+                <a:close/>
+              </a:path>
+            </a:pathLst>
+          </a:custGeom>
+          <a:solidFill>
+            <a:srgbClr val="000000"/>
+          </a:solidFill>
+          <a:ln w="9525" cap="flat">
+            <a:noFill/>
+            <a:prstDash val="solid"/>
+            <a:miter/>
+          </a:ln>
+        </p:spPr>
+        <p:txBody>
+          <a:bodyPr/>
+          <a:lstStyle/>
+          <a:p>
+            <a:endParaRPr lang="en-US"/>
+          </a:p>
+        </p:txBody>
+      </p:sp>
+      <p:sp>
+        <p:nvSpPr>
+          <p:cNvPr id="6" name="Graphic 3">
+            <a:extLst>
+              <a:ext uri="{FF2B5EF4-FFF2-40B4-BE49-F238E27FC236}">
+                <a16:creationId xmlns:a16="http://schemas.microsoft.com/office/drawing/2014/main" id="{6630DA6B-E113-196F-F9F4-583640753620}"/>
+              </a:ext>
+            </a:extLst>
+          </p:cNvPr>
+          <p:cNvSpPr/>
+          <p:nvPr/>
+        </p:nvSpPr>
+        <p:spPr>
+          <a:xfrm flipH="1">
+            <a:off x="8444713" y="4211901"/>
+            <a:ext cx="1527730" cy="1501200"/>
+          </a:xfrm>
+          <a:custGeom>
+            <a:avLst/>
+            <a:gdLst>
+              <a:gd name="csX0" fmla="*/ 4008944 w 4008943"/>
+              <a:gd name="csY0" fmla="*/ 1167165 h 3916469"/>
+              <a:gd name="csX1" fmla="*/ 4008944 w 4008943"/>
+              <a:gd name="csY1" fmla="*/ 2749696 h 3916469"/>
+              <a:gd name="csX2" fmla="*/ 3709059 w 4008943"/>
+              <a:gd name="csY2" fmla="*/ 3049315 h 3916469"/>
+              <a:gd name="csX3" fmla="*/ 2166704 w 4008943"/>
+              <a:gd name="csY3" fmla="*/ 3049315 h 3916469"/>
+              <a:gd name="csX4" fmla="*/ 2028020 w 4008943"/>
+              <a:gd name="csY4" fmla="*/ 3188170 h 3916469"/>
+              <a:gd name="csX5" fmla="*/ 2028020 w 4008943"/>
+              <a:gd name="csY5" fmla="*/ 3704044 h 3916469"/>
+              <a:gd name="csX6" fmla="*/ 1893327 w 4008943"/>
+              <a:gd name="csY6" fmla="*/ 3901164 h 3916469"/>
+              <a:gd name="csX7" fmla="*/ 1660812 w 4008943"/>
+              <a:gd name="csY7" fmla="*/ 3847100 h 3916469"/>
+              <a:gd name="csX8" fmla="*/ 56136 w 4008943"/>
+              <a:gd name="csY8" fmla="*/ 2101263 h 3916469"/>
+              <a:gd name="csX9" fmla="*/ 56136 w 4008943"/>
+              <a:gd name="csY9" fmla="*/ 1815141 h 3916469"/>
+              <a:gd name="csX10" fmla="*/ 1660812 w 4008943"/>
+              <a:gd name="csY10" fmla="*/ 69304 h 3916469"/>
+              <a:gd name="csX11" fmla="*/ 1813679 w 4008943"/>
+              <a:gd name="csY11" fmla="*/ 0 h 3916469"/>
+              <a:gd name="csX12" fmla="*/ 1893318 w 4008943"/>
+              <a:gd name="csY12" fmla="*/ 15697 h 3916469"/>
+              <a:gd name="csX13" fmla="*/ 2028011 w 4008943"/>
+              <a:gd name="csY13" fmla="*/ 212817 h 3916469"/>
+              <a:gd name="csX14" fmla="*/ 2028011 w 4008943"/>
+              <a:gd name="csY14" fmla="*/ 728243 h 3916469"/>
+              <a:gd name="csX15" fmla="*/ 2166695 w 4008943"/>
+              <a:gd name="csY15" fmla="*/ 867099 h 3916469"/>
+              <a:gd name="csX16" fmla="*/ 3709040 w 4008943"/>
+              <a:gd name="csY16" fmla="*/ 867099 h 3916469"/>
+              <a:gd name="csX17" fmla="*/ 4008944 w 4008943"/>
+              <a:gd name="csY17" fmla="*/ 1167165 h 3916469"/>
+            </a:gdLst>
+            <a:ahLst/>
+            <a:cxnLst>
+              <a:cxn ang="0">
+                <a:pos x="csX0" y="csY0"/>
+              </a:cxn>
+              <a:cxn ang="0">
+                <a:pos x="csX1" y="csY1"/>
+              </a:cxn>
+              <a:cxn ang="0">
+                <a:pos x="csX2" y="csY2"/>
+              </a:cxn>
+              <a:cxn ang="0">
+                <a:pos x="csX3" y="csY3"/>
+              </a:cxn>
+              <a:cxn ang="0">
+                <a:pos x="csX4" y="csY4"/>
+              </a:cxn>
+              <a:cxn ang="0">
+                <a:pos x="csX5" y="csY5"/>
+              </a:cxn>
+              <a:cxn ang="0">
+                <a:pos x="csX6" y="csY6"/>
+              </a:cxn>
+              <a:cxn ang="0">
+                <a:pos x="csX7" y="csY7"/>
+              </a:cxn>
+              <a:cxn ang="0">
+                <a:pos x="csX8" y="csY8"/>
+              </a:cxn>
+              <a:cxn ang="0">
+                <a:pos x="csX9" y="csY9"/>
+              </a:cxn>
+              <a:cxn ang="0">
+                <a:pos x="csX10" y="csY10"/>
+              </a:cxn>
+              <a:cxn ang="0">
+                <a:pos x="csX11" y="csY11"/>
+              </a:cxn>
+              <a:cxn ang="0">
+                <a:pos x="csX12" y="csY12"/>
+              </a:cxn>
+              <a:cxn ang="0">
+                <a:pos x="csX13" y="csY13"/>
+              </a:cxn>
+              <a:cxn ang="0">
+                <a:pos x="csX14" y="csY14"/>
+              </a:cxn>
+              <a:cxn ang="0">
+                <a:pos x="csX15" y="csY15"/>
+              </a:cxn>
+              <a:cxn ang="0">
+                <a:pos x="csX16" y="csY16"/>
+              </a:cxn>
+              <a:cxn ang="0">
+                <a:pos x="csX17" y="csY17"/>
+              </a:cxn>
+            </a:cxnLst>
+            <a:rect l="l" t="t" r="r" b="b"/>
+            <a:pathLst>
+              <a:path w="4008943" h="3916469">
+                <a:moveTo>
+                  <a:pt x="4008944" y="1167165"/>
+                </a:moveTo>
+                <a:lnTo>
+                  <a:pt x="4008944" y="2749696"/>
+                </a:lnTo>
+                <a:cubicBezTo>
+                  <a:pt x="4008944" y="2914936"/>
+                  <a:pt x="3874241" y="3049315"/>
+                  <a:pt x="3709059" y="3049315"/>
+                </a:cubicBezTo>
+                <a:lnTo>
+                  <a:pt x="2166704" y="3049315"/>
+                </a:lnTo>
+                <a:cubicBezTo>
+                  <a:pt x="2090123" y="3049315"/>
+                  <a:pt x="2028020" y="3111627"/>
+                  <a:pt x="2028020" y="3188170"/>
+                </a:cubicBezTo>
+                <a:lnTo>
+                  <a:pt x="2028020" y="3704044"/>
+                </a:lnTo>
+                <a:cubicBezTo>
+                  <a:pt x="2028020" y="3794303"/>
+                  <a:pt x="1977500" y="3868455"/>
+                  <a:pt x="1893327" y="3901164"/>
+                </a:cubicBezTo>
+                <a:cubicBezTo>
+                  <a:pt x="1809288" y="3933825"/>
+                  <a:pt x="1721830" y="3913489"/>
+                  <a:pt x="1660812" y="3847100"/>
+                </a:cubicBezTo>
+                <a:lnTo>
+                  <a:pt x="56136" y="2101263"/>
+                </a:lnTo>
+                <a:cubicBezTo>
+                  <a:pt x="-18712" y="2019834"/>
+                  <a:pt x="-18712" y="1896570"/>
+                  <a:pt x="56136" y="1815141"/>
+                </a:cubicBezTo>
+                <a:lnTo>
+                  <a:pt x="1660812" y="69304"/>
+                </a:lnTo>
+                <a:cubicBezTo>
+                  <a:pt x="1700836" y="25765"/>
+                  <a:pt x="1754319" y="0"/>
+                  <a:pt x="1813679" y="0"/>
+                </a:cubicBezTo>
+                <a:cubicBezTo>
+                  <a:pt x="1841006" y="0"/>
+                  <a:pt x="1867895" y="5829"/>
+                  <a:pt x="1893318" y="15697"/>
+                </a:cubicBezTo>
+                <a:cubicBezTo>
+                  <a:pt x="1977642" y="48406"/>
+                  <a:pt x="2028011" y="122415"/>
+                  <a:pt x="2028011" y="212817"/>
+                </a:cubicBezTo>
+                <a:lnTo>
+                  <a:pt x="2028011" y="728243"/>
+                </a:lnTo>
+                <a:cubicBezTo>
+                  <a:pt x="2028011" y="804786"/>
+                  <a:pt x="2090114" y="867099"/>
+                  <a:pt x="2166695" y="867099"/>
+                </a:cubicBezTo>
+                <a:lnTo>
+                  <a:pt x="3709040" y="867099"/>
+                </a:lnTo>
+                <a:cubicBezTo>
+                  <a:pt x="3874508" y="867099"/>
+                  <a:pt x="4008944" y="1001744"/>
+                  <a:pt x="4008944" y="1167165"/>
+                </a:cubicBezTo>
+                <a:close/>
+              </a:path>
+            </a:pathLst>
+          </a:custGeom>
+          <a:solidFill>
+            <a:srgbClr val="000000"/>
+          </a:solidFill>
+          <a:ln w="9525" cap="flat">
+            <a:noFill/>
+            <a:prstDash val="solid"/>
+            <a:miter/>
+          </a:ln>
+        </p:spPr>
+        <p:txBody>
+          <a:bodyPr/>
+          <a:lstStyle/>
+          <a:p>
             <a:endParaRPr lang="en-US"/>
           </a:p>
         </p:txBody>

</xml_diff>